<commit_message>
Refactor renderer and serializer for placeholder support; add inheritance tests
- Updated renderer to include placeholder attributes (ph_type, ph_idx) in shapes.
- Refactored serializer to handle placeholder properties in autoshapes.
- Introduced new string helper functions in xml.mbt for substring operations.
- Enhanced svg_parser to extract placeholder data from SVG nodes.
- Added comprehensive tests for slide master inheritance and placeholder styles in test_features.pptx.
- Updated Node.js test script to validate PPTX structure and relationships, including new inheritance features.
</commit_message>
<xml_diff>
--- a/test_fixtures/test_features.pptx
+++ b/test_fixtures/test_features.pptx
@@ -10,6 +10,9 @@
     <p:sldId id="258" r:id="rId9"/>
     <p:sldId id="259" r:id="rId10"/>
     <p:sldId id="260" r:id="rId11"/>
+    <p:sldId id="261" r:id="rId12"/>
+    <p:sldId id="262" r:id="rId13"/>
+    <p:sldId id="263" r:id="rId14"/>
   </p:sldIdLst>
   <p:sldSz cx="9144000" cy="6858000" type="screen4x3"/>
   <p:notesSz cx="6858000" cy="9144000"/>
@@ -2576,9 +2579,12 @@
 <p:sldMaster xmlns:a="http://schemas.openxmlformats.org/drawingml/2006/main" xmlns:r="http://schemas.openxmlformats.org/officeDocument/2006/relationships" xmlns:p="http://schemas.openxmlformats.org/presentationml/2006/main">
   <p:cSld>
     <p:bg>
-      <p:bgRef idx="1001">
-        <a:schemeClr val="bg1"/>
-      </p:bgRef>
+      <p:bgPr>
+        <a:solidFill>
+          <a:srgbClr val="1B3A6B"/>
+        </a:solidFill>
+        <a:effectLst/>
+      </p:bgPr>
     </p:bg>
     <p:spTree>
       <p:nvGrpSpPr>
@@ -2831,252 +2837,40 @@
   </p:sldLayoutIdLst>
   <p:txStyles>
     <p:titleStyle>
-      <a:lvl1pPr algn="ctr" defTabSz="457200" rtl="0" eaLnBrk="1" latinLnBrk="0" hangingPunct="1">
-        <a:spcBef>
-          <a:spcPct val="0"/>
-        </a:spcBef>
-        <a:buNone/>
-        <a:defRPr sz="4400" kern="1200">
+      <a:lvl1pPr algn="ctr">
+        <a:defRPr sz="4400">
           <a:solidFill>
-            <a:schemeClr val="tx1"/>
+            <a:srgbClr val="FFFFFF"/>
           </a:solidFill>
-          <a:latin typeface="+mj-lt"/>
-          <a:ea typeface="+mj-ea"/>
-          <a:cs typeface="+mj-cs"/>
         </a:defRPr>
       </a:lvl1pPr>
     </p:titleStyle>
     <p:bodyStyle>
-      <a:lvl1pPr marL="342900" indent="-342900" algn="l" defTabSz="457200" rtl="0" eaLnBrk="1" latinLnBrk="0" hangingPunct="1">
-        <a:spcBef>
-          <a:spcPct val="20000"/>
-        </a:spcBef>
-        <a:buFont typeface="Arial"/>
+      <a:lvl1pPr algn="l" marL="342900">
         <a:buChar char="•"/>
-        <a:defRPr sz="3200" kern="1200">
+        <a:defRPr sz="2400">
           <a:solidFill>
-            <a:schemeClr val="tx1"/>
+            <a:srgbClr val="FFFFFF"/>
           </a:solidFill>
-          <a:latin typeface="+mn-lt"/>
-          <a:ea typeface="+mn-ea"/>
-          <a:cs typeface="+mn-cs"/>
         </a:defRPr>
       </a:lvl1pPr>
-      <a:lvl2pPr marL="742950" indent="-285750" algn="l" defTabSz="457200" rtl="0" eaLnBrk="1" latinLnBrk="0" hangingPunct="1">
-        <a:spcBef>
-          <a:spcPct val="20000"/>
-        </a:spcBef>
-        <a:buFont typeface="Arial"/>
+      <a:lvl2pPr algn="l" marL="685800">
         <a:buChar char="–"/>
-        <a:defRPr sz="2800" kern="1200">
+        <a:defRPr sz="2000">
           <a:solidFill>
-            <a:schemeClr val="tx1"/>
+            <a:srgbClr val="CCCCCC"/>
           </a:solidFill>
-          <a:latin typeface="+mn-lt"/>
-          <a:ea typeface="+mn-ea"/>
-          <a:cs typeface="+mn-cs"/>
         </a:defRPr>
       </a:lvl2pPr>
-      <a:lvl3pPr marL="1143000" indent="-228600" algn="l" defTabSz="457200" rtl="0" eaLnBrk="1" latinLnBrk="0" hangingPunct="1">
-        <a:spcBef>
-          <a:spcPct val="20000"/>
-        </a:spcBef>
-        <a:buFont typeface="Arial"/>
-        <a:buChar char="•"/>
-        <a:defRPr sz="2400" kern="1200">
-          <a:solidFill>
-            <a:schemeClr val="tx1"/>
-          </a:solidFill>
-          <a:latin typeface="+mn-lt"/>
-          <a:ea typeface="+mn-ea"/>
-          <a:cs typeface="+mn-cs"/>
-        </a:defRPr>
-      </a:lvl3pPr>
-      <a:lvl4pPr marL="1600200" indent="-228600" algn="l" defTabSz="457200" rtl="0" eaLnBrk="1" latinLnBrk="0" hangingPunct="1">
-        <a:spcBef>
-          <a:spcPct val="20000"/>
-        </a:spcBef>
-        <a:buFont typeface="Arial"/>
-        <a:buChar char="–"/>
-        <a:defRPr sz="2000" kern="1200">
-          <a:solidFill>
-            <a:schemeClr val="tx1"/>
-          </a:solidFill>
-          <a:latin typeface="+mn-lt"/>
-          <a:ea typeface="+mn-ea"/>
-          <a:cs typeface="+mn-cs"/>
-        </a:defRPr>
-      </a:lvl4pPr>
-      <a:lvl5pPr marL="2057400" indent="-228600" algn="l" defTabSz="457200" rtl="0" eaLnBrk="1" latinLnBrk="0" hangingPunct="1">
-        <a:spcBef>
-          <a:spcPct val="20000"/>
-        </a:spcBef>
-        <a:buFont typeface="Arial"/>
-        <a:buChar char="»"/>
-        <a:defRPr sz="2000" kern="1200">
-          <a:solidFill>
-            <a:schemeClr val="tx1"/>
-          </a:solidFill>
-          <a:latin typeface="+mn-lt"/>
-          <a:ea typeface="+mn-ea"/>
-          <a:cs typeface="+mn-cs"/>
-        </a:defRPr>
-      </a:lvl5pPr>
-      <a:lvl6pPr marL="2514600" indent="-228600" algn="l" defTabSz="457200" rtl="0" eaLnBrk="1" latinLnBrk="0" hangingPunct="1">
-        <a:spcBef>
-          <a:spcPct val="20000"/>
-        </a:spcBef>
-        <a:buFont typeface="Arial"/>
-        <a:buChar char="•"/>
-        <a:defRPr sz="2000" kern="1200">
-          <a:solidFill>
-            <a:schemeClr val="tx1"/>
-          </a:solidFill>
-          <a:latin typeface="+mn-lt"/>
-          <a:ea typeface="+mn-ea"/>
-          <a:cs typeface="+mn-cs"/>
-        </a:defRPr>
-      </a:lvl6pPr>
-      <a:lvl7pPr marL="2971800" indent="-228600" algn="l" defTabSz="457200" rtl="0" eaLnBrk="1" latinLnBrk="0" hangingPunct="1">
-        <a:spcBef>
-          <a:spcPct val="20000"/>
-        </a:spcBef>
-        <a:buFont typeface="Arial"/>
-        <a:buChar char="•"/>
-        <a:defRPr sz="2000" kern="1200">
-          <a:solidFill>
-            <a:schemeClr val="tx1"/>
-          </a:solidFill>
-          <a:latin typeface="+mn-lt"/>
-          <a:ea typeface="+mn-ea"/>
-          <a:cs typeface="+mn-cs"/>
-        </a:defRPr>
-      </a:lvl7pPr>
-      <a:lvl8pPr marL="3429000" indent="-228600" algn="l" defTabSz="457200" rtl="0" eaLnBrk="1" latinLnBrk="0" hangingPunct="1">
-        <a:spcBef>
-          <a:spcPct val="20000"/>
-        </a:spcBef>
-        <a:buFont typeface="Arial"/>
-        <a:buChar char="•"/>
-        <a:defRPr sz="2000" kern="1200">
-          <a:solidFill>
-            <a:schemeClr val="tx1"/>
-          </a:solidFill>
-          <a:latin typeface="+mn-lt"/>
-          <a:ea typeface="+mn-ea"/>
-          <a:cs typeface="+mn-cs"/>
-        </a:defRPr>
-      </a:lvl8pPr>
-      <a:lvl9pPr marL="3886200" indent="-228600" algn="l" defTabSz="457200" rtl="0" eaLnBrk="1" latinLnBrk="0" hangingPunct="1">
-        <a:spcBef>
-          <a:spcPct val="20000"/>
-        </a:spcBef>
-        <a:buFont typeface="Arial"/>
-        <a:buChar char="•"/>
-        <a:defRPr sz="2000" kern="1200">
-          <a:solidFill>
-            <a:schemeClr val="tx1"/>
-          </a:solidFill>
-          <a:latin typeface="+mn-lt"/>
-          <a:ea typeface="+mn-ea"/>
-          <a:cs typeface="+mn-cs"/>
-        </a:defRPr>
-      </a:lvl9pPr>
     </p:bodyStyle>
     <p:otherStyle>
-      <a:defPPr>
-        <a:defRPr lang="en-US"/>
-      </a:defPPr>
-      <a:lvl1pPr marL="0" algn="l" defTabSz="457200" rtl="0" eaLnBrk="1" latinLnBrk="0" hangingPunct="1">
-        <a:defRPr sz="1800" kern="1200">
+      <a:lvl1pPr>
+        <a:defRPr sz="1800">
           <a:solidFill>
-            <a:schemeClr val="tx1"/>
+            <a:srgbClr val="999999"/>
           </a:solidFill>
-          <a:latin typeface="+mn-lt"/>
-          <a:ea typeface="+mn-ea"/>
-          <a:cs typeface="+mn-cs"/>
         </a:defRPr>
       </a:lvl1pPr>
-      <a:lvl2pPr marL="457200" algn="l" defTabSz="457200" rtl="0" eaLnBrk="1" latinLnBrk="0" hangingPunct="1">
-        <a:defRPr sz="1800" kern="1200">
-          <a:solidFill>
-            <a:schemeClr val="tx1"/>
-          </a:solidFill>
-          <a:latin typeface="+mn-lt"/>
-          <a:ea typeface="+mn-ea"/>
-          <a:cs typeface="+mn-cs"/>
-        </a:defRPr>
-      </a:lvl2pPr>
-      <a:lvl3pPr marL="914400" algn="l" defTabSz="457200" rtl="0" eaLnBrk="1" latinLnBrk="0" hangingPunct="1">
-        <a:defRPr sz="1800" kern="1200">
-          <a:solidFill>
-            <a:schemeClr val="tx1"/>
-          </a:solidFill>
-          <a:latin typeface="+mn-lt"/>
-          <a:ea typeface="+mn-ea"/>
-          <a:cs typeface="+mn-cs"/>
-        </a:defRPr>
-      </a:lvl3pPr>
-      <a:lvl4pPr marL="1371600" algn="l" defTabSz="457200" rtl="0" eaLnBrk="1" latinLnBrk="0" hangingPunct="1">
-        <a:defRPr sz="1800" kern="1200">
-          <a:solidFill>
-            <a:schemeClr val="tx1"/>
-          </a:solidFill>
-          <a:latin typeface="+mn-lt"/>
-          <a:ea typeface="+mn-ea"/>
-          <a:cs typeface="+mn-cs"/>
-        </a:defRPr>
-      </a:lvl4pPr>
-      <a:lvl5pPr marL="1828800" algn="l" defTabSz="457200" rtl="0" eaLnBrk="1" latinLnBrk="0" hangingPunct="1">
-        <a:defRPr sz="1800" kern="1200">
-          <a:solidFill>
-            <a:schemeClr val="tx1"/>
-          </a:solidFill>
-          <a:latin typeface="+mn-lt"/>
-          <a:ea typeface="+mn-ea"/>
-          <a:cs typeface="+mn-cs"/>
-        </a:defRPr>
-      </a:lvl5pPr>
-      <a:lvl6pPr marL="2286000" algn="l" defTabSz="457200" rtl="0" eaLnBrk="1" latinLnBrk="0" hangingPunct="1">
-        <a:defRPr sz="1800" kern="1200">
-          <a:solidFill>
-            <a:schemeClr val="tx1"/>
-          </a:solidFill>
-          <a:latin typeface="+mn-lt"/>
-          <a:ea typeface="+mn-ea"/>
-          <a:cs typeface="+mn-cs"/>
-        </a:defRPr>
-      </a:lvl6pPr>
-      <a:lvl7pPr marL="2743200" algn="l" defTabSz="457200" rtl="0" eaLnBrk="1" latinLnBrk="0" hangingPunct="1">
-        <a:defRPr sz="1800" kern="1200">
-          <a:solidFill>
-            <a:schemeClr val="tx1"/>
-          </a:solidFill>
-          <a:latin typeface="+mn-lt"/>
-          <a:ea typeface="+mn-ea"/>
-          <a:cs typeface="+mn-cs"/>
-        </a:defRPr>
-      </a:lvl7pPr>
-      <a:lvl8pPr marL="3200400" algn="l" defTabSz="457200" rtl="0" eaLnBrk="1" latinLnBrk="0" hangingPunct="1">
-        <a:defRPr sz="1800" kern="1200">
-          <a:solidFill>
-            <a:schemeClr val="tx1"/>
-          </a:solidFill>
-          <a:latin typeface="+mn-lt"/>
-          <a:ea typeface="+mn-ea"/>
-          <a:cs typeface="+mn-cs"/>
-        </a:defRPr>
-      </a:lvl8pPr>
-      <a:lvl9pPr marL="3657600" algn="l" defTabSz="457200" rtl="0" eaLnBrk="1" latinLnBrk="0" hangingPunct="1">
-        <a:defRPr sz="1800" kern="1200">
-          <a:solidFill>
-            <a:schemeClr val="tx1"/>
-          </a:solidFill>
-          <a:latin typeface="+mn-lt"/>
-          <a:ea typeface="+mn-ea"/>
-          <a:cs typeface="+mn-cs"/>
-        </a:defRPr>
-      </a:lvl9pPr>
     </p:otherStyle>
   </p:txStyles>
 </p:sldMaster>
@@ -3923,6 +3717,320 @@
             </a:pPr>
             <a:r>
               <a:t>Third item with underline run</a:t>
+            </a:r>
+          </a:p>
+        </p:txBody>
+      </p:sp>
+    </p:spTree>
+  </p:cSld>
+  <p:clrMapOvr>
+    <a:masterClrMapping/>
+  </p:clrMapOvr>
+</p:sld>
+</file>
+
+<file path=ppt/slides/slide6.xml><?xml version="1.0" encoding="utf-8"?>
+<p:sld xmlns:a="http://schemas.openxmlformats.org/drawingml/2006/main" xmlns:p="http://schemas.openxmlformats.org/presentationml/2006/main" xmlns:r="http://schemas.openxmlformats.org/officeDocument/2006/relationships">
+  <p:cSld>
+    <p:spTree>
+      <p:nvGrpSpPr>
+        <p:cNvPr id="1" name=""/>
+        <p:cNvGrpSpPr/>
+        <p:nvPr/>
+      </p:nvGrpSpPr>
+      <p:grpSpPr/>
+      <p:sp>
+        <p:nvSpPr>
+          <p:cNvPr id="2" name="TextBox 1"/>
+          <p:cNvSpPr txBox="1"/>
+          <p:nvPr/>
+        </p:nvSpPr>
+        <p:spPr>
+          <a:xfrm>
+            <a:off x="457200" y="274320"/>
+            <a:ext cx="8229600" cy="731520"/>
+          </a:xfrm>
+          <a:prstGeom prst="rect">
+            <a:avLst/>
+          </a:prstGeom>
+          <a:noFill/>
+        </p:spPr>
+        <p:txBody>
+          <a:bodyPr wrap="none">
+            <a:spAutoFit/>
+          </a:bodyPr>
+          <a:lstStyle/>
+          <a:p>
+            <a:pPr>
+              <a:defRPr sz="2400" b="1">
+                <a:solidFill>
+                  <a:srgbClr val="FFFFFF"/>
+                </a:solidFill>
+              </a:defRPr>
+            </a:pPr>
+            <a:r>
+              <a:t>Slide 6: Inherits master navy bg</a:t>
+            </a:r>
+          </a:p>
+        </p:txBody>
+      </p:sp>
+      <p:sp>
+        <p:nvSpPr>
+          <p:cNvPr id="3" name="TextBox 2"/>
+          <p:cNvSpPr txBox="1"/>
+          <p:nvPr/>
+        </p:nvSpPr>
+        <p:spPr>
+          <a:xfrm>
+            <a:off x="457200" y="1828800"/>
+            <a:ext cx="8229600" cy="2743200"/>
+          </a:xfrm>
+          <a:prstGeom prst="rect">
+            <a:avLst/>
+          </a:prstGeom>
+          <a:noFill/>
+        </p:spPr>
+        <p:txBody>
+          <a:bodyPr wrap="square">
+            <a:spAutoFit/>
+          </a:bodyPr>
+          <a:lstStyle/>
+          <a:p>
+            <a:pPr>
+              <a:defRPr sz="1800">
+                <a:solidFill>
+                  <a:srgbClr val="C8DCFF"/>
+                </a:solidFill>
+              </a:defRPr>
+            </a:pPr>
+            <a:r>
+              <a:t>Navy bg (#1B3A6B) = inheritance OK</a:t>
+            </a:r>
+          </a:p>
+          <a:p>
+            <a:pPr>
+              <a:defRPr sz="1800">
+                <a:solidFill>
+                  <a:srgbClr val="FF9696"/>
+                </a:solidFill>
+              </a:defRPr>
+            </a:pPr>
+            <a:r>
+              <a:t>White bg = inheritance FAILED</a:t>
+            </a:r>
+          </a:p>
+        </p:txBody>
+      </p:sp>
+    </p:spTree>
+  </p:cSld>
+  <p:clrMapOvr>
+    <a:masterClrMapping/>
+  </p:clrMapOvr>
+</p:sld>
+</file>
+
+<file path=ppt/slides/slide7.xml><?xml version="1.0" encoding="utf-8"?>
+<p:sld xmlns:a="http://schemas.openxmlformats.org/drawingml/2006/main" xmlns:p="http://schemas.openxmlformats.org/presentationml/2006/main" xmlns:r="http://schemas.openxmlformats.org/officeDocument/2006/relationships">
+  <p:cSld>
+    <p:spTree>
+      <p:nvGrpSpPr>
+        <p:cNvPr id="1" name=""/>
+        <p:cNvGrpSpPr/>
+        <p:nvPr/>
+      </p:nvGrpSpPr>
+      <p:grpSpPr/>
+      <p:sp>
+        <p:nvSpPr>
+          <p:cNvPr id="2" name="Title 1"/>
+          <p:cNvSpPr>
+            <a:spLocks noGrp="1"/>
+          </p:cNvSpPr>
+          <p:nvPr>
+            <p:ph type="title"/>
+          </p:nvPr>
+        </p:nvSpPr>
+        <p:spPr/>
+        <p:txBody>
+          <a:bodyPr/>
+          <a:lstStyle/>
+          <a:p>
+            <a:r>
+              <a:t>Slide 7: Placeholder Title (inherits 44pt ctr white)</a:t>
+            </a:r>
+          </a:p>
+        </p:txBody>
+      </p:sp>
+      <p:sp>
+        <p:nvSpPr>
+          <p:cNvPr id="3" name="Content Placeholder 2"/>
+          <p:cNvSpPr>
+            <a:spLocks noGrp="1"/>
+          </p:cNvSpPr>
+          <p:nvPr>
+            <p:ph idx="1"/>
+          </p:nvPr>
+        </p:nvSpPr>
+        <p:spPr/>
+        <p:txBody>
+          <a:bodyPr/>
+          <a:lstStyle/>
+          <a:p>
+            <a:r>
+              <a:t>Level 0: Should inherit 24pt white from master bodyStyle</a:t>
+            </a:r>
+          </a:p>
+          <a:p>
+            <a:pPr lvl="1"/>
+            <a:r>
+              <a:t>Level 1: Should inherit 20pt lightgray from master bodyStyle lvl2</a:t>
+            </a:r>
+          </a:p>
+          <a:p>
+            <a:r>
+              <a:t>Level 0 again: back to 24pt white</a:t>
+            </a:r>
+          </a:p>
+        </p:txBody>
+      </p:sp>
+      <p:sp>
+        <p:nvSpPr>
+          <p:cNvPr id="4" name="TextBox 3"/>
+          <p:cNvSpPr txBox="1"/>
+          <p:nvPr/>
+        </p:nvSpPr>
+        <p:spPr>
+          <a:xfrm>
+            <a:off x="457200" y="5029200"/>
+            <a:ext cx="8229600" cy="1371600"/>
+          </a:xfrm>
+          <a:prstGeom prst="rect">
+            <a:avLst/>
+          </a:prstGeom>
+          <a:noFill/>
+        </p:spPr>
+        <p:txBody>
+          <a:bodyPr wrap="square">
+            <a:spAutoFit/>
+          </a:bodyPr>
+          <a:lstStyle/>
+          <a:p>
+            <a:pPr>
+              <a:defRPr sz="1200">
+                <a:solidFill>
+                  <a:srgbClr val="B4C8FF"/>
+                </a:solidFill>
+              </a:defRPr>
+            </a:pPr>
+            <a:r>
+              <a:t>^ Title should be 44pt centered white. Body bullets should be 24pt/20pt white/gray.</a:t>
+            </a:r>
+          </a:p>
+        </p:txBody>
+      </p:sp>
+    </p:spTree>
+  </p:cSld>
+  <p:clrMapOvr>
+    <a:masterClrMapping/>
+  </p:clrMapOvr>
+</p:sld>
+</file>
+
+<file path=ppt/slides/slide8.xml><?xml version="1.0" encoding="utf-8"?>
+<p:sld xmlns:a="http://schemas.openxmlformats.org/drawingml/2006/main" xmlns:p="http://schemas.openxmlformats.org/presentationml/2006/main" xmlns:r="http://schemas.openxmlformats.org/officeDocument/2006/relationships">
+  <p:cSld>
+    <p:bg>
+      <p:bgPr>
+        <a:solidFill>
+          <a:srgbClr val="228B22"/>
+        </a:solidFill>
+        <a:effectLst/>
+      </p:bgPr>
+    </p:bg>
+    <p:spTree>
+      <p:nvGrpSpPr>
+        <p:cNvPr id="1" name=""/>
+        <p:cNvGrpSpPr/>
+        <p:nvPr/>
+      </p:nvGrpSpPr>
+      <p:grpSpPr/>
+      <p:sp>
+        <p:nvSpPr>
+          <p:cNvPr id="2" name="TextBox 1"/>
+          <p:cNvSpPr txBox="1"/>
+          <p:nvPr/>
+        </p:nvSpPr>
+        <p:spPr>
+          <a:xfrm>
+            <a:off x="457200" y="274320"/>
+            <a:ext cx="8229600" cy="731520"/>
+          </a:xfrm>
+          <a:prstGeom prst="rect">
+            <a:avLst/>
+          </a:prstGeom>
+          <a:noFill/>
+        </p:spPr>
+        <p:txBody>
+          <a:bodyPr wrap="none">
+            <a:spAutoFit/>
+          </a:bodyPr>
+          <a:lstStyle/>
+          <a:p>
+            <a:pPr>
+              <a:defRPr sz="2000" b="1">
+                <a:solidFill>
+                  <a:srgbClr val="FFFFFF"/>
+                </a:solidFill>
+              </a:defRPr>
+            </a:pPr>
+            <a:r>
+              <a:t>Slide 8: Explicit green bg (#228B22) — overrides master</a:t>
+            </a:r>
+          </a:p>
+        </p:txBody>
+      </p:sp>
+      <p:sp>
+        <p:nvSpPr>
+          <p:cNvPr id="3" name="TextBox 2"/>
+          <p:cNvSpPr txBox="1"/>
+          <p:nvPr/>
+        </p:nvSpPr>
+        <p:spPr>
+          <a:xfrm>
+            <a:off x="457200" y="1828800"/>
+            <a:ext cx="8229600" cy="2743200"/>
+          </a:xfrm>
+          <a:prstGeom prst="rect">
+            <a:avLst/>
+          </a:prstGeom>
+          <a:noFill/>
+        </p:spPr>
+        <p:txBody>
+          <a:bodyPr wrap="square">
+            <a:spAutoFit/>
+          </a:bodyPr>
+          <a:lstStyle/>
+          <a:p>
+            <a:pPr>
+              <a:defRPr sz="1800">
+                <a:solidFill>
+                  <a:srgbClr val="DCFFDC"/>
+                </a:solidFill>
+              </a:defRPr>
+            </a:pPr>
+            <a:r>
+              <a:t>This slide has an explicit green background. It should NOT show the master's navy.</a:t>
+            </a:r>
+          </a:p>
+          <a:p>
+            <a:pPr>
+              <a:defRPr sz="1800">
+                <a:solidFill>
+                  <a:srgbClr val="FFFFFF"/>
+                </a:solidFill>
+              </a:defRPr>
+            </a:pPr>
+            <a:r>
+              <a:t>If you see green, explicit bg override is working correctly.</a:t>
             </a:r>
           </a:p>
         </p:txBody>

</xml_diff>

<commit_message>
feat: Enhance text rendering and serialization with line and character spacing support
- Implemented line spacing handling in `para_line_height` function to support both EMU and percentage values.
- Updated text rendering functions to accommodate East Asian fonts and character spacing attributes.
- Enhanced serialization of text properties to include line spacing and character spacing in the output XML.
- Added tests for East Asian font handling, line spacing, and character spacing to ensure proper functionality.
- Updated test fixtures to reflect the new features and validate the output.
</commit_message>
<xml_diff>
--- a/test_fixtures/test_features.pptx
+++ b/test_fixtures/test_features.pptx
@@ -13,6 +13,9 @@
     <p:sldId id="261" r:id="rId12"/>
     <p:sldId id="262" r:id="rId13"/>
     <p:sldId id="263" r:id="rId14"/>
+    <p:sldId id="264" r:id="rId15"/>
+    <p:sldId id="265" r:id="rId16"/>
+    <p:sldId id="266" r:id="rId17"/>
   </p:sldIdLst>
   <p:sldSz cx="9144000" cy="6858000" type="screen4x3"/>
   <p:notesSz cx="6858000" cy="9144000"/>
@@ -3084,6 +3087,371 @@
 </p:sld>
 </file>
 
+<file path=ppt/slides/slide10.xml><?xml version="1.0" encoding="utf-8"?>
+<p:sld xmlns:a="http://schemas.openxmlformats.org/drawingml/2006/main" xmlns:p="http://schemas.openxmlformats.org/presentationml/2006/main" xmlns:r="http://schemas.openxmlformats.org/officeDocument/2006/relationships">
+  <p:cSld>
+    <p:spTree>
+      <p:nvGrpSpPr>
+        <p:cNvPr id="1" name=""/>
+        <p:cNvGrpSpPr/>
+        <p:nvPr/>
+      </p:nvGrpSpPr>
+      <p:grpSpPr/>
+      <p:sp>
+        <p:nvSpPr>
+          <p:cNvPr id="2" name="TextBox 1"/>
+          <p:cNvSpPr txBox="1"/>
+          <p:nvPr/>
+        </p:nvSpPr>
+        <p:spPr>
+          <a:xfrm>
+            <a:off x="457200" y="274320"/>
+            <a:ext cx="8229600" cy="548640"/>
+          </a:xfrm>
+          <a:prstGeom prst="rect">
+            <a:avLst/>
+          </a:prstGeom>
+          <a:noFill/>
+        </p:spPr>
+        <p:txBody>
+          <a:bodyPr wrap="none">
+            <a:spAutoFit/>
+          </a:bodyPr>
+          <a:lstStyle/>
+          <a:p>
+            <a:pPr>
+              <a:defRPr sz="2400" b="1"/>
+            </a:pPr>
+            <a:r>
+              <a:t>Slide 10: Line Spacing (a:lnSpc)</a:t>
+            </a:r>
+          </a:p>
+        </p:txBody>
+      </p:sp>
+      <p:sp>
+        <p:nvSpPr>
+          <p:cNvPr id="3" name="TextBox 2"/>
+          <p:cNvSpPr txBox="1"/>
+          <p:nvPr/>
+        </p:nvSpPr>
+        <p:spPr>
+          <a:xfrm>
+            <a:off x="457200" y="1097280"/>
+            <a:ext cx="3657600" cy="2743200"/>
+          </a:xfrm>
+          <a:prstGeom prst="rect">
+            <a:avLst/>
+          </a:prstGeom>
+          <a:solidFill>
+            <a:srgbClr val="E6F5FF"/>
+          </a:solidFill>
+        </p:spPr>
+        <p:txBody>
+          <a:bodyPr wrap="square">
+            <a:spAutoFit/>
+          </a:bodyPr>
+          <a:lstStyle/>
+          <a:p>
+            <a:pPr>
+              <a:defRPr sz="1400"/>
+              <a:lnSpc>
+                <a:spcPct val="150000"/>
+              </a:lnSpc>
+            </a:pPr>
+            <a:r>
+              <a:t>Line 1: 150% spacing</a:t>
+            </a:r>
+          </a:p>
+          <a:p>
+            <a:pPr>
+              <a:defRPr sz="1400"/>
+              <a:lnSpc>
+                <a:spcPct val="150000"/>
+              </a:lnSpc>
+            </a:pPr>
+            <a:r>
+              <a:t>Line 2: wider gap above</a:t>
+            </a:r>
+          </a:p>
+          <a:p>
+            <a:pPr>
+              <a:defRPr sz="1400"/>
+              <a:lnSpc>
+                <a:spcPct val="150000"/>
+              </a:lnSpc>
+            </a:pPr>
+            <a:r>
+              <a:t>Line 3: still 150%</a:t>
+            </a:r>
+          </a:p>
+        </p:txBody>
+      </p:sp>
+      <p:sp>
+        <p:nvSpPr>
+          <p:cNvPr id="4" name="TextBox 3"/>
+          <p:cNvSpPr txBox="1"/>
+          <p:nvPr/>
+        </p:nvSpPr>
+        <p:spPr>
+          <a:xfrm>
+            <a:off x="4572000" y="1097280"/>
+            <a:ext cx="4114800" cy="2743200"/>
+          </a:xfrm>
+          <a:prstGeom prst="rect">
+            <a:avLst/>
+          </a:prstGeom>
+          <a:solidFill>
+            <a:srgbClr val="FFF0E6"/>
+          </a:solidFill>
+        </p:spPr>
+        <p:txBody>
+          <a:bodyPr wrap="square">
+            <a:spAutoFit/>
+          </a:bodyPr>
+          <a:lstStyle/>
+          <a:p>
+            <a:pPr>
+              <a:defRPr sz="1400"/>
+              <a:lnSpc>
+                <a:spcPts val="3600"/>
+              </a:lnSpc>
+            </a:pPr>
+            <a:r>
+              <a:t>Line 1: 36pt absolute</a:t>
+            </a:r>
+          </a:p>
+          <a:p>
+            <a:pPr>
+              <a:defRPr sz="1400"/>
+              <a:lnSpc>
+                <a:spcPts val="3600"/>
+              </a:lnSpc>
+            </a:pPr>
+            <a:r>
+              <a:t>Line 2: fixed height</a:t>
+            </a:r>
+          </a:p>
+          <a:p>
+            <a:pPr>
+              <a:defRPr sz="1400"/>
+              <a:lnSpc>
+                <a:spcPts val="3600"/>
+              </a:lnSpc>
+            </a:pPr>
+            <a:r>
+              <a:t>Line 3: still 36pt</a:t>
+            </a:r>
+          </a:p>
+        </p:txBody>
+      </p:sp>
+      <p:sp>
+        <p:nvSpPr>
+          <p:cNvPr id="5" name="TextBox 4"/>
+          <p:cNvSpPr txBox="1"/>
+          <p:nvPr/>
+        </p:nvSpPr>
+        <p:spPr>
+          <a:xfrm>
+            <a:off x="457200" y="4114800"/>
+            <a:ext cx="3657600" cy="2286000"/>
+          </a:xfrm>
+          <a:prstGeom prst="rect">
+            <a:avLst/>
+          </a:prstGeom>
+          <a:solidFill>
+            <a:srgbClr val="F5FFF0"/>
+          </a:solidFill>
+        </p:spPr>
+        <p:txBody>
+          <a:bodyPr wrap="square">
+            <a:spAutoFit/>
+          </a:bodyPr>
+          <a:lstStyle/>
+          <a:p>
+            <a:pPr>
+              <a:defRPr sz="1400"/>
+              <a:lnSpc>
+                <a:spcPct val="80000"/>
+              </a:lnSpc>
+            </a:pPr>
+            <a:r>
+              <a:t>Tight: 80% spacing</a:t>
+            </a:r>
+          </a:p>
+          <a:p>
+            <a:pPr>
+              <a:defRPr sz="1400"/>
+              <a:lnSpc>
+                <a:spcPct val="80000"/>
+              </a:lnSpc>
+            </a:pPr>
+            <a:r>
+              <a:t>Lines should be close together</a:t>
+            </a:r>
+          </a:p>
+          <a:p>
+            <a:pPr>
+              <a:defRPr sz="1400"/>
+              <a:lnSpc>
+                <a:spcPct val="80000"/>
+              </a:lnSpc>
+            </a:pPr>
+            <a:r>
+              <a:t>Third tight line</a:t>
+            </a:r>
+          </a:p>
+        </p:txBody>
+      </p:sp>
+    </p:spTree>
+  </p:cSld>
+  <p:clrMapOvr>
+    <a:masterClrMapping/>
+  </p:clrMapOvr>
+</p:sld>
+</file>
+
+<file path=ppt/slides/slide11.xml><?xml version="1.0" encoding="utf-8"?>
+<p:sld xmlns:a="http://schemas.openxmlformats.org/drawingml/2006/main" xmlns:p="http://schemas.openxmlformats.org/presentationml/2006/main" xmlns:r="http://schemas.openxmlformats.org/officeDocument/2006/relationships">
+  <p:cSld>
+    <p:spTree>
+      <p:nvGrpSpPr>
+        <p:cNvPr id="1" name=""/>
+        <p:cNvGrpSpPr/>
+        <p:nvPr/>
+      </p:nvGrpSpPr>
+      <p:grpSpPr/>
+      <p:sp>
+        <p:nvSpPr>
+          <p:cNvPr id="2" name="TextBox 1"/>
+          <p:cNvSpPr txBox="1"/>
+          <p:nvPr/>
+        </p:nvSpPr>
+        <p:spPr>
+          <a:xfrm>
+            <a:off x="457200" y="274320"/>
+            <a:ext cx="8229600" cy="548640"/>
+          </a:xfrm>
+          <a:prstGeom prst="rect">
+            <a:avLst/>
+          </a:prstGeom>
+          <a:noFill/>
+        </p:spPr>
+        <p:txBody>
+          <a:bodyPr wrap="none">
+            <a:spAutoFit/>
+          </a:bodyPr>
+          <a:lstStyle/>
+          <a:p>
+            <a:pPr>
+              <a:defRPr sz="2400" b="1"/>
+            </a:pPr>
+            <a:r>
+              <a:t>Slide 11: Character Spacing &amp; lstStyle</a:t>
+            </a:r>
+          </a:p>
+        </p:txBody>
+      </p:sp>
+      <p:sp>
+        <p:nvSpPr>
+          <p:cNvPr id="3" name="TextBox 2"/>
+          <p:cNvSpPr txBox="1"/>
+          <p:nvPr/>
+        </p:nvSpPr>
+        <p:spPr>
+          <a:xfrm>
+            <a:off x="457200" y="1097280"/>
+            <a:ext cx="8229600" cy="2286000"/>
+          </a:xfrm>
+          <a:prstGeom prst="rect">
+            <a:avLst/>
+          </a:prstGeom>
+          <a:solidFill>
+            <a:srgbClr val="F5F0FF"/>
+          </a:solidFill>
+        </p:spPr>
+        <p:txBody>
+          <a:bodyPr wrap="square">
+            <a:spAutoFit/>
+          </a:bodyPr>
+          <a:lstStyle/>
+          <a:p>
+            <a:r>
+              <a:rPr sz="1600"/>
+              <a:t>Normal spacing (spc=0)</a:t>
+            </a:r>
+          </a:p>
+          <a:p>
+            <a:r>
+              <a:rPr sz="1600" spc="300"/>
+              <a:t>Wide spacing (spc=300, 3pt)</a:t>
+            </a:r>
+          </a:p>
+          <a:p>
+            <a:r>
+              <a:rPr sz="1600" spc="1000"/>
+              <a:t>Very wide (spc=1000, 10pt)</a:t>
+            </a:r>
+          </a:p>
+          <a:p>
+            <a:r>
+              <a:rPr sz="1600" spc="-100"/>
+              <a:t>Tight spacing (spc=-100, -1pt)</a:t>
+            </a:r>
+          </a:p>
+        </p:txBody>
+      </p:sp>
+      <p:sp>
+        <p:nvSpPr>
+          <p:cNvPr id="4" name="TextBox 3"/>
+          <p:cNvSpPr txBox="1"/>
+          <p:nvPr/>
+        </p:nvSpPr>
+        <p:spPr>
+          <a:xfrm>
+            <a:off x="457200" y="3840480"/>
+            <a:ext cx="8229600" cy="2286000"/>
+          </a:xfrm>
+          <a:prstGeom prst="rect">
+            <a:avLst/>
+          </a:prstGeom>
+          <a:solidFill>
+            <a:srgbClr val="FFFAEB"/>
+          </a:solidFill>
+        </p:spPr>
+        <p:txBody>
+          <a:bodyPr wrap="square">
+            <a:spAutoFit/>
+          </a:bodyPr>
+          <a:lstStyle>
+            <a:lvl1pPr>
+              <a:defRPr sz="2000" b="1">
+                <a:solidFill>
+                  <a:srgbClr val="003366"/>
+                </a:solidFill>
+                <a:ea typeface="Meiryo"/>
+              </a:defRPr>
+            </a:lvl1pPr>
+          </a:lstStyle>
+          <a:p>
+            <a:r>
+              <a:t>lstStyle lvl1: inherits 20pt bold #003366 Meiryo</a:t>
+            </a:r>
+          </a:p>
+          <a:p>
+            <a:r>
+              <a:t>Second paragraph: should also inherit lstStyle defaults</a:t>
+            </a:r>
+          </a:p>
+        </p:txBody>
+      </p:sp>
+    </p:spTree>
+  </p:cSld>
+  <p:clrMapOvr>
+    <a:masterClrMapping/>
+  </p:clrMapOvr>
+</p:sld>
+</file>
+
 <file path=ppt/slides/slide2.xml><?xml version="1.0" encoding="utf-8"?>
 <p:sld xmlns:a="http://schemas.openxmlformats.org/drawingml/2006/main" xmlns:p="http://schemas.openxmlformats.org/presentationml/2006/main" xmlns:r="http://schemas.openxmlformats.org/officeDocument/2006/relationships">
   <p:cSld>
@@ -4031,6 +4399,176 @@
             </a:pPr>
             <a:r>
               <a:t>If you see green, explicit bg override is working correctly.</a:t>
+            </a:r>
+          </a:p>
+        </p:txBody>
+      </p:sp>
+    </p:spTree>
+  </p:cSld>
+  <p:clrMapOvr>
+    <a:masterClrMapping/>
+  </p:clrMapOvr>
+</p:sld>
+</file>
+
+<file path=ppt/slides/slide9.xml><?xml version="1.0" encoding="utf-8"?>
+<p:sld xmlns:a="http://schemas.openxmlformats.org/drawingml/2006/main" xmlns:p="http://schemas.openxmlformats.org/presentationml/2006/main" xmlns:r="http://schemas.openxmlformats.org/officeDocument/2006/relationships">
+  <p:cSld>
+    <p:spTree>
+      <p:nvGrpSpPr>
+        <p:cNvPr id="1" name=""/>
+        <p:cNvGrpSpPr/>
+        <p:nvPr/>
+      </p:nvGrpSpPr>
+      <p:grpSpPr/>
+      <p:sp>
+        <p:nvSpPr>
+          <p:cNvPr id="2" name="TextBox 1"/>
+          <p:cNvSpPr txBox="1"/>
+          <p:nvPr/>
+        </p:nvSpPr>
+        <p:spPr>
+          <a:xfrm>
+            <a:off x="457200" y="274320"/>
+            <a:ext cx="8229600" cy="548640"/>
+          </a:xfrm>
+          <a:prstGeom prst="rect">
+            <a:avLst/>
+          </a:prstGeom>
+          <a:noFill/>
+        </p:spPr>
+        <p:txBody>
+          <a:bodyPr wrap="none">
+            <a:spAutoFit/>
+          </a:bodyPr>
+          <a:lstStyle/>
+          <a:p>
+            <a:pPr>
+              <a:defRPr sz="2400" b="1"/>
+            </a:pPr>
+            <a:r>
+              <a:t>Slide 9: East Asian Fonts &amp; Theme References</a:t>
+            </a:r>
+          </a:p>
+        </p:txBody>
+      </p:sp>
+      <p:sp>
+        <p:nvSpPr>
+          <p:cNvPr id="3" name="TextBox 2"/>
+          <p:cNvSpPr txBox="1"/>
+          <p:nvPr/>
+        </p:nvSpPr>
+        <p:spPr>
+          <a:xfrm>
+            <a:off x="457200" y="1097280"/>
+            <a:ext cx="3657600" cy="1828800"/>
+          </a:xfrm>
+          <a:prstGeom prst="rect">
+            <a:avLst/>
+          </a:prstGeom>
+          <a:solidFill>
+            <a:srgbClr val="F0F0FF"/>
+          </a:solidFill>
+        </p:spPr>
+        <p:txBody>
+          <a:bodyPr wrap="square">
+            <a:spAutoFit/>
+          </a:bodyPr>
+          <a:lstStyle/>
+          <a:p>
+            <a:r>
+              <a:rPr sz="1800">
+                <a:ea typeface="MS PGothic"/>
+                <a:latin typeface="Arial"/>
+              </a:rPr>
+              <a:t>日本語テキスト（MS PGothic）</a:t>
+            </a:r>
+          </a:p>
+          <a:p>
+            <a:r>
+              <a:rPr sz="1600">
+                <a:ea typeface="+mj-ea"/>
+                <a:latin typeface="+mj-lt"/>
+              </a:rPr>
+              <a:t>テーマ参照: +mj-ea / +mj-lt</a:t>
+            </a:r>
+          </a:p>
+          <a:p>
+            <a:r>
+              <a:rPr sz="1400">
+                <a:ea typeface="+mn-ea"/>
+                <a:latin typeface="+mn-lt"/>
+              </a:rPr>
+              <a:t>マイナーフォント: +mn-ea / +mn-lt</a:t>
+            </a:r>
+          </a:p>
+        </p:txBody>
+      </p:sp>
+      <p:sp>
+        <p:nvSpPr>
+          <p:cNvPr id="4" name="TextBox 3"/>
+          <p:cNvSpPr txBox="1"/>
+          <p:nvPr/>
+        </p:nvSpPr>
+        <p:spPr>
+          <a:xfrm>
+            <a:off x="4572000" y="1097280"/>
+            <a:ext cx="4114800" cy="1828800"/>
+          </a:xfrm>
+          <a:prstGeom prst="rect">
+            <a:avLst/>
+          </a:prstGeom>
+          <a:solidFill>
+            <a:srgbClr val="FFF5EB"/>
+          </a:solidFill>
+        </p:spPr>
+        <p:txBody>
+          <a:bodyPr wrap="square">
+            <a:spAutoFit/>
+          </a:bodyPr>
+          <a:lstStyle/>
+          <a:p>
+            <a:r>
+              <a:rPr sz="1800">
+                <a:ea typeface="Meiryo"/>
+                <a:latin typeface="Segoe UI"/>
+              </a:rPr>
+              <a:t>Mixed: ABC + あいう + 123</a:t>
+            </a:r>
+          </a:p>
+        </p:txBody>
+      </p:sp>
+      <p:sp>
+        <p:nvSpPr>
+          <p:cNvPr id="5" name="TextBox 4"/>
+          <p:cNvSpPr txBox="1"/>
+          <p:nvPr/>
+        </p:nvSpPr>
+        <p:spPr>
+          <a:xfrm>
+            <a:off x="457200" y="3657600"/>
+            <a:ext cx="8229600" cy="1828800"/>
+          </a:xfrm>
+          <a:prstGeom prst="rect">
+            <a:avLst/>
+          </a:prstGeom>
+          <a:noFill/>
+        </p:spPr>
+        <p:txBody>
+          <a:bodyPr wrap="square">
+            <a:spAutoFit/>
+          </a:bodyPr>
+          <a:lstStyle/>
+          <a:p>
+            <a:pPr>
+              <a:defRPr sz="1200">
+                <a:solidFill>
+                  <a:srgbClr val="646464"/>
+                </a:solidFill>
+              </a:defRPr>
+            </a:pPr>
+            <a:r>
+              <a:t>Verify: EA fonts should appear in font-family. Theme refs (+mj-ea/+mn-ea) should resolve to Yu Gothic.</a:t>
             </a:r>
           </a:p>
         </p:txBody>
@@ -4087,7 +4625,6 @@
     <a:fontScheme name="Office">
       <a:majorFont>
         <a:latin typeface="Calibri"/>
-        <a:ea typeface=""/>
         <a:cs typeface=""/>
         <a:font script="Jpan" typeface="ＭＳ Ｐゴシック"/>
         <a:font script="Hang" typeface="맑은 고딕"/>
@@ -4119,10 +4656,10 @@
         <a:font script="Viet" typeface="Times New Roman"/>
         <a:font script="Uigh" typeface="Microsoft Uighur"/>
         <a:font script="Geor" typeface="Sylfaen"/>
+        <a:ea typeface="Yu Gothic"/>
       </a:majorFont>
       <a:minorFont>
         <a:latin typeface="Calibri"/>
-        <a:ea typeface=""/>
         <a:cs typeface=""/>
         <a:font script="Jpan" typeface="ＭＳ Ｐゴシック"/>
         <a:font script="Hang" typeface="맑은 고딕"/>
@@ -4154,6 +4691,7 @@
         <a:font script="Viet" typeface="Arial"/>
         <a:font script="Uigh" typeface="Microsoft Uighur"/>
         <a:font script="Geor" typeface="Sylfaen"/>
+        <a:ea typeface="Yu Gothic"/>
       </a:minorFont>
     </a:fontScheme>
     <a:fmtScheme name="Office">

</xml_diff>

<commit_message>
feat: Implement normAutofit support with font scaling and line spacing reduction
</commit_message>
<xml_diff>
--- a/test_fixtures/test_features.pptx
+++ b/test_fixtures/test_features.pptx
@@ -16,6 +16,7 @@
     <p:sldId id="264" r:id="rId15"/>
     <p:sldId id="265" r:id="rId16"/>
     <p:sldId id="266" r:id="rId17"/>
+    <p:sldId id="267" r:id="rId18"/>
   </p:sldIdLst>
   <p:sldSz cx="9144000" cy="6858000" type="screen4x3"/>
   <p:notesSz cx="6858000" cy="9144000"/>
@@ -3440,6 +3441,297 @@
           <a:p>
             <a:r>
               <a:t>Second paragraph: should also inherit lstStyle defaults</a:t>
+            </a:r>
+          </a:p>
+        </p:txBody>
+      </p:sp>
+    </p:spTree>
+  </p:cSld>
+  <p:clrMapOvr>
+    <a:masterClrMapping/>
+  </p:clrMapOvr>
+</p:sld>
+</file>
+
+<file path=ppt/slides/slide12.xml><?xml version="1.0" encoding="utf-8"?>
+<p:sld xmlns:a="http://schemas.openxmlformats.org/drawingml/2006/main" xmlns:p="http://schemas.openxmlformats.org/presentationml/2006/main" xmlns:r="http://schemas.openxmlformats.org/officeDocument/2006/relationships">
+  <p:cSld>
+    <p:spTree>
+      <p:nvGrpSpPr>
+        <p:cNvPr id="1" name=""/>
+        <p:cNvGrpSpPr/>
+        <p:nvPr/>
+      </p:nvGrpSpPr>
+      <p:grpSpPr/>
+      <p:sp>
+        <p:nvSpPr>
+          <p:cNvPr id="2" name="TextBox 1"/>
+          <p:cNvSpPr txBox="1"/>
+          <p:nvPr/>
+        </p:nvSpPr>
+        <p:spPr>
+          <a:xfrm>
+            <a:off x="457200" y="274320"/>
+            <a:ext cx="8229600" cy="548640"/>
+          </a:xfrm>
+          <a:prstGeom prst="rect">
+            <a:avLst/>
+          </a:prstGeom>
+          <a:noFill/>
+        </p:spPr>
+        <p:txBody>
+          <a:bodyPr wrap="none">
+            <a:spAutoFit/>
+          </a:bodyPr>
+          <a:lstStyle/>
+          <a:p>
+            <a:pPr>
+              <a:defRPr sz="2400" b="1"/>
+            </a:pPr>
+            <a:r>
+              <a:t>Slide 12: normAutofit (fontScale / lnSpcReduction)</a:t>
+            </a:r>
+          </a:p>
+        </p:txBody>
+      </p:sp>
+      <p:sp>
+        <p:nvSpPr>
+          <p:cNvPr id="3" name="TextBox 2"/>
+          <p:cNvSpPr txBox="1"/>
+          <p:nvPr/>
+        </p:nvSpPr>
+        <p:spPr>
+          <a:xfrm>
+            <a:off x="457200" y="1097280"/>
+            <a:ext cx="3657600" cy="1645920"/>
+          </a:xfrm>
+          <a:prstGeom prst="rect">
+            <a:avLst/>
+          </a:prstGeom>
+          <a:solidFill>
+            <a:srgbClr val="E8EAF6"/>
+          </a:solidFill>
+          <a:ln w="12700">
+            <a:solidFill>
+              <a:srgbClr val="3F51B5"/>
+            </a:solidFill>
+          </a:ln>
+        </p:spPr>
+        <p:txBody>
+          <a:bodyPr wrap="square" lIns="91440" tIns="45720" rIns="91440" bIns="45720">
+            <a:spAutoFit/>
+            <a:normAutofit fontScale="80000"/>
+          </a:bodyPr>
+          <a:lstStyle/>
+          <a:p>
+            <a:r>
+              <a:rPr sz="2000" b="1"/>
+              <a:t>fontScale=80%</a:t>
+            </a:r>
+          </a:p>
+          <a:p>
+            <a:r>
+              <a:rPr sz="1600"/>
+              <a:t>Line 2: scaled down</a:t>
+            </a:r>
+          </a:p>
+          <a:p>
+            <a:r>
+              <a:rPr sz="1600"/>
+              <a:t>Line 3: smaller text</a:t>
+            </a:r>
+          </a:p>
+          <a:p>
+            <a:r>
+              <a:rPr sz="1600"/>
+              <a:t>Line 4: fits in box</a:t>
+            </a:r>
+          </a:p>
+        </p:txBody>
+      </p:sp>
+      <p:sp>
+        <p:nvSpPr>
+          <p:cNvPr id="4" name="TextBox 3"/>
+          <p:cNvSpPr txBox="1"/>
+          <p:nvPr/>
+        </p:nvSpPr>
+        <p:spPr>
+          <a:xfrm>
+            <a:off x="4572000" y="1097280"/>
+            <a:ext cx="3657600" cy="1645920"/>
+          </a:xfrm>
+          <a:prstGeom prst="rect">
+            <a:avLst/>
+          </a:prstGeom>
+          <a:solidFill>
+            <a:srgbClr val="FFF3E0"/>
+          </a:solidFill>
+          <a:ln w="12700">
+            <a:solidFill>
+              <a:srgbClr val="FF9800"/>
+            </a:solidFill>
+          </a:ln>
+        </p:spPr>
+        <p:txBody>
+          <a:bodyPr wrap="square" lIns="91440" tIns="45720" rIns="91440" bIns="45720">
+            <a:spAutoFit/>
+            <a:normAutofit fontScale="62500" lnSpcReduction="20000"/>
+          </a:bodyPr>
+          <a:lstStyle/>
+          <a:p>
+            <a:r>
+              <a:rPr sz="2000" b="1"/>
+              <a:t>62.5% + lnSpc 20%</a:t>
+            </a:r>
+          </a:p>
+          <a:p>
+            <a:r>
+              <a:rPr sz="1600"/>
+              <a:t>Line 2: even smaller</a:t>
+            </a:r>
+          </a:p>
+          <a:p>
+            <a:r>
+              <a:rPr sz="1600"/>
+              <a:t>Line 3: tighter spacing</a:t>
+            </a:r>
+          </a:p>
+          <a:p>
+            <a:r>
+              <a:rPr sz="1600"/>
+              <a:t>Line 4: compact text</a:t>
+            </a:r>
+          </a:p>
+        </p:txBody>
+      </p:sp>
+      <p:sp>
+        <p:nvSpPr>
+          <p:cNvPr id="5" name="TextBox 4"/>
+          <p:cNvSpPr txBox="1"/>
+          <p:nvPr/>
+        </p:nvSpPr>
+        <p:spPr>
+          <a:xfrm>
+            <a:off x="457200" y="3200400"/>
+            <a:ext cx="3657600" cy="1645920"/>
+          </a:xfrm>
+          <a:prstGeom prst="rect">
+            <a:avLst/>
+          </a:prstGeom>
+          <a:solidFill>
+            <a:srgbClr val="E8F5E9"/>
+          </a:solidFill>
+          <a:ln w="12700">
+            <a:solidFill>
+              <a:srgbClr val="4CAF50"/>
+            </a:solidFill>
+          </a:ln>
+        </p:spPr>
+        <p:txBody>
+          <a:bodyPr wrap="square" lIns="91440" tIns="45720" rIns="91440" bIns="45720">
+            <a:spAutoFit/>
+            <a:normAutofit/>
+          </a:bodyPr>
+          <a:lstStyle/>
+          <a:p>
+            <a:r>
+              <a:rPr sz="2000" b="1"/>
+              <a:t>normAutofit default</a:t>
+            </a:r>
+          </a:p>
+          <a:p>
+            <a:r>
+              <a:rPr sz="1600"/>
+              <a:t>Line 2: no scaling</a:t>
+            </a:r>
+          </a:p>
+          <a:p>
+            <a:r>
+              <a:rPr sz="1600"/>
+              <a:t>Line 3: same as original</a:t>
+            </a:r>
+          </a:p>
+        </p:txBody>
+      </p:sp>
+      <p:sp>
+        <p:nvSpPr>
+          <p:cNvPr id="6" name="TextBox 5"/>
+          <p:cNvSpPr txBox="1"/>
+          <p:nvPr/>
+        </p:nvSpPr>
+        <p:spPr>
+          <a:xfrm>
+            <a:off x="4572000" y="3200400"/>
+            <a:ext cx="3657600" cy="1645920"/>
+          </a:xfrm>
+          <a:prstGeom prst="rect">
+            <a:avLst/>
+          </a:prstGeom>
+          <a:solidFill>
+            <a:srgbClr val="F3E5F5"/>
+          </a:solidFill>
+          <a:ln w="12700">
+            <a:solidFill>
+              <a:srgbClr val="9C27B0"/>
+            </a:solidFill>
+          </a:ln>
+        </p:spPr>
+        <p:txBody>
+          <a:bodyPr wrap="square" lIns="91440" tIns="45720" rIns="91440" bIns="45720">
+            <a:spAutoFit/>
+          </a:bodyPr>
+          <a:lstStyle/>
+          <a:p>
+            <a:r>
+              <a:rPr sz="2000" b="1"/>
+              <a:t>No autofit (ref)</a:t>
+            </a:r>
+          </a:p>
+          <a:p>
+            <a:r>
+              <a:rPr sz="1600"/>
+              <a:t>Line 2: original size</a:t>
+            </a:r>
+          </a:p>
+          <a:p>
+            <a:r>
+              <a:rPr sz="1600"/>
+              <a:t>Line 3: may overflow</a:t>
+            </a:r>
+          </a:p>
+        </p:txBody>
+      </p:sp>
+      <p:sp>
+        <p:nvSpPr>
+          <p:cNvPr id="7" name="TextBox 6"/>
+          <p:cNvSpPr txBox="1"/>
+          <p:nvPr/>
+        </p:nvSpPr>
+        <p:spPr>
+          <a:xfrm>
+            <a:off x="457200" y="5303520"/>
+            <a:ext cx="8229600" cy="914400"/>
+          </a:xfrm>
+          <a:prstGeom prst="rect">
+            <a:avLst/>
+          </a:prstGeom>
+          <a:noFill/>
+        </p:spPr>
+        <p:txBody>
+          <a:bodyPr wrap="square">
+            <a:spAutoFit/>
+          </a:bodyPr>
+          <a:lstStyle/>
+          <a:p>
+            <a:pPr>
+              <a:defRPr sz="1200">
+                <a:solidFill>
+                  <a:srgbClr val="646464"/>
+                </a:solidFill>
+              </a:defRPr>
+            </a:pPr>
+            <a:r>
+              <a:t>Compare: top-left (80%) should be visibly smaller than bottom-right (no autofit). Top-right (62.5%+20%) should be smallest and tightest.</a:t>
             </a:r>
           </a:p>
         </p:txBody>

</xml_diff>

<commit_message>
feat: Enhance text handling and formatting features
- Added support for text wrapping in serializer and SVG parser, including handling of CJK text and wrap="none" attribute.
- Implemented bullet formatting options including custom bullet fonts, sizes (percentage and points), and colors.
- Introduced capitalization options for text runs, allowing for "all" and "small" caps.
- Updated test fixtures to include new slides for text wrapping, bullet formatting, and capitalization features.
- Adjusted tests to verify the presence of new attributes and formatting in the generated PPTX.
</commit_message>
<xml_diff>
--- a/test_fixtures/test_features.pptx
+++ b/test_fixtures/test_features.pptx
@@ -17,6 +17,9 @@
     <p:sldId id="265" r:id="rId16"/>
     <p:sldId id="266" r:id="rId17"/>
     <p:sldId id="267" r:id="rId18"/>
+    <p:sldId id="268" r:id="rId19"/>
+    <p:sldId id="269" r:id="rId20"/>
+    <p:sldId id="270" r:id="rId21"/>
   </p:sldIdLst>
   <p:sldSz cx="9144000" cy="6858000" type="screen4x3"/>
   <p:notesSz cx="6858000" cy="9144000"/>
@@ -3732,6 +3735,675 @@
             </a:pPr>
             <a:r>
               <a:t>Compare: top-left (80%) should be visibly smaller than bottom-right (no autofit). Top-right (62.5%+20%) should be smallest and tightest.</a:t>
+            </a:r>
+          </a:p>
+        </p:txBody>
+      </p:sp>
+    </p:spTree>
+  </p:cSld>
+  <p:clrMapOvr>
+    <a:masterClrMapping/>
+  </p:clrMapOvr>
+</p:sld>
+</file>
+
+<file path=ppt/slides/slide13.xml><?xml version="1.0" encoding="utf-8"?>
+<p:sld xmlns:a="http://schemas.openxmlformats.org/drawingml/2006/main" xmlns:p="http://schemas.openxmlformats.org/presentationml/2006/main" xmlns:r="http://schemas.openxmlformats.org/officeDocument/2006/relationships">
+  <p:cSld>
+    <p:spTree>
+      <p:nvGrpSpPr>
+        <p:cNvPr id="1" name=""/>
+        <p:cNvGrpSpPr/>
+        <p:nvPr/>
+      </p:nvGrpSpPr>
+      <p:grpSpPr/>
+      <p:sp>
+        <p:nvSpPr>
+          <p:cNvPr id="2" name="TextBox 1"/>
+          <p:cNvSpPr txBox="1"/>
+          <p:nvPr/>
+        </p:nvSpPr>
+        <p:spPr>
+          <a:xfrm>
+            <a:off x="457200" y="274320"/>
+            <a:ext cx="8229600" cy="548640"/>
+          </a:xfrm>
+          <a:prstGeom prst="rect">
+            <a:avLst/>
+          </a:prstGeom>
+          <a:noFill/>
+        </p:spPr>
+        <p:txBody>
+          <a:bodyPr wrap="none">
+            <a:spAutoFit/>
+          </a:bodyPr>
+          <a:lstStyle/>
+          <a:p>
+            <a:pPr>
+              <a:defRPr sz="2400" b="1"/>
+            </a:pPr>
+            <a:r>
+              <a:t>Slide 13: Text Wrapping</a:t>
+            </a:r>
+          </a:p>
+        </p:txBody>
+      </p:sp>
+      <p:sp>
+        <p:nvSpPr>
+          <p:cNvPr id="3" name="TextBox 2"/>
+          <p:cNvSpPr txBox="1"/>
+          <p:nvPr/>
+        </p:nvSpPr>
+        <p:spPr>
+          <a:xfrm>
+            <a:off x="457200" y="1097280"/>
+            <a:ext cx="3657600" cy="2286000"/>
+          </a:xfrm>
+          <a:prstGeom prst="rect">
+            <a:avLst/>
+          </a:prstGeom>
+          <a:solidFill>
+            <a:srgbClr val="E6F0FF"/>
+          </a:solidFill>
+        </p:spPr>
+        <p:txBody>
+          <a:bodyPr wrap="square">
+            <a:spAutoFit/>
+          </a:bodyPr>
+          <a:lstStyle/>
+          <a:p>
+            <a:pPr>
+              <a:defRPr sz="1600"/>
+            </a:pPr>
+            <a:r>
+              <a:t>This is a long paragraph of Latin text that should automatically wrap at the shape boundary. Word-level wrapping should break at spaces.</a:t>
+            </a:r>
+          </a:p>
+          <a:p>
+            <a:pPr>
+              <a:defRPr sz="1400"/>
+            </a:pPr>
+            <a:r>
+              <a:t>Another paragraph with a very long sentence that exercises the wrapping algorithm more thoroughly, including multiple lines of content.</a:t>
+            </a:r>
+          </a:p>
+        </p:txBody>
+      </p:sp>
+      <p:sp>
+        <p:nvSpPr>
+          <p:cNvPr id="4" name="TextBox 3"/>
+          <p:cNvSpPr txBox="1"/>
+          <p:nvPr/>
+        </p:nvSpPr>
+        <p:spPr>
+          <a:xfrm>
+            <a:off x="4572000" y="1097280"/>
+            <a:ext cx="4114800" cy="2286000"/>
+          </a:xfrm>
+          <a:prstGeom prst="rect">
+            <a:avLst/>
+          </a:prstGeom>
+          <a:solidFill>
+            <a:srgbClr val="FFF5E6"/>
+          </a:solidFill>
+        </p:spPr>
+        <p:txBody>
+          <a:bodyPr wrap="square">
+            <a:spAutoFit/>
+          </a:bodyPr>
+          <a:lstStyle/>
+          <a:p>
+            <a:r>
+              <a:rPr sz="1600">
+                <a:ea typeface="Yu Gothic"/>
+              </a:rPr>
+              <a:t>日本語テキストの折り返しテスト。文字単位で折り返されるべきです。漢字とひらがなが混在しています。</a:t>
+            </a:r>
+          </a:p>
+          <a:p>
+            <a:r>
+              <a:rPr sz="1400">
+                <a:ea typeface="Yu Gothic"/>
+              </a:rPr>
+              <a:t>Mixed テキスト: ABC あいう 123 日本語 English words and 漢字が混在</a:t>
+            </a:r>
+          </a:p>
+        </p:txBody>
+      </p:sp>
+      <p:sp>
+        <p:nvSpPr>
+          <p:cNvPr id="5" name="TextBox 4"/>
+          <p:cNvSpPr txBox="1"/>
+          <p:nvPr/>
+        </p:nvSpPr>
+        <p:spPr>
+          <a:xfrm>
+            <a:off x="457200" y="3840480"/>
+            <a:ext cx="3657600" cy="1371600"/>
+          </a:xfrm>
+          <a:prstGeom prst="rect">
+            <a:avLst/>
+          </a:prstGeom>
+          <a:solidFill>
+            <a:srgbClr val="FFE6E6"/>
+          </a:solidFill>
+        </p:spPr>
+        <p:txBody>
+          <a:bodyPr wrap="none">
+            <a:spAutoFit/>
+          </a:bodyPr>
+          <a:lstStyle/>
+          <a:p>
+            <a:pPr>
+              <a:defRPr sz="1600"/>
+            </a:pPr>
+            <a:r>
+              <a:t>wrap=none: This text should NOT wrap even though it is long and exceeds the box width</a:t>
+            </a:r>
+          </a:p>
+        </p:txBody>
+      </p:sp>
+      <p:sp>
+        <p:nvSpPr>
+          <p:cNvPr id="6" name="TextBox 5"/>
+          <p:cNvSpPr txBox="1"/>
+          <p:nvPr/>
+        </p:nvSpPr>
+        <p:spPr>
+          <a:xfrm>
+            <a:off x="4572000" y="3840480"/>
+            <a:ext cx="2286000" cy="2286000"/>
+          </a:xfrm>
+          <a:prstGeom prst="rect">
+            <a:avLst/>
+          </a:prstGeom>
+          <a:solidFill>
+            <a:srgbClr val="E6FFE6"/>
+          </a:solidFill>
+        </p:spPr>
+        <p:txBody>
+          <a:bodyPr wrap="square">
+            <a:spAutoFit/>
+          </a:bodyPr>
+          <a:lstStyle/>
+          <a:p>
+            <a:pPr>
+              <a:defRPr sz="2800"/>
+            </a:pPr>
+            <a:r>
+              <a:t>Large font in narrow box</a:t>
+            </a:r>
+          </a:p>
+          <a:p>
+            <a:pPr>
+              <a:defRPr sz="2000"/>
+            </a:pPr>
+            <a:r>
+              <a:t>Should wrap to multiple lines</a:t>
+            </a:r>
+          </a:p>
+        </p:txBody>
+      </p:sp>
+    </p:spTree>
+  </p:cSld>
+  <p:clrMapOvr>
+    <a:masterClrMapping/>
+  </p:clrMapOvr>
+</p:sld>
+</file>
+
+<file path=ppt/slides/slide14.xml><?xml version="1.0" encoding="utf-8"?>
+<p:sld xmlns:a="http://schemas.openxmlformats.org/drawingml/2006/main" xmlns:p="http://schemas.openxmlformats.org/presentationml/2006/main" xmlns:r="http://schemas.openxmlformats.org/officeDocument/2006/relationships">
+  <p:cSld>
+    <p:spTree>
+      <p:nvGrpSpPr>
+        <p:cNvPr id="1" name=""/>
+        <p:cNvGrpSpPr/>
+        <p:nvPr/>
+      </p:nvGrpSpPr>
+      <p:grpSpPr/>
+      <p:sp>
+        <p:nvSpPr>
+          <p:cNvPr id="2" name="TextBox 1"/>
+          <p:cNvSpPr txBox="1"/>
+          <p:nvPr/>
+        </p:nvSpPr>
+        <p:spPr>
+          <a:xfrm>
+            <a:off x="457200" y="274320"/>
+            <a:ext cx="8229600" cy="548640"/>
+          </a:xfrm>
+          <a:prstGeom prst="rect">
+            <a:avLst/>
+          </a:prstGeom>
+          <a:noFill/>
+        </p:spPr>
+        <p:txBody>
+          <a:bodyPr wrap="none">
+            <a:spAutoFit/>
+          </a:bodyPr>
+          <a:lstStyle/>
+          <a:p>
+            <a:pPr>
+              <a:defRPr sz="2200" b="1"/>
+            </a:pPr>
+            <a:r>
+              <a:t>Slide 14: Bullet Formatting (buFont / buSzPct / buSzPts / buClr)</a:t>
+            </a:r>
+          </a:p>
+        </p:txBody>
+      </p:sp>
+      <p:sp>
+        <p:nvSpPr>
+          <p:cNvPr id="3" name="TextBox 2"/>
+          <p:cNvSpPr txBox="1"/>
+          <p:nvPr/>
+        </p:nvSpPr>
+        <p:spPr>
+          <a:xfrm>
+            <a:off x="457200" y="1097280"/>
+            <a:ext cx="3657600" cy="2286000"/>
+          </a:xfrm>
+          <a:prstGeom prst="rect">
+            <a:avLst/>
+          </a:prstGeom>
+          <a:solidFill>
+            <a:srgbClr val="F0EBFF"/>
+          </a:solidFill>
+        </p:spPr>
+        <p:txBody>
+          <a:bodyPr wrap="square">
+            <a:spAutoFit/>
+          </a:bodyPr>
+          <a:lstStyle/>
+          <a:p>
+            <a:pPr marL="457200" indent="-228600">
+              <a:defRPr sz="1600"/>
+              <a:buFont typeface="Wingdings"/>
+              <a:buChar char="l"/>
+            </a:pPr>
+            <a:r>
+              <a:t>Wingdings bullet font</a:t>
+            </a:r>
+          </a:p>
+          <a:p>
+            <a:pPr marL="457200" indent="-228600">
+              <a:defRPr sz="1600"/>
+              <a:buFont typeface="Symbol"/>
+              <a:buChar char="·"/>
+            </a:pPr>
+            <a:r>
+              <a:t>Symbol bullet font</a:t>
+            </a:r>
+          </a:p>
+          <a:p>
+            <a:pPr marL="457200" indent="-228600">
+              <a:defRPr sz="1600"/>
+              <a:buChar char="•"/>
+            </a:pPr>
+            <a:r>
+              <a:t>Default font bullet</a:t>
+            </a:r>
+          </a:p>
+        </p:txBody>
+      </p:sp>
+      <p:sp>
+        <p:nvSpPr>
+          <p:cNvPr id="4" name="TextBox 3"/>
+          <p:cNvSpPr txBox="1"/>
+          <p:nvPr/>
+        </p:nvSpPr>
+        <p:spPr>
+          <a:xfrm>
+            <a:off x="4572000" y="1097280"/>
+            <a:ext cx="4114800" cy="2286000"/>
+          </a:xfrm>
+          <a:prstGeom prst="rect">
+            <a:avLst/>
+          </a:prstGeom>
+          <a:solidFill>
+            <a:srgbClr val="E6FFF0"/>
+          </a:solidFill>
+        </p:spPr>
+        <p:txBody>
+          <a:bodyPr wrap="square">
+            <a:spAutoFit/>
+          </a:bodyPr>
+          <a:lstStyle/>
+          <a:p>
+            <a:pPr marL="457200" indent="-228600">
+              <a:defRPr sz="1600"/>
+              <a:buChar char="•"/>
+              <a:buSzPct val="150000"/>
+            </a:pPr>
+            <a:r>
+              <a:t>buSzPct=150000 (150%)</a:t>
+            </a:r>
+          </a:p>
+          <a:p>
+            <a:pPr marL="457200" indent="-228600">
+              <a:defRPr sz="1600"/>
+              <a:buChar char="•"/>
+              <a:buSzPct val="75000"/>
+            </a:pPr>
+            <a:r>
+              <a:t>buSzPct=75000 (75%)</a:t>
+            </a:r>
+          </a:p>
+          <a:p>
+            <a:pPr marL="457200" indent="-228600">
+              <a:defRPr sz="1600"/>
+              <a:buChar char="•"/>
+              <a:buSzPts val="3200"/>
+            </a:pPr>
+            <a:r>
+              <a:t>buSzPts=3200 (32pt)</a:t>
+            </a:r>
+          </a:p>
+          <a:p>
+            <a:pPr marL="457200" indent="-228600">
+              <a:defRPr sz="1600"/>
+              <a:buChar char="•"/>
+              <a:buSzPts val="800"/>
+            </a:pPr>
+            <a:r>
+              <a:t>buSzPts=800 (8pt)</a:t>
+            </a:r>
+          </a:p>
+        </p:txBody>
+      </p:sp>
+      <p:sp>
+        <p:nvSpPr>
+          <p:cNvPr id="5" name="TextBox 4"/>
+          <p:cNvSpPr txBox="1"/>
+          <p:nvPr/>
+        </p:nvSpPr>
+        <p:spPr>
+          <a:xfrm>
+            <a:off x="457200" y="3840480"/>
+            <a:ext cx="3657600" cy="2286000"/>
+          </a:xfrm>
+          <a:prstGeom prst="rect">
+            <a:avLst/>
+          </a:prstGeom>
+          <a:solidFill>
+            <a:srgbClr val="FFF5EB"/>
+          </a:solidFill>
+        </p:spPr>
+        <p:txBody>
+          <a:bodyPr wrap="square">
+            <a:spAutoFit/>
+          </a:bodyPr>
+          <a:lstStyle/>
+          <a:p>
+            <a:pPr marL="457200" indent="-228600">
+              <a:defRPr sz="1600"/>
+              <a:buChar char="•"/>
+              <a:buClr>
+                <a:srgbClr val="FF0000"/>
+              </a:buClr>
+            </a:pPr>
+            <a:r>
+              <a:t>Red bullet</a:t>
+            </a:r>
+          </a:p>
+          <a:p>
+            <a:pPr marL="457200" indent="-228600">
+              <a:defRPr sz="1600"/>
+              <a:buChar char="•"/>
+              <a:buClr>
+                <a:srgbClr val="00AA00"/>
+              </a:buClr>
+            </a:pPr>
+            <a:r>
+              <a:t>Green bullet</a:t>
+            </a:r>
+          </a:p>
+          <a:p>
+            <a:pPr marL="457200" indent="-228600">
+              <a:defRPr sz="1600"/>
+              <a:buChar char="•"/>
+              <a:buClr>
+                <a:srgbClr val="0000FF"/>
+              </a:buClr>
+            </a:pPr>
+            <a:r>
+              <a:t>Blue bullet</a:t>
+            </a:r>
+          </a:p>
+          <a:p>
+            <a:pPr marL="457200" indent="-228600">
+              <a:defRPr sz="1600"/>
+              <a:buChar char="•"/>
+            </a:pPr>
+            <a:r>
+              <a:t>No bullet color (inherits)</a:t>
+            </a:r>
+          </a:p>
+        </p:txBody>
+      </p:sp>
+      <p:sp>
+        <p:nvSpPr>
+          <p:cNvPr id="6" name="TextBox 5"/>
+          <p:cNvSpPr txBox="1"/>
+          <p:nvPr/>
+        </p:nvSpPr>
+        <p:spPr>
+          <a:xfrm>
+            <a:off x="4572000" y="3840480"/>
+            <a:ext cx="4114800" cy="2286000"/>
+          </a:xfrm>
+          <a:prstGeom prst="rect">
+            <a:avLst/>
+          </a:prstGeom>
+          <a:solidFill>
+            <a:srgbClr val="F5F0FF"/>
+          </a:solidFill>
+        </p:spPr>
+        <p:txBody>
+          <a:bodyPr wrap="square">
+            <a:spAutoFit/>
+          </a:bodyPr>
+          <a:lstStyle/>
+          <a:p>
+            <a:pPr marL="457200" indent="-228600">
+              <a:defRPr sz="1600"/>
+              <a:buFont typeface="Wingdings"/>
+              <a:buSzPct val="120000"/>
+              <a:buClr>
+                <a:srgbClr val="FF0000"/>
+              </a:buClr>
+              <a:buChar char="l"/>
+            </a:pPr>
+            <a:r>
+              <a:t>Combined: Wingdings + 120% + red</a:t>
+            </a:r>
+          </a:p>
+          <a:p>
+            <a:pPr marL="457200" indent="-228600">
+              <a:defRPr sz="1600"/>
+              <a:buChar char="•"/>
+            </a:pPr>
+            <a:r>
+              <a:t>Normal bullet for comparison</a:t>
+            </a:r>
+          </a:p>
+        </p:txBody>
+      </p:sp>
+    </p:spTree>
+  </p:cSld>
+  <p:clrMapOvr>
+    <a:masterClrMapping/>
+  </p:clrMapOvr>
+</p:sld>
+</file>
+
+<file path=ppt/slides/slide15.xml><?xml version="1.0" encoding="utf-8"?>
+<p:sld xmlns:a="http://schemas.openxmlformats.org/drawingml/2006/main" xmlns:p="http://schemas.openxmlformats.org/presentationml/2006/main" xmlns:r="http://schemas.openxmlformats.org/officeDocument/2006/relationships">
+  <p:cSld>
+    <p:spTree>
+      <p:nvGrpSpPr>
+        <p:cNvPr id="1" name=""/>
+        <p:cNvGrpSpPr/>
+        <p:nvPr/>
+      </p:nvGrpSpPr>
+      <p:grpSpPr/>
+      <p:sp>
+        <p:nvSpPr>
+          <p:cNvPr id="2" name="TextBox 1"/>
+          <p:cNvSpPr txBox="1"/>
+          <p:nvPr/>
+        </p:nvSpPr>
+        <p:spPr>
+          <a:xfrm>
+            <a:off x="457200" y="274320"/>
+            <a:ext cx="8229600" cy="548640"/>
+          </a:xfrm>
+          <a:prstGeom prst="rect">
+            <a:avLst/>
+          </a:prstGeom>
+          <a:noFill/>
+        </p:spPr>
+        <p:txBody>
+          <a:bodyPr wrap="none">
+            <a:spAutoFit/>
+          </a:bodyPr>
+          <a:lstStyle/>
+          <a:p>
+            <a:pPr>
+              <a:defRPr sz="2400" b="1"/>
+            </a:pPr>
+            <a:r>
+              <a:t>Slide 15: Capitalization (a:rPr cap)</a:t>
+            </a:r>
+          </a:p>
+        </p:txBody>
+      </p:sp>
+      <p:sp>
+        <p:nvSpPr>
+          <p:cNvPr id="3" name="TextBox 2"/>
+          <p:cNvSpPr txBox="1"/>
+          <p:nvPr/>
+        </p:nvSpPr>
+        <p:spPr>
+          <a:xfrm>
+            <a:off x="457200" y="1097280"/>
+            <a:ext cx="3657600" cy="2286000"/>
+          </a:xfrm>
+          <a:prstGeom prst="rect">
+            <a:avLst/>
+          </a:prstGeom>
+          <a:solidFill>
+            <a:srgbClr val="E6F5FF"/>
+          </a:solidFill>
+        </p:spPr>
+        <p:txBody>
+          <a:bodyPr wrap="square">
+            <a:spAutoFit/>
+          </a:bodyPr>
+          <a:lstStyle/>
+          <a:p>
+            <a:r>
+              <a:rPr sz="1800" cap="all"/>
+              <a:t>cap=all: This Should Be All Caps</a:t>
+            </a:r>
+          </a:p>
+          <a:p>
+            <a:r>
+              <a:rPr sz="1600"/>
+              <a:t>Mixed: </a:t>
+            </a:r>
+            <a:r>
+              <a:rPr sz="1600" cap="all"/>
+              <a:t>all caps part</a:t>
+            </a:r>
+            <a:r>
+              <a:rPr sz="1600"/>
+              <a:t> and normal part</a:t>
+            </a:r>
+          </a:p>
+          <a:p>
+            <a:r>
+              <a:rPr sz="1600"/>
+              <a:t>No cap: Regular text for comparison</a:t>
+            </a:r>
+          </a:p>
+        </p:txBody>
+      </p:sp>
+      <p:sp>
+        <p:nvSpPr>
+          <p:cNvPr id="4" name="TextBox 3"/>
+          <p:cNvSpPr txBox="1"/>
+          <p:nvPr/>
+        </p:nvSpPr>
+        <p:spPr>
+          <a:xfrm>
+            <a:off x="4572000" y="1097280"/>
+            <a:ext cx="4114800" cy="2286000"/>
+          </a:xfrm>
+          <a:prstGeom prst="rect">
+            <a:avLst/>
+          </a:prstGeom>
+          <a:solidFill>
+            <a:srgbClr val="FFF5E6"/>
+          </a:solidFill>
+        </p:spPr>
+        <p:txBody>
+          <a:bodyPr wrap="square">
+            <a:spAutoFit/>
+          </a:bodyPr>
+          <a:lstStyle/>
+          <a:p>
+            <a:r>
+              <a:rPr sz="1800" cap="small"/>
+              <a:t>cap=small: Small Caps Text</a:t>
+            </a:r>
+          </a:p>
+          <a:p>
+            <a:r>
+              <a:rPr sz="1600"/>
+              <a:t>No cap: Regular text</a:t>
+            </a:r>
+          </a:p>
+          <a:p>
+            <a:r>
+              <a:rPr sz="1800" b="1" cap="small"/>
+              <a:t>Bold Small Caps</a:t>
+            </a:r>
+          </a:p>
+        </p:txBody>
+      </p:sp>
+      <p:sp>
+        <p:nvSpPr>
+          <p:cNvPr id="5" name="TextBox 4"/>
+          <p:cNvSpPr txBox="1"/>
+          <p:nvPr/>
+        </p:nvSpPr>
+        <p:spPr>
+          <a:xfrm>
+            <a:off x="457200" y="4114800"/>
+            <a:ext cx="8229600" cy="1828800"/>
+          </a:xfrm>
+          <a:prstGeom prst="rect">
+            <a:avLst/>
+          </a:prstGeom>
+          <a:noFill/>
+        </p:spPr>
+        <p:txBody>
+          <a:bodyPr wrap="square">
+            <a:spAutoFit/>
+          </a:bodyPr>
+          <a:lstStyle/>
+          <a:p>
+            <a:pPr>
+              <a:defRPr sz="1200">
+                <a:solidFill>
+                  <a:srgbClr val="646464"/>
+                </a:solidFill>
+              </a:defRPr>
+            </a:pPr>
+            <a:r>
+              <a:t>cap=all: lowercase a-z should display as UPPERCASE A-Z. cap=small: should display with SVG font-variant=small-caps.</a:t>
             </a:r>
           </a:p>
         </p:txBody>

</xml_diff>

<commit_message>
feat: Add color map override support for slides with p:clrMapOvr
</commit_message>
<xml_diff>
--- a/test_fixtures/test_features.pptx
+++ b/test_fixtures/test_features.pptx
@@ -20,6 +20,7 @@
     <p:sldId id="268" r:id="rId19"/>
     <p:sldId id="269" r:id="rId20"/>
     <p:sldId id="270" r:id="rId21"/>
+    <p:sldId id="271" r:id="rId22"/>
   </p:sldIdLst>
   <p:sldSz cx="9144000" cy="6858000" type="screen4x3"/>
   <p:notesSz cx="6858000" cy="9144000"/>
@@ -4412,6 +4413,137 @@
   </p:cSld>
   <p:clrMapOvr>
     <a:masterClrMapping/>
+  </p:clrMapOvr>
+</p:sld>
+</file>
+
+<file path=ppt/slides/slide16.xml><?xml version="1.0" encoding="utf-8"?>
+<p:sld xmlns:a="http://schemas.openxmlformats.org/drawingml/2006/main" xmlns:p="http://schemas.openxmlformats.org/presentationml/2006/main" xmlns:r="http://schemas.openxmlformats.org/officeDocument/2006/relationships">
+  <p:bg>
+    <p:bgPr>
+      <a:solidFill>
+        <a:srgbClr val="1A1A2E"/>
+      </a:solidFill>
+    </p:bgPr>
+  </p:bg>
+  <p:cSld>
+    <p:spTree>
+      <p:nvGrpSpPr>
+        <p:cNvPr id="1" name=""/>
+        <p:cNvGrpSpPr/>
+        <p:nvPr/>
+      </p:nvGrpSpPr>
+      <p:grpSpPr/>
+      <p:sp>
+        <p:nvSpPr>
+          <p:cNvPr id="2" name="Title 1"/>
+          <p:cNvSpPr>
+            <a:spLocks noGrp="1"/>
+          </p:cNvSpPr>
+          <p:nvPr>
+            <p:ph type="ctrTitle"/>
+          </p:nvPr>
+        </p:nvSpPr>
+        <p:spPr/>
+        <p:txBody>
+          <a:bodyPr/>
+          <a:lstStyle/>
+          <a:p/>
+        </p:txBody>
+      </p:sp>
+      <p:sp>
+        <p:nvSpPr>
+          <p:cNvPr id="3" name="Subtitle 2"/>
+          <p:cNvSpPr>
+            <a:spLocks noGrp="1"/>
+          </p:cNvSpPr>
+          <p:nvPr>
+            <p:ph type="subTitle" idx="1"/>
+          </p:nvPr>
+        </p:nvSpPr>
+        <p:spPr/>
+        <p:txBody>
+          <a:bodyPr/>
+          <a:lstStyle/>
+          <a:p/>
+        </p:txBody>
+      </p:sp>
+      <p:sp>
+        <p:nvSpPr>
+          <p:cNvPr id="4" name="TextBox 3"/>
+          <p:cNvSpPr txBox="1"/>
+          <p:nvPr/>
+        </p:nvSpPr>
+        <p:spPr>
+          <a:xfrm>
+            <a:off x="457200" y="457200"/>
+            <a:ext cx="8229600" cy="1371600"/>
+          </a:xfrm>
+          <a:prstGeom prst="rect">
+            <a:avLst/>
+          </a:prstGeom>
+          <a:noFill/>
+        </p:spPr>
+        <p:txBody>
+          <a:bodyPr wrap="square">
+            <a:spAutoFit/>
+          </a:bodyPr>
+          <a:lstStyle/>
+          <a:p>
+            <a:pPr>
+              <a:defRPr sz="2800" b="1"/>
+            </a:pPr>
+            <a:r>
+              <a:rPr>
+                <a:solidFill>
+                  <a:schemeClr val="tx1"/>
+                </a:solidFill>
+              </a:rPr>
+              <a:t>Color Map Override: bg1=dk1, tx1=lt1</a:t>
+            </a:r>
+          </a:p>
+        </p:txBody>
+      </p:sp>
+      <p:sp>
+        <p:nvSpPr>
+          <p:cNvPr id="5" name="TextBox 4"/>
+          <p:cNvSpPr txBox="1"/>
+          <p:nvPr/>
+        </p:nvSpPr>
+        <p:spPr>
+          <a:xfrm>
+            <a:off x="457200" y="2286000"/>
+            <a:ext cx="8229600" cy="1828800"/>
+          </a:xfrm>
+          <a:prstGeom prst="rect">
+            <a:avLst/>
+          </a:prstGeom>
+          <a:noFill/>
+        </p:spPr>
+        <p:txBody>
+          <a:bodyPr wrap="square">
+            <a:spAutoFit/>
+          </a:bodyPr>
+          <a:lstStyle/>
+          <a:p>
+            <a:pPr>
+              <a:defRPr sz="1600"/>
+            </a:pPr>
+            <a:r>
+              <a:rPr>
+                <a:solidFill>
+                  <a:schemeClr val="tx1"/>
+                </a:solidFill>
+              </a:rPr>
+              <a:t>This slide has clrMapOvr swapping bg1/tx1. Text using scheme color tx1 should appear light (white) because tx1 maps to lt1.</a:t>
+            </a:r>
+          </a:p>
+        </p:txBody>
+      </p:sp>
+    </p:spTree>
+  </p:cSld>
+  <p:clrMapOvr>
+    <a:overrideClrMapping bg1="dk1" tx1="lt1" bg2="lt2" tx2="dk2" accent1="accent1" accent2="accent2" accent3="accent3" accent4="accent4" accent5="accent5" accent6="accent6" hlink="hlink" folHlink="folHlink"/>
   </p:clrMapOvr>
 </p:sld>
 </file>

</xml_diff>

<commit_message>
Enhance serialization and parsing for text properties in presentations
- Updated serializer to handle additional properties in BodyProps and TextRun, including rotation, vertical text, column settings, and hyperlink support.
- Enhanced SVG parser to extract complex script and symbol fonts, kerning, and additional text attributes.
- Expanded test features to cover new functionalities such as text rotation, tab stops, vertical text, hyperlinks, and image bullets.
- Updated test assertions to validate the presence of new elements and attributes in generated slides.
</commit_message>
<xml_diff>
--- a/test_fixtures/test_features.pptx
+++ b/test_fixtures/test_features.pptx
@@ -21,6 +21,11 @@
     <p:sldId id="269" r:id="rId20"/>
     <p:sldId id="270" r:id="rId21"/>
     <p:sldId id="271" r:id="rId22"/>
+    <p:sldId id="272" r:id="rId23"/>
+    <p:sldId id="273" r:id="rId24"/>
+    <p:sldId id="274" r:id="rId25"/>
+    <p:sldId id="275" r:id="rId26"/>
+    <p:sldId id="276" r:id="rId27"/>
   </p:sldIdLst>
   <p:sldSz cx="9144000" cy="6858000" type="screen4x3"/>
   <p:notesSz cx="6858000" cy="9144000"/>
@@ -4548,6 +4553,319 @@
 </p:sld>
 </file>
 
+<file path=ppt/slides/slide17.xml><?xml version="1.0" encoding="utf-8"?>
+<p:sld xmlns:a="http://schemas.openxmlformats.org/drawingml/2006/main" xmlns:p="http://schemas.openxmlformats.org/presentationml/2006/main" xmlns:r="http://schemas.openxmlformats.org/officeDocument/2006/relationships">
+  <p:cSld>
+    <p:spTree>
+      <p:nvGrpSpPr>
+        <p:cNvPr id="1" name=""/>
+        <p:cNvGrpSpPr/>
+        <p:nvPr/>
+      </p:nvGrpSpPr>
+      <p:grpSpPr/>
+      <p:sp>
+        <p:nvSpPr>
+          <p:cNvPr id="2" name="TextBox 1"/>
+          <p:cNvSpPr txBox="1"/>
+          <p:nvPr/>
+        </p:nvSpPr>
+        <p:spPr>
+          <a:xfrm>
+            <a:off x="457200" y="457200"/>
+            <a:ext cx="8229600" cy="1371600"/>
+          </a:xfrm>
+          <a:prstGeom prst="rect">
+            <a:avLst/>
+          </a:prstGeom>
+          <a:noFill/>
+        </p:spPr>
+        <p:txBody>
+          <a:bodyPr wrap="square">
+            <a:spAutoFit/>
+          </a:bodyPr>
+          <a:lstStyle/>
+          <a:p>
+            <a:pPr>
+              <a:defRPr sz="2400" b="1"/>
+            </a:pPr>
+            <a:r>
+              <a:rPr>
+                <a:cs typeface="Arial"/>
+              </a:rPr>
+              <a:t>Complex Script Font (Arabic style)</a:t>
+            </a:r>
+          </a:p>
+        </p:txBody>
+      </p:sp>
+      <p:sp>
+        <p:nvSpPr>
+          <p:cNvPr id="3" name="TextBox 2"/>
+          <p:cNvSpPr txBox="1"/>
+          <p:nvPr/>
+        </p:nvSpPr>
+        <p:spPr>
+          <a:xfrm>
+            <a:off x="457200" y="2286000"/>
+            <a:ext cx="8229600" cy="1371600"/>
+          </a:xfrm>
+          <a:prstGeom prst="rect">
+            <a:avLst/>
+          </a:prstGeom>
+          <a:noFill/>
+        </p:spPr>
+        <p:txBody>
+          <a:bodyPr wrap="none">
+            <a:spAutoFit/>
+          </a:bodyPr>
+          <a:lstStyle/>
+          <a:p>
+            <a:pPr>
+              <a:defRPr sz="2400"/>
+            </a:pPr>
+            <a:r>
+              <a:rPr>
+                <a:sym typeface="Wingdings"/>
+              </a:rPr>
+              <a:t>Symbol Font Text</a:t>
+            </a:r>
+          </a:p>
+        </p:txBody>
+      </p:sp>
+      <p:sp>
+        <p:nvSpPr>
+          <p:cNvPr id="4" name="TextBox 3"/>
+          <p:cNvSpPr txBox="1"/>
+          <p:nvPr/>
+        </p:nvSpPr>
+        <p:spPr>
+          <a:xfrm>
+            <a:off x="457200" y="4114800"/>
+            <a:ext cx="8229600" cy="1371600"/>
+          </a:xfrm>
+          <a:prstGeom prst="rect">
+            <a:avLst/>
+          </a:prstGeom>
+          <a:noFill/>
+        </p:spPr>
+        <p:txBody>
+          <a:bodyPr wrap="none">
+            <a:spAutoFit/>
+          </a:bodyPr>
+          <a:lstStyle/>
+          <a:p>
+            <a:pPr>
+              <a:defRPr sz="2400"/>
+            </a:pPr>
+            <a:r>
+              <a:rPr kern="1200"/>
+              <a:t>Kerning enabled at 1200 hundredths-pt</a:t>
+            </a:r>
+          </a:p>
+        </p:txBody>
+      </p:sp>
+    </p:spTree>
+  </p:cSld>
+  <p:clrMapOvr>
+    <a:masterClrMapping/>
+  </p:clrMapOvr>
+</p:sld>
+</file>
+
+<file path=ppt/slides/slide18.xml><?xml version="1.0" encoding="utf-8"?>
+<p:sld xmlns:a="http://schemas.openxmlformats.org/drawingml/2006/main" xmlns:p="http://schemas.openxmlformats.org/presentationml/2006/main" xmlns:r="http://schemas.openxmlformats.org/officeDocument/2006/relationships">
+  <p:cSld>
+    <p:spTree>
+      <p:nvGrpSpPr>
+        <p:cNvPr id="1" name=""/>
+        <p:cNvGrpSpPr/>
+        <p:nvPr/>
+      </p:nvGrpSpPr>
+      <p:grpSpPr/>
+      <p:sp>
+        <p:nvSpPr>
+          <p:cNvPr id="2" name="TextBox 1"/>
+          <p:cNvSpPr txBox="1"/>
+          <p:nvPr/>
+        </p:nvSpPr>
+        <p:spPr>
+          <a:xfrm>
+            <a:off x="457200" y="457200"/>
+            <a:ext cx="3657600" cy="1828800"/>
+          </a:xfrm>
+          <a:prstGeom prst="rect">
+            <a:avLst/>
+          </a:prstGeom>
+          <a:noFill/>
+        </p:spPr>
+        <p:txBody>
+          <a:bodyPr wrap="none" rot="2700000">
+            <a:spAutoFit/>
+          </a:bodyPr>
+          <a:lstStyle/>
+          <a:p>
+            <a:pPr>
+              <a:defRPr sz="2000"/>
+            </a:pPr>
+            <a:r>
+              <a:t>Rotated text (45 degrees)</a:t>
+            </a:r>
+          </a:p>
+        </p:txBody>
+      </p:sp>
+      <p:sp>
+        <p:nvSpPr>
+          <p:cNvPr id="3" name="TextBox 2"/>
+          <p:cNvSpPr txBox="1"/>
+          <p:nvPr/>
+        </p:nvSpPr>
+        <p:spPr>
+          <a:xfrm>
+            <a:off x="457200" y="2743200"/>
+            <a:ext cx="8229600" cy="2743200"/>
+          </a:xfrm>
+          <a:prstGeom prst="rect">
+            <a:avLst/>
+          </a:prstGeom>
+          <a:noFill/>
+        </p:spPr>
+        <p:txBody>
+          <a:bodyPr wrap="square">
+            <a:spAutoFit/>
+          </a:bodyPr>
+          <a:lstStyle/>
+          <a:p>
+            <a:pPr>
+              <a:defRPr sz="1800"/>
+              <a:tabLst>
+                <a:tab pos="2743200" algn="l"/>
+                <a:tab pos="5486400" algn="r"/>
+              </a:tabLst>
+            </a:pPr>
+            <a:r>
+              <a:t>Col1	Col2	Col3</a:t>
+            </a:r>
+          </a:p>
+        </p:txBody>
+      </p:sp>
+    </p:spTree>
+  </p:cSld>
+  <p:clrMapOvr>
+    <a:masterClrMapping/>
+  </p:clrMapOvr>
+</p:sld>
+</file>
+
+<file path=ppt/slides/slide19.xml><?xml version="1.0" encoding="utf-8"?>
+<p:sld xmlns:a="http://schemas.openxmlformats.org/drawingml/2006/main" xmlns:p="http://schemas.openxmlformats.org/presentationml/2006/main" xmlns:r="http://schemas.openxmlformats.org/officeDocument/2006/relationships">
+  <p:cSld>
+    <p:spTree>
+      <p:nvGrpSpPr>
+        <p:cNvPr id="1" name=""/>
+        <p:cNvGrpSpPr/>
+        <p:nvPr/>
+      </p:nvGrpSpPr>
+      <p:grpSpPr/>
+      <p:sp>
+        <p:nvSpPr>
+          <p:cNvPr id="2" name="TextBox 1"/>
+          <p:cNvSpPr txBox="1"/>
+          <p:nvPr/>
+        </p:nvSpPr>
+        <p:spPr>
+          <a:xfrm>
+            <a:off x="457200" y="457200"/>
+            <a:ext cx="1828800" cy="4572000"/>
+          </a:xfrm>
+          <a:prstGeom prst="rect">
+            <a:avLst/>
+          </a:prstGeom>
+          <a:noFill/>
+        </p:spPr>
+        <p:txBody>
+          <a:bodyPr wrap="none" vert="vert">
+            <a:spAutoFit/>
+          </a:bodyPr>
+          <a:lstStyle/>
+          <a:p>
+            <a:pPr>
+              <a:defRPr sz="2000"/>
+            </a:pPr>
+            <a:r>
+              <a:t>Vertical text</a:t>
+            </a:r>
+          </a:p>
+        </p:txBody>
+      </p:sp>
+      <p:sp>
+        <p:nvSpPr>
+          <p:cNvPr id="3" name="TextBox 2"/>
+          <p:cNvSpPr txBox="1"/>
+          <p:nvPr/>
+        </p:nvSpPr>
+        <p:spPr>
+          <a:xfrm>
+            <a:off x="2743200" y="457200"/>
+            <a:ext cx="1828800" cy="4572000"/>
+          </a:xfrm>
+          <a:prstGeom prst="rect">
+            <a:avLst/>
+          </a:prstGeom>
+          <a:noFill/>
+        </p:spPr>
+        <p:txBody>
+          <a:bodyPr wrap="none" vert="eaVert">
+            <a:spAutoFit/>
+          </a:bodyPr>
+          <a:lstStyle/>
+          <a:p>
+            <a:pPr>
+              <a:defRPr sz="2000"/>
+            </a:pPr>
+            <a:r>
+              <a:t>EA Vertical</a:t>
+            </a:r>
+          </a:p>
+        </p:txBody>
+      </p:sp>
+      <p:sp>
+        <p:nvSpPr>
+          <p:cNvPr id="4" name="TextBox 3"/>
+          <p:cNvSpPr txBox="1"/>
+          <p:nvPr/>
+        </p:nvSpPr>
+        <p:spPr>
+          <a:xfrm>
+            <a:off x="5029200" y="457200"/>
+            <a:ext cx="3657600" cy="4572000"/>
+          </a:xfrm>
+          <a:prstGeom prst="rect">
+            <a:avLst/>
+          </a:prstGeom>
+          <a:noFill/>
+        </p:spPr>
+        <p:txBody>
+          <a:bodyPr wrap="square" numCol="2" spcCol="457200">
+            <a:spAutoFit/>
+          </a:bodyPr>
+          <a:lstStyle/>
+          <a:p>
+            <a:pPr>
+              <a:defRPr sz="1400"/>
+            </a:pPr>
+            <a:r>
+              <a:t>This is column text that spans multiple columns. The text should flow from the first column to the second column when it reaches the bottom.</a:t>
+            </a:r>
+          </a:p>
+        </p:txBody>
+      </p:sp>
+    </p:spTree>
+  </p:cSld>
+  <p:clrMapOvr>
+    <a:masterClrMapping/>
+  </p:clrMapOvr>
+</p:sld>
+</file>
+
 <file path=ppt/slides/slide2.xml><?xml version="1.0" encoding="utf-8"?>
 <p:sld xmlns:a="http://schemas.openxmlformats.org/drawingml/2006/main" xmlns:p="http://schemas.openxmlformats.org/presentationml/2006/main" xmlns:r="http://schemas.openxmlformats.org/officeDocument/2006/relationships">
   <p:cSld>
@@ -4656,6 +4974,152 @@
             </a:pPr>
             <a:r>
               <a:t>Paragraph 5: After the 18pt gap. Should be visibly separated from P4.</a:t>
+            </a:r>
+          </a:p>
+        </p:txBody>
+      </p:sp>
+    </p:spTree>
+  </p:cSld>
+  <p:clrMapOvr>
+    <a:masterClrMapping/>
+  </p:clrMapOvr>
+</p:sld>
+</file>
+
+<file path=ppt/slides/slide20.xml><?xml version="1.0" encoding="utf-8"?>
+<p:sld xmlns:a="http://schemas.openxmlformats.org/drawingml/2006/main" xmlns:p="http://schemas.openxmlformats.org/presentationml/2006/main" xmlns:r="http://schemas.openxmlformats.org/officeDocument/2006/relationships">
+  <p:cSld>
+    <p:spTree>
+      <p:nvGrpSpPr>
+        <p:cNvPr id="1" name=""/>
+        <p:cNvGrpSpPr/>
+        <p:nvPr/>
+      </p:nvGrpSpPr>
+      <p:grpSpPr/>
+      <p:sp>
+        <p:nvSpPr>
+          <p:cNvPr id="2" name="TextBox 1"/>
+          <p:cNvSpPr txBox="1"/>
+          <p:nvPr/>
+        </p:nvSpPr>
+        <p:spPr>
+          <a:xfrm>
+            <a:off x="457200" y="457200"/>
+            <a:ext cx="8229600" cy="1828800"/>
+          </a:xfrm>
+          <a:prstGeom prst="rect">
+            <a:avLst/>
+          </a:prstGeom>
+          <a:noFill/>
+        </p:spPr>
+        <p:txBody>
+          <a:bodyPr wrap="square">
+            <a:spAutoFit/>
+          </a:bodyPr>
+          <a:lstStyle/>
+          <a:p>
+            <a:r>
+              <a:rPr sz="2000" u="sng">
+                <a:solidFill>
+                  <a:srgbClr val="0066CC"/>
+                </a:solidFill>
+                <a:hlinkClick r:id="rId2"/>
+              </a:rPr>
+              <a:t>Click here to visit example.com</a:t>
+            </a:r>
+          </a:p>
+        </p:txBody>
+      </p:sp>
+      <p:sp>
+        <p:nvSpPr>
+          <p:cNvPr id="3" name="TextBox 2"/>
+          <p:cNvSpPr txBox="1"/>
+          <p:nvPr/>
+        </p:nvSpPr>
+        <p:spPr>
+          <a:xfrm>
+            <a:off x="457200" y="2743200"/>
+            <a:ext cx="8229600" cy="1828800"/>
+          </a:xfrm>
+          <a:prstGeom prst="rect">
+            <a:avLst/>
+          </a:prstGeom>
+          <a:noFill/>
+        </p:spPr>
+        <p:txBody>
+          <a:bodyPr wrap="square">
+            <a:spAutoFit/>
+          </a:bodyPr>
+          <a:lstStyle/>
+          <a:p>
+            <a:pPr rtl="1">
+              <a:defRPr sz="2000"/>
+            </a:pPr>
+            <a:r>
+              <a:t>RTL paragraph text (right-to-left)</a:t>
+            </a:r>
+          </a:p>
+        </p:txBody>
+      </p:sp>
+    </p:spTree>
+  </p:cSld>
+  <p:clrMapOvr>
+    <a:masterClrMapping/>
+  </p:clrMapOvr>
+</p:sld>
+</file>
+
+<file path=ppt/slides/slide21.xml><?xml version="1.0" encoding="utf-8"?>
+<p:sld xmlns:a="http://schemas.openxmlformats.org/drawingml/2006/main" xmlns:p="http://schemas.openxmlformats.org/presentationml/2006/main" xmlns:r="http://schemas.openxmlformats.org/officeDocument/2006/relationships">
+  <p:cSld>
+    <p:spTree>
+      <p:nvGrpSpPr>
+        <p:cNvPr id="1" name=""/>
+        <p:cNvGrpSpPr/>
+        <p:nvPr/>
+      </p:nvGrpSpPr>
+      <p:grpSpPr/>
+      <p:sp>
+        <p:nvSpPr>
+          <p:cNvPr id="2" name="TextBox 1"/>
+          <p:cNvSpPr txBox="1"/>
+          <p:nvPr/>
+        </p:nvSpPr>
+        <p:spPr>
+          <a:xfrm>
+            <a:off x="457200" y="457200"/>
+            <a:ext cx="8229600" cy="4572000"/>
+          </a:xfrm>
+          <a:prstGeom prst="rect">
+            <a:avLst/>
+          </a:prstGeom>
+          <a:noFill/>
+        </p:spPr>
+        <p:txBody>
+          <a:bodyPr wrap="square">
+            <a:spAutoFit/>
+          </a:bodyPr>
+          <a:lstStyle/>
+          <a:p>
+            <a:pPr>
+              <a:defRPr sz="2000"/>
+              <a:buBlip>
+                <a:blip r:embed="rId2"/>
+              </a:buBlip>
+            </a:pPr>
+            <a:r>
+              <a:t>Image bullet paragraph 1</a:t>
+            </a:r>
+          </a:p>
+          <a:p>
+            <a:pPr>
+              <a:buBlip>
+                <a:blip r:embed="rId2"/>
+              </a:buBlip>
+            </a:pPr>
+            <a:r>
+              <a:rPr lang="en-US" sz="2000"/>
+              <a:t>Image bullet paragraph 2</a:t>
             </a:r>
           </a:p>
         </p:txBody>

</xml_diff>

<commit_message>
feat: Enhance text hyperlink functionality with hover links and link colors
- Updated TODO.md to reflect completion of text hyperlink features including hover links and link colors.
- Modified main.mbt to remove slide size parameter from slide master and layout parsing functions.
- Improved color handling in ooxml.mbt by introducing constants for HSL color space and updating RGB to HSL conversion.
- Added support for hover links in text runs and updated rendering logic in renderer.mbt to handle hover link attributes.
- Enhanced serializer.mbt to serialize hover link attributes.
- Updated SVG parser to parse hover link attributes from SVG text nodes.
- Added tests for hover links and link colors in gen_test_features.py and updated test assertions in test_node.mjs.
- Updated test_features.pptx to include new test cases for hover links.
</commit_message>
<xml_diff>
--- a/test_fixtures/test_features.pptx
+++ b/test_fixtures/test_features.pptx
@@ -26,6 +26,7 @@
     <p:sldId id="274" r:id="rId25"/>
     <p:sldId id="275" r:id="rId26"/>
     <p:sldId id="276" r:id="rId27"/>
+    <p:sldId id="277" r:id="rId28"/>
   </p:sldIdLst>
   <p:sldSz cx="9144000" cy="6858000" type="screen4x3"/>
   <p:notesSz cx="6858000" cy="9144000"/>
@@ -5120,6 +5121,72 @@
             <a:r>
               <a:rPr lang="en-US" sz="2000"/>
               <a:t>Image bullet paragraph 2</a:t>
+            </a:r>
+          </a:p>
+        </p:txBody>
+      </p:sp>
+    </p:spTree>
+  </p:cSld>
+  <p:clrMapOvr>
+    <a:masterClrMapping/>
+  </p:clrMapOvr>
+</p:sld>
+</file>
+
+<file path=ppt/slides/slide22.xml><?xml version="1.0" encoding="utf-8"?>
+<p:sld xmlns:a="http://schemas.openxmlformats.org/drawingml/2006/main" xmlns:p="http://schemas.openxmlformats.org/presentationml/2006/main" xmlns:r="http://schemas.openxmlformats.org/officeDocument/2006/relationships">
+  <p:cSld>
+    <p:spTree>
+      <p:nvGrpSpPr>
+        <p:cNvPr id="1" name=""/>
+        <p:cNvGrpSpPr/>
+        <p:nvPr/>
+      </p:nvGrpSpPr>
+      <p:grpSpPr/>
+      <p:sp>
+        <p:nvSpPr>
+          <p:cNvPr id="2" name="TextBox 1"/>
+          <p:cNvSpPr txBox="1"/>
+          <p:nvPr/>
+        </p:nvSpPr>
+        <p:spPr>
+          <a:xfrm>
+            <a:off x="457200" y="457200"/>
+            <a:ext cx="8229600" cy="4572000"/>
+          </a:xfrm>
+          <a:prstGeom prst="rect">
+            <a:avLst/>
+          </a:prstGeom>
+          <a:noFill/>
+        </p:spPr>
+        <p:txBody>
+          <a:bodyPr wrap="square">
+            <a:spAutoFit/>
+          </a:bodyPr>
+          <a:lstStyle/>
+          <a:p>
+            <a:r>
+              <a:rPr sz="2400">
+                <a:hlinkClick r:id="rId2"/>
+              </a:rPr>
+              <a:t>Click link</a:t>
+            </a:r>
+          </a:p>
+          <a:p>
+            <a:r>
+              <a:rPr sz="2400">
+                <a:hlinkHover r:id="rId3"/>
+              </a:rPr>
+              <a:t>Hover link</a:t>
+            </a:r>
+          </a:p>
+          <a:p>
+            <a:r>
+              <a:rPr sz="2400">
+                <a:hlinkClick r:id="rId4"/>
+                <a:hlinkHover r:id="rId5"/>
+              </a:rPr>
+              <a:t>Both links</a:t>
             </a:r>
           </a:p>
         </p:txBody>

</xml_diff>

<commit_message>
feat: add support for gradient fills in shapes and backgrounds
- Introduced GradientFill and GradientStop structures in the OOXML module.
- Updated SlideData and Shape structures to include gradient fill properties.
- Implemented gradient fill parsing from XML and serialization to XML.
- Enhanced SVG rendering to support gradient definitions and application.
- Added tests for linear and radial gradient fills in slides.
- Updated test fixtures to include new gradient fill features and validate their presence in generated PPTX files.
</commit_message>
<xml_diff>
--- a/test_fixtures/test_features.pptx
+++ b/test_fixtures/test_features.pptx
@@ -27,6 +27,9 @@
     <p:sldId id="275" r:id="rId26"/>
     <p:sldId id="276" r:id="rId27"/>
     <p:sldId id="277" r:id="rId28"/>
+    <p:sldId id="278" r:id="rId29"/>
+    <p:sldId id="279" r:id="rId30"/>
+    <p:sldId id="280" r:id="rId31"/>
   </p:sldIdLst>
   <p:sldSz cx="9144000" cy="6858000" type="screen4x3"/>
   <p:notesSz cx="6858000" cy="9144000"/>
@@ -5187,6 +5190,458 @@
                 <a:hlinkHover r:id="rId5"/>
               </a:rPr>
               <a:t>Both links</a:t>
+            </a:r>
+          </a:p>
+        </p:txBody>
+      </p:sp>
+    </p:spTree>
+  </p:cSld>
+  <p:clrMapOvr>
+    <a:masterClrMapping/>
+  </p:clrMapOvr>
+</p:sld>
+</file>
+
+<file path=ppt/slides/slide23.xml><?xml version="1.0" encoding="utf-8"?>
+<p:sld xmlns:a="http://schemas.openxmlformats.org/drawingml/2006/main" xmlns:p="http://schemas.openxmlformats.org/presentationml/2006/main" xmlns:r="http://schemas.openxmlformats.org/officeDocument/2006/relationships">
+  <p:cSld>
+    <p:spTree>
+      <p:nvGrpSpPr>
+        <p:cNvPr id="1" name=""/>
+        <p:cNvGrpSpPr/>
+        <p:nvPr/>
+      </p:nvGrpSpPr>
+      <p:grpSpPr/>
+      <p:sp>
+        <p:nvSpPr>
+          <p:cNvPr id="2" name="Rectangle 1"/>
+          <p:cNvSpPr/>
+          <p:nvPr/>
+        </p:nvSpPr>
+        <p:spPr>
+          <a:xfrm>
+            <a:off x="457200" y="457200"/>
+            <a:ext cx="2743200" cy="1828800"/>
+          </a:xfrm>
+          <a:prstGeom prst="rect">
+            <a:avLst/>
+          </a:prstGeom>
+          <a:gradFill rotWithShape="1">
+            <a:gsLst>
+              <a:gs pos="0">
+                <a:srgbClr val="FF0000"/>
+              </a:gs>
+              <a:gs pos="50000">
+                <a:srgbClr val="FFFF00"/>
+              </a:gs>
+              <a:gs pos="100000">
+                <a:srgbClr val="0000FF"/>
+              </a:gs>
+            </a:gsLst>
+            <a:lin ang="0" scaled="1"/>
+          </a:gradFill>
+        </p:spPr>
+        <p:style>
+          <a:lnRef idx="1">
+            <a:schemeClr val="accent1"/>
+          </a:lnRef>
+          <a:fillRef idx="3">
+            <a:schemeClr val="accent1"/>
+          </a:fillRef>
+          <a:effectRef idx="2">
+            <a:schemeClr val="accent1"/>
+          </a:effectRef>
+          <a:fontRef idx="minor">
+            <a:schemeClr val="lt1"/>
+          </a:fontRef>
+        </p:style>
+        <p:txBody>
+          <a:bodyPr rtlCol="0" anchor="ctr"/>
+          <a:lstStyle/>
+          <a:p>
+            <a:pPr>
+              <a:defRPr sz="1800">
+                <a:solidFill>
+                  <a:srgbClr val="FFFFFF"/>
+                </a:solidFill>
+              </a:defRPr>
+            </a:pPr>
+            <a:r>
+              <a:t>Linear 0deg</a:t>
+            </a:r>
+          </a:p>
+        </p:txBody>
+      </p:sp>
+      <p:sp>
+        <p:nvSpPr>
+          <p:cNvPr id="3" name="Rectangle 2"/>
+          <p:cNvSpPr/>
+          <p:nvPr/>
+        </p:nvSpPr>
+        <p:spPr>
+          <a:xfrm>
+            <a:off x="3657600" y="457200"/>
+            <a:ext cx="2743200" cy="1828800"/>
+          </a:xfrm>
+          <a:prstGeom prst="rect">
+            <a:avLst/>
+          </a:prstGeom>
+          <a:gradFill rotWithShape="1">
+            <a:gsLst>
+              <a:gs pos="0">
+                <a:srgbClr val="003366"/>
+              </a:gs>
+              <a:gs pos="100000">
+                <a:srgbClr val="66CCFF"/>
+              </a:gs>
+            </a:gsLst>
+            <a:lin ang="5400000" scaled="1"/>
+          </a:gradFill>
+        </p:spPr>
+        <p:style>
+          <a:lnRef idx="1">
+            <a:schemeClr val="accent1"/>
+          </a:lnRef>
+          <a:fillRef idx="3">
+            <a:schemeClr val="accent1"/>
+          </a:fillRef>
+          <a:effectRef idx="2">
+            <a:schemeClr val="accent1"/>
+          </a:effectRef>
+          <a:fontRef idx="minor">
+            <a:schemeClr val="lt1"/>
+          </a:fontRef>
+        </p:style>
+        <p:txBody>
+          <a:bodyPr rtlCol="0" anchor="ctr"/>
+          <a:lstStyle/>
+          <a:p>
+            <a:pPr>
+              <a:defRPr sz="1800">
+                <a:solidFill>
+                  <a:srgbClr val="FFFFFF"/>
+                </a:solidFill>
+              </a:defRPr>
+            </a:pPr>
+            <a:r>
+              <a:t>Linear 90deg</a:t>
+            </a:r>
+          </a:p>
+        </p:txBody>
+      </p:sp>
+      <p:sp>
+        <p:nvSpPr>
+          <p:cNvPr id="4" name="Rectangle 3"/>
+          <p:cNvSpPr/>
+          <p:nvPr/>
+        </p:nvSpPr>
+        <p:spPr>
+          <a:xfrm>
+            <a:off x="6858000" y="457200"/>
+            <a:ext cx="1828800" cy="1828800"/>
+          </a:xfrm>
+          <a:prstGeom prst="rect">
+            <a:avLst/>
+          </a:prstGeom>
+          <a:gradFill rotWithShape="0">
+            <a:gsLst>
+              <a:gs pos="0">
+                <a:srgbClr val="00FF00"/>
+              </a:gs>
+              <a:gs pos="100000">
+                <a:srgbClr val="006600"/>
+              </a:gs>
+            </a:gsLst>
+            <a:lin ang="2700000" scaled="1"/>
+          </a:gradFill>
+        </p:spPr>
+        <p:style>
+          <a:lnRef idx="1">
+            <a:schemeClr val="accent1"/>
+          </a:lnRef>
+          <a:fillRef idx="3">
+            <a:schemeClr val="accent1"/>
+          </a:fillRef>
+          <a:effectRef idx="2">
+            <a:schemeClr val="accent1"/>
+          </a:effectRef>
+          <a:fontRef idx="minor">
+            <a:schemeClr val="lt1"/>
+          </a:fontRef>
+        </p:style>
+        <p:txBody>
+          <a:bodyPr rtlCol="0" anchor="ctr"/>
+          <a:lstStyle/>
+          <a:p>
+            <a:pPr>
+              <a:defRPr sz="1400"/>
+            </a:pPr>
+            <a:r>
+              <a:t>Linear 45deg</a:t>
+            </a:r>
+          </a:p>
+        </p:txBody>
+      </p:sp>
+    </p:spTree>
+  </p:cSld>
+  <p:clrMapOvr>
+    <a:masterClrMapping/>
+  </p:clrMapOvr>
+</p:sld>
+</file>
+
+<file path=ppt/slides/slide24.xml><?xml version="1.0" encoding="utf-8"?>
+<p:sld xmlns:a="http://schemas.openxmlformats.org/drawingml/2006/main" xmlns:p="http://schemas.openxmlformats.org/presentationml/2006/main" xmlns:r="http://schemas.openxmlformats.org/officeDocument/2006/relationships">
+  <p:cSld>
+    <p:spTree>
+      <p:nvGrpSpPr>
+        <p:cNvPr id="1" name=""/>
+        <p:cNvGrpSpPr/>
+        <p:nvPr/>
+      </p:nvGrpSpPr>
+      <p:grpSpPr/>
+      <p:sp>
+        <p:nvSpPr>
+          <p:cNvPr id="2" name="Rectangle 1"/>
+          <p:cNvSpPr/>
+          <p:nvPr/>
+        </p:nvSpPr>
+        <p:spPr>
+          <a:xfrm>
+            <a:off x="457200" y="457200"/>
+            <a:ext cx="2743200" cy="2286000"/>
+          </a:xfrm>
+          <a:prstGeom prst="rect">
+            <a:avLst/>
+          </a:prstGeom>
+          <a:gradFill rotWithShape="1">
+            <a:gsLst>
+              <a:gs pos="0">
+                <a:srgbClr val="FFFFFF"/>
+              </a:gs>
+              <a:gs pos="100000">
+                <a:srgbClr val="FF6600"/>
+              </a:gs>
+            </a:gsLst>
+            <a:path path="circle">
+              <a:fillToRect l="50000" t="50000" r="50000" b="50000"/>
+            </a:path>
+          </a:gradFill>
+        </p:spPr>
+        <p:style>
+          <a:lnRef idx="1">
+            <a:schemeClr val="accent1"/>
+          </a:lnRef>
+          <a:fillRef idx="3">
+            <a:schemeClr val="accent1"/>
+          </a:fillRef>
+          <a:effectRef idx="2">
+            <a:schemeClr val="accent1"/>
+          </a:effectRef>
+          <a:fontRef idx="minor">
+            <a:schemeClr val="lt1"/>
+          </a:fontRef>
+        </p:style>
+        <p:txBody>
+          <a:bodyPr rtlCol="0" anchor="ctr"/>
+          <a:lstStyle/>
+          <a:p>
+            <a:pPr>
+              <a:defRPr sz="1800">
+                <a:solidFill>
+                  <a:srgbClr val="FFFFFF"/>
+                </a:solidFill>
+              </a:defRPr>
+            </a:pPr>
+            <a:r>
+              <a:t>Radial circle</a:t>
+            </a:r>
+          </a:p>
+        </p:txBody>
+      </p:sp>
+      <p:sp>
+        <p:nvSpPr>
+          <p:cNvPr id="3" name="Rectangle 2"/>
+          <p:cNvSpPr/>
+          <p:nvPr/>
+        </p:nvSpPr>
+        <p:spPr>
+          <a:xfrm>
+            <a:off x="3657600" y="457200"/>
+            <a:ext cx="2743200" cy="2286000"/>
+          </a:xfrm>
+          <a:prstGeom prst="rect">
+            <a:avLst/>
+          </a:prstGeom>
+          <a:gradFill rotWithShape="1">
+            <a:gsLst>
+              <a:gs pos="0">
+                <a:srgbClr val="FFFF00"/>
+              </a:gs>
+              <a:gs pos="50000">
+                <a:srgbClr val="FF0000"/>
+              </a:gs>
+              <a:gs pos="100000">
+                <a:srgbClr val="660000"/>
+              </a:gs>
+            </a:gsLst>
+            <a:path path="rect">
+              <a:fillToRect l="25000" t="25000" r="75000" b="75000"/>
+            </a:path>
+          </a:gradFill>
+        </p:spPr>
+        <p:style>
+          <a:lnRef idx="1">
+            <a:schemeClr val="accent1"/>
+          </a:lnRef>
+          <a:fillRef idx="3">
+            <a:schemeClr val="accent1"/>
+          </a:fillRef>
+          <a:effectRef idx="2">
+            <a:schemeClr val="accent1"/>
+          </a:effectRef>
+          <a:fontRef idx="minor">
+            <a:schemeClr val="lt1"/>
+          </a:fontRef>
+        </p:style>
+        <p:txBody>
+          <a:bodyPr rtlCol="0" anchor="ctr"/>
+          <a:lstStyle/>
+          <a:p>
+            <a:pPr>
+              <a:defRPr sz="1800"/>
+            </a:pPr>
+            <a:r>
+              <a:t>Radial rect</a:t>
+            </a:r>
+          </a:p>
+        </p:txBody>
+      </p:sp>
+      <p:sp>
+        <p:nvSpPr>
+          <p:cNvPr id="4" name="Oval 3"/>
+          <p:cNvSpPr/>
+          <p:nvPr/>
+        </p:nvSpPr>
+        <p:spPr>
+          <a:xfrm>
+            <a:off x="6858000" y="457200"/>
+            <a:ext cx="1828800" cy="2286000"/>
+          </a:xfrm>
+          <a:prstGeom prst="ellipse">
+            <a:avLst/>
+          </a:prstGeom>
+          <a:gradFill>
+            <a:gsLst>
+              <a:gs pos="0">
+                <a:srgbClr val="9933FF"/>
+              </a:gs>
+              <a:gs pos="100000">
+                <a:srgbClr val="330066"/>
+              </a:gs>
+            </a:gsLst>
+            <a:lin ang="16200000" scaled="1"/>
+          </a:gradFill>
+        </p:spPr>
+        <p:style>
+          <a:lnRef idx="1">
+            <a:schemeClr val="accent1"/>
+          </a:lnRef>
+          <a:fillRef idx="3">
+            <a:schemeClr val="accent1"/>
+          </a:fillRef>
+          <a:effectRef idx="2">
+            <a:schemeClr val="accent1"/>
+          </a:effectRef>
+          <a:fontRef idx="minor">
+            <a:schemeClr val="lt1"/>
+          </a:fontRef>
+        </p:style>
+        <p:txBody>
+          <a:bodyPr rtlCol="0" anchor="ctr"/>
+          <a:lstStyle/>
+          <a:p>
+            <a:pPr>
+              <a:defRPr sz="1400">
+                <a:solidFill>
+                  <a:srgbClr val="FFFFFF"/>
+                </a:solidFill>
+              </a:defRPr>
+            </a:pPr>
+            <a:r>
+              <a:t>Ellipse grad</a:t>
+            </a:r>
+          </a:p>
+        </p:txBody>
+      </p:sp>
+    </p:spTree>
+  </p:cSld>
+  <p:clrMapOvr>
+    <a:masterClrMapping/>
+  </p:clrMapOvr>
+</p:sld>
+</file>
+
+<file path=ppt/slides/slide25.xml><?xml version="1.0" encoding="utf-8"?>
+<p:sld xmlns:a="http://schemas.openxmlformats.org/drawingml/2006/main" xmlns:p="http://schemas.openxmlformats.org/presentationml/2006/main" xmlns:r="http://schemas.openxmlformats.org/officeDocument/2006/relationships">
+  <p:cSld>
+    <p:bg>
+      <p:bgPr>
+        <a:gradFill>
+          <a:gsLst>
+            <a:gs pos="0">
+              <a:srgbClr val="1B2838"/>
+            </a:gs>
+            <a:gs pos="50000">
+              <a:srgbClr val="2A475E"/>
+            </a:gs>
+            <a:gs pos="100000">
+              <a:srgbClr val="66C0F4"/>
+            </a:gs>
+          </a:gsLst>
+          <a:lin ang="5400000" scaled="0"/>
+        </a:gradFill>
+        <a:effectLst/>
+      </p:bgPr>
+    </p:bg>
+    <p:spTree>
+      <p:nvGrpSpPr>
+        <p:cNvPr id="1" name=""/>
+        <p:cNvGrpSpPr/>
+        <p:nvPr/>
+      </p:nvGrpSpPr>
+      <p:grpSpPr/>
+      <p:sp>
+        <p:nvSpPr>
+          <p:cNvPr id="2" name="TextBox 1"/>
+          <p:cNvSpPr txBox="1"/>
+          <p:nvPr/>
+        </p:nvSpPr>
+        <p:spPr>
+          <a:xfrm>
+            <a:off x="914400" y="1828800"/>
+            <a:ext cx="7315200" cy="2743200"/>
+          </a:xfrm>
+          <a:prstGeom prst="rect">
+            <a:avLst/>
+          </a:prstGeom>
+          <a:noFill/>
+        </p:spPr>
+        <p:txBody>
+          <a:bodyPr wrap="none">
+            <a:spAutoFit/>
+          </a:bodyPr>
+          <a:lstStyle/>
+          <a:p>
+            <a:pPr algn="ctr">
+              <a:defRPr sz="3600">
+                <a:solidFill>
+                  <a:srgbClr val="FFFFFF"/>
+                </a:solidFill>
+              </a:defRPr>
+            </a:pPr>
+            <a:r>
+              <a:t>Gradient Background</a:t>
             </a:r>
           </a:p>
         </p:txBody>

</xml_diff>

<commit_message>
feat: add support for pattern fills, blip fills, and alpha transparency in shapes
- Implemented pattern fill rendering and serialization, including various presets (e.g., ltDnDiag, smCheck, dkHorz).
- Added blip fill support for shapes, allowing image fills with optional stretching and source rectangle attributes.
- Enhanced color serialization to handle alpha transparency for solid fills and gradient stops.
- Updated SVG rendering to include pattern and blip fills, ensuring proper display in generated SVG output.
- Added tests for new features, including slides demonstrating alpha transparency, image fills, and pattern fills.
</commit_message>
<xml_diff>
--- a/test_fixtures/test_features.pptx
+++ b/test_fixtures/test_features.pptx
@@ -30,6 +30,9 @@
     <p:sldId id="278" r:id="rId29"/>
     <p:sldId id="279" r:id="rId30"/>
     <p:sldId id="280" r:id="rId31"/>
+    <p:sldId id="281" r:id="rId32"/>
+    <p:sldId id="282" r:id="rId33"/>
+    <p:sldId id="283" r:id="rId34"/>
   </p:sldIdLst>
   <p:sldSz cx="9144000" cy="6858000" type="screen4x3"/>
   <p:notesSz cx="6858000" cy="9144000"/>
@@ -5642,6 +5645,359 @@
             </a:pPr>
             <a:r>
               <a:t>Gradient Background</a:t>
+            </a:r>
+          </a:p>
+        </p:txBody>
+      </p:sp>
+    </p:spTree>
+  </p:cSld>
+  <p:clrMapOvr>
+    <a:masterClrMapping/>
+  </p:clrMapOvr>
+</p:sld>
+</file>
+
+<file path=ppt/slides/slide26.xml><?xml version="1.0" encoding="utf-8"?>
+<p:sld xmlns:a="http://schemas.openxmlformats.org/drawingml/2006/main" xmlns:p="http://schemas.openxmlformats.org/presentationml/2006/main" xmlns:r="http://schemas.openxmlformats.org/officeDocument/2006/relationships">
+  <p:cSld>
+    <p:spTree>
+      <p:nvGrpSpPr>
+        <p:cNvPr id="1" name=""/>
+        <p:cNvGrpSpPr/>
+        <p:nvPr/>
+      </p:nvGrpSpPr>
+      <p:grpSpPr/>
+      <p:sp>
+        <p:nvSpPr>
+          <p:cNvPr id="2" name="Rectangle 1"/>
+          <p:cNvSpPr/>
+          <p:nvPr/>
+        </p:nvSpPr>
+        <p:spPr>
+          <a:xfrm>
+            <a:off x="457200" y="457200"/>
+            <a:ext cx="2743200" cy="1828800"/>
+          </a:xfrm>
+          <a:prstGeom prst="rect">
+            <a:avLst/>
+          </a:prstGeom>
+          <a:solidFill>
+            <a:srgbClr val="FF0000">
+              <a:alpha val="50000"/>
+            </a:srgbClr>
+          </a:solidFill>
+        </p:spPr>
+        <p:style>
+          <a:lnRef idx="1">
+            <a:schemeClr val="accent1"/>
+          </a:lnRef>
+          <a:fillRef idx="3">
+            <a:schemeClr val="accent1"/>
+          </a:fillRef>
+          <a:effectRef idx="2">
+            <a:schemeClr val="accent1"/>
+          </a:effectRef>
+          <a:fontRef idx="minor">
+            <a:schemeClr val="lt1"/>
+          </a:fontRef>
+        </p:style>
+        <p:txBody>
+          <a:bodyPr rtlCol="0" anchor="ctr"/>
+          <a:lstStyle/>
+          <a:p>
+            <a:pPr>
+              <a:defRPr sz="1800"/>
+            </a:pPr>
+            <a:r>
+              <a:t>Alpha 50%</a:t>
+            </a:r>
+          </a:p>
+        </p:txBody>
+      </p:sp>
+      <p:sp>
+        <p:nvSpPr>
+          <p:cNvPr id="3" name="Rectangle 2"/>
+          <p:cNvSpPr/>
+          <p:nvPr/>
+        </p:nvSpPr>
+        <p:spPr>
+          <a:xfrm>
+            <a:off x="3657600" y="457200"/>
+            <a:ext cx="2743200" cy="1828800"/>
+          </a:xfrm>
+          <a:prstGeom prst="rect">
+            <a:avLst/>
+          </a:prstGeom>
+          <a:gradFill rotWithShape="1">
+            <a:gsLst>
+              <a:gs pos="0">
+                <a:srgbClr val="0000FF">
+                  <a:alpha val="80000"/>
+                </a:srgbClr>
+              </a:gs>
+              <a:gs pos="100000">
+                <a:srgbClr val="0000FF">
+                  <a:alpha val="20000"/>
+                </a:srgbClr>
+              </a:gs>
+            </a:gsLst>
+            <a:lin ang="0" scaled="1"/>
+          </a:gradFill>
+        </p:spPr>
+        <p:style>
+          <a:lnRef idx="1">
+            <a:schemeClr val="accent1"/>
+          </a:lnRef>
+          <a:fillRef idx="3">
+            <a:schemeClr val="accent1"/>
+          </a:fillRef>
+          <a:effectRef idx="2">
+            <a:schemeClr val="accent1"/>
+          </a:effectRef>
+          <a:fontRef idx="minor">
+            <a:schemeClr val="lt1"/>
+          </a:fontRef>
+        </p:style>
+        <p:txBody>
+          <a:bodyPr rtlCol="0" anchor="ctr"/>
+          <a:lstStyle/>
+          <a:p>
+            <a:pPr>
+              <a:defRPr sz="1800">
+                <a:solidFill>
+                  <a:srgbClr val="FFFFFF"/>
+                </a:solidFill>
+              </a:defRPr>
+            </a:pPr>
+            <a:r>
+              <a:t>Alpha Gradient</a:t>
+            </a:r>
+          </a:p>
+        </p:txBody>
+      </p:sp>
+    </p:spTree>
+  </p:cSld>
+  <p:clrMapOvr>
+    <a:masterClrMapping/>
+  </p:clrMapOvr>
+</p:sld>
+</file>
+
+<file path=ppt/slides/slide27.xml><?xml version="1.0" encoding="utf-8"?>
+<p:sld xmlns:a="http://schemas.openxmlformats.org/drawingml/2006/main" xmlns:p="http://schemas.openxmlformats.org/presentationml/2006/main" xmlns:r="http://schemas.openxmlformats.org/officeDocument/2006/relationships">
+  <p:cSld>
+    <p:spTree>
+      <p:nvGrpSpPr>
+        <p:cNvPr id="1" name=""/>
+        <p:cNvGrpSpPr/>
+        <p:nvPr/>
+      </p:nvGrpSpPr>
+      <p:grpSpPr/>
+      <p:sp>
+        <p:nvSpPr>
+          <p:cNvPr id="2" name="Rectangle 1"/>
+          <p:cNvSpPr/>
+          <p:nvPr/>
+        </p:nvSpPr>
+        <p:spPr>
+          <a:xfrm>
+            <a:off x="914400" y="914400"/>
+            <a:ext cx="3657600" cy="2743200"/>
+          </a:xfrm>
+          <a:prstGeom prst="rect">
+            <a:avLst/>
+          </a:prstGeom>
+          <a:blipFill>
+            <a:blip r:embed="rId2"/>
+            <a:stretch>
+              <a:fillRect/>
+            </a:stretch>
+          </a:blipFill>
+        </p:spPr>
+        <p:style>
+          <a:lnRef idx="1">
+            <a:schemeClr val="accent1"/>
+          </a:lnRef>
+          <a:fillRef idx="3">
+            <a:schemeClr val="accent1"/>
+          </a:fillRef>
+          <a:effectRef idx="2">
+            <a:schemeClr val="accent1"/>
+          </a:effectRef>
+          <a:fontRef idx="minor">
+            <a:schemeClr val="lt1"/>
+          </a:fontRef>
+        </p:style>
+        <p:txBody>
+          <a:bodyPr rtlCol="0" anchor="ctr"/>
+          <a:lstStyle/>
+          <a:p/>
+        </p:txBody>
+      </p:sp>
+    </p:spTree>
+  </p:cSld>
+  <p:clrMapOvr>
+    <a:masterClrMapping/>
+  </p:clrMapOvr>
+</p:sld>
+</file>
+
+<file path=ppt/slides/slide28.xml><?xml version="1.0" encoding="utf-8"?>
+<p:sld xmlns:a="http://schemas.openxmlformats.org/drawingml/2006/main" xmlns:p="http://schemas.openxmlformats.org/presentationml/2006/main" xmlns:r="http://schemas.openxmlformats.org/officeDocument/2006/relationships">
+  <p:cSld>
+    <p:spTree>
+      <p:nvGrpSpPr>
+        <p:cNvPr id="1" name=""/>
+        <p:cNvGrpSpPr/>
+        <p:nvPr/>
+      </p:nvGrpSpPr>
+      <p:grpSpPr/>
+      <p:sp>
+        <p:nvSpPr>
+          <p:cNvPr id="2" name="Rectangle 1"/>
+          <p:cNvSpPr/>
+          <p:nvPr/>
+        </p:nvSpPr>
+        <p:spPr>
+          <a:xfrm>
+            <a:off x="457200" y="457200"/>
+            <a:ext cx="2286000" cy="1828800"/>
+          </a:xfrm>
+          <a:prstGeom prst="rect">
+            <a:avLst/>
+          </a:prstGeom>
+          <a:pattFill prst="ltDnDiag">
+            <a:fgClr>
+              <a:srgbClr val="000000"/>
+            </a:fgClr>
+            <a:bgClr>
+              <a:srgbClr val="FFFFFF"/>
+            </a:bgClr>
+          </a:pattFill>
+        </p:spPr>
+        <p:style>
+          <a:lnRef idx="1">
+            <a:schemeClr val="accent1"/>
+          </a:lnRef>
+          <a:fillRef idx="3">
+            <a:schemeClr val="accent1"/>
+          </a:fillRef>
+          <a:effectRef idx="2">
+            <a:schemeClr val="accent1"/>
+          </a:effectRef>
+          <a:fontRef idx="minor">
+            <a:schemeClr val="lt1"/>
+          </a:fontRef>
+        </p:style>
+        <p:txBody>
+          <a:bodyPr rtlCol="0" anchor="ctr"/>
+          <a:lstStyle/>
+          <a:p>
+            <a:pPr>
+              <a:defRPr sz="1400"/>
+            </a:pPr>
+            <a:r>
+              <a:t>ltDnDiag</a:t>
+            </a:r>
+          </a:p>
+        </p:txBody>
+      </p:sp>
+      <p:sp>
+        <p:nvSpPr>
+          <p:cNvPr id="3" name="Rectangle 2"/>
+          <p:cNvSpPr/>
+          <p:nvPr/>
+        </p:nvSpPr>
+        <p:spPr>
+          <a:xfrm>
+            <a:off x="3200400" y="457200"/>
+            <a:ext cx="2286000" cy="1828800"/>
+          </a:xfrm>
+          <a:prstGeom prst="rect">
+            <a:avLst/>
+          </a:prstGeom>
+          <a:pattFill prst="smCheck">
+            <a:fgClr>
+              <a:srgbClr val="FF0000"/>
+            </a:fgClr>
+            <a:bgClr>
+              <a:srgbClr val="FFFF00"/>
+            </a:bgClr>
+          </a:pattFill>
+        </p:spPr>
+        <p:style>
+          <a:lnRef idx="1">
+            <a:schemeClr val="accent1"/>
+          </a:lnRef>
+          <a:fillRef idx="3">
+            <a:schemeClr val="accent1"/>
+          </a:fillRef>
+          <a:effectRef idx="2">
+            <a:schemeClr val="accent1"/>
+          </a:effectRef>
+          <a:fontRef idx="minor">
+            <a:schemeClr val="lt1"/>
+          </a:fontRef>
+        </p:style>
+        <p:txBody>
+          <a:bodyPr rtlCol="0" anchor="ctr"/>
+          <a:lstStyle/>
+          <a:p>
+            <a:pPr>
+              <a:defRPr sz="1400"/>
+            </a:pPr>
+            <a:r>
+              <a:t>smCheck</a:t>
+            </a:r>
+          </a:p>
+        </p:txBody>
+      </p:sp>
+      <p:sp>
+        <p:nvSpPr>
+          <p:cNvPr id="4" name="Rectangle 3"/>
+          <p:cNvSpPr/>
+          <p:nvPr/>
+        </p:nvSpPr>
+        <p:spPr>
+          <a:xfrm>
+            <a:off x="5943600" y="457200"/>
+            <a:ext cx="2286000" cy="1828800"/>
+          </a:xfrm>
+          <a:prstGeom prst="rect">
+            <a:avLst/>
+          </a:prstGeom>
+          <a:pattFill prst="dkHorz">
+            <a:fgClr>
+              <a:srgbClr val="003366"/>
+            </a:fgClr>
+            <a:bgClr>
+              <a:srgbClr val="CCCCCC"/>
+            </a:bgClr>
+          </a:pattFill>
+        </p:spPr>
+        <p:style>
+          <a:lnRef idx="1">
+            <a:schemeClr val="accent1"/>
+          </a:lnRef>
+          <a:fillRef idx="3">
+            <a:schemeClr val="accent1"/>
+          </a:fillRef>
+          <a:effectRef idx="2">
+            <a:schemeClr val="accent1"/>
+          </a:effectRef>
+          <a:fontRef idx="minor">
+            <a:schemeClr val="lt1"/>
+          </a:fontRef>
+        </p:style>
+        <p:txBody>
+          <a:bodyPr rtlCol="0" anchor="ctr"/>
+          <a:lstStyle/>
+          <a:p>
+            <a:pPr>
+              <a:defRPr sz="1400"/>
+            </a:pPr>
+            <a:r>
+              <a:t>dkHorz</a:t>
             </a:r>
           </a:p>
         </p:txBody>

</xml_diff>

<commit_message>
feat: add support for tile flipping in gradient and blip fills, and enhance pattern fill options
</commit_message>
<xml_diff>
--- a/test_fixtures/test_features.pptx
+++ b/test_fixtures/test_features.pptx
@@ -33,6 +33,9 @@
     <p:sldId id="281" r:id="rId32"/>
     <p:sldId id="282" r:id="rId33"/>
     <p:sldId id="283" r:id="rId34"/>
+    <p:sldId id="284" r:id="rId35"/>
+    <p:sldId id="285" r:id="rId36"/>
+    <p:sldId id="286" r:id="rId37"/>
   </p:sldIdLst>
   <p:sldSz cx="9144000" cy="6858000" type="screen4x3"/>
   <p:notesSz cx="6858000" cy="9144000"/>
@@ -6010,6 +6013,186 @@
 </p:sld>
 </file>
 
+<file path=ppt/slides/slide29.xml><?xml version="1.0" encoding="utf-8"?>
+<p:sld xmlns:a="http://schemas.openxmlformats.org/drawingml/2006/main" xmlns:p="http://schemas.openxmlformats.org/presentationml/2006/main" xmlns:r="http://schemas.openxmlformats.org/officeDocument/2006/relationships">
+  <p:cSld>
+    <p:spTree>
+      <p:nvGrpSpPr>
+        <p:cNvPr id="1" name=""/>
+        <p:cNvGrpSpPr/>
+        <p:nvPr/>
+      </p:nvGrpSpPr>
+      <p:grpSpPr/>
+      <p:sp>
+        <p:nvSpPr>
+          <p:cNvPr id="2" name="Rectangle 1"/>
+          <p:cNvSpPr/>
+          <p:nvPr/>
+        </p:nvSpPr>
+        <p:spPr>
+          <a:xfrm>
+            <a:off x="457200" y="457200"/>
+            <a:ext cx="2286000" cy="1828800"/>
+          </a:xfrm>
+          <a:prstGeom prst="rect">
+            <a:avLst/>
+          </a:prstGeom>
+          <a:gradFill rotWithShape="1" tileFlip="x">
+            <a:gsLst>
+              <a:gs pos="0">
+                <a:srgbClr val="FF0000"/>
+              </a:gs>
+              <a:gs pos="100000">
+                <a:srgbClr val="0000FF"/>
+              </a:gs>
+            </a:gsLst>
+            <a:lin ang="0" scaled="1"/>
+          </a:gradFill>
+        </p:spPr>
+        <p:style>
+          <a:lnRef idx="1">
+            <a:schemeClr val="accent1"/>
+          </a:lnRef>
+          <a:fillRef idx="3">
+            <a:schemeClr val="accent1"/>
+          </a:fillRef>
+          <a:effectRef idx="2">
+            <a:schemeClr val="accent1"/>
+          </a:effectRef>
+          <a:fontRef idx="minor">
+            <a:schemeClr val="lt1"/>
+          </a:fontRef>
+        </p:style>
+        <p:txBody>
+          <a:bodyPr rtlCol="0" anchor="ctr"/>
+          <a:lstStyle/>
+          <a:p>
+            <a:pPr>
+              <a:defRPr sz="1400"/>
+            </a:pPr>
+            <a:r>
+              <a:t>tileFlip=x</a:t>
+            </a:r>
+          </a:p>
+        </p:txBody>
+      </p:sp>
+      <p:sp>
+        <p:nvSpPr>
+          <p:cNvPr id="3" name="Rectangle 2"/>
+          <p:cNvSpPr/>
+          <p:nvPr/>
+        </p:nvSpPr>
+        <p:spPr>
+          <a:xfrm>
+            <a:off x="3200400" y="457200"/>
+            <a:ext cx="2286000" cy="1828800"/>
+          </a:xfrm>
+          <a:prstGeom prst="rect">
+            <a:avLst/>
+          </a:prstGeom>
+          <a:gradFill rotWithShape="1" tileFlip="y">
+            <a:gsLst>
+              <a:gs pos="0">
+                <a:srgbClr val="00FF00"/>
+              </a:gs>
+              <a:gs pos="100000">
+                <a:srgbClr val="FF00FF"/>
+              </a:gs>
+            </a:gsLst>
+            <a:lin ang="5400000" scaled="1"/>
+          </a:gradFill>
+        </p:spPr>
+        <p:style>
+          <a:lnRef idx="1">
+            <a:schemeClr val="accent1"/>
+          </a:lnRef>
+          <a:fillRef idx="3">
+            <a:schemeClr val="accent1"/>
+          </a:fillRef>
+          <a:effectRef idx="2">
+            <a:schemeClr val="accent1"/>
+          </a:effectRef>
+          <a:fontRef idx="minor">
+            <a:schemeClr val="lt1"/>
+          </a:fontRef>
+        </p:style>
+        <p:txBody>
+          <a:bodyPr rtlCol="0" anchor="ctr"/>
+          <a:lstStyle/>
+          <a:p>
+            <a:pPr>
+              <a:defRPr sz="1400"/>
+            </a:pPr>
+            <a:r>
+              <a:t>tileFlip=y</a:t>
+            </a:r>
+          </a:p>
+        </p:txBody>
+      </p:sp>
+      <p:sp>
+        <p:nvSpPr>
+          <p:cNvPr id="4" name="Rectangle 3"/>
+          <p:cNvSpPr/>
+          <p:nvPr/>
+        </p:nvSpPr>
+        <p:spPr>
+          <a:xfrm>
+            <a:off x="5943600" y="457200"/>
+            <a:ext cx="2286000" cy="1828800"/>
+          </a:xfrm>
+          <a:prstGeom prst="rect">
+            <a:avLst/>
+          </a:prstGeom>
+          <a:gradFill rotWithShape="1" tileFlip="xy">
+            <a:gsLst>
+              <a:gs pos="0">
+                <a:srgbClr val="FFFF00"/>
+              </a:gs>
+              <a:gs pos="50000">
+                <a:srgbClr val="FF6600"/>
+              </a:gs>
+              <a:gs pos="100000">
+                <a:srgbClr val="0066FF"/>
+              </a:gs>
+            </a:gsLst>
+            <a:lin ang="2700000" scaled="1"/>
+          </a:gradFill>
+        </p:spPr>
+        <p:style>
+          <a:lnRef idx="1">
+            <a:schemeClr val="accent1"/>
+          </a:lnRef>
+          <a:fillRef idx="3">
+            <a:schemeClr val="accent1"/>
+          </a:fillRef>
+          <a:effectRef idx="2">
+            <a:schemeClr val="accent1"/>
+          </a:effectRef>
+          <a:fontRef idx="minor">
+            <a:schemeClr val="lt1"/>
+          </a:fontRef>
+        </p:style>
+        <p:txBody>
+          <a:bodyPr rtlCol="0" anchor="ctr"/>
+          <a:lstStyle/>
+          <a:p>
+            <a:pPr>
+              <a:defRPr sz="1400"/>
+            </a:pPr>
+            <a:r>
+              <a:t>tileFlip=xy</a:t>
+            </a:r>
+          </a:p>
+        </p:txBody>
+      </p:sp>
+    </p:spTree>
+  </p:cSld>
+  <p:clrMapOvr>
+    <a:masterClrMapping/>
+  </p:clrMapOvr>
+</p:sld>
+</file>
+
 <file path=ppt/slides/slide3.xml><?xml version="1.0" encoding="utf-8"?>
 <p:sld xmlns:a="http://schemas.openxmlformats.org/drawingml/2006/main" xmlns:p="http://schemas.openxmlformats.org/presentationml/2006/main" xmlns:r="http://schemas.openxmlformats.org/officeDocument/2006/relationships">
   <p:cSld>
@@ -6273,6 +6456,388 @@
             </a:pPr>
             <a:r>
               <a:t>Alpha lower c</a:t>
+            </a:r>
+          </a:p>
+        </p:txBody>
+      </p:sp>
+    </p:spTree>
+  </p:cSld>
+  <p:clrMapOvr>
+    <a:masterClrMapping/>
+  </p:clrMapOvr>
+</p:sld>
+</file>
+
+<file path=ppt/slides/slide30.xml><?xml version="1.0" encoding="utf-8"?>
+<p:sld xmlns:a="http://schemas.openxmlformats.org/drawingml/2006/main" xmlns:p="http://schemas.openxmlformats.org/presentationml/2006/main" xmlns:r="http://schemas.openxmlformats.org/officeDocument/2006/relationships">
+  <p:cSld>
+    <p:spTree>
+      <p:nvGrpSpPr>
+        <p:cNvPr id="1" name=""/>
+        <p:cNvGrpSpPr/>
+        <p:nvPr/>
+      </p:nvGrpSpPr>
+      <p:grpSpPr/>
+      <p:sp>
+        <p:nvSpPr>
+          <p:cNvPr id="2" name="Rectangle 1"/>
+          <p:cNvSpPr/>
+          <p:nvPr/>
+        </p:nvSpPr>
+        <p:spPr>
+          <a:xfrm>
+            <a:off x="457200" y="457200"/>
+            <a:ext cx="2286000" cy="1828800"/>
+          </a:xfrm>
+          <a:prstGeom prst="rect">
+            <a:avLst/>
+          </a:prstGeom>
+          <a:pattFill prst="pct50">
+            <a:fgClr>
+              <a:srgbClr val="333333"/>
+            </a:fgClr>
+            <a:bgClr>
+              <a:srgbClr val="CCCCCC"/>
+            </a:bgClr>
+          </a:pattFill>
+        </p:spPr>
+        <p:style>
+          <a:lnRef idx="1">
+            <a:schemeClr val="accent1"/>
+          </a:lnRef>
+          <a:fillRef idx="3">
+            <a:schemeClr val="accent1"/>
+          </a:fillRef>
+          <a:effectRef idx="2">
+            <a:schemeClr val="accent1"/>
+          </a:effectRef>
+          <a:fontRef idx="minor">
+            <a:schemeClr val="lt1"/>
+          </a:fontRef>
+        </p:style>
+        <p:txBody>
+          <a:bodyPr rtlCol="0" anchor="ctr"/>
+          <a:lstStyle/>
+          <a:p>
+            <a:pPr>
+              <a:defRPr sz="1400"/>
+            </a:pPr>
+            <a:r>
+              <a:t>pct50</a:t>
+            </a:r>
+          </a:p>
+        </p:txBody>
+      </p:sp>
+      <p:sp>
+        <p:nvSpPr>
+          <p:cNvPr id="3" name="Rectangle 2"/>
+          <p:cNvSpPr/>
+          <p:nvPr/>
+        </p:nvSpPr>
+        <p:spPr>
+          <a:xfrm>
+            <a:off x="3200400" y="457200"/>
+            <a:ext cx="2286000" cy="1828800"/>
+          </a:xfrm>
+          <a:prstGeom prst="rect">
+            <a:avLst/>
+          </a:prstGeom>
+          <a:pattFill prst="dnDiag">
+            <a:fgClr>
+              <a:srgbClr val="000080"/>
+            </a:fgClr>
+            <a:bgClr>
+              <a:srgbClr val="FFFFFF"/>
+            </a:bgClr>
+          </a:pattFill>
+        </p:spPr>
+        <p:style>
+          <a:lnRef idx="1">
+            <a:schemeClr val="accent1"/>
+          </a:lnRef>
+          <a:fillRef idx="3">
+            <a:schemeClr val="accent1"/>
+          </a:fillRef>
+          <a:effectRef idx="2">
+            <a:schemeClr val="accent1"/>
+          </a:effectRef>
+          <a:fontRef idx="minor">
+            <a:schemeClr val="lt1"/>
+          </a:fontRef>
+        </p:style>
+        <p:txBody>
+          <a:bodyPr rtlCol="0" anchor="ctr"/>
+          <a:lstStyle/>
+          <a:p>
+            <a:pPr>
+              <a:defRPr sz="1400"/>
+            </a:pPr>
+            <a:r>
+              <a:t>dnDiag</a:t>
+            </a:r>
+          </a:p>
+        </p:txBody>
+      </p:sp>
+      <p:sp>
+        <p:nvSpPr>
+          <p:cNvPr id="4" name="Rectangle 3"/>
+          <p:cNvSpPr/>
+          <p:nvPr/>
+        </p:nvSpPr>
+        <p:spPr>
+          <a:xfrm>
+            <a:off x="5943600" y="457200"/>
+            <a:ext cx="2286000" cy="1828800"/>
+          </a:xfrm>
+          <a:prstGeom prst="rect">
+            <a:avLst/>
+          </a:prstGeom>
+          <a:pattFill prst="cross">
+            <a:fgClr>
+              <a:srgbClr val="FF0000"/>
+            </a:fgClr>
+            <a:bgClr>
+              <a:srgbClr val="FFFFCC"/>
+            </a:bgClr>
+          </a:pattFill>
+        </p:spPr>
+        <p:style>
+          <a:lnRef idx="1">
+            <a:schemeClr val="accent1"/>
+          </a:lnRef>
+          <a:fillRef idx="3">
+            <a:schemeClr val="accent1"/>
+          </a:fillRef>
+          <a:effectRef idx="2">
+            <a:schemeClr val="accent1"/>
+          </a:effectRef>
+          <a:fontRef idx="minor">
+            <a:schemeClr val="lt1"/>
+          </a:fontRef>
+        </p:style>
+        <p:txBody>
+          <a:bodyPr rtlCol="0" anchor="ctr"/>
+          <a:lstStyle/>
+          <a:p>
+            <a:pPr>
+              <a:defRPr sz="1400"/>
+            </a:pPr>
+            <a:r>
+              <a:t>cross</a:t>
+            </a:r>
+          </a:p>
+        </p:txBody>
+      </p:sp>
+      <p:sp>
+        <p:nvSpPr>
+          <p:cNvPr id="5" name="Rectangle 4"/>
+          <p:cNvSpPr/>
+          <p:nvPr/>
+        </p:nvSpPr>
+        <p:spPr>
+          <a:xfrm>
+            <a:off x="457200" y="2743200"/>
+            <a:ext cx="2286000" cy="1828800"/>
+          </a:xfrm>
+          <a:prstGeom prst="rect">
+            <a:avLst/>
+          </a:prstGeom>
+          <a:pattFill prst="lgCheck">
+            <a:fgClr>
+              <a:srgbClr val="008000"/>
+            </a:fgClr>
+            <a:bgClr>
+              <a:srgbClr val="FFFFFF"/>
+            </a:bgClr>
+          </a:pattFill>
+        </p:spPr>
+        <p:style>
+          <a:lnRef idx="1">
+            <a:schemeClr val="accent1"/>
+          </a:lnRef>
+          <a:fillRef idx="3">
+            <a:schemeClr val="accent1"/>
+          </a:fillRef>
+          <a:effectRef idx="2">
+            <a:schemeClr val="accent1"/>
+          </a:effectRef>
+          <a:fontRef idx="minor">
+            <a:schemeClr val="lt1"/>
+          </a:fontRef>
+        </p:style>
+        <p:txBody>
+          <a:bodyPr rtlCol="0" anchor="ctr"/>
+          <a:lstStyle/>
+          <a:p>
+            <a:pPr>
+              <a:defRPr sz="1400"/>
+            </a:pPr>
+            <a:r>
+              <a:t>lgCheck</a:t>
+            </a:r>
+          </a:p>
+        </p:txBody>
+      </p:sp>
+      <p:sp>
+        <p:nvSpPr>
+          <p:cNvPr id="6" name="Rectangle 5"/>
+          <p:cNvSpPr/>
+          <p:nvPr/>
+        </p:nvSpPr>
+        <p:spPr>
+          <a:xfrm>
+            <a:off x="3200400" y="2743200"/>
+            <a:ext cx="2286000" cy="1828800"/>
+          </a:xfrm>
+          <a:prstGeom prst="rect">
+            <a:avLst/>
+          </a:prstGeom>
+          <a:pattFill prst="solidDmnd">
+            <a:fgClr>
+              <a:srgbClr val="800080"/>
+            </a:fgClr>
+            <a:bgClr>
+              <a:srgbClr val="FFE0FF"/>
+            </a:bgClr>
+          </a:pattFill>
+        </p:spPr>
+        <p:style>
+          <a:lnRef idx="1">
+            <a:schemeClr val="accent1"/>
+          </a:lnRef>
+          <a:fillRef idx="3">
+            <a:schemeClr val="accent1"/>
+          </a:fillRef>
+          <a:effectRef idx="2">
+            <a:schemeClr val="accent1"/>
+          </a:effectRef>
+          <a:fontRef idx="minor">
+            <a:schemeClr val="lt1"/>
+          </a:fontRef>
+        </p:style>
+        <p:txBody>
+          <a:bodyPr rtlCol="0" anchor="ctr"/>
+          <a:lstStyle/>
+          <a:p>
+            <a:pPr>
+              <a:defRPr sz="1400"/>
+            </a:pPr>
+            <a:r>
+              <a:t>solidDmnd</a:t>
+            </a:r>
+          </a:p>
+        </p:txBody>
+      </p:sp>
+      <p:sp>
+        <p:nvSpPr>
+          <p:cNvPr id="7" name="Rectangle 6"/>
+          <p:cNvSpPr/>
+          <p:nvPr/>
+        </p:nvSpPr>
+        <p:spPr>
+          <a:xfrm>
+            <a:off x="5943600" y="2743200"/>
+            <a:ext cx="2286000" cy="1828800"/>
+          </a:xfrm>
+          <a:prstGeom prst="rect">
+            <a:avLst/>
+          </a:prstGeom>
+          <a:pattFill prst="trellis">
+            <a:fgClr>
+              <a:srgbClr val="004040"/>
+            </a:fgClr>
+            <a:bgClr>
+              <a:srgbClr val="E0FFFF"/>
+            </a:bgClr>
+          </a:pattFill>
+        </p:spPr>
+        <p:style>
+          <a:lnRef idx="1">
+            <a:schemeClr val="accent1"/>
+          </a:lnRef>
+          <a:fillRef idx="3">
+            <a:schemeClr val="accent1"/>
+          </a:fillRef>
+          <a:effectRef idx="2">
+            <a:schemeClr val="accent1"/>
+          </a:effectRef>
+          <a:fontRef idx="minor">
+            <a:schemeClr val="lt1"/>
+          </a:fontRef>
+        </p:style>
+        <p:txBody>
+          <a:bodyPr rtlCol="0" anchor="ctr"/>
+          <a:lstStyle/>
+          <a:p>
+            <a:pPr>
+              <a:defRPr sz="1400"/>
+            </a:pPr>
+            <a:r>
+              <a:t>trellis</a:t>
+            </a:r>
+          </a:p>
+        </p:txBody>
+      </p:sp>
+    </p:spTree>
+  </p:cSld>
+  <p:clrMapOvr>
+    <a:masterClrMapping/>
+  </p:clrMapOvr>
+</p:sld>
+</file>
+
+<file path=ppt/slides/slide31.xml><?xml version="1.0" encoding="utf-8"?>
+<p:sld xmlns:a="http://schemas.openxmlformats.org/drawingml/2006/main" xmlns:p="http://schemas.openxmlformats.org/presentationml/2006/main" xmlns:r="http://schemas.openxmlformats.org/officeDocument/2006/relationships">
+  <p:cSld>
+    <p:spTree>
+      <p:nvGrpSpPr>
+        <p:cNvPr id="1" name=""/>
+        <p:cNvGrpSpPr/>
+        <p:nvPr/>
+      </p:nvGrpSpPr>
+      <p:grpSpPr/>
+      <p:sp>
+        <p:nvSpPr>
+          <p:cNvPr id="2" name="Rectangle 1"/>
+          <p:cNvSpPr/>
+          <p:nvPr/>
+        </p:nvSpPr>
+        <p:spPr>
+          <a:xfrm>
+            <a:off x="457200" y="457200"/>
+            <a:ext cx="3657600" cy="2743200"/>
+          </a:xfrm>
+          <a:prstGeom prst="rect">
+            <a:avLst/>
+          </a:prstGeom>
+          <a:blipFill>
+            <a:blip r:embed="rId2"/>
+            <a:tile tx="0" ty="0" sx="50000" sy="50000" flip="xy" algn="tl"/>
+          </a:blipFill>
+        </p:spPr>
+        <p:style>
+          <a:lnRef idx="1">
+            <a:schemeClr val="accent1"/>
+          </a:lnRef>
+          <a:fillRef idx="3">
+            <a:schemeClr val="accent1"/>
+          </a:fillRef>
+          <a:effectRef idx="2">
+            <a:schemeClr val="accent1"/>
+          </a:effectRef>
+          <a:fontRef idx="minor">
+            <a:schemeClr val="lt1"/>
+          </a:fontRef>
+        </p:style>
+        <p:txBody>
+          <a:bodyPr rtlCol="0" anchor="ctr"/>
+          <a:lstStyle/>
+          <a:p>
+            <a:pPr>
+              <a:defRPr sz="1400"/>
+            </a:pPr>
+            <a:r>
+              <a:t>Tile fill</a:t>
             </a:r>
           </a:p>
         </p:txBody>

</xml_diff>

<commit_message>
feat: complete 5.2 connectors (bent/curved) + refactor
- Add bent connectors (bentConnector2-5) as right-angle polyline paths
- Add curved connectors (curvedConnector2-5) as cubic bezier paths
- Add adjustment value (a:avLst) parsing, serialization, and round-trip
- Refactor: extract shape_with_inherited_transform helper (eliminate duplication)
- Refactor: consolidate defs collection into single loop in render_slide_svg
- Refactor: extract serialize_arrow_end and serialize_transform_with_extra helpers
- Refactor: replace manual rgb() with Color.to_css(), name magic numbers
- Update CLAUDE.md data model (GroupShapeData, Connector, StrokeProps)
- Fix TODO.md section 4 header (had ✅ but still has unchecked items)

Co-Authored-By: Claude Opus 4.6 <noreply@anthropic.com>
</commit_message>
<xml_diff>
--- a/test_fixtures/test_features.pptx
+++ b/test_fixtures/test_features.pptx
@@ -8428,9 +8428,58 @@
           </a:ln>
         </p:spPr>
       </p:cxnSp>
-      <p:sp>
-        <p:nvSpPr>
-          <p:cNvPr id="302" name="TextBox 301"/>
+      <p:cxnSp>
+        <p:nvCxnSpPr>
+          <p:cNvPr id="302" name="Bent Connector"/>
+          <p:cNvCxnSpPr/>
+          <p:nvPr/>
+        </p:nvCxnSpPr>
+        <p:spPr>
+          <a:xfrm>
+            <a:off x="5029200" y="1371600"/>
+            <a:ext cx="3657600" cy="1371600"/>
+          </a:xfrm>
+          <a:prstGeom prst="bentConnector3">
+            <a:avLst>
+              <a:gd name="adj1" fmla="val 50000"/>
+            </a:avLst>
+          </a:prstGeom>
+          <a:ln w="25400">
+            <a:solidFill>
+              <a:srgbClr val="009900"/>
+            </a:solidFill>
+            <a:tailEnd type="triangle"/>
+          </a:ln>
+        </p:spPr>
+      </p:cxnSp>
+      <p:cxnSp>
+        <p:nvCxnSpPr>
+          <p:cNvPr id="303" name="Curved Connector"/>
+          <p:cNvCxnSpPr/>
+          <p:nvPr/>
+        </p:nvCxnSpPr>
+        <p:spPr>
+          <a:xfrm>
+            <a:off x="5029200" y="3200400"/>
+            <a:ext cx="3657600" cy="1371600"/>
+          </a:xfrm>
+          <a:prstGeom prst="curvedConnector3">
+            <a:avLst>
+              <a:gd name="adj1" fmla="val 50000"/>
+            </a:avLst>
+          </a:prstGeom>
+          <a:ln w="25400">
+            <a:solidFill>
+              <a:srgbClr val="FF6600"/>
+            </a:solidFill>
+            <a:headEnd type="oval"/>
+            <a:tailEnd type="arrow"/>
+          </a:ln>
+        </p:spPr>
+      </p:cxnSp>
+      <p:sp>
+        <p:nvSpPr>
+          <p:cNvPr id="304" name="TextBox 303"/>
           <p:cNvSpPr txBox="1"/>
           <p:nvPr/>
         </p:nvSpPr>
@@ -8458,7 +8507,7 @@
               </a:defRPr>
             </a:pPr>
             <a:r>
-              <a:t>Top: straight connector (red, triangle arrow). Bottom: diagonal connector (blue dashed, diamond+stealth).</a:t>
+              <a:t>Left: straight + diagonal. Right: bent (green) + curved (orange).</a:t>
             </a:r>
           </a:p>
         </p:txBody>

</xml_diff>

<commit_message>
feat: custom dash, superscript overlap fix, and refactoring
- Add a:custDash parsing/rendering/serialization with round-trip support
- Fix superscript/subscript text overlapping adjacent lines by adding
  extra spacing above (super) and below (sub) paragraphs
- Extract magic numbers into named constants (ooxml_pct_denom,
  cust_dash_prefix, pattern_tile_sz, baseline_shift_extra_*)
- Remove duplicate hs variable in pattern fill rendering
- Use slot_tags.length() instead of hardcoded 12
- Update CLAUDE.md data model with explicit Shape field types

Co-Authored-By: Claude Opus 4.6 <noreply@anthropic.com>
</commit_message>
<xml_diff>
--- a/test_fixtures/test_features.pptx
+++ b/test_fixtures/test_features.pptx
@@ -7365,6 +7365,88 @@
             </a:pPr>
             <a:r>
               <a:t>sysDash</a:t>
+            </a:r>
+          </a:p>
+        </p:txBody>
+      </p:sp>
+      <p:sp>
+        <p:nvSpPr>
+          <p:cNvPr id="15" name="Rectangle 14"/>
+          <p:cNvSpPr/>
+          <p:nvPr/>
+        </p:nvSpPr>
+        <p:spPr>
+          <a:xfrm>
+            <a:off x="914400" y="5852160"/>
+            <a:ext cx="7315200" cy="0"/>
+          </a:xfrm>
+          <a:prstGeom prst="line">
+            <a:avLst/>
+          </a:prstGeom>
+          <a:noFill/>
+          <a:ln w="25400">
+            <a:solidFill>
+              <a:srgbClr val="FF6600"/>
+            </a:solidFill>
+            <a:custDash>
+              <a:ds d="400000" sp="100000"/>
+              <a:ds d="100000" sp="100000"/>
+            </a:custDash>
+          </a:ln>
+        </p:spPr>
+        <p:style>
+          <a:lnRef idx="1">
+            <a:schemeClr val="accent1"/>
+          </a:lnRef>
+          <a:fillRef idx="3">
+            <a:schemeClr val="accent1"/>
+          </a:fillRef>
+          <a:effectRef idx="2">
+            <a:schemeClr val="accent1"/>
+          </a:effectRef>
+          <a:fontRef idx="minor">
+            <a:schemeClr val="lt1"/>
+          </a:fontRef>
+        </p:style>
+        <p:txBody>
+          <a:bodyPr rtlCol="0" anchor="ctr"/>
+          <a:lstStyle/>
+          <a:p>
+            <a:pPr algn="ctr"/>
+          </a:p>
+        </p:txBody>
+      </p:sp>
+      <p:sp>
+        <p:nvSpPr>
+          <p:cNvPr id="16" name="TextBox 15"/>
+          <p:cNvSpPr txBox="1"/>
+          <p:nvPr/>
+        </p:nvSpPr>
+        <p:spPr>
+          <a:xfrm>
+            <a:off x="182880" y="5623560"/>
+            <a:ext cx="731520" cy="274320"/>
+          </a:xfrm>
+          <a:prstGeom prst="rect">
+            <a:avLst/>
+          </a:prstGeom>
+          <a:noFill/>
+        </p:spPr>
+        <p:txBody>
+          <a:bodyPr wrap="none">
+            <a:spAutoFit/>
+          </a:bodyPr>
+          <a:lstStyle/>
+          <a:p>
+            <a:pPr>
+              <a:defRPr sz="900">
+                <a:solidFill>
+                  <a:srgbClr val="FFFFFF"/>
+                </a:solidFill>
+              </a:defRPr>
+            </a:pPr>
+            <a:r>
+              <a:t>custDash</a:t>
             </a:r>
           </a:p>
         </p:txBody>

</xml_diff>

<commit_message>
feat: preset geometry engine + shape fixes + refactoring
- Add DrawingML guide formula evaluator (renderer_geom.mbt) supporting
  +-、*/、cos/sin/atan2/sqrt、pin/min/max/abs/mod/if operators
- Implement 80+ preset shapes (rectangles, arrows, stars, callouts, etc.)
- Fix pentagon, star5, heart rendering with correct OOXML angle conventions
- Fix inline trig bugs in star8, pie/arc, chord presets
- Add connector shapes (straight, bent, curved) with adjustable handles
- Remove duplicate helper aliases (str_sub, parse_int, int_to_str)
- Reduce digit_str visibility to private
- Clean up TODO.md and condense completed sections
- Migrate moon.pkg.json → moon.pkg format via moon fmt

Co-Authored-By: Claude Opus 4.6 <noreply@anthropic.com>
</commit_message>
<xml_diff>
--- a/test_fixtures/test_features.pptx
+++ b/test_fixtures/test_features.pptx
@@ -40,6 +40,7 @@
     <p:sldId id="288" r:id="rId39"/>
     <p:sldId id="289" r:id="rId40"/>
     <p:sldId id="290" r:id="rId41"/>
+    <p:sldId id="291" r:id="rId42"/>
   </p:sldIdLst>
   <p:sldSz cx="9144000" cy="6858000" type="screen4x3"/>
   <p:notesSz cx="6858000" cy="9144000"/>
@@ -8590,6 +8591,540 @@
             </a:pPr>
             <a:r>
               <a:t>Left: straight + diagonal. Right: bent (green) + curved (orange).</a:t>
+            </a:r>
+          </a:p>
+        </p:txBody>
+      </p:sp>
+    </p:spTree>
+  </p:cSld>
+  <p:clrMapOvr>
+    <a:masterClrMapping/>
+  </p:clrMapOvr>
+</p:sld>
+</file>
+
+<file path=ppt/slides/slide36.xml><?xml version="1.0" encoding="utf-8"?>
+<p:sld xmlns:a="http://schemas.openxmlformats.org/drawingml/2006/main" xmlns:p="http://schemas.openxmlformats.org/presentationml/2006/main" xmlns:r="http://schemas.openxmlformats.org/officeDocument/2006/relationships">
+  <p:cSld>
+    <p:spTree>
+      <p:nvGrpSpPr>
+        <p:cNvPr id="1" name=""/>
+        <p:cNvGrpSpPr/>
+        <p:nvPr/>
+      </p:nvGrpSpPr>
+      <p:grpSpPr/>
+      <p:sp>
+        <p:nvSpPr>
+          <p:cNvPr id="0" name="prst_triangle"/>
+          <p:cNvSpPr/>
+          <p:nvPr/>
+        </p:nvSpPr>
+        <p:spPr>
+          <a:xfrm>
+            <a:off x="457200" y="457200"/>
+            <a:ext cx="1143000" cy="1143000"/>
+          </a:xfrm>
+          <a:prstGeom prst="triangle">
+            <a:avLst/>
+          </a:prstGeom>
+          <a:solidFill>
+            <a:srgbClr val="FF6B6B"/>
+          </a:solidFill>
+          <a:ln w="12700">
+            <a:solidFill>
+              <a:srgbClr val="333333"/>
+            </a:solidFill>
+          </a:ln>
+        </p:spPr>
+        <p:txBody>
+          <a:bodyPr/>
+          <a:lstStyle/>
+          <a:p>
+            <a:r>
+              <a:rPr lang="en-US" sz="900"/>
+              <a:t>triangle</a:t>
+            </a:r>
+          </a:p>
+        </p:txBody>
+      </p:sp>
+      <p:sp>
+        <p:nvSpPr>
+          <p:cNvPr id="0" name="prst_diamond"/>
+          <p:cNvSpPr/>
+          <p:nvPr/>
+        </p:nvSpPr>
+        <p:spPr>
+          <a:xfrm>
+            <a:off x="1981200" y="457200"/>
+            <a:ext cx="1143000" cy="1143000"/>
+          </a:xfrm>
+          <a:prstGeom prst="diamond">
+            <a:avLst/>
+          </a:prstGeom>
+          <a:solidFill>
+            <a:srgbClr val="4ECDC4"/>
+          </a:solidFill>
+          <a:ln w="12700">
+            <a:solidFill>
+              <a:srgbClr val="333333"/>
+            </a:solidFill>
+          </a:ln>
+        </p:spPr>
+        <p:txBody>
+          <a:bodyPr/>
+          <a:lstStyle/>
+          <a:p>
+            <a:r>
+              <a:rPr lang="en-US" sz="900"/>
+              <a:t>diamond</a:t>
+            </a:r>
+          </a:p>
+        </p:txBody>
+      </p:sp>
+      <p:sp>
+        <p:nvSpPr>
+          <p:cNvPr id="0" name="prst_pentagon"/>
+          <p:cNvSpPr/>
+          <p:nvPr/>
+        </p:nvSpPr>
+        <p:spPr>
+          <a:xfrm>
+            <a:off x="3505200" y="457200"/>
+            <a:ext cx="1143000" cy="1143000"/>
+          </a:xfrm>
+          <a:prstGeom prst="pentagon">
+            <a:avLst/>
+          </a:prstGeom>
+          <a:solidFill>
+            <a:srgbClr val="FFD93D"/>
+          </a:solidFill>
+          <a:ln w="12700">
+            <a:solidFill>
+              <a:srgbClr val="333333"/>
+            </a:solidFill>
+          </a:ln>
+        </p:spPr>
+        <p:txBody>
+          <a:bodyPr/>
+          <a:lstStyle/>
+          <a:p>
+            <a:r>
+              <a:rPr lang="en-US" sz="900"/>
+              <a:t>pentagon</a:t>
+            </a:r>
+          </a:p>
+        </p:txBody>
+      </p:sp>
+      <p:sp>
+        <p:nvSpPr>
+          <p:cNvPr id="0" name="prst_hexagon"/>
+          <p:cNvSpPr/>
+          <p:nvPr/>
+        </p:nvSpPr>
+        <p:spPr>
+          <a:xfrm>
+            <a:off x="5029200" y="457200"/>
+            <a:ext cx="1143000" cy="1143000"/>
+          </a:xfrm>
+          <a:prstGeom prst="hexagon">
+            <a:avLst/>
+          </a:prstGeom>
+          <a:solidFill>
+            <a:srgbClr val="6C5CE7"/>
+          </a:solidFill>
+          <a:ln w="12700">
+            <a:solidFill>
+              <a:srgbClr val="333333"/>
+            </a:solidFill>
+          </a:ln>
+        </p:spPr>
+        <p:txBody>
+          <a:bodyPr/>
+          <a:lstStyle/>
+          <a:p>
+            <a:r>
+              <a:rPr lang="en-US" sz="900"/>
+              <a:t>hexagon</a:t>
+            </a:r>
+          </a:p>
+        </p:txBody>
+      </p:sp>
+      <p:sp>
+        <p:nvSpPr>
+          <p:cNvPr id="0" name="prst_rightArrow"/>
+          <p:cNvSpPr/>
+          <p:nvPr/>
+        </p:nvSpPr>
+        <p:spPr>
+          <a:xfrm>
+            <a:off x="6553200" y="457200"/>
+            <a:ext cx="1143000" cy="1143000"/>
+          </a:xfrm>
+          <a:prstGeom prst="rightArrow">
+            <a:avLst/>
+          </a:prstGeom>
+          <a:solidFill>
+            <a:srgbClr val="74B9FF"/>
+          </a:solidFill>
+          <a:ln w="12700">
+            <a:solidFill>
+              <a:srgbClr val="333333"/>
+            </a:solidFill>
+          </a:ln>
+        </p:spPr>
+        <p:txBody>
+          <a:bodyPr/>
+          <a:lstStyle/>
+          <a:p>
+            <a:r>
+              <a:rPr lang="en-US" sz="900"/>
+              <a:t>rightArrow</a:t>
+            </a:r>
+          </a:p>
+        </p:txBody>
+      </p:sp>
+      <p:sp>
+        <p:nvSpPr>
+          <p:cNvPr id="0" name="prst_star5"/>
+          <p:cNvSpPr/>
+          <p:nvPr/>
+        </p:nvSpPr>
+        <p:spPr>
+          <a:xfrm>
+            <a:off x="8077200" y="457200"/>
+            <a:ext cx="1143000" cy="1143000"/>
+          </a:xfrm>
+          <a:prstGeom prst="star5">
+            <a:avLst/>
+          </a:prstGeom>
+          <a:solidFill>
+            <a:srgbClr val="FDCB6E"/>
+          </a:solidFill>
+          <a:ln w="12700">
+            <a:solidFill>
+              <a:srgbClr val="333333"/>
+            </a:solidFill>
+          </a:ln>
+        </p:spPr>
+        <p:txBody>
+          <a:bodyPr/>
+          <a:lstStyle/>
+          <a:p>
+            <a:r>
+              <a:rPr lang="en-US" sz="900"/>
+              <a:t>star5</a:t>
+            </a:r>
+          </a:p>
+        </p:txBody>
+      </p:sp>
+      <p:sp>
+        <p:nvSpPr>
+          <p:cNvPr id="0" name="prst_heart"/>
+          <p:cNvSpPr/>
+          <p:nvPr/>
+        </p:nvSpPr>
+        <p:spPr>
+          <a:xfrm>
+            <a:off x="457200" y="2286000"/>
+            <a:ext cx="1143000" cy="1143000"/>
+          </a:xfrm>
+          <a:prstGeom prst="heart">
+            <a:avLst/>
+          </a:prstGeom>
+          <a:solidFill>
+            <a:srgbClr val="E17055"/>
+          </a:solidFill>
+          <a:ln w="12700">
+            <a:solidFill>
+              <a:srgbClr val="333333"/>
+            </a:solidFill>
+          </a:ln>
+        </p:spPr>
+        <p:txBody>
+          <a:bodyPr/>
+          <a:lstStyle/>
+          <a:p>
+            <a:r>
+              <a:rPr lang="en-US" sz="900"/>
+              <a:t>heart</a:t>
+            </a:r>
+          </a:p>
+        </p:txBody>
+      </p:sp>
+      <p:sp>
+        <p:nvSpPr>
+          <p:cNvPr id="0" name="prst_plus"/>
+          <p:cNvSpPr/>
+          <p:nvPr/>
+        </p:nvSpPr>
+        <p:spPr>
+          <a:xfrm>
+            <a:off x="1981200" y="2286000"/>
+            <a:ext cx="1143000" cy="1143000"/>
+          </a:xfrm>
+          <a:prstGeom prst="plus">
+            <a:avLst/>
+          </a:prstGeom>
+          <a:solidFill>
+            <a:srgbClr val="00CEC9"/>
+          </a:solidFill>
+          <a:ln w="12700">
+            <a:solidFill>
+              <a:srgbClr val="333333"/>
+            </a:solidFill>
+          </a:ln>
+        </p:spPr>
+        <p:txBody>
+          <a:bodyPr/>
+          <a:lstStyle/>
+          <a:p>
+            <a:r>
+              <a:rPr lang="en-US" sz="900"/>
+              <a:t>plus</a:t>
+            </a:r>
+          </a:p>
+        </p:txBody>
+      </p:sp>
+      <p:sp>
+        <p:nvSpPr>
+          <p:cNvPr id="0" name="prst_flowChartDecision"/>
+          <p:cNvSpPr/>
+          <p:nvPr/>
+        </p:nvSpPr>
+        <p:spPr>
+          <a:xfrm>
+            <a:off x="3505200" y="2286000"/>
+            <a:ext cx="1143000" cy="1143000"/>
+          </a:xfrm>
+          <a:prstGeom prst="flowChartDecision">
+            <a:avLst/>
+          </a:prstGeom>
+          <a:solidFill>
+            <a:srgbClr val="A29BFE"/>
+          </a:solidFill>
+          <a:ln w="12700">
+            <a:solidFill>
+              <a:srgbClr val="333333"/>
+            </a:solidFill>
+          </a:ln>
+        </p:spPr>
+        <p:txBody>
+          <a:bodyPr/>
+          <a:lstStyle/>
+          <a:p>
+            <a:r>
+              <a:rPr lang="en-US" sz="900"/>
+              <a:t>flowChartDecision</a:t>
+            </a:r>
+          </a:p>
+        </p:txBody>
+      </p:sp>
+      <p:sp>
+        <p:nvSpPr>
+          <p:cNvPr id="0" name="prst_chevron"/>
+          <p:cNvSpPr/>
+          <p:nvPr/>
+        </p:nvSpPr>
+        <p:spPr>
+          <a:xfrm>
+            <a:off x="5029200" y="2286000"/>
+            <a:ext cx="1143000" cy="1143000"/>
+          </a:xfrm>
+          <a:prstGeom prst="chevron">
+            <a:avLst/>
+          </a:prstGeom>
+          <a:solidFill>
+            <a:srgbClr val="55EFC4"/>
+          </a:solidFill>
+          <a:ln w="12700">
+            <a:solidFill>
+              <a:srgbClr val="333333"/>
+            </a:solidFill>
+          </a:ln>
+        </p:spPr>
+        <p:txBody>
+          <a:bodyPr/>
+          <a:lstStyle/>
+          <a:p>
+            <a:r>
+              <a:rPr lang="en-US" sz="900"/>
+              <a:t>chevron</a:t>
+            </a:r>
+          </a:p>
+        </p:txBody>
+      </p:sp>
+      <p:sp>
+        <p:nvSpPr>
+          <p:cNvPr id="0" name="prst_parallelogram"/>
+          <p:cNvSpPr/>
+          <p:nvPr/>
+        </p:nvSpPr>
+        <p:spPr>
+          <a:xfrm>
+            <a:off x="6553200" y="2286000"/>
+            <a:ext cx="1143000" cy="1143000"/>
+          </a:xfrm>
+          <a:prstGeom prst="parallelogram">
+            <a:avLst/>
+          </a:prstGeom>
+          <a:solidFill>
+            <a:srgbClr val="FF7675"/>
+          </a:solidFill>
+          <a:ln w="12700">
+            <a:solidFill>
+              <a:srgbClr val="333333"/>
+            </a:solidFill>
+          </a:ln>
+        </p:spPr>
+        <p:txBody>
+          <a:bodyPr/>
+          <a:lstStyle/>
+          <a:p>
+            <a:r>
+              <a:rPr lang="en-US" sz="900"/>
+              <a:t>parallelogram</a:t>
+            </a:r>
+          </a:p>
+        </p:txBody>
+      </p:sp>
+      <p:sp>
+        <p:nvSpPr>
+          <p:cNvPr id="0" name="prst_octagon"/>
+          <p:cNvSpPr/>
+          <p:nvPr/>
+        </p:nvSpPr>
+        <p:spPr>
+          <a:xfrm>
+            <a:off x="8077200" y="2286000"/>
+            <a:ext cx="1143000" cy="1143000"/>
+          </a:xfrm>
+          <a:prstGeom prst="octagon">
+            <a:avLst/>
+          </a:prstGeom>
+          <a:solidFill>
+            <a:srgbClr val="FFEAA7"/>
+          </a:solidFill>
+          <a:ln w="12700">
+            <a:solidFill>
+              <a:srgbClr val="333333"/>
+            </a:solidFill>
+          </a:ln>
+        </p:spPr>
+        <p:txBody>
+          <a:bodyPr/>
+          <a:lstStyle/>
+          <a:p>
+            <a:r>
+              <a:rPr lang="en-US" sz="900"/>
+              <a:t>octagon</a:t>
+            </a:r>
+          </a:p>
+        </p:txBody>
+      </p:sp>
+      <p:sp>
+        <p:nvSpPr>
+          <p:cNvPr id="0" name="rightArrow_adj"/>
+          <p:cNvSpPr/>
+          <p:nvPr/>
+        </p:nvSpPr>
+        <p:spPr>
+          <a:xfrm>
+            <a:off x="457200" y="4114800"/>
+            <a:ext cx="2286000" cy="914400"/>
+          </a:xfrm>
+          <a:prstGeom prst="rightArrow">
+            <a:avLst>
+              <a:gd name="adj1" fmla="val 70000"/>
+              <a:gd name="adj2" fmla="val 30000"/>
+            </a:avLst>
+          </a:prstGeom>
+          <a:solidFill>
+            <a:srgbClr val="74B9FF"/>
+          </a:solidFill>
+          <a:ln w="12700">
+            <a:solidFill>
+              <a:srgbClr val="333333"/>
+            </a:solidFill>
+          </a:ln>
+        </p:spPr>
+        <p:txBody>
+          <a:bodyPr/>
+          <a:lstStyle/>
+          <a:p>
+            <a:r>
+              <a:rPr lang="en-US" sz="900"/>
+              <a:t>rightArrow</a:t>
+            </a:r>
+          </a:p>
+        </p:txBody>
+      </p:sp>
+      <p:sp>
+        <p:nvSpPr>
+          <p:cNvPr id="0" name="star5_adj"/>
+          <p:cNvSpPr/>
+          <p:nvPr/>
+        </p:nvSpPr>
+        <p:spPr>
+          <a:xfrm>
+            <a:off x="3200400" y="4114800"/>
+            <a:ext cx="1143000" cy="1143000"/>
+          </a:xfrm>
+          <a:prstGeom prst="star5">
+            <a:avLst>
+              <a:gd name="adj" fmla="val 40000"/>
+            </a:avLst>
+          </a:prstGeom>
+          <a:solidFill>
+            <a:srgbClr val="FDCB6E"/>
+          </a:solidFill>
+          <a:ln w="12700">
+            <a:solidFill>
+              <a:srgbClr val="333333"/>
+            </a:solidFill>
+          </a:ln>
+        </p:spPr>
+        <p:txBody>
+          <a:bodyPr/>
+          <a:lstStyle/>
+          <a:p>
+            <a:r>
+              <a:rPr lang="en-US" sz="900"/>
+              <a:t>star5</a:t>
+            </a:r>
+          </a:p>
+        </p:txBody>
+      </p:sp>
+      <p:sp>
+        <p:nvSpPr>
+          <p:cNvPr id="2" name="TextBox 1"/>
+          <p:cNvSpPr txBox="1"/>
+          <p:nvPr/>
+        </p:nvSpPr>
+        <p:spPr>
+          <a:xfrm>
+            <a:off x="274320" y="5943600"/>
+            <a:ext cx="8229600" cy="457200"/>
+          </a:xfrm>
+          <a:prstGeom prst="rect">
+            <a:avLst/>
+          </a:prstGeom>
+          <a:noFill/>
+        </p:spPr>
+        <p:txBody>
+          <a:bodyPr wrap="none">
+            <a:spAutoFit/>
+          </a:bodyPr>
+          <a:lstStyle/>
+          <a:p>
+            <a:pPr>
+              <a:defRPr sz="1000">
+                <a:solidFill>
+                  <a:srgbClr val="646464"/>
+                </a:solidFill>
+              </a:defRPr>
+            </a:pPr>
+            <a:r>
+              <a:t>Preset geometry: triangle, diamond, pentagon, hexagon, rightArrow, star5, heart, plus, flowChartDecision, chevron, parallelogram, octagon</a:t>
             </a:r>
           </a:p>
         </p:txBody>

</xml_diff>

<commit_message>
feat: add custom geometry + 63 new preset shapes (91→154)
- Implement a:custGeom parsing, rendering, and round-trip (avLst/gdLst/pathLst)
- Add 63 preset shapes: stars, flowcharts, callouts, block arrows, action buttons
- Extract shared split_by_space to xml package, removing duplicates
- Add test slide 37 with custom geometry shapes

Co-Authored-By: Claude Opus 4.6 <noreply@anthropic.com>
</commit_message>
<xml_diff>
--- a/test_fixtures/test_features.pptx
+++ b/test_fixtures/test_features.pptx
@@ -41,6 +41,7 @@
     <p:sldId id="289" r:id="rId40"/>
     <p:sldId id="290" r:id="rId41"/>
     <p:sldId id="291" r:id="rId42"/>
+    <p:sldId id="292" r:id="rId43"/>
   </p:sldIdLst>
   <p:sldSz cx="9144000" cy="6858000" type="screen4x3"/>
   <p:notesSz cx="6858000" cy="9144000"/>
@@ -9125,6 +9126,204 @@
             </a:pPr>
             <a:r>
               <a:t>Preset geometry: triangle, diamond, pentagon, hexagon, rightArrow, star5, heart, plus, flowChartDecision, chevron, parallelogram, octagon</a:t>
+            </a:r>
+          </a:p>
+        </p:txBody>
+      </p:sp>
+    </p:spTree>
+  </p:cSld>
+  <p:clrMapOvr>
+    <a:masterClrMapping/>
+  </p:clrMapOvr>
+</p:sld>
+</file>
+
+<file path=ppt/slides/slide37.xml><?xml version="1.0" encoding="utf-8"?>
+<p:sld xmlns:a="http://schemas.openxmlformats.org/drawingml/2006/main" xmlns:p="http://schemas.openxmlformats.org/presentationml/2006/main" xmlns:r="http://schemas.openxmlformats.org/officeDocument/2006/relationships">
+  <p:cSld>
+    <p:spTree>
+      <p:nvGrpSpPr>
+        <p:cNvPr id="1" name=""/>
+        <p:cNvGrpSpPr/>
+        <p:nvPr/>
+      </p:nvGrpSpPr>
+      <p:grpSpPr/>
+      <p:sp>
+        <p:nvSpPr>
+          <p:cNvPr id="100" name="CustomStar"/>
+          <p:cNvSpPr/>
+          <p:nvPr/>
+        </p:nvSpPr>
+        <p:spPr>
+          <a:xfrm>
+            <a:off x="457200" y="457200"/>
+            <a:ext cx="1828800" cy="1828800"/>
+          </a:xfrm>
+          <a:custGeom>
+            <a:avLst/>
+            <a:gdLst/>
+            <a:pathLst>
+              <a:path w="200" h="200">
+                <a:moveTo>
+                  <a:pt x="100" y="0"/>
+                </a:moveTo>
+                <a:lnTo>
+                  <a:pt x="130" y="70"/>
+                </a:lnTo>
+                <a:lnTo>
+                  <a:pt x="200" y="80"/>
+                </a:lnTo>
+                <a:lnTo>
+                  <a:pt x="150" y="130"/>
+                </a:lnTo>
+                <a:lnTo>
+                  <a:pt x="160" y="200"/>
+                </a:lnTo>
+                <a:lnTo>
+                  <a:pt x="100" y="170"/>
+                </a:lnTo>
+                <a:lnTo>
+                  <a:pt x="40" y="200"/>
+                </a:lnTo>
+                <a:lnTo>
+                  <a:pt x="50" y="130"/>
+                </a:lnTo>
+                <a:lnTo>
+                  <a:pt x="0" y="80"/>
+                </a:lnTo>
+                <a:lnTo>
+                  <a:pt x="70" y="70"/>
+                </a:lnTo>
+                <a:close/>
+              </a:path>
+            </a:pathLst>
+          </a:custGeom>
+          <a:solidFill>
+            <a:srgbClr val="FFD700"/>
+          </a:solidFill>
+          <a:ln w="19050">
+            <a:solidFill>
+              <a:srgbClr val="B8860B"/>
+            </a:solidFill>
+          </a:ln>
+        </p:spPr>
+      </p:sp>
+      <p:sp>
+        <p:nvSpPr>
+          <p:cNvPr id="101" name="CustomCurve"/>
+          <p:cNvSpPr/>
+          <p:nvPr/>
+        </p:nvSpPr>
+        <p:spPr>
+          <a:xfrm>
+            <a:off x="2743200" y="457200"/>
+            <a:ext cx="1828800" cy="1828800"/>
+          </a:xfrm>
+          <a:custGeom>
+            <a:avLst/>
+            <a:gdLst/>
+            <a:pathLst>
+              <a:path w="100" h="100">
+                <a:moveTo>
+                  <a:pt x="0" y="100"/>
+                </a:moveTo>
+                <a:cubicBezTo>
+                  <a:pt x="0" y="0"/>
+                  <a:pt x="100" y="0"/>
+                  <a:pt x="100" y="100"/>
+                </a:cubicBezTo>
+                <a:close/>
+              </a:path>
+            </a:pathLst>
+          </a:custGeom>
+          <a:solidFill>
+            <a:srgbClr val="87CEEB"/>
+          </a:solidFill>
+          <a:ln w="12700">
+            <a:solidFill>
+              <a:srgbClr val="4169E1"/>
+            </a:solidFill>
+          </a:ln>
+        </p:spPr>
+      </p:sp>
+      <p:sp>
+        <p:nvSpPr>
+          <p:cNvPr id="102" name="CustomGuide"/>
+          <p:cNvSpPr/>
+          <p:nvPr/>
+        </p:nvSpPr>
+        <p:spPr>
+          <a:xfrm>
+            <a:off x="5029200" y="457200"/>
+            <a:ext cx="1828800" cy="1828800"/>
+          </a:xfrm>
+          <a:custGeom>
+            <a:avLst>
+              <a:gd name="adj" fmla="val 50000"/>
+            </a:avLst>
+            <a:gdLst>
+              <a:gd name="x1" fmla="*/ w adj 100000"/>
+              <a:gd name="y1" fmla="*/ h adj 100000"/>
+            </a:gdLst>
+            <a:pathLst>
+              <a:path>
+                <a:moveTo>
+                  <a:pt x="0" y="0"/>
+                </a:moveTo>
+                <a:lnTo>
+                  <a:pt x="x1" y="0"/>
+                </a:lnTo>
+                <a:lnTo>
+                  <a:pt x="x1" y="y1"/>
+                </a:lnTo>
+                <a:lnTo>
+                  <a:pt x="0" y="y1"/>
+                </a:lnTo>
+                <a:close/>
+              </a:path>
+            </a:pathLst>
+          </a:custGeom>
+          <a:solidFill>
+            <a:srgbClr val="98FB98"/>
+          </a:solidFill>
+          <a:ln w="12700">
+            <a:solidFill>
+              <a:srgbClr val="228B22"/>
+            </a:solidFill>
+          </a:ln>
+        </p:spPr>
+      </p:sp>
+      <p:sp>
+        <p:nvSpPr>
+          <p:cNvPr id="103" name="TextBox 102"/>
+          <p:cNvSpPr txBox="1"/>
+          <p:nvPr/>
+        </p:nvSpPr>
+        <p:spPr>
+          <a:xfrm>
+            <a:off x="274320" y="5943600"/>
+            <a:ext cx="8229600" cy="457200"/>
+          </a:xfrm>
+          <a:prstGeom prst="rect">
+            <a:avLst/>
+          </a:prstGeom>
+          <a:noFill/>
+        </p:spPr>
+        <p:txBody>
+          <a:bodyPr wrap="none">
+            <a:spAutoFit/>
+          </a:bodyPr>
+          <a:lstStyle/>
+          <a:p>
+            <a:pPr>
+              <a:defRPr sz="1000">
+                <a:solidFill>
+                  <a:srgbClr val="646464"/>
+                </a:solidFill>
+              </a:defRPr>
+            </a:pPr>
+            <a:r>
+              <a:t>Custom geometry (a:custGeom): freeform star, bezier curve, guide-based rect</a:t>
             </a:r>
           </a:p>
         </p:txBody>

</xml_diff>

<commit_message>
feat: complete section 5 — gear teeth, text rect, connection points
- gear6/gear9: accurate tooth paths with 6/9 teeth, center holes, adjustable depth
- a:rect: text rectangle computation for non-rectangular shapes (triangle, diamond, arrows, stars, etc.)
- a:cxnLst: parse connection points in custom geometry + round-trip
- stCxn/endCxn: parse connector endpoint references (shape id + index)
- p:cxnSp: serialize connectors with connection refs
- Extract serialize_stroke as reusable function
- Add test slides 38-40 (gear shapes, text rects, connection points)

Co-Authored-By: Claude Opus 4.6 <noreply@anthropic.com>
</commit_message>
<xml_diff>
--- a/test_fixtures/test_features.pptx
+++ b/test_fixtures/test_features.pptx
@@ -42,6 +42,9 @@
     <p:sldId id="290" r:id="rId41"/>
     <p:sldId id="291" r:id="rId42"/>
     <p:sldId id="292" r:id="rId43"/>
+    <p:sldId id="293" r:id="rId44"/>
+    <p:sldId id="294" r:id="rId45"/>
+    <p:sldId id="295" r:id="rId46"/>
   </p:sldIdLst>
   <p:sldSz cx="9144000" cy="6858000" type="screen4x3"/>
   <p:notesSz cx="6858000" cy="9144000"/>
@@ -9336,6 +9339,291 @@
 </p:sld>
 </file>
 
+<file path=ppt/slides/slide38.xml><?xml version="1.0" encoding="utf-8"?>
+<p:sld xmlns:a="http://schemas.openxmlformats.org/drawingml/2006/main" xmlns:p="http://schemas.openxmlformats.org/presentationml/2006/main" xmlns:r="http://schemas.openxmlformats.org/officeDocument/2006/relationships">
+  <p:cSld>
+    <p:spTree>
+      <p:nvGrpSpPr>
+        <p:cNvPr id="1" name=""/>
+        <p:cNvGrpSpPr/>
+        <p:nvPr/>
+      </p:nvGrpSpPr>
+      <p:grpSpPr/>
+      <p:sp>
+        <p:nvSpPr>
+          <p:cNvPr id="201" name="Gear6"/>
+          <p:cNvSpPr/>
+          <p:nvPr/>
+        </p:nvSpPr>
+        <p:spPr>
+          <a:xfrm>
+            <a:off x="457200" y="457200"/>
+            <a:ext cx="2286000" cy="2286000"/>
+          </a:xfrm>
+          <a:prstGeom prst="gear6">
+            <a:avLst/>
+          </a:prstGeom>
+          <a:solidFill>
+            <a:srgbClr val="4472C4"/>
+          </a:solidFill>
+          <a:ln w="12700">
+            <a:solidFill>
+              <a:srgbClr val="2F528F"/>
+            </a:solidFill>
+          </a:ln>
+        </p:spPr>
+      </p:sp>
+      <p:sp>
+        <p:nvSpPr>
+          <p:cNvPr id="202" name="Gear9"/>
+          <p:cNvSpPr/>
+          <p:nvPr/>
+        </p:nvSpPr>
+        <p:spPr>
+          <a:xfrm>
+            <a:off x="3429000" y="457200"/>
+            <a:ext cx="2286000" cy="2286000"/>
+          </a:xfrm>
+          <a:prstGeom prst="gear9">
+            <a:avLst/>
+          </a:prstGeom>
+          <a:solidFill>
+            <a:srgbClr val="ED7D31"/>
+          </a:solidFill>
+          <a:ln w="12700">
+            <a:solidFill>
+              <a:srgbClr val="AE5A21"/>
+            </a:solidFill>
+          </a:ln>
+        </p:spPr>
+      </p:sp>
+      <p:sp>
+        <p:nvSpPr>
+          <p:cNvPr id="203" name="Gear6Deep"/>
+          <p:cNvSpPr/>
+          <p:nvPr/>
+        </p:nvSpPr>
+        <p:spPr>
+          <a:xfrm>
+            <a:off x="6400800" y="457200"/>
+            <a:ext cx="2286000" cy="2286000"/>
+          </a:xfrm>
+          <a:prstGeom prst="gear6">
+            <a:avLst>
+              <a:gd name="adj" fmla="val 50000"/>
+            </a:avLst>
+          </a:prstGeom>
+          <a:solidFill>
+            <a:srgbClr val="70AD47"/>
+          </a:solidFill>
+          <a:ln w="12700">
+            <a:solidFill>
+              <a:srgbClr val="507E32"/>
+            </a:solidFill>
+          </a:ln>
+        </p:spPr>
+      </p:sp>
+      <p:sp>
+        <p:nvSpPr>
+          <p:cNvPr id="204" name="TextBox 203"/>
+          <p:cNvSpPr txBox="1"/>
+          <p:nvPr/>
+        </p:nvSpPr>
+        <p:spPr>
+          <a:xfrm>
+            <a:off x="274320" y="5943600"/>
+            <a:ext cx="8229600" cy="457200"/>
+          </a:xfrm>
+          <a:prstGeom prst="rect">
+            <a:avLst/>
+          </a:prstGeom>
+          <a:noFill/>
+        </p:spPr>
+        <p:txBody>
+          <a:bodyPr wrap="none">
+            <a:spAutoFit/>
+          </a:bodyPr>
+          <a:lstStyle/>
+          <a:p>
+            <a:pPr>
+              <a:defRPr sz="1000">
+                <a:solidFill>
+                  <a:srgbClr val="646464"/>
+                </a:solidFill>
+              </a:defRPr>
+            </a:pPr>
+            <a:r>
+              <a:t>Gear shapes: gear6 (default), gear9 (default), gear6 (adj=50000 deeper teeth)</a:t>
+            </a:r>
+          </a:p>
+        </p:txBody>
+      </p:sp>
+    </p:spTree>
+  </p:cSld>
+  <p:clrMapOvr>
+    <a:masterClrMapping/>
+  </p:clrMapOvr>
+</p:sld>
+</file>
+
+<file path=ppt/slides/slide39.xml><?xml version="1.0" encoding="utf-8"?>
+<p:sld xmlns:a="http://schemas.openxmlformats.org/drawingml/2006/main" xmlns:p="http://schemas.openxmlformats.org/presentationml/2006/main" xmlns:r="http://schemas.openxmlformats.org/officeDocument/2006/relationships">
+  <p:cSld>
+    <p:spTree>
+      <p:nvGrpSpPr>
+        <p:cNvPr id="1" name=""/>
+        <p:cNvGrpSpPr/>
+        <p:nvPr/>
+      </p:nvGrpSpPr>
+      <p:grpSpPr/>
+      <p:sp>
+        <p:nvSpPr>
+          <p:cNvPr id="301" name="Triangle"/>
+          <p:cNvSpPr/>
+          <p:nvPr/>
+        </p:nvSpPr>
+        <p:spPr>
+          <a:xfrm>
+            <a:off x="457200" y="457200"/>
+            <a:ext cx="2286000" cy="2286000"/>
+          </a:xfrm>
+          <a:prstGeom prst="triangle">
+            <a:avLst/>
+          </a:prstGeom>
+          <a:solidFill>
+            <a:srgbClr val="FFD700"/>
+          </a:solidFill>
+          <a:ln w="12700">
+            <a:solidFill>
+              <a:srgbClr val="B8860B"/>
+            </a:solidFill>
+          </a:ln>
+        </p:spPr>
+        <p:txBody>
+          <a:bodyPr anchor="ctr"/>
+          <a:lstStyle/>
+          <a:p>
+            <a:pPr algn="ctr"/>
+            <a:r>
+              <a:rPr lang="en-US" sz="1400"/>
+              <a:t>Text in Triangle</a:t>
+            </a:r>
+          </a:p>
+        </p:txBody>
+      </p:sp>
+      <p:sp>
+        <p:nvSpPr>
+          <p:cNvPr id="302" name="Diamond"/>
+          <p:cNvSpPr/>
+          <p:nvPr/>
+        </p:nvSpPr>
+        <p:spPr>
+          <a:xfrm>
+            <a:off x="3429000" y="457200"/>
+            <a:ext cx="2286000" cy="2286000"/>
+          </a:xfrm>
+          <a:prstGeom prst="diamond">
+            <a:avLst/>
+          </a:prstGeom>
+          <a:solidFill>
+            <a:srgbClr val="87CEEB"/>
+          </a:solidFill>
+          <a:ln w="12700">
+            <a:solidFill>
+              <a:srgbClr val="4682B4"/>
+            </a:solidFill>
+          </a:ln>
+        </p:spPr>
+        <p:txBody>
+          <a:bodyPr anchor="ctr"/>
+          <a:lstStyle/>
+          <a:p>
+            <a:pPr algn="ctr"/>
+            <a:r>
+              <a:rPr lang="en-US" sz="1400"/>
+              <a:t>Diamond</a:t>
+            </a:r>
+          </a:p>
+        </p:txBody>
+      </p:sp>
+      <p:sp>
+        <p:nvSpPr>
+          <p:cNvPr id="303" name="RightArrow"/>
+          <p:cNvSpPr/>
+          <p:nvPr/>
+        </p:nvSpPr>
+        <p:spPr>
+          <a:xfrm>
+            <a:off x="6400800" y="914400"/>
+            <a:ext cx="2743200" cy="1371600"/>
+          </a:xfrm>
+          <a:prstGeom prst="rightArrow">
+            <a:avLst/>
+          </a:prstGeom>
+          <a:solidFill>
+            <a:srgbClr val="FF6347"/>
+          </a:solidFill>
+          <a:ln w="12700">
+            <a:solidFill>
+              <a:srgbClr val="8B0000"/>
+            </a:solidFill>
+          </a:ln>
+        </p:spPr>
+        <p:txBody>
+          <a:bodyPr anchor="ctr"/>
+          <a:lstStyle/>
+          <a:p>
+            <a:pPr algn="ctr"/>
+            <a:r>
+              <a:rPr lang="en-US" sz="1400"/>
+              <a:t>Arrow</a:t>
+            </a:r>
+          </a:p>
+        </p:txBody>
+      </p:sp>
+      <p:sp>
+        <p:nvSpPr>
+          <p:cNvPr id="304" name="TextBox 303"/>
+          <p:cNvSpPr txBox="1"/>
+          <p:nvPr/>
+        </p:nvSpPr>
+        <p:spPr>
+          <a:xfrm>
+            <a:off x="274320" y="5943600"/>
+            <a:ext cx="8229600" cy="457200"/>
+          </a:xfrm>
+          <a:prstGeom prst="rect">
+            <a:avLst/>
+          </a:prstGeom>
+          <a:noFill/>
+        </p:spPr>
+        <p:txBody>
+          <a:bodyPr wrap="none">
+            <a:spAutoFit/>
+          </a:bodyPr>
+          <a:lstStyle/>
+          <a:p>
+            <a:pPr>
+              <a:defRPr sz="1000">
+                <a:solidFill>
+                  <a:srgbClr val="646464"/>
+                </a:solidFill>
+              </a:defRPr>
+            </a:pPr>
+            <a:r>
+              <a:t>Text rectangles: triangle (text in lower half), diamond (text inscribed), right arrow (text in shaft)</a:t>
+            </a:r>
+          </a:p>
+        </p:txBody>
+      </p:sp>
+    </p:spTree>
+  </p:cSld>
+  <p:clrMapOvr>
+    <a:masterClrMapping/>
+  </p:clrMapOvr>
+</p:sld>
+</file>
+
 <file path=ppt/slides/slide4.xml><?xml version="1.0" encoding="utf-8"?>
 <p:sld xmlns:a="http://schemas.openxmlformats.org/drawingml/2006/main" xmlns:p="http://schemas.openxmlformats.org/presentationml/2006/main" xmlns:r="http://schemas.openxmlformats.org/officeDocument/2006/relationships">
   <p:cSld>
@@ -9452,6 +9740,209 @@
             <a:r>
               <a:rPr b="1" i="1" u="sng" sz="1800"/>
               <a:t>BoldItalicUnderline</a:t>
+            </a:r>
+          </a:p>
+        </p:txBody>
+      </p:sp>
+    </p:spTree>
+  </p:cSld>
+  <p:clrMapOvr>
+    <a:masterClrMapping/>
+  </p:clrMapOvr>
+</p:sld>
+</file>
+
+<file path=ppt/slides/slide40.xml><?xml version="1.0" encoding="utf-8"?>
+<p:sld xmlns:a="http://schemas.openxmlformats.org/drawingml/2006/main" xmlns:p="http://schemas.openxmlformats.org/presentationml/2006/main" xmlns:r="http://schemas.openxmlformats.org/officeDocument/2006/relationships">
+  <p:cSld>
+    <p:spTree>
+      <p:nvGrpSpPr>
+        <p:cNvPr id="1" name=""/>
+        <p:cNvGrpSpPr/>
+        <p:nvPr/>
+      </p:nvGrpSpPr>
+      <p:grpSpPr/>
+      <p:sp>
+        <p:nvSpPr>
+          <p:cNvPr id="401" name="Rect1"/>
+          <p:cNvSpPr/>
+          <p:nvPr/>
+        </p:nvSpPr>
+        <p:spPr>
+          <a:xfrm>
+            <a:off x="914400" y="914400"/>
+            <a:ext cx="1828800" cy="1371600"/>
+          </a:xfrm>
+          <a:prstGeom prst="rect">
+            <a:avLst/>
+          </a:prstGeom>
+          <a:solidFill>
+            <a:srgbClr val="4472C4"/>
+          </a:solidFill>
+        </p:spPr>
+        <p:txBody>
+          <a:bodyPr anchor="ctr"/>
+          <a:lstStyle/>
+          <a:p>
+            <a:pPr algn="ctr"/>
+            <a:r>
+              <a:rPr lang="en-US" sz="1400">
+                <a:solidFill>
+                  <a:srgbClr val="FFFFFF"/>
+                </a:solidFill>
+              </a:rPr>
+              <a:t>Start</a:t>
+            </a:r>
+          </a:p>
+        </p:txBody>
+      </p:sp>
+      <p:sp>
+        <p:nvSpPr>
+          <p:cNvPr id="402" name="Rect2"/>
+          <p:cNvSpPr/>
+          <p:nvPr/>
+        </p:nvSpPr>
+        <p:spPr>
+          <a:xfrm>
+            <a:off x="5486400" y="914400"/>
+            <a:ext cx="1828800" cy="1371600"/>
+          </a:xfrm>
+          <a:prstGeom prst="rect">
+            <a:avLst/>
+          </a:prstGeom>
+          <a:solidFill>
+            <a:srgbClr val="ED7D31"/>
+          </a:solidFill>
+        </p:spPr>
+        <p:txBody>
+          <a:bodyPr anchor="ctr"/>
+          <a:lstStyle/>
+          <a:p>
+            <a:pPr algn="ctr"/>
+            <a:r>
+              <a:rPr lang="en-US" sz="1400">
+                <a:solidFill>
+                  <a:srgbClr val="FFFFFF"/>
+                </a:solidFill>
+              </a:rPr>
+              <a:t>End</a:t>
+            </a:r>
+          </a:p>
+        </p:txBody>
+      </p:sp>
+      <p:cxnSp>
+        <p:nvCxnSpPr>
+          <p:cNvPr id="403" name="Connector"/>
+          <p:cNvCxnSpPr>
+            <a:stCxn id="401" idx="3"/>
+            <a:endCxn id="402" idx="1"/>
+          </p:cNvCxnSpPr>
+          <p:nvPr/>
+        </p:nvCxnSpPr>
+        <p:spPr>
+          <a:xfrm>
+            <a:off x="2743200" y="1600200"/>
+            <a:ext cx="2743200" cy="0"/>
+          </a:xfrm>
+          <a:prstGeom prst="straightConnector1">
+            <a:avLst/>
+          </a:prstGeom>
+          <a:ln w="25400">
+            <a:solidFill>
+              <a:srgbClr val="333333"/>
+            </a:solidFill>
+            <a:tailEnd type="triangle"/>
+          </a:ln>
+        </p:spPr>
+      </p:cxnSp>
+      <p:sp>
+        <p:nvSpPr>
+          <p:cNvPr id="404" name="CustomWithCxn"/>
+          <p:cNvSpPr/>
+          <p:nvPr/>
+        </p:nvSpPr>
+        <p:spPr>
+          <a:xfrm>
+            <a:off x="3200400" y="3429000"/>
+            <a:ext cx="2286000" cy="1828800"/>
+          </a:xfrm>
+          <a:custGeom>
+            <a:avLst/>
+            <a:gdLst/>
+            <a:cxnLst>
+              <a:cxn ang="0">
+                <a:pos x="r" y="vc"/>
+              </a:cxn>
+              <a:cxn ang="5400000">
+                <a:pos x="hc" y="b"/>
+              </a:cxn>
+              <a:cxn ang="10800000">
+                <a:pos x="l" y="vc"/>
+              </a:cxn>
+              <a:cxn ang="16200000">
+                <a:pos x="hc" y="t"/>
+              </a:cxn>
+            </a:cxnLst>
+            <a:rect l="l" t="t" r="r" b="b"/>
+            <a:pathLst>
+              <a:path w="100" h="100">
+                <a:moveTo>
+                  <a:pt x="50" y="0"/>
+                </a:moveTo>
+                <a:lnTo>
+                  <a:pt x="100" y="50"/>
+                </a:lnTo>
+                <a:lnTo>
+                  <a:pt x="50" y="100"/>
+                </a:lnTo>
+                <a:lnTo>
+                  <a:pt x="0" y="50"/>
+                </a:lnTo>
+                <a:close/>
+              </a:path>
+            </a:pathLst>
+          </a:custGeom>
+          <a:solidFill>
+            <a:srgbClr val="9370DB"/>
+          </a:solidFill>
+          <a:ln w="12700">
+            <a:solidFill>
+              <a:srgbClr val="4B0082"/>
+            </a:solidFill>
+          </a:ln>
+        </p:spPr>
+      </p:sp>
+      <p:sp>
+        <p:nvSpPr>
+          <p:cNvPr id="405" name="TextBox 404"/>
+          <p:cNvSpPr txBox="1"/>
+          <p:nvPr/>
+        </p:nvSpPr>
+        <p:spPr>
+          <a:xfrm>
+            <a:off x="274320" y="5943600"/>
+            <a:ext cx="8229600" cy="457200"/>
+          </a:xfrm>
+          <a:prstGeom prst="rect">
+            <a:avLst/>
+          </a:prstGeom>
+          <a:noFill/>
+        </p:spPr>
+        <p:txBody>
+          <a:bodyPr wrap="none">
+            <a:spAutoFit/>
+          </a:bodyPr>
+          <a:lstStyle/>
+          <a:p>
+            <a:pPr>
+              <a:defRPr sz="1000">
+                <a:solidFill>
+                  <a:srgbClr val="646464"/>
+                </a:solidFill>
+              </a:defRPr>
+            </a:pPr>
+            <a:r>
+              <a:t>Connection points: connector with stCxn/endCxn refs, custom geom with a:cxnLst</a:t>
             </a:r>
           </a:p>
         </p:txBody>

</xml_diff>

<commit_message>
feat: table cell merge, borders, margins, and anchor
Add four table features to complete section 6 core items:
- Cell merge: gridSpan (horizontal), rowSpan/vMerge (vertical)
- Cell borders: a:lnL/lnR/lnT/lnB with color and noFill support
- Cell margins: marL/marR/marT/marB with OOXML default fallback
- Cell anchor: vertical text alignment (top/center/bottom)

Full round-trip: parse → render → serialize for all new fields.
Test slide 41 added with 16 new assertions (442 total, all pass).

Co-Authored-By: Claude Opus 4.6 <noreply@anthropic.com>
</commit_message>
<xml_diff>
--- a/test_fixtures/test_features.pptx
+++ b/test_fixtures/test_features.pptx
@@ -45,6 +45,7 @@
     <p:sldId id="293" r:id="rId44"/>
     <p:sldId id="294" r:id="rId45"/>
     <p:sldId id="295" r:id="rId46"/>
+    <p:sldId id="296" r:id="rId47"/>
   </p:sldIdLst>
   <p:sldSz cx="9144000" cy="6858000" type="screen4x3"/>
   <p:notesSz cx="6858000" cy="9144000"/>
@@ -9943,6 +9944,361 @@
             </a:pPr>
             <a:r>
               <a:t>Connection points: connector with stCxn/endCxn refs, custom geom with a:cxnLst</a:t>
+            </a:r>
+          </a:p>
+        </p:txBody>
+      </p:sp>
+    </p:spTree>
+  </p:cSld>
+  <p:clrMapOvr>
+    <a:masterClrMapping/>
+  </p:clrMapOvr>
+</p:sld>
+</file>
+
+<file path=ppt/slides/slide41.xml><?xml version="1.0" encoding="utf-8"?>
+<p:sld xmlns:a="http://schemas.openxmlformats.org/drawingml/2006/main" xmlns:p="http://schemas.openxmlformats.org/presentationml/2006/main" xmlns:r="http://schemas.openxmlformats.org/officeDocument/2006/relationships">
+  <p:cSld>
+    <p:spTree>
+      <p:nvGrpSpPr>
+        <p:cNvPr id="1" name=""/>
+        <p:cNvGrpSpPr/>
+        <p:nvPr/>
+      </p:nvGrpSpPr>
+      <p:grpSpPr/>
+      <p:graphicFrame>
+        <p:nvGraphicFramePr>
+          <p:cNvPr id="100" name="Table41"/>
+          <p:cNvGraphicFramePr>
+            <a:graphicFrameLocks noGrp="1"/>
+          </p:cNvGraphicFramePr>
+          <p:nvPr/>
+        </p:nvGraphicFramePr>
+        <p:xfrm>
+          <a:off x="457200" y="457200"/>
+          <a:ext cx="8229600" cy="4572000"/>
+        </p:xfrm>
+        <a:graphic>
+          <a:graphicData uri="http://schemas.openxmlformats.org/drawingml/2006/table">
+            <a:tbl>
+              <a:tblPr firstRow="1" bandRow="1"/>
+              <a:tblGrid>
+                <a:gridCol w="2743200"/>
+                <a:gridCol w="2743200"/>
+                <a:gridCol w="2743200"/>
+              </a:tblGrid>
+              <!-- Row 1: horizontal merge (gridSpan=2) + custom borders -->
+              <a:tr h="914400">
+                <a:tc gridSpan="2">
+                  <a:txBody>
+                    <a:bodyPr/>
+                    <a:lstStyle/>
+                    <a:p>
+                      <a:r>
+                        <a:rPr lang="en-US" sz="1400" b="1"/>
+                        <a:t>Merged 2 cols</a:t>
+                      </a:r>
+                    </a:p>
+                  </a:txBody>
+                  <a:tcPr marL="182880" marR="91440" marT="91440" marB="45720" anchor="ctr">
+                    <a:lnL w="25400">
+                      <a:solidFill>
+                        <a:srgbClr val="FF0000"/>
+                      </a:solidFill>
+                    </a:lnL>
+                    <a:lnR w="25400">
+                      <a:solidFill>
+                        <a:srgbClr val="0000FF"/>
+                      </a:solidFill>
+                    </a:lnR>
+                    <a:lnT w="38100">
+                      <a:solidFill>
+                        <a:srgbClr val="00AA00"/>
+                      </a:solidFill>
+                    </a:lnT>
+                    <a:lnB w="12700">
+                      <a:solidFill>
+                        <a:srgbClr val="FF8800"/>
+                      </a:solidFill>
+                    </a:lnB>
+                    <a:solidFill>
+                      <a:srgbClr val="DDEEFF"/>
+                    </a:solidFill>
+                  </a:tcPr>
+                </a:tc>
+                <a:tc>
+                  <a:txBody>
+                    <a:bodyPr/>
+                    <a:lstStyle/>
+                    <a:p>
+                      <a:endParaRPr lang="en-US"/>
+                    </a:p>
+                  </a:txBody>
+                  <a:tcPr/>
+                </a:tc>
+                <a:tc>
+                  <a:txBody>
+                    <a:bodyPr/>
+                    <a:lstStyle/>
+                    <a:p>
+                      <a:r>
+                        <a:rPr lang="en-US" sz="1200"/>
+                        <a:t>Normal cell</a:t>
+                      </a:r>
+                    </a:p>
+                  </a:txBody>
+                  <a:tcPr anchor="b">
+                    <a:lnL w="12700">
+                      <a:solidFill>
+                        <a:srgbClr val="333333"/>
+                      </a:solidFill>
+                    </a:lnL>
+                    <a:lnR w="12700">
+                      <a:solidFill>
+                        <a:srgbClr val="333333"/>
+                      </a:solidFill>
+                    </a:lnR>
+                    <a:lnT w="12700">
+                      <a:solidFill>
+                        <a:srgbClr val="333333"/>
+                      </a:solidFill>
+                    </a:lnT>
+                    <a:lnB w="12700">
+                      <a:solidFill>
+                        <a:srgbClr val="333333"/>
+                      </a:solidFill>
+                    </a:lnB>
+                    <a:solidFill>
+                      <a:srgbClr val="FFFFDD"/>
+                    </a:solidFill>
+                  </a:tcPr>
+                </a:tc>
+              </a:tr>
+              <!-- Row 2: vertical merge start (rowSpan=2) + noFill border -->
+              <a:tr h="914400">
+                <a:tc rowSpan="2">
+                  <a:txBody>
+                    <a:bodyPr/>
+                    <a:lstStyle/>
+                    <a:p>
+                      <a:r>
+                        <a:rPr lang="en-US" sz="1400" b="1"/>
+                        <a:t>Merged 2 rows</a:t>
+                      </a:r>
+                    </a:p>
+                  </a:txBody>
+                  <a:tcPr anchor="ctr">
+                    <a:lnL w="19050">
+                      <a:solidFill>
+                        <a:srgbClr val="9900CC"/>
+                      </a:solidFill>
+                    </a:lnL>
+                    <a:lnR w="19050">
+                      <a:solidFill>
+                        <a:srgbClr val="9900CC"/>
+                      </a:solidFill>
+                    </a:lnR>
+                    <a:lnT w="19050">
+                      <a:solidFill>
+                        <a:srgbClr val="9900CC"/>
+                      </a:solidFill>
+                    </a:lnT>
+                    <a:lnB w="19050">
+                      <a:solidFill>
+                        <a:srgbClr val="9900CC"/>
+                      </a:solidFill>
+                    </a:lnB>
+                    <a:solidFill>
+                      <a:srgbClr val="F0E0FF"/>
+                    </a:solidFill>
+                  </a:tcPr>
+                </a:tc>
+                <a:tc>
+                  <a:txBody>
+                    <a:bodyPr/>
+                    <a:lstStyle/>
+                    <a:p>
+                      <a:r>
+                        <a:rPr lang="en-US" sz="1200"/>
+                        <a:t>Cell B2</a:t>
+                      </a:r>
+                    </a:p>
+                  </a:txBody>
+                  <a:tcPr>
+                    <a:lnL w="12700">
+                      <a:noFill/>
+                    </a:lnL>
+                    <a:lnR w="12700">
+                      <a:solidFill>
+                        <a:srgbClr val="666666"/>
+                      </a:solidFill>
+                    </a:lnR>
+                    <a:lnT w="12700">
+                      <a:solidFill>
+                        <a:srgbClr val="666666"/>
+                      </a:solidFill>
+                    </a:lnT>
+                    <a:lnB w="12700">
+                      <a:solidFill>
+                        <a:srgbClr val="666666"/>
+                      </a:solidFill>
+                    </a:lnB>
+                  </a:tcPr>
+                </a:tc>
+                <a:tc>
+                  <a:txBody>
+                    <a:bodyPr/>
+                    <a:lstStyle/>
+                    <a:p>
+                      <a:r>
+                        <a:rPr lang="en-US" sz="1200"/>
+                        <a:t>Cell C2</a:t>
+                      </a:r>
+                    </a:p>
+                  </a:txBody>
+                  <a:tcPr>
+                    <a:lnL w="12700">
+                      <a:solidFill>
+                        <a:srgbClr val="666666"/>
+                      </a:solidFill>
+                    </a:lnL>
+                    <a:lnR w="12700">
+                      <a:solidFill>
+                        <a:srgbClr val="666666"/>
+                      </a:solidFill>
+                    </a:lnR>
+                    <a:lnT w="12700">
+                      <a:solidFill>
+                        <a:srgbClr val="666666"/>
+                      </a:solidFill>
+                    </a:lnT>
+                    <a:lnB w="12700">
+                      <a:solidFill>
+                        <a:srgbClr val="666666"/>
+                      </a:solidFill>
+                    </a:lnB>
+                  </a:tcPr>
+                </a:tc>
+              </a:tr>
+              <!-- Row 3: vertical merge continuation -->
+              <a:tr h="914400">
+                <a:tc vMerge="1">
+                  <a:txBody>
+                    <a:bodyPr/>
+                    <a:lstStyle/>
+                    <a:p>
+                      <a:endParaRPr lang="en-US"/>
+                    </a:p>
+                  </a:txBody>
+                  <a:tcPr/>
+                </a:tc>
+                <a:tc>
+                  <a:txBody>
+                    <a:bodyPr/>
+                    <a:lstStyle/>
+                    <a:p>
+                      <a:r>
+                        <a:rPr lang="en-US" sz="1200"/>
+                        <a:t>Cell B3 (large margin)</a:t>
+                      </a:r>
+                    </a:p>
+                  </a:txBody>
+                  <a:tcPr marL="274320" marT="137160">
+                    <a:lnL w="12700">
+                      <a:solidFill>
+                        <a:srgbClr val="666666"/>
+                      </a:solidFill>
+                    </a:lnL>
+                    <a:lnR w="12700">
+                      <a:solidFill>
+                        <a:srgbClr val="666666"/>
+                      </a:solidFill>
+                    </a:lnR>
+                    <a:lnT w="12700">
+                      <a:solidFill>
+                        <a:srgbClr val="666666"/>
+                      </a:solidFill>
+                    </a:lnT>
+                    <a:lnB w="12700">
+                      <a:solidFill>
+                        <a:srgbClr val="666666"/>
+                      </a:solidFill>
+                    </a:lnB>
+                  </a:tcPr>
+                </a:tc>
+                <a:tc>
+                  <a:txBody>
+                    <a:bodyPr/>
+                    <a:lstStyle/>
+                    <a:p>
+                      <a:r>
+                        <a:rPr lang="en-US" sz="1200"/>
+                        <a:t>Cell C3 (top anchor)</a:t>
+                      </a:r>
+                    </a:p>
+                  </a:txBody>
+                  <a:tcPr anchor="t">
+                    <a:lnL w="12700">
+                      <a:solidFill>
+                        <a:srgbClr val="666666"/>
+                      </a:solidFill>
+                    </a:lnL>
+                    <a:lnR w="12700">
+                      <a:solidFill>
+                        <a:srgbClr val="666666"/>
+                      </a:solidFill>
+                    </a:lnR>
+                    <a:lnT w="12700">
+                      <a:solidFill>
+                        <a:srgbClr val="666666"/>
+                      </a:solidFill>
+                    </a:lnT>
+                    <a:lnB w="12700">
+                      <a:solidFill>
+                        <a:srgbClr val="666666"/>
+                      </a:solidFill>
+                    </a:lnB>
+                    <a:solidFill>
+                      <a:srgbClr val="EEFFEE"/>
+                    </a:solidFill>
+                  </a:tcPr>
+                </a:tc>
+              </a:tr>
+            </a:tbl>
+          </a:graphicData>
+        </a:graphic>
+      </p:graphicFrame>
+      <p:sp>
+        <p:nvSpPr>
+          <p:cNvPr id="101" name="TextBox 100"/>
+          <p:cNvSpPr txBox="1"/>
+          <p:nvPr/>
+        </p:nvSpPr>
+        <p:spPr>
+          <a:xfrm>
+            <a:off x="274320" y="5943600"/>
+            <a:ext cx="8229600" cy="457200"/>
+          </a:xfrm>
+          <a:prstGeom prst="rect">
+            <a:avLst/>
+          </a:prstGeom>
+          <a:noFill/>
+        </p:spPr>
+        <p:txBody>
+          <a:bodyPr wrap="none">
+            <a:spAutoFit/>
+          </a:bodyPr>
+          <a:lstStyle/>
+          <a:p>
+            <a:pPr>
+              <a:defRPr sz="1000">
+                <a:solidFill>
+                  <a:srgbClr val="646464"/>
+                </a:solidFill>
+              </a:defRPr>
+            </a:pPr>
+            <a:r>
+              <a:t>Table: cell merge (gridSpan/rowSpan/vMerge) + borders + margins + anchor</a:t>
             </a:r>
           </a:p>
         </p:txBody>

</xml_diff>

<commit_message>
feat: complete table section — diagonal borders, table styles, band formatting
- Diagonal borders: parse/render/serialize a:lnTlToBr and a:lnBlToTr
- Table properties: parse a:tblPr flags (firstRow/lastRow/firstCol/lastCol/
  bandRow/bandCol) and tblStyleId for round-trip
- Table styles: parse tableStyles.xml (a:tblStyleLst), resolve style per cell
  position with priority: firstRow/lastRow > firstCol/lastCol > band > wholeTbl
- Data model: TableStyleDef/TableStyleCell types, TableData extended with
  style_id and 6 boolean flags
- Refactor: extract eff_bdr_w/eff_bdr_c helpers, remove unused _cell_w param,
  fix TableStyleCell::is_none() to check border widths

Test slide 42 added with 11 new assertions (456 total, all pass).
Section 6 (Table) is now fully complete.

Co-Authored-By: Claude Opus 4.6 <noreply@anthropic.com>
</commit_message>
<xml_diff>
--- a/test_fixtures/test_features.pptx
+++ b/test_fixtures/test_features.pptx
@@ -46,6 +46,7 @@
     <p:sldId id="294" r:id="rId45"/>
     <p:sldId id="295" r:id="rId46"/>
     <p:sldId id="296" r:id="rId47"/>
+    <p:sldId id="297" r:id="rId48"/>
   </p:sldIdLst>
   <p:sldSz cx="9144000" cy="6858000" type="screen4x3"/>
   <p:notesSz cx="6858000" cy="9144000"/>
@@ -10299,6 +10300,242 @@
             </a:pPr>
             <a:r>
               <a:t>Table: cell merge (gridSpan/rowSpan/vMerge) + borders + margins + anchor</a:t>
+            </a:r>
+          </a:p>
+        </p:txBody>
+      </p:sp>
+    </p:spTree>
+  </p:cSld>
+  <p:clrMapOvr>
+    <a:masterClrMapping/>
+  </p:clrMapOvr>
+</p:sld>
+</file>
+
+<file path=ppt/slides/slide42.xml><?xml version="1.0" encoding="utf-8"?>
+<p:sld xmlns:a="http://schemas.openxmlformats.org/drawingml/2006/main" xmlns:p="http://schemas.openxmlformats.org/presentationml/2006/main" xmlns:r="http://schemas.openxmlformats.org/officeDocument/2006/relationships">
+  <p:cSld>
+    <p:spTree>
+      <p:nvGrpSpPr>
+        <p:cNvPr id="1" name=""/>
+        <p:cNvGrpSpPr/>
+        <p:nvPr/>
+      </p:nvGrpSpPr>
+      <p:grpSpPr/>
+      <p:graphicFrame>
+        <p:nvGraphicFramePr>
+          <p:cNvPr id="200" name="Table42"/>
+          <p:cNvGraphicFramePr>
+            <a:graphicFrameLocks noGrp="1"/>
+          </p:cNvGraphicFramePr>
+          <p:nvPr/>
+        </p:nvGraphicFramePr>
+        <p:xfrm>
+          <a:off x="457200" y="457200"/>
+          <a:ext cx="8229600" cy="3657600"/>
+        </p:xfrm>
+        <a:graphic>
+          <a:graphicData uri="http://schemas.openxmlformats.org/drawingml/2006/table">
+            <a:tbl>
+              <a:tblPr firstRow="1" lastRow="1" firstCol="0" lastCol="0" bandRow="1" bandCol="0" tblStyleId="{5C22544A-7EE6-4342-B048-85BDC9FD1C3A}"/>
+              <a:tblGrid>
+                <a:gridCol w="2743200"/>
+                <a:gridCol w="2743200"/>
+                <a:gridCol w="2743200"/>
+              </a:tblGrid>
+              <!-- Row 1: diagonal borders -->
+              <a:tr h="914400">
+                <a:tc>
+                  <a:txBody>
+                    <a:bodyPr/>
+                    <a:lstStyle/>
+                    <a:p>
+                      <a:r>
+                        <a:rPr lang="en-US" sz="1200" b="1"/>
+                        <a:t>TL-BR diagonal</a:t>
+                      </a:r>
+                    </a:p>
+                  </a:txBody>
+                  <a:tcPr>
+                    <a:lnTlToBr w="19050">
+                      <a:solidFill>
+                        <a:srgbClr val="FF0000"/>
+                      </a:solidFill>
+                    </a:lnTlToBr>
+                    <a:solidFill>
+                      <a:srgbClr val="FFF0F0"/>
+                    </a:solidFill>
+                  </a:tcPr>
+                </a:tc>
+                <a:tc>
+                  <a:txBody>
+                    <a:bodyPr/>
+                    <a:lstStyle/>
+                    <a:p>
+                      <a:r>
+                        <a:rPr lang="en-US" sz="1200" b="1"/>
+                        <a:t>BL-TR diagonal</a:t>
+                      </a:r>
+                    </a:p>
+                  </a:txBody>
+                  <a:tcPr>
+                    <a:lnBlToTr w="19050">
+                      <a:solidFill>
+                        <a:srgbClr val="0000FF"/>
+                      </a:solidFill>
+                    </a:lnBlToTr>
+                    <a:solidFill>
+                      <a:srgbClr val="F0F0FF"/>
+                    </a:solidFill>
+                  </a:tcPr>
+                </a:tc>
+                <a:tc>
+                  <a:txBody>
+                    <a:bodyPr/>
+                    <a:lstStyle/>
+                    <a:p>
+                      <a:r>
+                        <a:rPr lang="en-US" sz="1200" b="1"/>
+                        <a:t>Both diagonals</a:t>
+                      </a:r>
+                    </a:p>
+                  </a:txBody>
+                  <a:tcPr>
+                    <a:lnTlToBr w="12700">
+                      <a:solidFill>
+                        <a:srgbClr val="008800"/>
+                      </a:solidFill>
+                    </a:lnTlToBr>
+                    <a:lnBlToTr w="12700">
+                      <a:solidFill>
+                        <a:srgbClr val="880000"/>
+                      </a:solidFill>
+                    </a:lnBlToTr>
+                    <a:solidFill>
+                      <a:srgbClr val="FFFFF0"/>
+                    </a:solidFill>
+                  </a:tcPr>
+                </a:tc>
+              </a:tr>
+              <!-- Row 2: band row test -->
+              <a:tr h="914400">
+                <a:tc>
+                  <a:txBody>
+                    <a:bodyPr/>
+                    <a:lstStyle/>
+                    <a:p>
+                      <a:r>
+                        <a:rPr lang="en-US" sz="1200"/>
+                        <a:t>Band row 1</a:t>
+                      </a:r>
+                    </a:p>
+                  </a:txBody>
+                  <a:tcPr/>
+                </a:tc>
+                <a:tc>
+                  <a:txBody>
+                    <a:bodyPr/>
+                    <a:lstStyle/>
+                    <a:p>
+                      <a:r>
+                        <a:rPr lang="en-US" sz="1200"/>
+                        <a:t>Normal</a:t>
+                      </a:r>
+                    </a:p>
+                  </a:txBody>
+                  <a:tcPr/>
+                </a:tc>
+                <a:tc>
+                  <a:txBody>
+                    <a:bodyPr/>
+                    <a:lstStyle/>
+                    <a:p>
+                      <a:r>
+                        <a:rPr lang="en-US" sz="1200"/>
+                        <a:t>Normal</a:t>
+                      </a:r>
+                    </a:p>
+                  </a:txBody>
+                  <a:tcPr/>
+                </a:tc>
+              </a:tr>
+              <!-- Row 3: band row test -->
+              <a:tr h="914400">
+                <a:tc>
+                  <a:txBody>
+                    <a:bodyPr/>
+                    <a:lstStyle/>
+                    <a:p>
+                      <a:r>
+                        <a:rPr lang="en-US" sz="1200"/>
+                        <a:t>Band row 2</a:t>
+                      </a:r>
+                    </a:p>
+                  </a:txBody>
+                  <a:tcPr/>
+                </a:tc>
+                <a:tc>
+                  <a:txBody>
+                    <a:bodyPr/>
+                    <a:lstStyle/>
+                    <a:p>
+                      <a:r>
+                        <a:rPr lang="en-US" sz="1200"/>
+                        <a:t>Normal</a:t>
+                      </a:r>
+                    </a:p>
+                  </a:txBody>
+                  <a:tcPr/>
+                </a:tc>
+                <a:tc>
+                  <a:txBody>
+                    <a:bodyPr/>
+                    <a:lstStyle/>
+                    <a:p>
+                      <a:r>
+                        <a:rPr lang="en-US" sz="1200"/>
+                        <a:t>Last row cell</a:t>
+                      </a:r>
+                    </a:p>
+                  </a:txBody>
+                  <a:tcPr/>
+                </a:tc>
+              </a:tr>
+            </a:tbl>
+          </a:graphicData>
+        </a:graphic>
+      </p:graphicFrame>
+      <p:sp>
+        <p:nvSpPr>
+          <p:cNvPr id="201" name="TextBox 200"/>
+          <p:cNvSpPr txBox="1"/>
+          <p:nvPr/>
+        </p:nvSpPr>
+        <p:spPr>
+          <a:xfrm>
+            <a:off x="274320" y="5943600"/>
+            <a:ext cx="8229600" cy="457200"/>
+          </a:xfrm>
+          <a:prstGeom prst="rect">
+            <a:avLst/>
+          </a:prstGeom>
+          <a:noFill/>
+        </p:spPr>
+        <p:txBody>
+          <a:bodyPr wrap="none">
+            <a:spAutoFit/>
+          </a:bodyPr>
+          <a:lstStyle/>
+          <a:p>
+            <a:pPr>
+              <a:defRPr sz="1000">
+                <a:solidFill>
+                  <a:srgbClr val="646464"/>
+                </a:solidFill>
+              </a:defRPr>
+            </a:pPr>
+            <a:r>
+              <a:t>Table: diagonal borders (lnTlToBr/lnBlToTr) + tblPr flags + tblStyleId</a:t>
             </a:r>
           </a:p>
         </p:txBody>

</xml_diff>

<commit_message>
feat: image crop, alpha, and external image references
- Image crop (srcRect → SVG clipPath) for both Picture and AutoShape blipFill
- Image alpha (a:alphaModFix) parsed from a:blip children, rendered as SVG opacity
- External image references (TargetMode="External") with direct URL support
- Refactored shared helpers: resolve_image_href, blip_opacity_attr, render_cropped_image
- Shape::default_with_blip constructor for Picture shapes with BlipFill
- Unified pct_100 constant usage across renderer and serializer

Co-Authored-By: Claude Opus 4.6 <noreply@anthropic.com>
</commit_message>
<xml_diff>
--- a/test_fixtures/test_features.pptx
+++ b/test_fixtures/test_features.pptx
@@ -47,6 +47,8 @@
     <p:sldId id="295" r:id="rId46"/>
     <p:sldId id="296" r:id="rId47"/>
     <p:sldId id="297" r:id="rId48"/>
+    <p:sldId id="298" r:id="rId49"/>
+    <p:sldId id="299" r:id="rId50"/>
   </p:sldIdLst>
   <p:sldSz cx="9144000" cy="6858000" type="screen4x3"/>
   <p:notesSz cx="6858000" cy="9144000"/>
@@ -10536,6 +10538,307 @@
             </a:pPr>
             <a:r>
               <a:t>Table: diagonal borders (lnTlToBr/lnBlToTr) + tblPr flags + tblStyleId</a:t>
+            </a:r>
+          </a:p>
+        </p:txBody>
+      </p:sp>
+    </p:spTree>
+  </p:cSld>
+  <p:clrMapOvr>
+    <a:masterClrMapping/>
+  </p:clrMapOvr>
+</p:sld>
+</file>
+
+<file path=ppt/slides/slide43.xml><?xml version="1.0" encoding="utf-8"?>
+<p:sld xmlns:a="http://schemas.openxmlformats.org/drawingml/2006/main" xmlns:p="http://schemas.openxmlformats.org/presentationml/2006/main" xmlns:r="http://schemas.openxmlformats.org/officeDocument/2006/relationships">
+  <p:cSld>
+    <p:spTree>
+      <p:nvGrpSpPr>
+        <p:cNvPr id="1" name=""/>
+        <p:cNvGrpSpPr/>
+        <p:nvPr/>
+      </p:nvGrpSpPr>
+      <p:grpSpPr/>
+      <p:sp>
+        <p:nvSpPr>
+          <p:cNvPr id="2" name="Rectangle 1"/>
+          <p:cNvSpPr/>
+          <p:nvPr/>
+        </p:nvSpPr>
+        <p:spPr>
+          <a:xfrm>
+            <a:off x="457200" y="4114800"/>
+            <a:ext cx="2743200" cy="2286000"/>
+          </a:xfrm>
+          <a:prstGeom prst="rect">
+            <a:avLst/>
+          </a:prstGeom>
+          <a:blipFill>
+            <a:blip r:embed="rId2"/>
+            <a:srcRect l="0" t="50000" r="0" b="0"/>
+            <a:stretch>
+              <a:fillRect/>
+            </a:stretch>
+          </a:blipFill>
+        </p:spPr>
+        <p:style>
+          <a:lnRef idx="1">
+            <a:schemeClr val="accent1"/>
+          </a:lnRef>
+          <a:fillRef idx="3">
+            <a:schemeClr val="accent1"/>
+          </a:fillRef>
+          <a:effectRef idx="2">
+            <a:schemeClr val="accent1"/>
+          </a:effectRef>
+          <a:fontRef idx="minor">
+            <a:schemeClr val="lt1"/>
+          </a:fontRef>
+        </p:style>
+        <p:txBody>
+          <a:bodyPr rtlCol="0" anchor="ctr"/>
+          <a:lstStyle/>
+          <a:p/>
+        </p:txBody>
+      </p:sp>
+      <p:pic>
+        <p:nvPicPr>
+          <p:cNvPr id="100" name="CropPic"/>
+          <p:cNvPicPr>
+            <a:picLocks noChangeAspect="1"/>
+          </p:cNvPicPr>
+          <p:nvPr/>
+        </p:nvPicPr>
+        <p:blipFill>
+          <a:blip r:embed="rId2"/>
+          <a:srcRect l="25000" t="25000" r="25000" b="25000"/>
+          <a:stretch>
+            <a:fillRect/>
+          </a:stretch>
+        </p:blipFill>
+        <p:spPr>
+          <a:xfrm>
+            <a:off x="457200" y="914400"/>
+            <a:ext cx="2743200" cy="2743200"/>
+          </a:xfrm>
+          <a:prstGeom prst="rect">
+            <a:avLst/>
+          </a:prstGeom>
+        </p:spPr>
+      </p:pic>
+      <p:pic>
+        <p:nvPicPr>
+          <p:cNvPr id="101" name="AlphaPic"/>
+          <p:cNvPicPr>
+            <a:picLocks noChangeAspect="1"/>
+          </p:cNvPicPr>
+          <p:nvPr/>
+        </p:nvPicPr>
+        <p:blipFill>
+          <a:blip r:embed="rId2">
+            <a:alphaModFix amt="50000"/>
+          </a:blip>
+          <a:stretch>
+            <a:fillRect/>
+          </a:stretch>
+        </p:blipFill>
+        <p:spPr>
+          <a:xfrm>
+            <a:off x="3657600" y="914400"/>
+            <a:ext cx="2743200" cy="2743200"/>
+          </a:xfrm>
+          <a:prstGeom prst="rect">
+            <a:avLst/>
+          </a:prstGeom>
+        </p:spPr>
+      </p:pic>
+      <p:pic>
+        <p:nvPicPr>
+          <p:cNvPr id="102" name="CropAlphaPic"/>
+          <p:cNvPicPr>
+            <a:picLocks noChangeAspect="1"/>
+          </p:cNvPicPr>
+          <p:nvPr/>
+        </p:nvPicPr>
+        <p:blipFill>
+          <a:blip r:embed="rId2">
+            <a:alphaModFix amt="75000"/>
+          </a:blip>
+          <a:srcRect l="50000"/>
+          <a:stretch>
+            <a:fillRect/>
+          </a:stretch>
+        </p:blipFill>
+        <p:spPr>
+          <a:xfrm>
+            <a:off x="6858000" y="914400"/>
+            <a:ext cx="2286000" cy="2743200"/>
+          </a:xfrm>
+          <a:prstGeom prst="rect">
+            <a:avLst/>
+          </a:prstGeom>
+        </p:spPr>
+      </p:pic>
+      <p:sp>
+        <p:nvSpPr>
+          <p:cNvPr id="103" name="TextBox 102"/>
+          <p:cNvSpPr txBox="1"/>
+          <p:nvPr/>
+        </p:nvSpPr>
+        <p:spPr>
+          <a:xfrm>
+            <a:off x="274320" y="182880"/>
+            <a:ext cx="8229600" cy="457200"/>
+          </a:xfrm>
+          <a:prstGeom prst="rect">
+            <a:avLst/>
+          </a:prstGeom>
+          <a:noFill/>
+        </p:spPr>
+        <p:txBody>
+          <a:bodyPr wrap="none">
+            <a:spAutoFit/>
+          </a:bodyPr>
+          <a:lstStyle/>
+          <a:p>
+            <a:pPr>
+              <a:defRPr sz="1800" b="1"/>
+            </a:pPr>
+            <a:r>
+              <a:t>Slide 43: Image crop (srcRect) + alpha (alphaModFix)</a:t>
+            </a:r>
+          </a:p>
+        </p:txBody>
+      </p:sp>
+    </p:spTree>
+  </p:cSld>
+  <p:clrMapOvr>
+    <a:masterClrMapping/>
+  </p:clrMapOvr>
+</p:sld>
+</file>
+
+<file path=ppt/slides/slide44.xml><?xml version="1.0" encoding="utf-8"?>
+<p:sld xmlns:a="http://schemas.openxmlformats.org/drawingml/2006/main" xmlns:p="http://schemas.openxmlformats.org/presentationml/2006/main" xmlns:r="http://schemas.openxmlformats.org/officeDocument/2006/relationships">
+  <p:cSld>
+    <p:spTree>
+      <p:nvGrpSpPr>
+        <p:cNvPr id="1" name=""/>
+        <p:cNvGrpSpPr/>
+        <p:nvPr/>
+      </p:nvGrpSpPr>
+      <p:grpSpPr/>
+      <p:pic>
+        <p:nvPicPr>
+          <p:cNvPr id="200" name="ExtPic1"/>
+          <p:cNvPicPr>
+            <a:picLocks noChangeAspect="1"/>
+          </p:cNvPicPr>
+          <p:nvPr/>
+        </p:nvPicPr>
+        <p:blipFill>
+          <a:blip r:embed="rId2"/>
+          <a:stretch>
+            <a:fillRect/>
+          </a:stretch>
+        </p:blipFill>
+        <p:spPr>
+          <a:xfrm>
+            <a:off x="457200" y="914400"/>
+            <a:ext cx="3657600" cy="3657600"/>
+          </a:xfrm>
+          <a:prstGeom prst="rect">
+            <a:avLst/>
+          </a:prstGeom>
+        </p:spPr>
+      </p:pic>
+      <p:pic>
+        <p:nvPicPr>
+          <p:cNvPr id="201" name="ExtPic2"/>
+          <p:cNvPicPr>
+            <a:picLocks noChangeAspect="1"/>
+          </p:cNvPicPr>
+          <p:nvPr/>
+        </p:nvPicPr>
+        <p:blipFill>
+          <a:blip r:embed="rId3"/>
+          <a:stretch>
+            <a:fillRect/>
+          </a:stretch>
+        </p:blipFill>
+        <p:spPr>
+          <a:xfrm>
+            <a:off x="4572000" y="914400"/>
+            <a:ext cx="2743200" cy="3657600"/>
+          </a:xfrm>
+          <a:prstGeom prst="rect">
+            <a:avLst/>
+          </a:prstGeom>
+        </p:spPr>
+      </p:pic>
+      <p:sp>
+        <p:nvSpPr>
+          <p:cNvPr id="202" name="TextBox 201"/>
+          <p:cNvSpPr txBox="1"/>
+          <p:nvPr/>
+        </p:nvSpPr>
+        <p:spPr>
+          <a:xfrm>
+            <a:off x="274320" y="182880"/>
+            <a:ext cx="8229600" cy="457200"/>
+          </a:xfrm>
+          <a:prstGeom prst="rect">
+            <a:avLst/>
+          </a:prstGeom>
+          <a:noFill/>
+        </p:spPr>
+        <p:txBody>
+          <a:bodyPr wrap="none">
+            <a:spAutoFit/>
+          </a:bodyPr>
+          <a:lstStyle/>
+          <a:p>
+            <a:pPr>
+              <a:defRPr sz="1800" b="1"/>
+            </a:pPr>
+            <a:r>
+              <a:t>Slide 44: External image reference (TargetMode=External)</a:t>
+            </a:r>
+          </a:p>
+        </p:txBody>
+      </p:sp>
+      <p:sp>
+        <p:nvSpPr>
+          <p:cNvPr id="203" name="TextBox 202"/>
+          <p:cNvSpPr txBox="1"/>
+          <p:nvPr/>
+        </p:nvSpPr>
+        <p:spPr>
+          <a:xfrm>
+            <a:off x="457200" y="4754880"/>
+            <a:ext cx="8229600" cy="1371600"/>
+          </a:xfrm>
+          <a:prstGeom prst="rect">
+            <a:avLst/>
+          </a:prstGeom>
+          <a:noFill/>
+        </p:spPr>
+        <p:txBody>
+          <a:bodyPr wrap="none">
+            <a:spAutoFit/>
+          </a:bodyPr>
+          <a:lstStyle/>
+          <a:p>
+            <a:pPr>
+              <a:defRPr sz="1200"/>
+            </a:pPr>
+            <a:r>
+              <a:t>Left: Wikimedia Commons PNG</a:t>
+            </a:r>
+            <a:br/>
+            <a:r>
+              <a:t>Right: picsum.photos (id=237)</a:t>
             </a:r>
           </a:p>
         </p:txBody>

</xml_diff>

<commit_message>
feat: image effects — SVG blip, brightness/contrast, duotone, clrChange
- Add SVG image support (asvg:svgBlip / a16:svgBlip in a:extLst)
- Add brightness/contrast (a:lum) rendering via SVG feComponentTransfer filter
- Add duotone (a:duotone) rendering via grayscale + color mapping filter
- Add color change (a:clrChange) parsing and round-trip (data preserved, not rendered)
- Wire resolve_blip_href and render_blip_filter into Picture and AutoShape paths
- Extract blip_filter_id/blip_clip_id helpers for consistent ID generation
- Fix serializer to use to_hex_rgb() for OOXML srgbClr attributes
- Use BlipFill::has_crop() in serializer instead of inline condition
- Reorganize TODO.md: move infeasible items to "保留" section at bottom
- Add test slides 45-46 (brightness/contrast, duotone, clrChange), 498 tests pass

Co-Authored-By: Claude Opus 4.6 <noreply@anthropic.com>
</commit_message>
<xml_diff>
--- a/test_fixtures/test_features.pptx
+++ b/test_fixtures/test_features.pptx
@@ -49,6 +49,8 @@
     <p:sldId id="297" r:id="rId48"/>
     <p:sldId id="298" r:id="rId49"/>
     <p:sldId id="299" r:id="rId50"/>
+    <p:sldId id="300" r:id="rId51"/>
+    <p:sldId id="301" r:id="rId52"/>
   </p:sldIdLst>
   <p:sldSz cx="9144000" cy="6858000" type="screen4x3"/>
   <p:notesSz cx="6858000" cy="9144000"/>
@@ -10839,6 +10841,306 @@
             <a:br/>
             <a:r>
               <a:t>Right: picsum.photos (id=237)</a:t>
+            </a:r>
+          </a:p>
+        </p:txBody>
+      </p:sp>
+    </p:spTree>
+  </p:cSld>
+  <p:clrMapOvr>
+    <a:masterClrMapping/>
+  </p:clrMapOvr>
+</p:sld>
+</file>
+
+<file path=ppt/slides/slide45.xml><?xml version="1.0" encoding="utf-8"?>
+<p:sld xmlns:a="http://schemas.openxmlformats.org/drawingml/2006/main" xmlns:p="http://schemas.openxmlformats.org/presentationml/2006/main" xmlns:r="http://schemas.openxmlformats.org/officeDocument/2006/relationships">
+  <p:cSld>
+    <p:spTree>
+      <p:nvGrpSpPr>
+        <p:cNvPr id="1" name=""/>
+        <p:cNvGrpSpPr/>
+        <p:nvPr/>
+      </p:nvGrpSpPr>
+      <p:grpSpPr/>
+      <p:pic>
+        <p:nvPicPr>
+          <p:cNvPr id="300" name="BrightPic"/>
+          <p:cNvPicPr>
+            <a:picLocks noChangeAspect="1"/>
+          </p:cNvPicPr>
+          <p:nvPr/>
+        </p:nvPicPr>
+        <p:blipFill>
+          <a:blip r:embed="rId2">
+            <a:lum bright="50000"/>
+          </a:blip>
+          <a:stretch>
+            <a:fillRect/>
+          </a:stretch>
+        </p:blipFill>
+        <p:spPr>
+          <a:xfrm>
+            <a:off x="457200" y="914400"/>
+            <a:ext cx="2286000" cy="2286000"/>
+          </a:xfrm>
+          <a:prstGeom prst="rect">
+            <a:avLst/>
+          </a:prstGeom>
+        </p:spPr>
+      </p:pic>
+      <p:pic>
+        <p:nvPicPr>
+          <p:cNvPr id="301" name="ContrastPic"/>
+          <p:cNvPicPr>
+            <a:picLocks noChangeAspect="1"/>
+          </p:cNvPicPr>
+          <p:nvPr/>
+        </p:nvPicPr>
+        <p:blipFill>
+          <a:blip r:embed="rId2">
+            <a:lum contrast="-30000"/>
+          </a:blip>
+          <a:stretch>
+            <a:fillRect/>
+          </a:stretch>
+        </p:blipFill>
+        <p:spPr>
+          <a:xfrm>
+            <a:off x="3429000" y="914400"/>
+            <a:ext cx="2286000" cy="2286000"/>
+          </a:xfrm>
+          <a:prstGeom prst="rect">
+            <a:avLst/>
+          </a:prstGeom>
+        </p:spPr>
+      </p:pic>
+      <p:pic>
+        <p:nvPicPr>
+          <p:cNvPr id="302" name="BrightContrastPic"/>
+          <p:cNvPicPr>
+            <a:picLocks noChangeAspect="1"/>
+          </p:cNvPicPr>
+          <p:nvPr/>
+        </p:nvPicPr>
+        <p:blipFill>
+          <a:blip r:embed="rId2">
+            <a:lum bright="20000" contrast="40000"/>
+          </a:blip>
+          <a:stretch>
+            <a:fillRect/>
+          </a:stretch>
+        </p:blipFill>
+        <p:spPr>
+          <a:xfrm>
+            <a:off x="6400800" y="914400"/>
+            <a:ext cx="2286000" cy="2286000"/>
+          </a:xfrm>
+          <a:prstGeom prst="rect">
+            <a:avLst/>
+          </a:prstGeom>
+        </p:spPr>
+      </p:pic>
+      <p:sp>
+        <p:nvSpPr>
+          <p:cNvPr id="303" name="TextBox 302"/>
+          <p:cNvSpPr txBox="1"/>
+          <p:nvPr/>
+        </p:nvSpPr>
+        <p:spPr>
+          <a:xfrm>
+            <a:off x="274320" y="182880"/>
+            <a:ext cx="8229600" cy="457200"/>
+          </a:xfrm>
+          <a:prstGeom prst="rect">
+            <a:avLst/>
+          </a:prstGeom>
+          <a:noFill/>
+        </p:spPr>
+        <p:txBody>
+          <a:bodyPr wrap="none">
+            <a:spAutoFit/>
+          </a:bodyPr>
+          <a:lstStyle/>
+          <a:p>
+            <a:pPr>
+              <a:defRPr sz="1800" b="1"/>
+            </a:pPr>
+            <a:r>
+              <a:t>Slide 45: Image effects — brightness/contrast (a:lum)</a:t>
+            </a:r>
+          </a:p>
+        </p:txBody>
+      </p:sp>
+      <p:sp>
+        <p:nvSpPr>
+          <p:cNvPr id="304" name="TextBox 303"/>
+          <p:cNvSpPr txBox="1"/>
+          <p:nvPr/>
+        </p:nvSpPr>
+        <p:spPr>
+          <a:xfrm>
+            <a:off x="457200" y="3931920"/>
+            <a:ext cx="8229600" cy="914400"/>
+          </a:xfrm>
+          <a:prstGeom prst="rect">
+            <a:avLst/>
+          </a:prstGeom>
+          <a:noFill/>
+        </p:spPr>
+        <p:txBody>
+          <a:bodyPr wrap="none">
+            <a:spAutoFit/>
+          </a:bodyPr>
+          <a:lstStyle/>
+          <a:p>
+            <a:pPr>
+              <a:defRPr sz="1200"/>
+            </a:pPr>
+            <a:r>
+              <a:t>Left: bright +50% | Center: contrast -30% | Right: bright +20% contrast +40%</a:t>
+            </a:r>
+          </a:p>
+        </p:txBody>
+      </p:sp>
+    </p:spTree>
+  </p:cSld>
+  <p:clrMapOvr>
+    <a:masterClrMapping/>
+  </p:clrMapOvr>
+</p:sld>
+</file>
+
+<file path=ppt/slides/slide46.xml><?xml version="1.0" encoding="utf-8"?>
+<p:sld xmlns:a="http://schemas.openxmlformats.org/drawingml/2006/main" xmlns:p="http://schemas.openxmlformats.org/presentationml/2006/main" xmlns:r="http://schemas.openxmlformats.org/officeDocument/2006/relationships">
+  <p:cSld>
+    <p:spTree>
+      <p:nvGrpSpPr>
+        <p:cNvPr id="1" name=""/>
+        <p:cNvGrpSpPr/>
+        <p:nvPr/>
+      </p:nvGrpSpPr>
+      <p:grpSpPr/>
+      <p:pic>
+        <p:nvPicPr>
+          <p:cNvPr id="400" name="DuotonePic"/>
+          <p:cNvPicPr>
+            <a:picLocks noChangeAspect="1"/>
+          </p:cNvPicPr>
+          <p:nvPr/>
+        </p:nvPicPr>
+        <p:blipFill>
+          <a:blip r:embed="rId2">
+            <a:duotone>
+              <a:srgbClr val="000080"/>
+              <a:srgbClr val="FFFF00"/>
+            </a:duotone>
+          </a:blip>
+          <a:stretch>
+            <a:fillRect/>
+          </a:stretch>
+        </p:blipFill>
+        <p:spPr>
+          <a:xfrm>
+            <a:off x="457200" y="914400"/>
+            <a:ext cx="3657600" cy="3657600"/>
+          </a:xfrm>
+          <a:prstGeom prst="rect">
+            <a:avLst/>
+          </a:prstGeom>
+        </p:spPr>
+      </p:pic>
+      <p:pic>
+        <p:nvPicPr>
+          <p:cNvPr id="401" name="ClrChangePic"/>
+          <p:cNvPicPr>
+            <a:picLocks noChangeAspect="1"/>
+          </p:cNvPicPr>
+          <p:nvPr/>
+        </p:nvPicPr>
+        <p:blipFill>
+          <a:blip r:embed="rId2">
+            <a:clrChange>
+              <a:clrFrom>
+                <a:srgbClr val="FF0000"/>
+              </a:clrFrom>
+              <a:clrTo>
+                <a:srgbClr val="00FF00"/>
+              </a:clrTo>
+            </a:clrChange>
+          </a:blip>
+          <a:stretch>
+            <a:fillRect/>
+          </a:stretch>
+        </p:blipFill>
+        <p:spPr>
+          <a:xfrm>
+            <a:off x="4572000" y="914400"/>
+            <a:ext cx="3657600" cy="3657600"/>
+          </a:xfrm>
+          <a:prstGeom prst="rect">
+            <a:avLst/>
+          </a:prstGeom>
+        </p:spPr>
+      </p:pic>
+      <p:sp>
+        <p:nvSpPr>
+          <p:cNvPr id="402" name="TextBox 401"/>
+          <p:cNvSpPr txBox="1"/>
+          <p:nvPr/>
+        </p:nvSpPr>
+        <p:spPr>
+          <a:xfrm>
+            <a:off x="274320" y="182880"/>
+            <a:ext cx="8229600" cy="457200"/>
+          </a:xfrm>
+          <a:prstGeom prst="rect">
+            <a:avLst/>
+          </a:prstGeom>
+          <a:noFill/>
+        </p:spPr>
+        <p:txBody>
+          <a:bodyPr wrap="none">
+            <a:spAutoFit/>
+          </a:bodyPr>
+          <a:lstStyle/>
+          <a:p>
+            <a:pPr>
+              <a:defRPr sz="1800" b="1"/>
+            </a:pPr>
+            <a:r>
+              <a:t>Slide 46: Duotone (a:duotone) + Color change (a:clrChange)</a:t>
+            </a:r>
+          </a:p>
+        </p:txBody>
+      </p:sp>
+      <p:sp>
+        <p:nvSpPr>
+          <p:cNvPr id="403" name="TextBox 402"/>
+          <p:cNvSpPr txBox="1"/>
+          <p:nvPr/>
+        </p:nvSpPr>
+        <p:spPr>
+          <a:xfrm>
+            <a:off x="457200" y="4754880"/>
+            <a:ext cx="8229600" cy="914400"/>
+          </a:xfrm>
+          <a:prstGeom prst="rect">
+            <a:avLst/>
+          </a:prstGeom>
+          <a:noFill/>
+        </p:spPr>
+        <p:txBody>
+          <a:bodyPr wrap="none">
+            <a:spAutoFit/>
+          </a:bodyPr>
+          <a:lstStyle/>
+          <a:p>
+            <a:pPr>
+              <a:defRPr sz="1200"/>
+            </a:pPr>
+            <a:r>
+              <a:t>Left: Duotone (navy→yellow) | Right: clrChange (red→green, data preserved)</a:t>
             </a:r>
           </a:p>
         </p:txBody>

</xml_diff>

<commit_message>
feat: complete section 11 — color modifiers, shape links, bg fills, stroke fills, placeholder auto-content
- Color modifiers: comp/inv/gamma/invGamma/hueMod/hueOff/satOff in apply_color_modifiers()
- Shape hyperlinks: a:hlinkClick/a:hlinkHover on p:cNvPr (parse/render/round-trip/serialize)
- Background blipFill/pattFill: p:bg/p:bgPr image and pattern fill (parse/render/serialize)
- Line gradient/pattern fill: a:ln gradFill/pattFill (parse/SVG defs/serialize)
- Placeholder auto-content: inject slide number/date/footer for empty sldNum/dt/ftr placeholders
- Refactor: consolidate Shape constructors with spread syntax, remove duplicate extract_sub(),
  clean unused ffi import from svg_parser, update CLAUDE.md data model, reorganize TODO.md

Test: 521/521 passing (3 new slides: 47-49)

Co-Authored-By: Claude Opus 4.6 <noreply@anthropic.com>
</commit_message>
<xml_diff>
--- a/test_fixtures/test_features.pptx
+++ b/test_fixtures/test_features.pptx
@@ -51,6 +51,9 @@
     <p:sldId id="299" r:id="rId50"/>
     <p:sldId id="300" r:id="rId51"/>
     <p:sldId id="301" r:id="rId52"/>
+    <p:sldId id="302" r:id="rId53"/>
+    <p:sldId id="303" r:id="rId54"/>
+    <p:sldId id="304" r:id="rId55"/>
   </p:sldIdLst>
   <p:sldSz cx="9144000" cy="6858000" type="screen4x3"/>
   <p:notesSz cx="6858000" cy="9144000"/>
@@ -11141,6 +11144,387 @@
             </a:pPr>
             <a:r>
               <a:t>Left: Duotone (navy→yellow) | Right: clrChange (red→green, data preserved)</a:t>
+            </a:r>
+          </a:p>
+        </p:txBody>
+      </p:sp>
+    </p:spTree>
+  </p:cSld>
+  <p:clrMapOvr>
+    <a:masterClrMapping/>
+  </p:clrMapOvr>
+</p:sld>
+</file>
+
+<file path=ppt/slides/slide47.xml><?xml version="1.0" encoding="utf-8"?>
+<p:sld xmlns:a="http://schemas.openxmlformats.org/drawingml/2006/main" xmlns:p="http://schemas.openxmlformats.org/presentationml/2006/main" xmlns:r="http://schemas.openxmlformats.org/officeDocument/2006/relationships">
+  <p:cSld>
+    <p:bg>
+      <p:bgPr>
+        <a:pattFill prst="ltDnDiag">
+          <a:fgClr>
+            <a:srgbClr val="3366CC"/>
+          </a:fgClr>
+          <a:bgClr>
+            <a:srgbClr val="FFFFFF"/>
+          </a:bgClr>
+        </a:pattFill>
+        <a:effectLst/>
+      </p:bgPr>
+    </p:bg>
+    <p:spTree>
+      <p:nvGrpSpPr>
+        <p:cNvPr id="1" name=""/>
+        <p:cNvGrpSpPr/>
+        <p:nvPr/>
+      </p:nvGrpSpPr>
+      <p:grpSpPr/>
+      <p:sp>
+        <p:nvSpPr>
+          <p:cNvPr id="2" name="TextBox 1"/>
+          <p:cNvSpPr txBox="1"/>
+          <p:nvPr/>
+        </p:nvSpPr>
+        <p:spPr>
+          <a:xfrm>
+            <a:off x="274320" y="182880"/>
+            <a:ext cx="8229600" cy="457200"/>
+          </a:xfrm>
+          <a:prstGeom prst="rect">
+            <a:avLst/>
+          </a:prstGeom>
+          <a:noFill/>
+        </p:spPr>
+        <p:txBody>
+          <a:bodyPr wrap="none">
+            <a:spAutoFit/>
+          </a:bodyPr>
+          <a:lstStyle/>
+          <a:p>
+            <a:pPr>
+              <a:defRPr sz="1800" b="1"/>
+            </a:pPr>
+            <a:r>
+              <a:t>Slide 47: Background pattern fill (ltDnDiag)</a:t>
+            </a:r>
+          </a:p>
+        </p:txBody>
+      </p:sp>
+    </p:spTree>
+  </p:cSld>
+  <p:clrMapOvr>
+    <a:masterClrMapping/>
+  </p:clrMapOvr>
+</p:sld>
+</file>
+
+<file path=ppt/slides/slide48.xml><?xml version="1.0" encoding="utf-8"?>
+<p:sld xmlns:a="http://schemas.openxmlformats.org/drawingml/2006/main" xmlns:p="http://schemas.openxmlformats.org/presentationml/2006/main" xmlns:r="http://schemas.openxmlformats.org/officeDocument/2006/relationships">
+  <p:cSld>
+    <p:spTree>
+      <p:nvGrpSpPr>
+        <p:cNvPr id="1" name=""/>
+        <p:cNvGrpSpPr/>
+        <p:nvPr/>
+      </p:nvGrpSpPr>
+      <p:grpSpPr/>
+      <p:sp>
+        <p:nvSpPr>
+          <p:cNvPr id="100" name="GradStrokeRect"/>
+          <p:cNvSpPr/>
+          <p:nvPr/>
+        </p:nvSpPr>
+        <p:spPr>
+          <a:xfrm>
+            <a:off x="457200" y="1371600"/>
+            <a:ext cx="3657600" cy="2286000"/>
+          </a:xfrm>
+          <a:prstGeom prst="rect">
+            <a:avLst/>
+          </a:prstGeom>
+          <a:solidFill>
+            <a:srgbClr val="F0F0F0"/>
+          </a:solidFill>
+          <a:ln w="76200">
+            <a:gradFill>
+              <a:gsLst>
+                <a:gs pos="0">
+                  <a:srgbClr val="FF0000"/>
+                </a:gs>
+                <a:gs pos="50000">
+                  <a:srgbClr val="00FF00"/>
+                </a:gs>
+                <a:gs pos="100000">
+                  <a:srgbClr val="0000FF"/>
+                </a:gs>
+              </a:gsLst>
+              <a:lin ang="0" scaled="1"/>
+            </a:gradFill>
+          </a:ln>
+        </p:spPr>
+        <p:txBody>
+          <a:bodyPr/>
+          <a:lstStyle/>
+          <a:p>
+            <a:r>
+              <a:rPr lang="en-US" sz="1400"/>
+              <a:t>Gradient stroke</a:t>
+            </a:r>
+          </a:p>
+        </p:txBody>
+      </p:sp>
+      <p:sp>
+        <p:nvSpPr>
+          <p:cNvPr id="101" name="PattStrokeEllipse"/>
+          <p:cNvSpPr/>
+          <p:nvPr/>
+        </p:nvSpPr>
+        <p:spPr>
+          <a:xfrm>
+            <a:off x="5029200" y="1371600"/>
+            <a:ext cx="3657600" cy="2286000"/>
+          </a:xfrm>
+          <a:prstGeom prst="ellipse">
+            <a:avLst/>
+          </a:prstGeom>
+          <a:solidFill>
+            <a:srgbClr val="FFFFCC"/>
+          </a:solidFill>
+          <a:ln w="57150">
+            <a:pattFill prst="smCheck">
+              <a:fgClr>
+                <a:srgbClr val="990000"/>
+              </a:fgClr>
+              <a:bgClr>
+                <a:srgbClr val="FFCC00"/>
+              </a:bgClr>
+            </a:pattFill>
+          </a:ln>
+        </p:spPr>
+        <p:txBody>
+          <a:bodyPr/>
+          <a:lstStyle/>
+          <a:p>
+            <a:r>
+              <a:rPr lang="en-US" sz="1400"/>
+              <a:t>Pattern stroke</a:t>
+            </a:r>
+          </a:p>
+        </p:txBody>
+      </p:sp>
+      <p:sp>
+        <p:nvSpPr>
+          <p:cNvPr id="102" name="TextBox 101"/>
+          <p:cNvSpPr txBox="1"/>
+          <p:nvPr/>
+        </p:nvSpPr>
+        <p:spPr>
+          <a:xfrm>
+            <a:off x="274320" y="182880"/>
+            <a:ext cx="8229600" cy="457200"/>
+          </a:xfrm>
+          <a:prstGeom prst="rect">
+            <a:avLst/>
+          </a:prstGeom>
+          <a:noFill/>
+        </p:spPr>
+        <p:txBody>
+          <a:bodyPr wrap="none">
+            <a:spAutoFit/>
+          </a:bodyPr>
+          <a:lstStyle/>
+          <a:p>
+            <a:pPr>
+              <a:defRPr sz="1800" b="1"/>
+            </a:pPr>
+            <a:r>
+              <a:t>Slide 48: Line gradient fill + Line pattern fill</a:t>
+            </a:r>
+          </a:p>
+        </p:txBody>
+      </p:sp>
+    </p:spTree>
+  </p:cSld>
+  <p:clrMapOvr>
+    <a:masterClrMapping/>
+  </p:clrMapOvr>
+</p:sld>
+</file>
+
+<file path=ppt/slides/slide49.xml><?xml version="1.0" encoding="utf-8"?>
+<p:sld xmlns:a="http://schemas.openxmlformats.org/drawingml/2006/main" xmlns:p="http://schemas.openxmlformats.org/presentationml/2006/main" xmlns:r="http://schemas.openxmlformats.org/officeDocument/2006/relationships">
+  <p:cSld>
+    <p:spTree>
+      <p:nvGrpSpPr>
+        <p:cNvPr id="1" name=""/>
+        <p:cNvGrpSpPr/>
+        <p:nvPr/>
+      </p:nvGrpSpPr>
+      <p:grpSpPr/>
+      <p:sp>
+        <p:nvSpPr>
+          <p:cNvPr id="200" name="LinkedShape">
+            <a:hlinkClick r:id="rId99"/>
+          </p:cNvPr>
+          <p:cNvSpPr/>
+          <p:nvPr/>
+        </p:nvSpPr>
+        <p:spPr>
+          <a:xfrm>
+            <a:off x="457200" y="1371600"/>
+            <a:ext cx="3657600" cy="1828800"/>
+          </a:xfrm>
+          <a:prstGeom prst="roundRect">
+            <a:avLst/>
+          </a:prstGeom>
+          <a:solidFill>
+            <a:srgbClr val="4472C4"/>
+          </a:solidFill>
+          <a:ln w="25400">
+            <a:solidFill>
+              <a:srgbClr val="2F5597"/>
+            </a:solidFill>
+          </a:ln>
+        </p:spPr>
+        <p:txBody>
+          <a:bodyPr anchor="ctr"/>
+          <a:lstStyle/>
+          <a:p>
+            <a:pPr algn="ctr"/>
+            <a:r>
+              <a:rPr lang="en-US" sz="1600" b="1">
+                <a:solidFill>
+                  <a:srgbClr val="FFFFFF"/>
+                </a:solidFill>
+              </a:rPr>
+              <a:t>Click me (shape link)</a:t>
+            </a:r>
+          </a:p>
+        </p:txBody>
+      </p:sp>
+      <p:sp>
+        <p:nvSpPr>
+          <p:cNvPr id="201" name="CompColor"/>
+          <p:cNvSpPr/>
+          <p:nvPr/>
+        </p:nvSpPr>
+        <p:spPr>
+          <a:xfrm>
+            <a:off x="5029200" y="1371600"/>
+            <a:ext cx="3657600" cy="1828800"/>
+          </a:xfrm>
+          <a:prstGeom prst="rect">
+            <a:avLst/>
+          </a:prstGeom>
+          <a:solidFill>
+            <a:srgbClr val="FF6600">
+              <a:comp/>
+            </a:srgbClr>
+          </a:solidFill>
+        </p:spPr>
+        <p:txBody>
+          <a:bodyPr anchor="ctr"/>
+          <a:lstStyle/>
+          <a:p>
+            <a:pPr algn="ctr"/>
+            <a:r>
+              <a:rPr lang="en-US" sz="1400"/>
+              <a:t>comp(#FF6600) = complementary hue</a:t>
+            </a:r>
+          </a:p>
+        </p:txBody>
+      </p:sp>
+      <p:sp>
+        <p:nvSpPr>
+          <p:cNvPr id="202" name="InvColor"/>
+          <p:cNvSpPr/>
+          <p:nvPr/>
+        </p:nvSpPr>
+        <p:spPr>
+          <a:xfrm>
+            <a:off x="457200" y="3657600"/>
+            <a:ext cx="3657600" cy="1828800"/>
+          </a:xfrm>
+          <a:prstGeom prst="rect">
+            <a:avLst/>
+          </a:prstGeom>
+          <a:solidFill>
+            <a:srgbClr val="3366CC">
+              <a:inv/>
+            </a:srgbClr>
+          </a:solidFill>
+        </p:spPr>
+        <p:txBody>
+          <a:bodyPr anchor="ctr"/>
+          <a:lstStyle/>
+          <a:p>
+            <a:pPr algn="ctr"/>
+            <a:r>
+              <a:rPr lang="en-US" sz="1400"/>
+              <a:t>inv(#3366CC) → #CC9933</a:t>
+            </a:r>
+          </a:p>
+        </p:txBody>
+      </p:sp>
+      <p:sp>
+        <p:nvSpPr>
+          <p:cNvPr id="203" name="HueModColor"/>
+          <p:cNvSpPr/>
+          <p:nvPr/>
+        </p:nvSpPr>
+        <p:spPr>
+          <a:xfrm>
+            <a:off x="5029200" y="3657600"/>
+            <a:ext cx="3657600" cy="1828800"/>
+          </a:xfrm>
+          <a:prstGeom prst="rect">
+            <a:avLst/>
+          </a:prstGeom>
+          <a:solidFill>
+            <a:srgbClr val="FF0000">
+              <a:hueMod val="50000"/>
+            </a:srgbClr>
+          </a:solidFill>
+        </p:spPr>
+        <p:txBody>
+          <a:bodyPr anchor="ctr"/>
+          <a:lstStyle/>
+          <a:p>
+            <a:pPr algn="ctr"/>
+            <a:r>
+              <a:rPr lang="en-US" sz="1400"/>
+              <a:t>hueMod 50% of red</a:t>
+            </a:r>
+          </a:p>
+        </p:txBody>
+      </p:sp>
+      <p:sp>
+        <p:nvSpPr>
+          <p:cNvPr id="204" name="TextBox 203"/>
+          <p:cNvSpPr txBox="1"/>
+          <p:nvPr/>
+        </p:nvSpPr>
+        <p:spPr>
+          <a:xfrm>
+            <a:off x="274320" y="182880"/>
+            <a:ext cx="8229600" cy="457200"/>
+          </a:xfrm>
+          <a:prstGeom prst="rect">
+            <a:avLst/>
+          </a:prstGeom>
+          <a:noFill/>
+        </p:spPr>
+        <p:txBody>
+          <a:bodyPr wrap="none">
+            <a:spAutoFit/>
+          </a:bodyPr>
+          <a:lstStyle/>
+          <a:p>
+            <a:pPr>
+              <a:defRPr sz="1800" b="1"/>
+            </a:pPr>
+            <a:r>
+              <a:t>Slide 49: Shape hyperlinks + Color modifiers (comp/inv/hueMod)</a:t>
             </a:r>
           </a:p>
         </p:txBody>

</xml_diff>

<commit_message>
feat: 3D data preservation, text effects rendering, and refactoring
- Add 3D support (scene3d/sp3d/bevel/extrusion) — parse, round-trip, serialize (data preservation only)
- Add text-level effects (a:rPr effectLst) — parse, CSS filter drop-shadow rendering, round-trip, serialize
- Extract reusable effect parsers (parse_outer_shadow, parse_inner_shadow, parse_glow)
- Consolidate SVG ID builders via shared svg_id() helper
- Replace magic number 60000 with ooxml_angle_unit constant
- Extract css_rgba() helper for text effect rendering
- Improve file header documentation (renderer_text, ooxml_text)
- Clean up TODO.md: merge completed section 9 into summary, renumber sections

Co-Authored-By: Claude Opus 4.6 <noreply@anthropic.com>
</commit_message>
<xml_diff>
--- a/test_fixtures/test_features.pptx
+++ b/test_fixtures/test_features.pptx
@@ -55,6 +55,7 @@
     <p:sldId id="303" r:id="rId54"/>
     <p:sldId id="304" r:id="rId55"/>
     <p:sldId id="305" r:id="rId56"/>
+    <p:sldId id="306" r:id="rId57"/>
   </p:sldIdLst>
   <p:sldSz cx="9144000" cy="6858000" type="screen4x3"/>
   <p:notesSz cx="6858000" cy="9144000"/>
@@ -11841,6 +11842,195 @@
             </a:pPr>
             <a:r>
               <a:t>Slide 50: Shape effects (outerShdw / innerShdw / glow / softEdge)</a:t>
+            </a:r>
+          </a:p>
+        </p:txBody>
+      </p:sp>
+    </p:spTree>
+  </p:cSld>
+  <p:clrMapOvr>
+    <a:masterClrMapping/>
+  </p:clrMapOvr>
+</p:sld>
+</file>
+
+<file path=ppt/slides/slide51.xml><?xml version="1.0" encoding="utf-8"?>
+<p:sld xmlns:a="http://schemas.openxmlformats.org/drawingml/2006/main" xmlns:p="http://schemas.openxmlformats.org/presentationml/2006/main" xmlns:r="http://schemas.openxmlformats.org/officeDocument/2006/relationships">
+  <p:cSld>
+    <p:spTree>
+      <p:nvGrpSpPr>
+        <p:cNvPr id="1" name=""/>
+        <p:cNvGrpSpPr/>
+        <p:nvPr/>
+      </p:nvGrpSpPr>
+      <p:grpSpPr/>
+      <p:sp>
+        <p:nvSpPr>
+          <p:cNvPr id="401" name="Bevel3D"/>
+          <p:cNvSpPr/>
+          <p:nvPr/>
+        </p:nvSpPr>
+        <p:spPr>
+          <a:xfrm>
+            <a:off x="457200" y="1371600"/>
+            <a:ext cx="3200400" cy="1828800"/>
+          </a:xfrm>
+          <a:prstGeom prst="roundRect">
+            <a:avLst/>
+          </a:prstGeom>
+          <a:solidFill>
+            <a:srgbClr val="4472C4"/>
+          </a:solidFill>
+          <a:scene3d>
+            <a:camera prst="orthographicFront"/>
+            <a:lightRig rig="threePt" dir="t"/>
+          </a:scene3d>
+          <a:sp3d prstMaterial="plastic">
+            <a:bevelT w="152400" h="50800" prst="relaxedInset"/>
+          </a:sp3d>
+        </p:spPr>
+        <p:txBody>
+          <a:bodyPr anchor="ctr"/>
+          <a:lstStyle/>
+          <a:p>
+            <a:pPr algn="ctr"/>
+            <a:r>
+              <a:rPr lang="en-US" sz="1400" b="1"/>
+              <a:t>3D Bevel</a:t>
+            </a:r>
+          </a:p>
+        </p:txBody>
+      </p:sp>
+      <p:sp>
+        <p:nvSpPr>
+          <p:cNvPr id="402" name="TextShadow"/>
+          <p:cNvSpPr/>
+          <p:nvPr/>
+        </p:nvSpPr>
+        <p:spPr>
+          <a:xfrm>
+            <a:off x="5029200" y="1371600"/>
+            <a:ext cx="3200400" cy="1828800"/>
+          </a:xfrm>
+          <a:prstGeom prst="rect">
+            <a:avLst/>
+          </a:prstGeom>
+          <a:solidFill>
+            <a:srgbClr val="FFFFFF"/>
+          </a:solidFill>
+        </p:spPr>
+        <p:txBody>
+          <a:bodyPr anchor="ctr"/>
+          <a:lstStyle/>
+          <a:p>
+            <a:pPr algn="ctr"/>
+            <a:r>
+              <a:rPr lang="en-US" sz="2400" b="1">
+                <a:solidFill>
+                  <a:srgbClr val="333333"/>
+                </a:solidFill>
+                <a:effectLst>
+                  <a:outerShdw blurRad="38100" dist="38100" dir="5400000">
+                    <a:srgbClr val="000000">
+                      <a:alpha val="40000"/>
+                    </a:srgbClr>
+                  </a:outerShdw>
+                </a:effectLst>
+              </a:rPr>
+              <a:t>Text with Shadow</a:t>
+            </a:r>
+          </a:p>
+          <a:p>
+            <a:pPr algn="ctr"/>
+            <a:r>
+              <a:rPr lang="en-US" sz="2000">
+                <a:solidFill>
+                  <a:srgbClr val="FF4444"/>
+                </a:solidFill>
+                <a:effectLst>
+                  <a:glow rad="101600">
+                    <a:srgbClr val="FF0000">
+                      <a:alpha val="50000"/>
+                    </a:srgbClr>
+                  </a:glow>
+                </a:effectLst>
+              </a:rPr>
+              <a:t>Text with Glow</a:t>
+            </a:r>
+          </a:p>
+        </p:txBody>
+      </p:sp>
+      <p:sp>
+        <p:nvSpPr>
+          <p:cNvPr id="403" name="Extrusion3D"/>
+          <p:cNvSpPr/>
+          <p:nvPr/>
+        </p:nvSpPr>
+        <p:spPr>
+          <a:xfrm>
+            <a:off x="457200" y="3657600"/>
+            <a:ext cx="3200400" cy="1828800"/>
+          </a:xfrm>
+          <a:prstGeom prst="roundRect">
+            <a:avLst/>
+          </a:prstGeom>
+          <a:solidFill>
+            <a:srgbClr val="70AD47"/>
+          </a:solidFill>
+          <a:scene3d>
+            <a:camera prst="isometricLeftDown"/>
+            <a:lightRig rig="balanced" dir="t"/>
+          </a:scene3d>
+          <a:sp3d extrusionH="76200" contourW="12700" prstMaterial="warmMatte">
+            <a:bevelT w="101600" h="38100" prst="circle"/>
+            <a:bevelB w="50800" h="25400"/>
+            <a:extrusionClr>
+              <a:srgbClr val="5B8C3C"/>
+            </a:extrusionClr>
+            <a:contourClr>
+              <a:srgbClr val="2E5B14"/>
+            </a:contourClr>
+          </a:sp3d>
+        </p:spPr>
+        <p:txBody>
+          <a:bodyPr anchor="ctr"/>
+          <a:lstStyle/>
+          <a:p>
+            <a:pPr algn="ctr"/>
+            <a:r>
+              <a:rPr lang="en-US" sz="1400" b="1"/>
+              <a:t>3D Extrusion</a:t>
+            </a:r>
+          </a:p>
+        </p:txBody>
+      </p:sp>
+      <p:sp>
+        <p:nvSpPr>
+          <p:cNvPr id="404" name="TextBox 403"/>
+          <p:cNvSpPr txBox="1"/>
+          <p:nvPr/>
+        </p:nvSpPr>
+        <p:spPr>
+          <a:xfrm>
+            <a:off x="274320" y="182880"/>
+            <a:ext cx="8229600" cy="457200"/>
+          </a:xfrm>
+          <a:prstGeom prst="rect">
+            <a:avLst/>
+          </a:prstGeom>
+          <a:noFill/>
+        </p:spPr>
+        <p:txBody>
+          <a:bodyPr wrap="none">
+            <a:spAutoFit/>
+          </a:bodyPr>
+          <a:lstStyle/>
+          <a:p>
+            <a:pPr>
+              <a:defRPr sz="1800" b="1"/>
+            </a:pPr>
+            <a:r>
+              <a:t>Slide 51: 3D effects (bevel/extrusion/scene3d) + text shadow/glow</a:t>
             </a:r>
           </a:p>
         </p:txBody>

</xml_diff>

<commit_message>
feat: chart rendering — ChartML parser + SVG renderer for 7 chart types
Add complete chart support pipeline:
- ChartML parser (ooxml_chart.mbt): c:chartSpace → ChartData with bar/column,
  line, pie, donut, scatter, area, radar chart types
- Lazy chart resolution: parse_graphic_frame stores r:id placeholder,
  main.mbt resolves via rels + ffi_get_file
- Chart SVG renderer (renderer_chart.mbt): layout engine with title, legend,
  axes, and plot area; horizontal bar axis swap; pie/donut centered layout
- Integer trigonometry: cos/sin lookup table (1° × 1000) for pie/donut arcs
- Pie/donut legend shows category labels; bar/line legend shows series titles
- Test fixtures: slides 52-55 (column, line, pie, bar+donut charts)
- Documentation: CLAUDE.md, TODO.md, and memory updated with chart data model

Co-Authored-By: Claude Opus 4.6 <noreply@anthropic.com>
</commit_message>
<xml_diff>
--- a/test_fixtures/test_features.pptx
+++ b/test_fixtures/test_features.pptx
@@ -56,6 +56,10 @@
     <p:sldId id="304" r:id="rId55"/>
     <p:sldId id="305" r:id="rId56"/>
     <p:sldId id="306" r:id="rId57"/>
+    <p:sldId id="307" r:id="rId58"/>
+    <p:sldId id="308" r:id="rId59"/>
+    <p:sldId id="309" r:id="rId60"/>
+    <p:sldId id="310" r:id="rId61"/>
   </p:sldIdLst>
   <p:sldSz cx="9144000" cy="6858000" type="screen4x3"/>
   <p:notesSz cx="6858000" cy="9144000"/>
@@ -155,6 +159,672 @@
     </a:lvl9pPr>
   </p:defaultTextStyle>
 </p:presentation>
+</file>
+
+<file path=ppt/charts/chart1.xml><?xml version="1.0" encoding="utf-8"?>
+<c:chartSpace xmlns:c="http://schemas.openxmlformats.org/drawingml/2006/chart" xmlns:a="http://schemas.openxmlformats.org/drawingml/2006/main" xmlns:r="http://schemas.openxmlformats.org/officeDocument/2006/relationships">
+  <c:date1904 val="0"/>
+  <c:chart>
+    <c:autoTitleDeleted val="0"/>
+    <c:plotArea>
+      <c:barChart>
+        <c:barDir val="col"/>
+        <c:grouping val="clustered"/>
+        <c:ser>
+          <c:idx val="0"/>
+          <c:order val="0"/>
+          <c:tx>
+            <c:strRef>
+              <c:f>Sheet1!$B$1</c:f>
+              <c:strCache>
+                <c:ptCount val="1"/>
+                <c:pt idx="0">
+                  <c:v>Sales 2024</c:v>
+                </c:pt>
+              </c:strCache>
+            </c:strRef>
+          </c:tx>
+          <c:cat>
+            <c:strRef>
+              <c:f>Sheet1!$A$2:$A$5</c:f>
+              <c:strCache>
+                <c:ptCount val="4"/>
+                <c:pt idx="0">
+                  <c:v>Q1</c:v>
+                </c:pt>
+                <c:pt idx="1">
+                  <c:v>Q2</c:v>
+                </c:pt>
+                <c:pt idx="2">
+                  <c:v>Q3</c:v>
+                </c:pt>
+                <c:pt idx="3">
+                  <c:v>Q4</c:v>
+                </c:pt>
+              </c:strCache>
+            </c:strRef>
+          </c:cat>
+          <c:val>
+            <c:numRef>
+              <c:f>Sheet1!$B$2:$B$5</c:f>
+              <c:numCache>
+                <c:formatCode>General</c:formatCode>
+                <c:ptCount val="4"/>
+                <c:pt idx="0">
+                  <c:v>120</c:v>
+                </c:pt>
+                <c:pt idx="1">
+                  <c:v>150</c:v>
+                </c:pt>
+                <c:pt idx="2">
+                  <c:v>180</c:v>
+                </c:pt>
+                <c:pt idx="3">
+                  <c:v>200</c:v>
+                </c:pt>
+              </c:numCache>
+            </c:numRef>
+          </c:val>
+        </c:ser>
+        <c:ser>
+          <c:idx val="1"/>
+          <c:order val="1"/>
+          <c:tx>
+            <c:strRef>
+              <c:f>Sheet1!$C$1</c:f>
+              <c:strCache>
+                <c:ptCount val="1"/>
+                <c:pt idx="0">
+                  <c:v>Sales 2025</c:v>
+                </c:pt>
+              </c:strCache>
+            </c:strRef>
+          </c:tx>
+          <c:cat>
+            <c:strRef>
+              <c:f>Sheet1!$A$2:$A$5</c:f>
+              <c:strCache>
+                <c:ptCount val="4"/>
+                <c:pt idx="0">
+                  <c:v>Q1</c:v>
+                </c:pt>
+                <c:pt idx="1">
+                  <c:v>Q2</c:v>
+                </c:pt>
+                <c:pt idx="2">
+                  <c:v>Q3</c:v>
+                </c:pt>
+                <c:pt idx="3">
+                  <c:v>Q4</c:v>
+                </c:pt>
+              </c:strCache>
+            </c:strRef>
+          </c:cat>
+          <c:val>
+            <c:numRef>
+              <c:f>Sheet1!$C$2:$C$5</c:f>
+              <c:numCache>
+                <c:formatCode>General</c:formatCode>
+                <c:ptCount val="4"/>
+                <c:pt idx="0">
+                  <c:v>100</c:v>
+                </c:pt>
+                <c:pt idx="1">
+                  <c:v>130</c:v>
+                </c:pt>
+                <c:pt idx="2">
+                  <c:v>160</c:v>
+                </c:pt>
+                <c:pt idx="3">
+                  <c:v>190</c:v>
+                </c:pt>
+              </c:numCache>
+            </c:numRef>
+          </c:val>
+        </c:ser>
+        <c:axId val="-2068027336"/>
+        <c:axId val="-2113994440"/>
+      </c:barChart>
+      <c:catAx>
+        <c:axId val="-2068027336"/>
+        <c:scaling>
+          <c:orientation val="minMax"/>
+        </c:scaling>
+        <c:delete val="0"/>
+        <c:axPos val="b"/>
+        <c:majorTickMark val="out"/>
+        <c:minorTickMark val="none"/>
+        <c:tickLblPos val="nextTo"/>
+        <c:crossAx val="-2113994440"/>
+        <c:crosses val="autoZero"/>
+        <c:auto val="1"/>
+        <c:lblAlgn val="ctr"/>
+        <c:lblOffset val="100"/>
+        <c:noMultiLvlLbl val="0"/>
+      </c:catAx>
+      <c:valAx>
+        <c:axId val="-2113994440"/>
+        <c:scaling/>
+        <c:delete val="0"/>
+        <c:axPos val="l"/>
+        <c:majorGridlines/>
+        <c:majorTickMark val="out"/>
+        <c:minorTickMark val="none"/>
+        <c:tickLblPos val="nextTo"/>
+        <c:crossAx val="-2068027336"/>
+        <c:crosses val="autoZero"/>
+      </c:valAx>
+    </c:plotArea>
+    <c:legend/>
+    <c:dispBlanksAs val="gap"/>
+  </c:chart>
+  <c:txPr>
+    <a:bodyPr/>
+    <a:lstStyle/>
+    <a:p>
+      <a:pPr>
+        <a:defRPr sz="1800"/>
+      </a:pPr>
+      <a:endParaRPr lang="en-US"/>
+    </a:p>
+  </c:txPr>
+  <c:externalData r:id="rId1">
+    <c:autoUpdate val="0"/>
+  </c:externalData>
+</c:chartSpace>
+</file>
+
+<file path=ppt/charts/chart2.xml><?xml version="1.0" encoding="utf-8"?>
+<c:chartSpace xmlns:c="http://schemas.openxmlformats.org/drawingml/2006/chart" xmlns:a="http://schemas.openxmlformats.org/drawingml/2006/main" xmlns:r="http://schemas.openxmlformats.org/officeDocument/2006/relationships">
+  <c:date1904 val="0"/>
+  <c:chart>
+    <c:autoTitleDeleted val="0"/>
+    <c:plotArea>
+      <c:lineChart>
+        <c:grouping val="standard"/>
+        <c:varyColors val="0"/>
+        <c:ser>
+          <c:idx val="0"/>
+          <c:order val="0"/>
+          <c:tx>
+            <c:strRef>
+              <c:f>Sheet1!$B$1</c:f>
+              <c:strCache>
+                <c:ptCount val="1"/>
+                <c:pt idx="0">
+                  <c:v>Revenue</c:v>
+                </c:pt>
+              </c:strCache>
+            </c:strRef>
+          </c:tx>
+          <c:marker>
+            <c:symbol val="none"/>
+          </c:marker>
+          <c:cat>
+            <c:strRef>
+              <c:f>Sheet1!$A$2:$A$6</c:f>
+              <c:strCache>
+                <c:ptCount val="5"/>
+                <c:pt idx="0">
+                  <c:v>Jan</c:v>
+                </c:pt>
+                <c:pt idx="1">
+                  <c:v>Feb</c:v>
+                </c:pt>
+                <c:pt idx="2">
+                  <c:v>Mar</c:v>
+                </c:pt>
+                <c:pt idx="3">
+                  <c:v>Apr</c:v>
+                </c:pt>
+                <c:pt idx="4">
+                  <c:v>May</c:v>
+                </c:pt>
+              </c:strCache>
+            </c:strRef>
+          </c:cat>
+          <c:val>
+            <c:numRef>
+              <c:f>Sheet1!$B$2:$B$6</c:f>
+              <c:numCache>
+                <c:formatCode>General</c:formatCode>
+                <c:ptCount val="5"/>
+                <c:pt idx="0">
+                  <c:v>80</c:v>
+                </c:pt>
+                <c:pt idx="1">
+                  <c:v>95</c:v>
+                </c:pt>
+                <c:pt idx="2">
+                  <c:v>110</c:v>
+                </c:pt>
+                <c:pt idx="3">
+                  <c:v>105</c:v>
+                </c:pt>
+                <c:pt idx="4">
+                  <c:v>130</c:v>
+                </c:pt>
+              </c:numCache>
+            </c:numRef>
+          </c:val>
+          <c:smooth val="0"/>
+        </c:ser>
+        <c:ser>
+          <c:idx val="1"/>
+          <c:order val="1"/>
+          <c:tx>
+            <c:strRef>
+              <c:f>Sheet1!$C$1</c:f>
+              <c:strCache>
+                <c:ptCount val="1"/>
+                <c:pt idx="0">
+                  <c:v>Cost</c:v>
+                </c:pt>
+              </c:strCache>
+            </c:strRef>
+          </c:tx>
+          <c:marker>
+            <c:symbol val="none"/>
+          </c:marker>
+          <c:cat>
+            <c:strRef>
+              <c:f>Sheet1!$A$2:$A$6</c:f>
+              <c:strCache>
+                <c:ptCount val="5"/>
+                <c:pt idx="0">
+                  <c:v>Jan</c:v>
+                </c:pt>
+                <c:pt idx="1">
+                  <c:v>Feb</c:v>
+                </c:pt>
+                <c:pt idx="2">
+                  <c:v>Mar</c:v>
+                </c:pt>
+                <c:pt idx="3">
+                  <c:v>Apr</c:v>
+                </c:pt>
+                <c:pt idx="4">
+                  <c:v>May</c:v>
+                </c:pt>
+              </c:strCache>
+            </c:strRef>
+          </c:cat>
+          <c:val>
+            <c:numRef>
+              <c:f>Sheet1!$C$2:$C$6</c:f>
+              <c:numCache>
+                <c:formatCode>General</c:formatCode>
+                <c:ptCount val="5"/>
+                <c:pt idx="0">
+                  <c:v>60</c:v>
+                </c:pt>
+                <c:pt idx="1">
+                  <c:v>65</c:v>
+                </c:pt>
+                <c:pt idx="2">
+                  <c:v>70</c:v>
+                </c:pt>
+                <c:pt idx="3">
+                  <c:v>75</c:v>
+                </c:pt>
+                <c:pt idx="4">
+                  <c:v>80</c:v>
+                </c:pt>
+              </c:numCache>
+            </c:numRef>
+          </c:val>
+          <c:smooth val="0"/>
+        </c:ser>
+        <c:marker val="1"/>
+        <c:smooth val="0"/>
+        <c:axId val="2118791784"/>
+        <c:axId val="2140495176"/>
+      </c:lineChart>
+      <c:catAx>
+        <c:axId val="2118791784"/>
+        <c:scaling>
+          <c:orientation val="minMax"/>
+        </c:scaling>
+        <c:delete val="0"/>
+        <c:axPos val="b"/>
+        <c:majorTickMark val="out"/>
+        <c:minorTickMark val="none"/>
+        <c:tickLblPos val="nextTo"/>
+        <c:crossAx val="2140495176"/>
+        <c:crosses val="autoZero"/>
+        <c:auto val="1"/>
+        <c:lblAlgn val="ctr"/>
+        <c:lblOffset val="100"/>
+        <c:noMultiLvlLbl val="0"/>
+      </c:catAx>
+      <c:valAx>
+        <c:axId val="2140495176"/>
+        <c:scaling/>
+        <c:delete val="0"/>
+        <c:axPos val="l"/>
+        <c:majorGridlines/>
+        <c:majorTickMark val="out"/>
+        <c:minorTickMark val="none"/>
+        <c:tickLblPos val="nextTo"/>
+        <c:crossAx val="2118791784"/>
+        <c:crosses val="autoZero"/>
+      </c:valAx>
+    </c:plotArea>
+    <c:legend>
+      <c:legendPos val="r"/>
+      <c:layout/>
+      <c:overlay val="0"/>
+    </c:legend>
+    <c:plotVisOnly val="1"/>
+    <c:dispBlanksAs val="gap"/>
+    <c:showDLblsOverMax val="0"/>
+  </c:chart>
+  <c:txPr>
+    <a:bodyPr/>
+    <a:lstStyle/>
+    <a:p>
+      <a:pPr>
+        <a:defRPr sz="1800"/>
+      </a:pPr>
+      <a:endParaRPr lang="en-US"/>
+    </a:p>
+  </c:txPr>
+  <c:externalData r:id="rId1">
+    <c:autoUpdate val="0"/>
+  </c:externalData>
+</c:chartSpace>
+</file>
+
+<file path=ppt/charts/chart3.xml><?xml version="1.0" encoding="utf-8"?>
+<c:chartSpace xmlns:c="http://schemas.openxmlformats.org/drawingml/2006/chart" xmlns:a="http://schemas.openxmlformats.org/drawingml/2006/main" xmlns:r="http://schemas.openxmlformats.org/officeDocument/2006/relationships">
+  <c:chart>
+    <c:autoTitleDeleted val="0"/>
+    <c:plotArea>
+      <c:pieChart>
+        <c:varyColors val="1"/>
+        <c:ser>
+          <c:idx val="0"/>
+          <c:order val="0"/>
+          <c:tx>
+            <c:strRef>
+              <c:f>Sheet1!$B$1</c:f>
+              <c:strCache>
+                <c:ptCount val="1"/>
+                <c:pt idx="0">
+                  <c:v>Market Share</c:v>
+                </c:pt>
+              </c:strCache>
+            </c:strRef>
+          </c:tx>
+          <c:cat>
+            <c:strRef>
+              <c:f>Sheet1!$A$2:$A$5</c:f>
+              <c:strCache>
+                <c:ptCount val="4"/>
+                <c:pt idx="0">
+                  <c:v>Desktop</c:v>
+                </c:pt>
+                <c:pt idx="1">
+                  <c:v>Mobile</c:v>
+                </c:pt>
+                <c:pt idx="2">
+                  <c:v>Tablet</c:v>
+                </c:pt>
+                <c:pt idx="3">
+                  <c:v>Other</c:v>
+                </c:pt>
+              </c:strCache>
+            </c:strRef>
+          </c:cat>
+          <c:val>
+            <c:numRef>
+              <c:f>Sheet1!$B$2:$B$5</c:f>
+              <c:numCache>
+                <c:formatCode>General</c:formatCode>
+                <c:ptCount val="4"/>
+                <c:pt idx="0">
+                  <c:v>45</c:v>
+                </c:pt>
+                <c:pt idx="1">
+                  <c:v>35</c:v>
+                </c:pt>
+                <c:pt idx="2">
+                  <c:v>15</c:v>
+                </c:pt>
+                <c:pt idx="3">
+                  <c:v>5</c:v>
+                </c:pt>
+              </c:numCache>
+            </c:numRef>
+          </c:val>
+        </c:ser>
+      </c:pieChart>
+    </c:plotArea>
+    <c:legend/>
+    <c:dispBlanksAs val="gap"/>
+  </c:chart>
+  <c:txPr>
+    <a:bodyPr/>
+    <a:lstStyle/>
+    <a:p>
+      <a:pPr>
+        <a:defRPr sz="1800"/>
+      </a:pPr>
+      <a:endParaRPr lang="en-US"/>
+    </a:p>
+  </c:txPr>
+  <c:externalData r:id="rId1">
+    <c:autoUpdate val="0"/>
+  </c:externalData>
+</c:chartSpace>
+</file>
+
+<file path=ppt/charts/chart4.xml><?xml version="1.0" encoding="utf-8"?>
+<c:chartSpace xmlns:c="http://schemas.openxmlformats.org/drawingml/2006/chart" xmlns:a="http://schemas.openxmlformats.org/drawingml/2006/main" xmlns:r="http://schemas.openxmlformats.org/officeDocument/2006/relationships">
+  <c:date1904 val="0"/>
+  <c:chart>
+    <c:autoTitleDeleted val="0"/>
+    <c:plotArea>
+      <c:barChart>
+        <c:barDir val="bar"/>
+        <c:grouping val="clustered"/>
+        <c:ser>
+          <c:idx val="0"/>
+          <c:order val="0"/>
+          <c:tx>
+            <c:strRef>
+              <c:f>Sheet1!$B$1</c:f>
+              <c:strCache>
+                <c:ptCount val="1"/>
+                <c:pt idx="0">
+                  <c:v>Units Sold</c:v>
+                </c:pt>
+              </c:strCache>
+            </c:strRef>
+          </c:tx>
+          <c:cat>
+            <c:strRef>
+              <c:f>Sheet1!$A$2:$A$4</c:f>
+              <c:strCache>
+                <c:ptCount val="3"/>
+                <c:pt idx="0">
+                  <c:v>Product A</c:v>
+                </c:pt>
+                <c:pt idx="1">
+                  <c:v>Product B</c:v>
+                </c:pt>
+                <c:pt idx="2">
+                  <c:v>Product C</c:v>
+                </c:pt>
+              </c:strCache>
+            </c:strRef>
+          </c:cat>
+          <c:val>
+            <c:numRef>
+              <c:f>Sheet1!$B$2:$B$4</c:f>
+              <c:numCache>
+                <c:formatCode>General</c:formatCode>
+                <c:ptCount val="3"/>
+                <c:pt idx="0">
+                  <c:v>250</c:v>
+                </c:pt>
+                <c:pt idx="1">
+                  <c:v>180</c:v>
+                </c:pt>
+                <c:pt idx="2">
+                  <c:v>320</c:v>
+                </c:pt>
+              </c:numCache>
+            </c:numRef>
+          </c:val>
+        </c:ser>
+        <c:axId val="-2068027336"/>
+        <c:axId val="-2113994440"/>
+      </c:barChart>
+      <c:catAx>
+        <c:axId val="-2068027336"/>
+        <c:scaling>
+          <c:orientation val="minMax"/>
+        </c:scaling>
+        <c:delete val="0"/>
+        <c:axPos val="l"/>
+        <c:majorTickMark val="out"/>
+        <c:minorTickMark val="none"/>
+        <c:tickLblPos val="nextTo"/>
+        <c:crossAx val="-2113994440"/>
+        <c:crosses val="autoZero"/>
+        <c:auto val="1"/>
+        <c:lblAlgn val="ctr"/>
+        <c:lblOffset val="100"/>
+        <c:noMultiLvlLbl val="0"/>
+      </c:catAx>
+      <c:valAx>
+        <c:axId val="-2113994440"/>
+        <c:scaling/>
+        <c:delete val="0"/>
+        <c:axPos val="b"/>
+        <c:majorGridlines/>
+        <c:majorTickMark val="out"/>
+        <c:minorTickMark val="none"/>
+        <c:tickLblPos val="nextTo"/>
+        <c:crossAx val="-2068027336"/>
+        <c:crosses val="autoZero"/>
+      </c:valAx>
+    </c:plotArea>
+    <c:dispBlanksAs val="gap"/>
+  </c:chart>
+  <c:txPr>
+    <a:bodyPr/>
+    <a:lstStyle/>
+    <a:p>
+      <a:pPr>
+        <a:defRPr sz="1800"/>
+      </a:pPr>
+      <a:endParaRPr lang="en-US"/>
+    </a:p>
+  </c:txPr>
+  <c:externalData r:id="rId1">
+    <c:autoUpdate val="0"/>
+  </c:externalData>
+</c:chartSpace>
+</file>
+
+<file path=ppt/charts/chart5.xml><?xml version="1.0" encoding="utf-8"?>
+<c:chartSpace xmlns:c="http://schemas.openxmlformats.org/drawingml/2006/chart" xmlns:a="http://schemas.openxmlformats.org/drawingml/2006/main" xmlns:r="http://schemas.openxmlformats.org/officeDocument/2006/relationships">
+  <c:date1904 val="0"/>
+  <c:roundedCorners val="0"/>
+  <c:chart>
+    <c:autoTitleDeleted val="0"/>
+    <c:plotArea>
+      <c:layout/>
+      <c:doughnutChart>
+        <c:varyColors val="1"/>
+        <c:ser>
+          <c:idx val="0"/>
+          <c:order val="0"/>
+          <c:tx>
+            <c:strRef>
+              <c:f>Sheet1!$B$1</c:f>
+              <c:strCache>
+                <c:ptCount val="1"/>
+                <c:pt idx="0">
+                  <c:v>Responses</c:v>
+                </c:pt>
+              </c:strCache>
+            </c:strRef>
+          </c:tx>
+          <c:cat>
+            <c:strRef>
+              <c:f>Sheet1!$A$2:$A$4</c:f>
+              <c:strCache>
+                <c:ptCount val="3"/>
+                <c:pt idx="0">
+                  <c:v>Yes</c:v>
+                </c:pt>
+                <c:pt idx="1">
+                  <c:v>No</c:v>
+                </c:pt>
+                <c:pt idx="2">
+                  <c:v>Maybe</c:v>
+                </c:pt>
+              </c:strCache>
+            </c:strRef>
+          </c:cat>
+          <c:val>
+            <c:numRef>
+              <c:f>Sheet1!$B$2:$B$4</c:f>
+              <c:numCache>
+                <c:formatCode>General</c:formatCode>
+                <c:ptCount val="3"/>
+                <c:pt idx="0">
+                  <c:v>60</c:v>
+                </c:pt>
+                <c:pt idx="1">
+                  <c:v>25</c:v>
+                </c:pt>
+                <c:pt idx="2">
+                  <c:v>15</c:v>
+                </c:pt>
+              </c:numCache>
+            </c:numRef>
+          </c:val>
+        </c:ser>
+        <c:dLbls>
+          <c:showLegendKey val="0"/>
+          <c:showVal val="0"/>
+          <c:showCatName val="0"/>
+          <c:showSerName val="0"/>
+          <c:showPercent val="0"/>
+          <c:showBubbleSize val="0"/>
+          <c:showLeaderLines val="1"/>
+        </c:dLbls>
+        <c:firstSliceAng val="0"/>
+        <c:holeSize val="50"/>
+      </c:doughnutChart>
+    </c:plotArea>
+    <c:legend>
+      <c:legendPos val="r"/>
+      <c:layout/>
+      <c:overlay val="0"/>
+    </c:legend>
+    <c:plotVisOnly val="1"/>
+    <c:dispBlanksAs val="gap"/>
+    <c:showDLblsOverMax val="0"/>
+  </c:chart>
+  <c:txPr>
+    <a:bodyPr/>
+    <a:lstStyle/>
+    <a:p>
+      <a:pPr>
+        <a:defRPr sz="1800"/>
+      </a:pPr>
+      <a:endParaRPr/>
+    </a:p>
+  </c:txPr>
+  <c:externalData r:id="rId1">
+    <c:autoUpdate val="0"/>
+  </c:externalData>
+</c:chartSpace>
 </file>
 
 <file path=ppt/slideLayouts/slideLayout1.xml><?xml version="1.0" encoding="utf-8"?>
@@ -12031,6 +12701,292 @@
             </a:pPr>
             <a:r>
               <a:t>Slide 51: 3D effects (bevel/extrusion/scene3d) + text shadow/glow</a:t>
+            </a:r>
+          </a:p>
+        </p:txBody>
+      </p:sp>
+    </p:spTree>
+  </p:cSld>
+  <p:clrMapOvr>
+    <a:masterClrMapping/>
+  </p:clrMapOvr>
+</p:sld>
+</file>
+
+<file path=ppt/slides/slide52.xml><?xml version="1.0" encoding="utf-8"?>
+<p:sld xmlns:a="http://schemas.openxmlformats.org/drawingml/2006/main" xmlns:p="http://schemas.openxmlformats.org/presentationml/2006/main" xmlns:r="http://schemas.openxmlformats.org/officeDocument/2006/relationships">
+  <p:cSld>
+    <p:spTree>
+      <p:nvGrpSpPr>
+        <p:cNvPr id="1" name=""/>
+        <p:cNvGrpSpPr/>
+        <p:nvPr/>
+      </p:nvGrpSpPr>
+      <p:grpSpPr/>
+      <p:graphicFrame>
+        <p:nvGraphicFramePr>
+          <p:cNvPr id="2" name="Chart 1"/>
+          <p:cNvGraphicFramePr>
+            <a:graphicFrameLocks noGrp="1"/>
+          </p:cNvGraphicFramePr>
+          <p:nvPr/>
+        </p:nvGraphicFramePr>
+        <p:xfrm>
+          <a:off x="914400" y="1371600"/>
+          <a:ext cx="4572000" cy="3657600"/>
+        </p:xfrm>
+        <a:graphic>
+          <a:graphicData uri="http://schemas.openxmlformats.org/drawingml/2006/chart">
+            <c:chart xmlns:c="http://schemas.openxmlformats.org/drawingml/2006/chart" r:id="rId2"/>
+          </a:graphicData>
+        </a:graphic>
+      </p:graphicFrame>
+      <p:sp>
+        <p:nvSpPr>
+          <p:cNvPr id="3" name="TextBox 2"/>
+          <p:cNvSpPr txBox="1"/>
+          <p:nvPr/>
+        </p:nvSpPr>
+        <p:spPr>
+          <a:xfrm>
+            <a:off x="274320" y="182880"/>
+            <a:ext cx="8229600" cy="457200"/>
+          </a:xfrm>
+          <a:prstGeom prst="rect">
+            <a:avLst/>
+          </a:prstGeom>
+          <a:noFill/>
+        </p:spPr>
+        <p:txBody>
+          <a:bodyPr wrap="none">
+            <a:spAutoFit/>
+          </a:bodyPr>
+          <a:lstStyle/>
+          <a:p>
+            <a:pPr>
+              <a:defRPr sz="1800" b="1"/>
+            </a:pPr>
+            <a:r>
+              <a:t>Slide 52: Column chart (clustered)</a:t>
+            </a:r>
+          </a:p>
+        </p:txBody>
+      </p:sp>
+    </p:spTree>
+  </p:cSld>
+  <p:clrMapOvr>
+    <a:masterClrMapping/>
+  </p:clrMapOvr>
+</p:sld>
+</file>
+
+<file path=ppt/slides/slide53.xml><?xml version="1.0" encoding="utf-8"?>
+<p:sld xmlns:a="http://schemas.openxmlformats.org/drawingml/2006/main" xmlns:p="http://schemas.openxmlformats.org/presentationml/2006/main" xmlns:r="http://schemas.openxmlformats.org/officeDocument/2006/relationships">
+  <p:cSld>
+    <p:spTree>
+      <p:nvGrpSpPr>
+        <p:cNvPr id="1" name=""/>
+        <p:cNvGrpSpPr/>
+        <p:nvPr/>
+      </p:nvGrpSpPr>
+      <p:grpSpPr/>
+      <p:graphicFrame>
+        <p:nvGraphicFramePr>
+          <p:cNvPr id="2" name="Chart 1"/>
+          <p:cNvGraphicFramePr>
+            <a:graphicFrameLocks noGrp="1"/>
+          </p:cNvGraphicFramePr>
+          <p:nvPr/>
+        </p:nvGraphicFramePr>
+        <p:xfrm>
+          <a:off x="914400" y="1371600"/>
+          <a:ext cx="4572000" cy="3657600"/>
+        </p:xfrm>
+        <a:graphic>
+          <a:graphicData uri="http://schemas.openxmlformats.org/drawingml/2006/chart">
+            <c:chart xmlns:c="http://schemas.openxmlformats.org/drawingml/2006/chart" r:id="rId2"/>
+          </a:graphicData>
+        </a:graphic>
+      </p:graphicFrame>
+      <p:sp>
+        <p:nvSpPr>
+          <p:cNvPr id="3" name="TextBox 2"/>
+          <p:cNvSpPr txBox="1"/>
+          <p:nvPr/>
+        </p:nvSpPr>
+        <p:spPr>
+          <a:xfrm>
+            <a:off x="274320" y="182880"/>
+            <a:ext cx="8229600" cy="457200"/>
+          </a:xfrm>
+          <a:prstGeom prst="rect">
+            <a:avLst/>
+          </a:prstGeom>
+          <a:noFill/>
+        </p:spPr>
+        <p:txBody>
+          <a:bodyPr wrap="none">
+            <a:spAutoFit/>
+          </a:bodyPr>
+          <a:lstStyle/>
+          <a:p>
+            <a:pPr>
+              <a:defRPr sz="1800" b="1"/>
+            </a:pPr>
+            <a:r>
+              <a:t>Slide 53: Line chart</a:t>
+            </a:r>
+          </a:p>
+        </p:txBody>
+      </p:sp>
+    </p:spTree>
+  </p:cSld>
+  <p:clrMapOvr>
+    <a:masterClrMapping/>
+  </p:clrMapOvr>
+</p:sld>
+</file>
+
+<file path=ppt/slides/slide54.xml><?xml version="1.0" encoding="utf-8"?>
+<p:sld xmlns:a="http://schemas.openxmlformats.org/drawingml/2006/main" xmlns:p="http://schemas.openxmlformats.org/presentationml/2006/main" xmlns:r="http://schemas.openxmlformats.org/officeDocument/2006/relationships">
+  <p:cSld>
+    <p:spTree>
+      <p:nvGrpSpPr>
+        <p:cNvPr id="1" name=""/>
+        <p:cNvGrpSpPr/>
+        <p:nvPr/>
+      </p:nvGrpSpPr>
+      <p:grpSpPr/>
+      <p:graphicFrame>
+        <p:nvGraphicFramePr>
+          <p:cNvPr id="2" name="Chart 1"/>
+          <p:cNvGraphicFramePr>
+            <a:graphicFrameLocks noGrp="1"/>
+          </p:cNvGraphicFramePr>
+          <p:nvPr/>
+        </p:nvGraphicFramePr>
+        <p:xfrm>
+          <a:off x="1828800" y="1371600"/>
+          <a:ext cx="4572000" cy="3657600"/>
+        </p:xfrm>
+        <a:graphic>
+          <a:graphicData uri="http://schemas.openxmlformats.org/drawingml/2006/chart">
+            <c:chart xmlns:c="http://schemas.openxmlformats.org/drawingml/2006/chart" r:id="rId2"/>
+          </a:graphicData>
+        </a:graphic>
+      </p:graphicFrame>
+      <p:sp>
+        <p:nvSpPr>
+          <p:cNvPr id="3" name="TextBox 2"/>
+          <p:cNvSpPr txBox="1"/>
+          <p:nvPr/>
+        </p:nvSpPr>
+        <p:spPr>
+          <a:xfrm>
+            <a:off x="274320" y="182880"/>
+            <a:ext cx="8229600" cy="457200"/>
+          </a:xfrm>
+          <a:prstGeom prst="rect">
+            <a:avLst/>
+          </a:prstGeom>
+          <a:noFill/>
+        </p:spPr>
+        <p:txBody>
+          <a:bodyPr wrap="none">
+            <a:spAutoFit/>
+          </a:bodyPr>
+          <a:lstStyle/>
+          <a:p>
+            <a:pPr>
+              <a:defRPr sz="1800" b="1"/>
+            </a:pPr>
+            <a:r>
+              <a:t>Slide 54: Pie chart</a:t>
+            </a:r>
+          </a:p>
+        </p:txBody>
+      </p:sp>
+    </p:spTree>
+  </p:cSld>
+  <p:clrMapOvr>
+    <a:masterClrMapping/>
+  </p:clrMapOvr>
+</p:sld>
+</file>
+
+<file path=ppt/slides/slide55.xml><?xml version="1.0" encoding="utf-8"?>
+<p:sld xmlns:a="http://schemas.openxmlformats.org/drawingml/2006/main" xmlns:p="http://schemas.openxmlformats.org/presentationml/2006/main" xmlns:r="http://schemas.openxmlformats.org/officeDocument/2006/relationships">
+  <p:cSld>
+    <p:spTree>
+      <p:nvGrpSpPr>
+        <p:cNvPr id="1" name=""/>
+        <p:cNvGrpSpPr/>
+        <p:nvPr/>
+      </p:nvGrpSpPr>
+      <p:grpSpPr/>
+      <p:graphicFrame>
+        <p:nvGraphicFramePr>
+          <p:cNvPr id="2" name="Chart 1"/>
+          <p:cNvGraphicFramePr>
+            <a:graphicFrameLocks noGrp="1"/>
+          </p:cNvGraphicFramePr>
+          <p:nvPr/>
+        </p:nvGraphicFramePr>
+        <p:xfrm>
+          <a:off x="457200" y="1371600"/>
+          <a:ext cx="3657600" cy="3657600"/>
+        </p:xfrm>
+        <a:graphic>
+          <a:graphicData uri="http://schemas.openxmlformats.org/drawingml/2006/chart">
+            <c:chart xmlns:c="http://schemas.openxmlformats.org/drawingml/2006/chart" r:id="rId2"/>
+          </a:graphicData>
+        </a:graphic>
+      </p:graphicFrame>
+      <p:graphicFrame>
+        <p:nvGraphicFramePr>
+          <p:cNvPr id="3" name="Chart 2"/>
+          <p:cNvGraphicFramePr>
+            <a:graphicFrameLocks noGrp="1"/>
+          </p:cNvGraphicFramePr>
+          <p:nvPr/>
+        </p:nvGraphicFramePr>
+        <p:xfrm>
+          <a:off x="4572000" y="1371600"/>
+          <a:ext cx="3657600" cy="3657600"/>
+        </p:xfrm>
+        <a:graphic>
+          <a:graphicData uri="http://schemas.openxmlformats.org/drawingml/2006/chart">
+            <c:chart xmlns:c="http://schemas.openxmlformats.org/drawingml/2006/chart" r:id="rId3"/>
+          </a:graphicData>
+        </a:graphic>
+      </p:graphicFrame>
+      <p:sp>
+        <p:nvSpPr>
+          <p:cNvPr id="4" name="TextBox 3"/>
+          <p:cNvSpPr txBox="1"/>
+          <p:nvPr/>
+        </p:nvSpPr>
+        <p:spPr>
+          <a:xfrm>
+            <a:off x="274320" y="182880"/>
+            <a:ext cx="8229600" cy="457200"/>
+          </a:xfrm>
+          <a:prstGeom prst="rect">
+            <a:avLst/>
+          </a:prstGeom>
+          <a:noFill/>
+        </p:spPr>
+        <p:txBody>
+          <a:bodyPr wrap="none">
+            <a:spAutoFit/>
+          </a:bodyPr>
+          <a:lstStyle/>
+          <a:p>
+            <a:pPr>
+              <a:defRPr sz="1800" b="1"/>
+            </a:pPr>
+            <a:r>
+              <a:t>Slide 55: Bar chart (horizontal) + Donut chart</a:t>
             </a:r>
           </a:p>
         </p:txBody>

</xml_diff>

<commit_message>
feat: chart data labels, per-point colors, theme palette + refactoring
Add c:dLbls parsing (showVal/showCatName/showSerName/showPercent) with
SVG rendering for bar, line, pie, and donut charts. Add c:dPt per-point
color overrides for pie/donut/bar slices. Build chart color palette from
theme accent1-6 with darker variants fallback. Fix legend colors for
pie/donut to respect dPt overrides. Fix line chart series color to check
stroke (a:ln) when fill is unset.

Refactoring: remove unused ChartSpPr::is_none and ChartSeries::default,
consolidate duplicate chart_data_label_color constant, extract
render_legend_entry helper, deduplicate get_cat_labels branches,
modernize while loops to for-in throughout chart code.

Co-Authored-By: Claude Opus 4.6 <noreply@anthropic.com>
</commit_message>
<xml_diff>
--- a/test_fixtures/test_features.pptx
+++ b/test_fixtures/test_features.pptx
@@ -60,6 +60,9 @@
     <p:sldId id="308" r:id="rId59"/>
     <p:sldId id="309" r:id="rId60"/>
     <p:sldId id="310" r:id="rId61"/>
+    <p:sldId id="311" r:id="rId62"/>
+    <p:sldId id="312" r:id="rId63"/>
+    <p:sldId id="313" r:id="rId64"/>
   </p:sldIdLst>
   <p:sldSz cx="9144000" cy="6858000" type="screen4x3"/>
   <p:notesSz cx="6858000" cy="9144000"/>
@@ -827,6 +830,483 @@
 </c:chartSpace>
 </file>
 
+<file path=ppt/charts/chart6.xml><?xml version="1.0" encoding="utf-8"?>
+<c:chartSpace xmlns:c="http://schemas.openxmlformats.org/drawingml/2006/chart" xmlns:a="http://schemas.openxmlformats.org/drawingml/2006/main" xmlns:r="http://schemas.openxmlformats.org/officeDocument/2006/relationships">
+  <c:date1904 val="0"/>
+  <c:chart>
+    <c:autoTitleDeleted val="0"/>
+    <c:plotArea>
+      <c:barChart>
+        <c:barDir val="col"/>
+        <c:grouping val="clustered"/>
+        <c:ser>
+          <c:idx val="0"/>
+          <c:order val="0"/>
+          <c:tx>
+            <c:strRef>
+              <c:f>Sheet1!$B$1</c:f>
+              <c:strCache>
+                <c:ptCount val="1"/>
+                <c:pt idx="0">
+                  <c:v>Revenue</c:v>
+                </c:pt>
+              </c:strCache>
+            </c:strRef>
+          </c:tx>
+          <c:cat>
+            <c:strRef>
+              <c:f>Sheet1!$A$2:$A$5</c:f>
+              <c:strCache>
+                <c:ptCount val="4"/>
+                <c:pt idx="0">
+                  <c:v>North</c:v>
+                </c:pt>
+                <c:pt idx="1">
+                  <c:v>South</c:v>
+                </c:pt>
+                <c:pt idx="2">
+                  <c:v>East</c:v>
+                </c:pt>
+                <c:pt idx="3">
+                  <c:v>West</c:v>
+                </c:pt>
+              </c:strCache>
+            </c:strRef>
+          </c:cat>
+          <c:val>
+            <c:numRef>
+              <c:f>Sheet1!$B$2:$B$5</c:f>
+              <c:numCache>
+                <c:formatCode>General</c:formatCode>
+                <c:ptCount val="4"/>
+                <c:pt idx="0">
+                  <c:v>320</c:v>
+                </c:pt>
+                <c:pt idx="1">
+                  <c:v>280</c:v>
+                </c:pt>
+                <c:pt idx="2">
+                  <c:v>190</c:v>
+                </c:pt>
+                <c:pt idx="3">
+                  <c:v>410</c:v>
+                </c:pt>
+              </c:numCache>
+            </c:numRef>
+          </c:val>
+        </c:ser>
+        <c:dLbls>
+          <c:showLegendKey val="0"/>
+          <c:showVal val="1"/>
+          <c:showCatName val="0"/>
+          <c:showSerName val="0"/>
+          <c:showPercent val="0"/>
+          <c:showBubbleSize val="0"/>
+          <c:showLeaderLines val="1"/>
+        </c:dLbls>
+        <c:axId val="-2068027336"/>
+        <c:axId val="-2113994440"/>
+      </c:barChart>
+      <c:catAx>
+        <c:axId val="-2068027336"/>
+        <c:scaling>
+          <c:orientation val="minMax"/>
+        </c:scaling>
+        <c:delete val="0"/>
+        <c:axPos val="b"/>
+        <c:majorTickMark val="out"/>
+        <c:minorTickMark val="none"/>
+        <c:tickLblPos val="nextTo"/>
+        <c:crossAx val="-2113994440"/>
+        <c:crosses val="autoZero"/>
+        <c:auto val="1"/>
+        <c:lblAlgn val="ctr"/>
+        <c:lblOffset val="100"/>
+        <c:noMultiLvlLbl val="0"/>
+      </c:catAx>
+      <c:valAx>
+        <c:axId val="-2113994440"/>
+        <c:scaling/>
+        <c:delete val="0"/>
+        <c:axPos val="l"/>
+        <c:majorGridlines/>
+        <c:majorTickMark val="out"/>
+        <c:minorTickMark val="none"/>
+        <c:tickLblPos val="nextTo"/>
+        <c:crossAx val="-2068027336"/>
+        <c:crosses val="autoZero"/>
+      </c:valAx>
+    </c:plotArea>
+    <c:legend/>
+    <c:dispBlanksAs val="gap"/>
+  </c:chart>
+  <c:txPr>
+    <a:bodyPr/>
+    <a:lstStyle/>
+    <a:p>
+      <a:pPr>
+        <a:defRPr sz="1800"/>
+      </a:pPr>
+      <a:endParaRPr lang="en-US"/>
+    </a:p>
+  </c:txPr>
+  <c:externalData r:id="rId1">
+    <c:autoUpdate val="0"/>
+  </c:externalData>
+</c:chartSpace>
+</file>
+
+<file path=ppt/charts/chart7.xml><?xml version="1.0" encoding="utf-8"?>
+<c:chartSpace xmlns:c="http://schemas.openxmlformats.org/drawingml/2006/chart" xmlns:a="http://schemas.openxmlformats.org/drawingml/2006/main" xmlns:r="http://schemas.openxmlformats.org/officeDocument/2006/relationships">
+  <c:chart>
+    <c:autoTitleDeleted val="0"/>
+    <c:plotArea>
+      <c:pieChart>
+        <c:varyColors val="1"/>
+        <c:ser>
+          <c:idx val="0"/>
+          <c:order val="0"/>
+          <c:tx>
+            <c:strRef>
+              <c:f>Sheet1!$B$1</c:f>
+              <c:strCache>
+                <c:ptCount val="1"/>
+                <c:pt idx="0">
+                  <c:v>Browser Share</c:v>
+                </c:pt>
+              </c:strCache>
+            </c:strRef>
+          </c:tx>
+          <c:cat>
+            <c:strRef>
+              <c:f>Sheet1!$A$2:$A$6</c:f>
+              <c:strCache>
+                <c:ptCount val="5"/>
+                <c:pt idx="0">
+                  <c:v>Chrome</c:v>
+                </c:pt>
+                <c:pt idx="1">
+                  <c:v>Firefox</c:v>
+                </c:pt>
+                <c:pt idx="2">
+                  <c:v>Safari</c:v>
+                </c:pt>
+                <c:pt idx="3">
+                  <c:v>Edge</c:v>
+                </c:pt>
+                <c:pt idx="4">
+                  <c:v>Other</c:v>
+                </c:pt>
+              </c:strCache>
+            </c:strRef>
+          </c:cat>
+          <c:val>
+            <c:numRef>
+              <c:f>Sheet1!$B$2:$B$6</c:f>
+              <c:numCache>
+                <c:formatCode>General</c:formatCode>
+                <c:ptCount val="5"/>
+                <c:pt idx="0">
+                  <c:v>65</c:v>
+                </c:pt>
+                <c:pt idx="1">
+                  <c:v>10</c:v>
+                </c:pt>
+                <c:pt idx="2">
+                  <c:v>18</c:v>
+                </c:pt>
+                <c:pt idx="3">
+                  <c:v>5</c:v>
+                </c:pt>
+                <c:pt idx="4">
+                  <c:v>2</c:v>
+                </c:pt>
+              </c:numCache>
+            </c:numRef>
+          </c:val>
+          <c:dPt>
+            <c:idx val="0"/>
+            <c:spPr>
+              <a:solidFill>
+                <a:srgbClr val="4285F4"/>
+              </a:solidFill>
+            </c:spPr>
+          </c:dPt>
+          <c:dPt>
+            <c:idx val="1"/>
+            <c:spPr>
+              <a:solidFill>
+                <a:srgbClr val="FF7139"/>
+              </a:solidFill>
+            </c:spPr>
+          </c:dPt>
+          <c:dPt>
+            <c:idx val="2"/>
+            <c:spPr>
+              <a:solidFill>
+                <a:srgbClr val="000000"/>
+              </a:solidFill>
+            </c:spPr>
+          </c:dPt>
+          <c:dPt>
+            <c:idx val="3"/>
+            <c:spPr>
+              <a:solidFill>
+                <a:srgbClr val="0078D4"/>
+              </a:solidFill>
+            </c:spPr>
+          </c:dPt>
+          <c:dPt>
+            <c:idx val="4"/>
+            <c:spPr>
+              <a:solidFill>
+                <a:srgbClr val="888888"/>
+              </a:solidFill>
+            </c:spPr>
+          </c:dPt>
+        </c:ser>
+        <c:dLbls>
+          <c:showLegendKey val="0"/>
+          <c:showVal val="0"/>
+          <c:showCatName val="1"/>
+          <c:showSerName val="0"/>
+          <c:showPercent val="1"/>
+          <c:showBubbleSize val="0"/>
+          <c:showLeaderLines val="1"/>
+        </c:dLbls>
+      </c:pieChart>
+    </c:plotArea>
+    <c:legend/>
+    <c:dispBlanksAs val="gap"/>
+  </c:chart>
+  <c:txPr>
+    <a:bodyPr/>
+    <a:lstStyle/>
+    <a:p>
+      <a:pPr>
+        <a:defRPr sz="1800"/>
+      </a:pPr>
+      <a:endParaRPr lang="en-US"/>
+    </a:p>
+  </c:txPr>
+  <c:externalData r:id="rId1">
+    <c:autoUpdate val="0"/>
+  </c:externalData>
+</c:chartSpace>
+</file>
+
+<file path=ppt/charts/chart8.xml><?xml version="1.0" encoding="utf-8"?>
+<c:chartSpace xmlns:c="http://schemas.openxmlformats.org/drawingml/2006/chart" xmlns:a="http://schemas.openxmlformats.org/drawingml/2006/main" xmlns:r="http://schemas.openxmlformats.org/officeDocument/2006/relationships">
+  <c:date1904 val="0"/>
+  <c:chart>
+    <c:autoTitleDeleted val="0"/>
+    <c:plotArea>
+      <c:lineChart>
+        <c:grouping val="standard"/>
+        <c:varyColors val="0"/>
+        <c:ser>
+          <c:idx val="0"/>
+          <c:order val="0"/>
+          <c:tx>
+            <c:strRef>
+              <c:f>Sheet1!$B$1</c:f>
+              <c:strCache>
+                <c:ptCount val="1"/>
+                <c:pt idx="0">
+                  <c:v>Actual</c:v>
+                </c:pt>
+              </c:strCache>
+            </c:strRef>
+          </c:tx>
+          <c:spPr>
+            <a:ln>
+              <a:solidFill>
+                <a:srgbClr val="008800"/>
+              </a:solidFill>
+            </a:ln>
+          </c:spPr>
+          <c:marker>
+            <c:symbol val="none"/>
+          </c:marker>
+          <c:cat>
+            <c:strRef>
+              <c:f>Sheet1!$A$2:$A$5</c:f>
+              <c:strCache>
+                <c:ptCount val="4"/>
+                <c:pt idx="0">
+                  <c:v>Week 1</c:v>
+                </c:pt>
+                <c:pt idx="1">
+                  <c:v>Week 2</c:v>
+                </c:pt>
+                <c:pt idx="2">
+                  <c:v>Week 3</c:v>
+                </c:pt>
+                <c:pt idx="3">
+                  <c:v>Week 4</c:v>
+                </c:pt>
+              </c:strCache>
+            </c:strRef>
+          </c:cat>
+          <c:val>
+            <c:numRef>
+              <c:f>Sheet1!$B$2:$B$5</c:f>
+              <c:numCache>
+                <c:formatCode>General</c:formatCode>
+                <c:ptCount val="4"/>
+                <c:pt idx="0">
+                  <c:v>10</c:v>
+                </c:pt>
+                <c:pt idx="1">
+                  <c:v>25</c:v>
+                </c:pt>
+                <c:pt idx="2">
+                  <c:v>40</c:v>
+                </c:pt>
+                <c:pt idx="3">
+                  <c:v>55</c:v>
+                </c:pt>
+              </c:numCache>
+            </c:numRef>
+          </c:val>
+          <c:smooth val="0"/>
+        </c:ser>
+        <c:ser>
+          <c:idx val="1"/>
+          <c:order val="1"/>
+          <c:tx>
+            <c:strRef>
+              <c:f>Sheet1!$C$1</c:f>
+              <c:strCache>
+                <c:ptCount val="1"/>
+                <c:pt idx="0">
+                  <c:v>Target</c:v>
+                </c:pt>
+              </c:strCache>
+            </c:strRef>
+          </c:tx>
+          <c:spPr>
+            <a:ln>
+              <a:solidFill>
+                <a:srgbClr val="FF0000"/>
+              </a:solidFill>
+            </a:ln>
+          </c:spPr>
+          <c:marker>
+            <c:symbol val="none"/>
+          </c:marker>
+          <c:cat>
+            <c:strRef>
+              <c:f>Sheet1!$A$2:$A$5</c:f>
+              <c:strCache>
+                <c:ptCount val="4"/>
+                <c:pt idx="0">
+                  <c:v>Week 1</c:v>
+                </c:pt>
+                <c:pt idx="1">
+                  <c:v>Week 2</c:v>
+                </c:pt>
+                <c:pt idx="2">
+                  <c:v>Week 3</c:v>
+                </c:pt>
+                <c:pt idx="3">
+                  <c:v>Week 4</c:v>
+                </c:pt>
+              </c:strCache>
+            </c:strRef>
+          </c:cat>
+          <c:val>
+            <c:numRef>
+              <c:f>Sheet1!$C$2:$C$5</c:f>
+              <c:numCache>
+                <c:formatCode>General</c:formatCode>
+                <c:ptCount val="4"/>
+                <c:pt idx="0">
+                  <c:v>15</c:v>
+                </c:pt>
+                <c:pt idx="1">
+                  <c:v>30</c:v>
+                </c:pt>
+                <c:pt idx="2">
+                  <c:v>45</c:v>
+                </c:pt>
+                <c:pt idx="3">
+                  <c:v>60</c:v>
+                </c:pt>
+              </c:numCache>
+            </c:numRef>
+          </c:val>
+          <c:smooth val="0"/>
+        </c:ser>
+        <c:dLbls>
+          <c:showLegendKey val="0"/>
+          <c:showVal val="1"/>
+          <c:showCatName val="0"/>
+          <c:showSerName val="0"/>
+          <c:showPercent val="0"/>
+          <c:showBubbleSize val="0"/>
+          <c:showLeaderLines val="1"/>
+        </c:dLbls>
+        <c:marker val="1"/>
+        <c:smooth val="0"/>
+        <c:axId val="2118791784"/>
+        <c:axId val="2140495176"/>
+      </c:lineChart>
+      <c:catAx>
+        <c:axId val="2118791784"/>
+        <c:scaling>
+          <c:orientation val="minMax"/>
+        </c:scaling>
+        <c:delete val="0"/>
+        <c:axPos val="b"/>
+        <c:majorTickMark val="out"/>
+        <c:minorTickMark val="none"/>
+        <c:tickLblPos val="nextTo"/>
+        <c:crossAx val="2140495176"/>
+        <c:crosses val="autoZero"/>
+        <c:auto val="1"/>
+        <c:lblAlgn val="ctr"/>
+        <c:lblOffset val="100"/>
+        <c:noMultiLvlLbl val="0"/>
+      </c:catAx>
+      <c:valAx>
+        <c:axId val="2140495176"/>
+        <c:scaling/>
+        <c:delete val="0"/>
+        <c:axPos val="l"/>
+        <c:majorGridlines/>
+        <c:majorTickMark val="out"/>
+        <c:minorTickMark val="none"/>
+        <c:tickLblPos val="nextTo"/>
+        <c:crossAx val="2118791784"/>
+        <c:crosses val="autoZero"/>
+      </c:valAx>
+    </c:plotArea>
+    <c:legend>
+      <c:legendPos val="r"/>
+      <c:layout/>
+      <c:overlay val="0"/>
+    </c:legend>
+    <c:plotVisOnly val="1"/>
+    <c:dispBlanksAs val="gap"/>
+    <c:showDLblsOverMax val="0"/>
+  </c:chart>
+  <c:txPr>
+    <a:bodyPr/>
+    <a:lstStyle/>
+    <a:p>
+      <a:pPr>
+        <a:defRPr sz="1800"/>
+      </a:pPr>
+      <a:endParaRPr lang="en-US"/>
+    </a:p>
+  </c:txPr>
+  <c:externalData r:id="rId1">
+    <c:autoUpdate val="0"/>
+  </c:externalData>
+</c:chartSpace>
+</file>
+
 <file path=ppt/slideLayouts/slideLayout1.xml><?xml version="1.0" encoding="utf-8"?>
 <p:sldLayout xmlns:a="http://schemas.openxmlformats.org/drawingml/2006/main" xmlns:r="http://schemas.openxmlformats.org/officeDocument/2006/relationships" xmlns:p="http://schemas.openxmlformats.org/presentationml/2006/main" type="title" preserve="1">
   <p:cSld name="Title Slide">
@@ -12987,6 +13467,207 @@
             </a:pPr>
             <a:r>
               <a:t>Slide 55: Bar chart (horizontal) + Donut chart</a:t>
+            </a:r>
+          </a:p>
+        </p:txBody>
+      </p:sp>
+    </p:spTree>
+  </p:cSld>
+  <p:clrMapOvr>
+    <a:masterClrMapping/>
+  </p:clrMapOvr>
+</p:sld>
+</file>
+
+<file path=ppt/slides/slide56.xml><?xml version="1.0" encoding="utf-8"?>
+<p:sld xmlns:a="http://schemas.openxmlformats.org/drawingml/2006/main" xmlns:p="http://schemas.openxmlformats.org/presentationml/2006/main" xmlns:r="http://schemas.openxmlformats.org/officeDocument/2006/relationships">
+  <p:cSld>
+    <p:spTree>
+      <p:nvGrpSpPr>
+        <p:cNvPr id="1" name=""/>
+        <p:cNvGrpSpPr/>
+        <p:nvPr/>
+      </p:nvGrpSpPr>
+      <p:grpSpPr/>
+      <p:graphicFrame>
+        <p:nvGraphicFramePr>
+          <p:cNvPr id="2" name="Chart 1"/>
+          <p:cNvGraphicFramePr>
+            <a:graphicFrameLocks noGrp="1"/>
+          </p:cNvGraphicFramePr>
+          <p:nvPr/>
+        </p:nvGraphicFramePr>
+        <p:xfrm>
+          <a:off x="914400" y="1371600"/>
+          <a:ext cx="4572000" cy="3657600"/>
+        </p:xfrm>
+        <a:graphic>
+          <a:graphicData uri="http://schemas.openxmlformats.org/drawingml/2006/chart">
+            <c:chart xmlns:c="http://schemas.openxmlformats.org/drawingml/2006/chart" r:id="rId2"/>
+          </a:graphicData>
+        </a:graphic>
+      </p:graphicFrame>
+      <p:sp>
+        <p:nvSpPr>
+          <p:cNvPr id="3" name="TextBox 2"/>
+          <p:cNvSpPr txBox="1"/>
+          <p:nvPr/>
+        </p:nvSpPr>
+        <p:spPr>
+          <a:xfrm>
+            <a:off x="274320" y="182880"/>
+            <a:ext cx="8229600" cy="457200"/>
+          </a:xfrm>
+          <a:prstGeom prst="rect">
+            <a:avLst/>
+          </a:prstGeom>
+          <a:noFill/>
+        </p:spPr>
+        <p:txBody>
+          <a:bodyPr wrap="none">
+            <a:spAutoFit/>
+          </a:bodyPr>
+          <a:lstStyle/>
+          <a:p>
+            <a:pPr>
+              <a:defRPr sz="1800" b="1"/>
+            </a:pPr>
+            <a:r>
+              <a:t>Slide 56: Column chart with data labels</a:t>
+            </a:r>
+          </a:p>
+        </p:txBody>
+      </p:sp>
+    </p:spTree>
+  </p:cSld>
+  <p:clrMapOvr>
+    <a:masterClrMapping/>
+  </p:clrMapOvr>
+</p:sld>
+</file>
+
+<file path=ppt/slides/slide57.xml><?xml version="1.0" encoding="utf-8"?>
+<p:sld xmlns:a="http://schemas.openxmlformats.org/drawingml/2006/main" xmlns:p="http://schemas.openxmlformats.org/presentationml/2006/main" xmlns:r="http://schemas.openxmlformats.org/officeDocument/2006/relationships">
+  <p:cSld>
+    <p:spTree>
+      <p:nvGrpSpPr>
+        <p:cNvPr id="1" name=""/>
+        <p:cNvGrpSpPr/>
+        <p:nvPr/>
+      </p:nvGrpSpPr>
+      <p:grpSpPr/>
+      <p:graphicFrame>
+        <p:nvGraphicFramePr>
+          <p:cNvPr id="2" name="Chart 1"/>
+          <p:cNvGraphicFramePr>
+            <a:graphicFrameLocks noGrp="1"/>
+          </p:cNvGraphicFramePr>
+          <p:nvPr/>
+        </p:nvGraphicFramePr>
+        <p:xfrm>
+          <a:off x="1828800" y="1371600"/>
+          <a:ext cx="4572000" cy="3657600"/>
+        </p:xfrm>
+        <a:graphic>
+          <a:graphicData uri="http://schemas.openxmlformats.org/drawingml/2006/chart">
+            <c:chart xmlns:c="http://schemas.openxmlformats.org/drawingml/2006/chart" r:id="rId2"/>
+          </a:graphicData>
+        </a:graphic>
+      </p:graphicFrame>
+      <p:sp>
+        <p:nvSpPr>
+          <p:cNvPr id="3" name="TextBox 2"/>
+          <p:cNvSpPr txBox="1"/>
+          <p:nvPr/>
+        </p:nvSpPr>
+        <p:spPr>
+          <a:xfrm>
+            <a:off x="274320" y="182880"/>
+            <a:ext cx="8229600" cy="457200"/>
+          </a:xfrm>
+          <a:prstGeom prst="rect">
+            <a:avLst/>
+          </a:prstGeom>
+          <a:noFill/>
+        </p:spPr>
+        <p:txBody>
+          <a:bodyPr wrap="none">
+            <a:spAutoFit/>
+          </a:bodyPr>
+          <a:lstStyle/>
+          <a:p>
+            <a:pPr>
+              <a:defRPr sz="1800" b="1"/>
+            </a:pPr>
+            <a:r>
+              <a:t>Slide 57: Pie chart with custom colors + % labels</a:t>
+            </a:r>
+          </a:p>
+        </p:txBody>
+      </p:sp>
+    </p:spTree>
+  </p:cSld>
+  <p:clrMapOvr>
+    <a:masterClrMapping/>
+  </p:clrMapOvr>
+</p:sld>
+</file>
+
+<file path=ppt/slides/slide58.xml><?xml version="1.0" encoding="utf-8"?>
+<p:sld xmlns:a="http://schemas.openxmlformats.org/drawingml/2006/main" xmlns:p="http://schemas.openxmlformats.org/presentationml/2006/main" xmlns:r="http://schemas.openxmlformats.org/officeDocument/2006/relationships">
+  <p:cSld>
+    <p:spTree>
+      <p:nvGrpSpPr>
+        <p:cNvPr id="1" name=""/>
+        <p:cNvGrpSpPr/>
+        <p:nvPr/>
+      </p:nvGrpSpPr>
+      <p:grpSpPr/>
+      <p:graphicFrame>
+        <p:nvGraphicFramePr>
+          <p:cNvPr id="2" name="Chart 1"/>
+          <p:cNvGraphicFramePr>
+            <a:graphicFrameLocks noGrp="1"/>
+          </p:cNvGraphicFramePr>
+          <p:nvPr/>
+        </p:nvGraphicFramePr>
+        <p:xfrm>
+          <a:off x="914400" y="1371600"/>
+          <a:ext cx="4572000" cy="3657600"/>
+        </p:xfrm>
+        <a:graphic>
+          <a:graphicData uri="http://schemas.openxmlformats.org/drawingml/2006/chart">
+            <c:chart xmlns:c="http://schemas.openxmlformats.org/drawingml/2006/chart" r:id="rId2"/>
+          </a:graphicData>
+        </a:graphic>
+      </p:graphicFrame>
+      <p:sp>
+        <p:nvSpPr>
+          <p:cNvPr id="3" name="TextBox 2"/>
+          <p:cNvSpPr txBox="1"/>
+          <p:nvPr/>
+        </p:nvSpPr>
+        <p:spPr>
+          <a:xfrm>
+            <a:off x="274320" y="182880"/>
+            <a:ext cx="8229600" cy="457200"/>
+          </a:xfrm>
+          <a:prstGeom prst="rect">
+            <a:avLst/>
+          </a:prstGeom>
+          <a:noFill/>
+        </p:spPr>
+        <p:txBody>
+          <a:bodyPr wrap="none">
+            <a:spAutoFit/>
+          </a:bodyPr>
+          <a:lstStyle/>
+          <a:p>
+            <a:pPr>
+              <a:defRPr sz="1800" b="1"/>
+            </a:pPr>
+            <a:r>
+              <a:t>Slide 58: Line chart with series colors + data labels</a:t>
             </a:r>
           </a:p>
         </p:txBody>

</xml_diff>

<commit_message>
feat: bubble/stock chart types + comprehensive test slides + refactoring
Add bubble chart (c:bubbleChart) and stock chart (c:stockChart OHLC)
parsing and SVG rendering. Fix scatter/bubble axis labels by adding
chart-type-aware axis range calculation. Add test slides 59-63
(scatter, area, radar, bubble, stock, all-charts overview).

Refactor: modernize while→for-in loops, extract get_xy_range helper,
centralize chart_bubble_max_r constant, consolidate TODO.md.

Co-Authored-By: Claude Opus 4.6 <noreply@anthropic.com>
</commit_message>
<xml_diff>
--- a/test_fixtures/test_features.pptx
+++ b/test_fixtures/test_features.pptx
@@ -63,6 +63,11 @@
     <p:sldId id="311" r:id="rId62"/>
     <p:sldId id="312" r:id="rId63"/>
     <p:sldId id="313" r:id="rId64"/>
+    <p:sldId id="314" r:id="rId65"/>
+    <p:sldId id="315" r:id="rId66"/>
+    <p:sldId id="316" r:id="rId67"/>
+    <p:sldId id="317" r:id="rId68"/>
+    <p:sldId id="318" r:id="rId69"/>
   </p:sldIdLst>
   <p:sldSz cx="9144000" cy="6858000" type="screen4x3"/>
   <p:notesSz cx="6858000" cy="9144000"/>
@@ -337,6 +342,1549 @@
 </c:chartSpace>
 </file>
 
+<file path=ppt/charts/chart10.xml><?xml version="1.0" encoding="utf-8"?>
+<c:chartSpace xmlns:c="http://schemas.openxmlformats.org/drawingml/2006/chart" xmlns:a="http://schemas.openxmlformats.org/drawingml/2006/main" xmlns:r="http://schemas.openxmlformats.org/officeDocument/2006/relationships">
+  <c:date1904 val="0"/>
+  <c:roundedCorners val="0"/>
+  <c:chart>
+    <c:autoTitleDeleted val="0"/>
+    <c:plotArea>
+      <c:layout/>
+      <c:areaChart>
+        <c:grouping val="standard"/>
+        <c:varyColors val="0"/>
+        <c:ser>
+          <c:idx val="0"/>
+          <c:order val="0"/>
+          <c:tx>
+            <c:strRef>
+              <c:f>Sheet1!$B$1</c:f>
+              <c:strCache>
+                <c:ptCount val="1"/>
+                <c:pt idx="0">
+                  <c:v>Downloads</c:v>
+                </c:pt>
+              </c:strCache>
+            </c:strRef>
+          </c:tx>
+          <c:cat>
+            <c:strRef>
+              <c:f>Sheet1!$A$2:$A$6</c:f>
+              <c:strCache>
+                <c:ptCount val="5"/>
+                <c:pt idx="0">
+                  <c:v>Jan</c:v>
+                </c:pt>
+                <c:pt idx="1">
+                  <c:v>Feb</c:v>
+                </c:pt>
+                <c:pt idx="2">
+                  <c:v>Mar</c:v>
+                </c:pt>
+                <c:pt idx="3">
+                  <c:v>Apr</c:v>
+                </c:pt>
+                <c:pt idx="4">
+                  <c:v>May</c:v>
+                </c:pt>
+              </c:strCache>
+            </c:strRef>
+          </c:cat>
+          <c:val>
+            <c:numRef>
+              <c:f>Sheet1!$B$2:$B$6</c:f>
+              <c:numCache>
+                <c:formatCode>General</c:formatCode>
+                <c:ptCount val="5"/>
+                <c:pt idx="0">
+                  <c:v>120</c:v>
+                </c:pt>
+                <c:pt idx="1">
+                  <c:v>180</c:v>
+                </c:pt>
+                <c:pt idx="2">
+                  <c:v>150</c:v>
+                </c:pt>
+                <c:pt idx="3">
+                  <c:v>200</c:v>
+                </c:pt>
+                <c:pt idx="4">
+                  <c:v>250</c:v>
+                </c:pt>
+              </c:numCache>
+            </c:numRef>
+          </c:val>
+        </c:ser>
+        <c:ser>
+          <c:idx val="1"/>
+          <c:order val="1"/>
+          <c:tx>
+            <c:strRef>
+              <c:f>Sheet1!$C$1</c:f>
+              <c:strCache>
+                <c:ptCount val="1"/>
+                <c:pt idx="0">
+                  <c:v>Uploads</c:v>
+                </c:pt>
+              </c:strCache>
+            </c:strRef>
+          </c:tx>
+          <c:cat>
+            <c:strRef>
+              <c:f>Sheet1!$A$2:$A$6</c:f>
+              <c:strCache>
+                <c:ptCount val="5"/>
+                <c:pt idx="0">
+                  <c:v>Jan</c:v>
+                </c:pt>
+                <c:pt idx="1">
+                  <c:v>Feb</c:v>
+                </c:pt>
+                <c:pt idx="2">
+                  <c:v>Mar</c:v>
+                </c:pt>
+                <c:pt idx="3">
+                  <c:v>Apr</c:v>
+                </c:pt>
+                <c:pt idx="4">
+                  <c:v>May</c:v>
+                </c:pt>
+              </c:strCache>
+            </c:strRef>
+          </c:cat>
+          <c:val>
+            <c:numRef>
+              <c:f>Sheet1!$C$2:$C$6</c:f>
+              <c:numCache>
+                <c:formatCode>General</c:formatCode>
+                <c:ptCount val="5"/>
+                <c:pt idx="0">
+                  <c:v>80</c:v>
+                </c:pt>
+                <c:pt idx="1">
+                  <c:v>100</c:v>
+                </c:pt>
+                <c:pt idx="2">
+                  <c:v>130</c:v>
+                </c:pt>
+                <c:pt idx="3">
+                  <c:v>110</c:v>
+                </c:pt>
+                <c:pt idx="4">
+                  <c:v>170</c:v>
+                </c:pt>
+              </c:numCache>
+            </c:numRef>
+          </c:val>
+        </c:ser>
+        <c:dLbls>
+          <c:showLegendKey val="0"/>
+          <c:showVal val="0"/>
+          <c:showCatName val="0"/>
+          <c:showSerName val="0"/>
+          <c:showPercent val="0"/>
+          <c:showBubbleSize val="0"/>
+        </c:dLbls>
+        <c:axId val="-2101159928"/>
+        <c:axId val="-2100718248"/>
+      </c:areaChart>
+      <c:catAx>
+        <c:axId val="-2101159928"/>
+        <c:scaling>
+          <c:orientation val="minMax"/>
+        </c:scaling>
+        <c:delete val="0"/>
+        <c:axPos val="b"/>
+        <c:numFmt formatCode="General" sourceLinked="1"/>
+        <c:majorTickMark val="out"/>
+        <c:minorTickMark val="none"/>
+        <c:tickLblPos val="nextTo"/>
+        <c:crossAx val="-2100718248"/>
+        <c:crosses val="autoZero"/>
+        <c:auto val="1"/>
+        <c:lblAlgn val="ctr"/>
+        <c:lblOffset val="100"/>
+        <c:noMultiLvlLbl val="0"/>
+      </c:catAx>
+      <c:valAx>
+        <c:axId val="-2100718248"/>
+        <c:scaling>
+          <c:orientation val="minMax"/>
+        </c:scaling>
+        <c:delete val="0"/>
+        <c:axPos val="l"/>
+        <c:majorGridlines/>
+        <c:numFmt formatCode="General" sourceLinked="1"/>
+        <c:majorTickMark val="out"/>
+        <c:minorTickMark val="none"/>
+        <c:tickLblPos val="nextTo"/>
+        <c:crossAx val="-2101159928"/>
+        <c:crosses val="autoZero"/>
+        <c:crossBetween val="midCat"/>
+      </c:valAx>
+    </c:plotArea>
+    <c:legend>
+      <c:legendPos val="r"/>
+      <c:layout/>
+      <c:overlay val="0"/>
+    </c:legend>
+    <c:plotVisOnly val="1"/>
+    <c:dispBlanksAs val="zero"/>
+    <c:showDLblsOverMax val="0"/>
+  </c:chart>
+  <c:txPr>
+    <a:bodyPr/>
+    <a:lstStyle/>
+    <a:p>
+      <a:pPr>
+        <a:defRPr sz="1800"/>
+      </a:pPr>
+      <a:endParaRPr/>
+    </a:p>
+  </c:txPr>
+  <c:externalData r:id="rId1">
+    <c:autoUpdate val="0"/>
+  </c:externalData>
+</c:chartSpace>
+</file>
+
+<file path=ppt/charts/chart11.xml><?xml version="1.0" encoding="utf-8"?>
+<c:chartSpace xmlns:c="http://schemas.openxmlformats.org/drawingml/2006/chart" xmlns:a="http://schemas.openxmlformats.org/drawingml/2006/main" xmlns:r="http://schemas.openxmlformats.org/officeDocument/2006/relationships">
+  <c:date1904 val="0"/>
+  <c:roundedCorners val="0"/>
+  <mc:AlternateContent xmlns:mc="http://schemas.openxmlformats.org/markup-compatibility/2006">
+    <mc:Choice xmlns:c14="http://schemas.microsoft.com/office/drawing/2007/8/2/chart" Requires="c14">
+      <c14:style val="118"/>
+    </mc:Choice>
+    <mc:Fallback>
+      <c:style val="18"/>
+    </mc:Fallback>
+  </mc:AlternateContent>
+  <c:chart>
+    <c:autoTitleDeleted val="0"/>
+    <c:plotArea>
+      <c:layout/>
+      <c:radarChart>
+        <c:radarStyle val="marker"/>
+        <c:varyColors val="0"/>
+        <c:ser>
+          <c:idx val="0"/>
+          <c:order val="0"/>
+          <c:tx>
+            <c:strRef>
+              <c:f>Sheet1!$B$1</c:f>
+              <c:strCache>
+                <c:ptCount val="1"/>
+                <c:pt idx="0">
+                  <c:v>Character A</c:v>
+                </c:pt>
+              </c:strCache>
+            </c:strRef>
+          </c:tx>
+          <c:marker>
+            <c:symbol val="none"/>
+          </c:marker>
+          <c:cat>
+            <c:strRef>
+              <c:f>Sheet1!$A$2:$A$7</c:f>
+              <c:strCache>
+                <c:ptCount val="6"/>
+                <c:pt idx="0">
+                  <c:v>Str</c:v>
+                </c:pt>
+                <c:pt idx="1">
+                  <c:v>Dex</c:v>
+                </c:pt>
+                <c:pt idx="2">
+                  <c:v>Con</c:v>
+                </c:pt>
+                <c:pt idx="3">
+                  <c:v>Int</c:v>
+                </c:pt>
+                <c:pt idx="4">
+                  <c:v>Wis</c:v>
+                </c:pt>
+                <c:pt idx="5">
+                  <c:v>Cha</c:v>
+                </c:pt>
+              </c:strCache>
+            </c:strRef>
+          </c:cat>
+          <c:val>
+            <c:numRef>
+              <c:f>Sheet1!$B$2:$B$7</c:f>
+              <c:numCache>
+                <c:formatCode>General</c:formatCode>
+                <c:ptCount val="6"/>
+                <c:pt idx="0">
+                  <c:v>15</c:v>
+                </c:pt>
+                <c:pt idx="1">
+                  <c:v>12</c:v>
+                </c:pt>
+                <c:pt idx="2">
+                  <c:v>14</c:v>
+                </c:pt>
+                <c:pt idx="3">
+                  <c:v>10</c:v>
+                </c:pt>
+                <c:pt idx="4">
+                  <c:v>8</c:v>
+                </c:pt>
+                <c:pt idx="5">
+                  <c:v>16</c:v>
+                </c:pt>
+              </c:numCache>
+            </c:numRef>
+          </c:val>
+          <c:smooth val="0"/>
+        </c:ser>
+        <c:ser>
+          <c:idx val="1"/>
+          <c:order val="1"/>
+          <c:tx>
+            <c:strRef>
+              <c:f>Sheet1!$C$1</c:f>
+              <c:strCache>
+                <c:ptCount val="1"/>
+                <c:pt idx="0">
+                  <c:v>Character B</c:v>
+                </c:pt>
+              </c:strCache>
+            </c:strRef>
+          </c:tx>
+          <c:marker>
+            <c:symbol val="none"/>
+          </c:marker>
+          <c:cat>
+            <c:strRef>
+              <c:f>Sheet1!$A$2:$A$7</c:f>
+              <c:strCache>
+                <c:ptCount val="6"/>
+                <c:pt idx="0">
+                  <c:v>Str</c:v>
+                </c:pt>
+                <c:pt idx="1">
+                  <c:v>Dex</c:v>
+                </c:pt>
+                <c:pt idx="2">
+                  <c:v>Con</c:v>
+                </c:pt>
+                <c:pt idx="3">
+                  <c:v>Int</c:v>
+                </c:pt>
+                <c:pt idx="4">
+                  <c:v>Wis</c:v>
+                </c:pt>
+                <c:pt idx="5">
+                  <c:v>Cha</c:v>
+                </c:pt>
+              </c:strCache>
+            </c:strRef>
+          </c:cat>
+          <c:val>
+            <c:numRef>
+              <c:f>Sheet1!$C$2:$C$7</c:f>
+              <c:numCache>
+                <c:formatCode>General</c:formatCode>
+                <c:ptCount val="6"/>
+                <c:pt idx="0">
+                  <c:v>10</c:v>
+                </c:pt>
+                <c:pt idx="1">
+                  <c:v>16</c:v>
+                </c:pt>
+                <c:pt idx="2">
+                  <c:v>8</c:v>
+                </c:pt>
+                <c:pt idx="3">
+                  <c:v>15</c:v>
+                </c:pt>
+                <c:pt idx="4">
+                  <c:v>14</c:v>
+                </c:pt>
+                <c:pt idx="5">
+                  <c:v>12</c:v>
+                </c:pt>
+              </c:numCache>
+            </c:numRef>
+          </c:val>
+          <c:smooth val="0"/>
+        </c:ser>
+        <c:axId val="2073612648"/>
+        <c:axId val="-2112772216"/>
+      </c:radarChart>
+      <c:catAx>
+        <c:axId val="2073612648"/>
+        <c:scaling>
+          <c:orientation val="minMax"/>
+        </c:scaling>
+        <c:delete val="0"/>
+        <c:axPos val="b"/>
+        <c:majorGridlines/>
+        <c:numFmt formatCode="m/d/yy" sourceLinked="1"/>
+        <c:majorTickMark val="out"/>
+        <c:minorTickMark val="none"/>
+        <c:tickLblPos val="nextTo"/>
+        <c:crossAx val="-2112772216"/>
+        <c:crosses val="autoZero"/>
+        <c:auto val="1"/>
+        <c:lblAlgn val="ctr"/>
+        <c:lblOffset val="100"/>
+        <c:noMultiLvlLbl val="0"/>
+      </c:catAx>
+      <c:valAx>
+        <c:axId val="-2112772216"/>
+        <c:scaling>
+          <c:orientation val="minMax"/>
+        </c:scaling>
+        <c:delete val="0"/>
+        <c:axPos val="l"/>
+        <c:majorGridlines/>
+        <c:numFmt formatCode="General" sourceLinked="1"/>
+        <c:majorTickMark val="cross"/>
+        <c:minorTickMark val="none"/>
+        <c:tickLblPos val="nextTo"/>
+        <c:crossAx val="2073612648"/>
+        <c:crosses val="autoZero"/>
+        <c:crossBetween val="between"/>
+      </c:valAx>
+    </c:plotArea>
+    <c:legend/>
+    <c:plotVisOnly val="1"/>
+    <c:dispBlanksAs val="gap"/>
+    <c:showDLblsOverMax val="0"/>
+  </c:chart>
+  <c:txPr>
+    <a:bodyPr/>
+    <a:lstStyle/>
+    <a:p>
+      <a:pPr>
+        <a:defRPr sz="1800"/>
+      </a:pPr>
+      <a:endParaRPr lang="en-US"/>
+    </a:p>
+  </c:txPr>
+  <c:externalData r:id="rId1">
+    <c:autoUpdate val="0"/>
+  </c:externalData>
+</c:chartSpace>
+</file>
+
+<file path=ppt/charts/chart12.xml><?xml version="1.0" encoding="utf-8"?>
+<c:chartSpace xmlns:c="http://schemas.openxmlformats.org/drawingml/2006/chart" xmlns:a="http://schemas.openxmlformats.org/drawingml/2006/main" xmlns:r="http://schemas.openxmlformats.org/officeDocument/2006/relationships">
+  <c:chart>
+    <c:autoTitleDeleted val="0"/>
+    <c:plotArea>
+      <c:layout/>
+      <c:bubbleChart>
+        <c:varyColors val="0"/>
+        <c:ser>
+          <c:idx val="0"/>
+          <c:order val="0"/>
+          <c:tx>
+            <c:strRef>
+              <c:f>Sheet1!$B$1</c:f>
+              <c:strCache>
+                <c:ptCount val="1"/>
+                <c:pt idx="0">
+                  <c:v>Product X</c:v>
+                </c:pt>
+              </c:strCache>
+            </c:strRef>
+          </c:tx>
+          <c:invertIfNegative val="0"/>
+          <c:xVal>
+            <c:numRef>
+              <c:f>Sheet1!$A$2:$A$5</c:f>
+              <c:numCache>
+                <c:formatCode>General</c:formatCode>
+                <c:ptCount val="4"/>
+                <c:pt idx="0">
+                  <c:v>10</c:v>
+                </c:pt>
+                <c:pt idx="1">
+                  <c:v>25</c:v>
+                </c:pt>
+                <c:pt idx="2">
+                  <c:v>40</c:v>
+                </c:pt>
+                <c:pt idx="3">
+                  <c:v>55</c:v>
+                </c:pt>
+              </c:numCache>
+            </c:numRef>
+          </c:xVal>
+          <c:yVal>
+            <c:numRef>
+              <c:f>Sheet1!$B$2:$B$5</c:f>
+              <c:numCache>
+                <c:formatCode>General</c:formatCode>
+                <c:ptCount val="4"/>
+                <c:pt idx="0">
+                  <c:v>40</c:v>
+                </c:pt>
+                <c:pt idx="1">
+                  <c:v>60</c:v>
+                </c:pt>
+                <c:pt idx="2">
+                  <c:v>30</c:v>
+                </c:pt>
+                <c:pt idx="3">
+                  <c:v>70</c:v>
+                </c:pt>
+              </c:numCache>
+            </c:numRef>
+          </c:yVal>
+          <c:bubbleSize>
+            <c:numRef>
+              <c:f>Sheet1!$C$2:$C$5</c:f>
+              <c:numCache>
+                <c:formatCode>General</c:formatCode>
+                <c:ptCount val="4"/>
+                <c:pt idx="0">
+                  <c:v>15</c:v>
+                </c:pt>
+                <c:pt idx="1">
+                  <c:v>30</c:v>
+                </c:pt>
+                <c:pt idx="2">
+                  <c:v>10</c:v>
+                </c:pt>
+                <c:pt idx="3">
+                  <c:v>25</c:v>
+                </c:pt>
+              </c:numCache>
+            </c:numRef>
+          </c:bubbleSize>
+          <c:bubble3D val="0"/>
+        </c:ser>
+        <c:ser>
+          <c:idx val="1"/>
+          <c:order val="1"/>
+          <c:tx>
+            <c:strRef>
+              <c:f>Sheet1!$B$7</c:f>
+              <c:strCache>
+                <c:ptCount val="1"/>
+                <c:pt idx="0">
+                  <c:v>Product Y</c:v>
+                </c:pt>
+              </c:strCache>
+            </c:strRef>
+          </c:tx>
+          <c:invertIfNegative val="0"/>
+          <c:xVal>
+            <c:numRef>
+              <c:f>Sheet1!$A$8:$A$10</c:f>
+              <c:numCache>
+                <c:formatCode>General</c:formatCode>
+                <c:ptCount val="3"/>
+                <c:pt idx="0">
+                  <c:v>15</c:v>
+                </c:pt>
+                <c:pt idx="1">
+                  <c:v>30</c:v>
+                </c:pt>
+                <c:pt idx="2">
+                  <c:v>50</c:v>
+                </c:pt>
+              </c:numCache>
+            </c:numRef>
+          </c:xVal>
+          <c:yVal>
+            <c:numRef>
+              <c:f>Sheet1!$B$8:$B$10</c:f>
+              <c:numCache>
+                <c:formatCode>General</c:formatCode>
+                <c:ptCount val="3"/>
+                <c:pt idx="0">
+                  <c:v>55</c:v>
+                </c:pt>
+                <c:pt idx="1">
+                  <c:v>35</c:v>
+                </c:pt>
+                <c:pt idx="2">
+                  <c:v>50</c:v>
+                </c:pt>
+              </c:numCache>
+            </c:numRef>
+          </c:yVal>
+          <c:bubbleSize>
+            <c:numRef>
+              <c:f>Sheet1!$C$8:$C$10</c:f>
+              <c:numCache>
+                <c:formatCode>General</c:formatCode>
+                <c:ptCount val="3"/>
+                <c:pt idx="0">
+                  <c:v>20</c:v>
+                </c:pt>
+                <c:pt idx="1">
+                  <c:v>12</c:v>
+                </c:pt>
+                <c:pt idx="2">
+                  <c:v>35</c:v>
+                </c:pt>
+              </c:numCache>
+            </c:numRef>
+          </c:bubbleSize>
+          <c:bubble3D val="0"/>
+        </c:ser>
+        <c:dLbls>
+          <c:showLegendKey val="0"/>
+          <c:showVal val="0"/>
+          <c:showCatName val="0"/>
+          <c:showSerName val="0"/>
+          <c:showPercent val="0"/>
+          <c:showBubbleSize val="0"/>
+        </c:dLbls>
+        <c:bubbleScale val="100"/>
+        <c:showNegBubbles val="0"/>
+        <c:axId val="-2115720072"/>
+        <c:axId val="-2115723560"/>
+      </c:bubbleChart>
+      <c:valAx>
+        <c:axId val="-2115720072"/>
+        <c:scaling>
+          <c:orientation val="minMax"/>
+        </c:scaling>
+        <c:delete val="0"/>
+        <c:axPos val="b"/>
+        <c:numFmt formatCode="General" sourceLinked="1"/>
+        <c:majorTickMark val="out"/>
+        <c:minorTickMark val="none"/>
+        <c:tickLblPos val="nextTo"/>
+        <c:crossAx val="-2115723560"/>
+        <c:crosses val="autoZero"/>
+        <c:crossBetween val="midCat"/>
+      </c:valAx>
+      <c:valAx>
+        <c:axId val="-2115723560"/>
+        <c:scaling>
+          <c:orientation val="minMax"/>
+        </c:scaling>
+        <c:delete val="0"/>
+        <c:axPos val="l"/>
+        <c:majorGridlines/>
+        <c:numFmt formatCode="General" sourceLinked="1"/>
+        <c:majorTickMark val="out"/>
+        <c:minorTickMark val="none"/>
+        <c:tickLblPos val="nextTo"/>
+        <c:crossAx val="-2115720072"/>
+        <c:crosses val="autoZero"/>
+        <c:crossBetween val="midCat"/>
+      </c:valAx>
+    </c:plotArea>
+    <c:legend>
+      <c:legendPos val="r"/>
+      <c:layout/>
+      <c:overlay val="0"/>
+    </c:legend>
+    <c:plotVisOnly val="1"/>
+    <c:dispBlanksAs val="gap"/>
+    <c:showDLblsOverMax val="0"/>
+  </c:chart>
+  <c:txPr>
+    <a:bodyPr/>
+    <a:lstStyle/>
+    <a:p>
+      <a:pPr>
+        <a:defRPr sz="1800"/>
+      </a:pPr>
+      <a:endParaRPr lang="en-US"/>
+    </a:p>
+  </c:txPr>
+  <c:externalData r:id="rId1">
+    <c:autoUpdate val="0"/>
+  </c:externalData>
+</c:chartSpace>
+</file>
+
+<file path=ppt/charts/chart13.xml><?xml version="1.0" encoding="utf-8"?>
+<c:chartSpace xmlns:c="http://schemas.openxmlformats.org/drawingml/2006/chart" xmlns:a="http://schemas.openxmlformats.org/drawingml/2006/main" xmlns:r="http://schemas.openxmlformats.org/officeDocument/2006/relationships">
+  <c:date1904 val="0"/>
+  <c:chart>
+    <c:autoTitleDeleted val="0"/>
+    <c:plotArea>
+      <c:stockChart>
+        <c:ser>
+          <c:idx val="0"/>
+          <c:order val="0"/>
+          <c:tx>
+            <c:strRef>
+              <c:f>Sheet1!$B$1</c:f>
+              <c:strCache>
+                <c:ptCount val="1"/>
+                <c:pt idx="0">
+                  <c:v>Open</c:v>
+                </c:pt>
+              </c:strCache>
+            </c:strRef>
+          </c:tx>
+          <c:cat>
+            <c:strRef>
+              <c:f>Sheet1!$A$2:$A$6</c:f>
+              <c:strCache>
+                <c:ptCount val="5"/>
+                <c:pt idx="0">
+                  <c:v>Day 1</c:v>
+                </c:pt>
+                <c:pt idx="1">
+                  <c:v>Day 2</c:v>
+                </c:pt>
+                <c:pt idx="2">
+                  <c:v>Day 3</c:v>
+                </c:pt>
+                <c:pt idx="3">
+                  <c:v>Day 4</c:v>
+                </c:pt>
+                <c:pt idx="4">
+                  <c:v>Day 5</c:v>
+                </c:pt>
+              </c:strCache>
+            </c:strRef>
+          </c:cat>
+          <c:val>
+            <c:numRef>
+              <c:f>Sheet1!$B$2:$B$6</c:f>
+              <c:numCache>
+                <c:formatCode>General</c:formatCode>
+                <c:ptCount val="5"/>
+                <c:pt idx="0">
+                  <c:v>100</c:v>
+                </c:pt>
+                <c:pt idx="1">
+                  <c:v>105</c:v>
+                </c:pt>
+                <c:pt idx="2">
+                  <c:v>98</c:v>
+                </c:pt>
+                <c:pt idx="3">
+                  <c:v>110</c:v>
+                </c:pt>
+                <c:pt idx="4">
+                  <c:v>108</c:v>
+                </c:pt>
+              </c:numCache>
+            </c:numRef>
+          </c:val>
+        </c:ser>
+        <c:ser>
+          <c:idx val="1"/>
+          <c:order val="1"/>
+          <c:tx>
+            <c:strRef>
+              <c:f>Sheet1!$C$1</c:f>
+              <c:strCache>
+                <c:ptCount val="1"/>
+                <c:pt idx="0">
+                  <c:v>High</c:v>
+                </c:pt>
+              </c:strCache>
+            </c:strRef>
+          </c:tx>
+          <c:val>
+            <c:numRef>
+              <c:f>Sheet1!$C$2:$C$6</c:f>
+              <c:numCache>
+                <c:formatCode>General</c:formatCode>
+                <c:ptCount val="5"/>
+                <c:pt idx="0">
+                  <c:v>115</c:v>
+                </c:pt>
+                <c:pt idx="1">
+                  <c:v>118</c:v>
+                </c:pt>
+                <c:pt idx="2">
+                  <c:v>112</c:v>
+                </c:pt>
+                <c:pt idx="3">
+                  <c:v>120</c:v>
+                </c:pt>
+                <c:pt idx="4">
+                  <c:v>122</c:v>
+                </c:pt>
+              </c:numCache>
+            </c:numRef>
+          </c:val>
+        </c:ser>
+        <c:ser>
+          <c:idx val="2"/>
+          <c:order val="2"/>
+          <c:tx>
+            <c:strRef>
+              <c:f>Sheet1!$D$1</c:f>
+              <c:strCache>
+                <c:ptCount val="1"/>
+                <c:pt idx="0">
+                  <c:v>Low</c:v>
+                </c:pt>
+              </c:strCache>
+            </c:strRef>
+          </c:tx>
+          <c:val>
+            <c:numRef>
+              <c:f>Sheet1!$D$2:$D$6</c:f>
+              <c:numCache>
+                <c:formatCode>General</c:formatCode>
+                <c:ptCount val="5"/>
+                <c:pt idx="0">
+                  <c:v>95</c:v>
+                </c:pt>
+                <c:pt idx="1">
+                  <c:v>100</c:v>
+                </c:pt>
+                <c:pt idx="2">
+                  <c:v>90</c:v>
+                </c:pt>
+                <c:pt idx="3">
+                  <c:v>105</c:v>
+                </c:pt>
+                <c:pt idx="4">
+                  <c:v>102</c:v>
+                </c:pt>
+              </c:numCache>
+            </c:numRef>
+          </c:val>
+        </c:ser>
+        <c:ser>
+          <c:idx val="3"/>
+          <c:order val="3"/>
+          <c:tx>
+            <c:strRef>
+              <c:f>Sheet1!$E$1</c:f>
+              <c:strCache>
+                <c:ptCount val="1"/>
+                <c:pt idx="0">
+                  <c:v>Close</c:v>
+                </c:pt>
+              </c:strCache>
+            </c:strRef>
+          </c:tx>
+          <c:val>
+            <c:numRef>
+              <c:f>Sheet1!$E$2:$E$6</c:f>
+              <c:numCache>
+                <c:formatCode>General</c:formatCode>
+                <c:ptCount val="5"/>
+                <c:pt idx="0">
+                  <c:v>108</c:v>
+                </c:pt>
+                <c:pt idx="1">
+                  <c:v>102</c:v>
+                </c:pt>
+                <c:pt idx="2">
+                  <c:v>107</c:v>
+                </c:pt>
+                <c:pt idx="3">
+                  <c:v>115</c:v>
+                </c:pt>
+                <c:pt idx="4">
+                  <c:v>118</c:v>
+                </c:pt>
+              </c:numCache>
+            </c:numRef>
+          </c:val>
+        </c:ser>
+        <c:axId val="10000001"/>
+        <c:axId val="10000002"/>
+      </c:stockChart>
+      <c:catAx>
+        <c:axId val="10000001"/>
+        <c:scaling>
+          <c:orientation val="minMax"/>
+        </c:scaling>
+        <c:delete val="0"/>
+        <c:axPos val="b"/>
+        <c:crossAx val="10000002"/>
+      </c:catAx>
+      <c:valAx>
+        <c:axId val="10000002"/>
+        <c:scaling>
+          <c:orientation val="minMax"/>
+        </c:scaling>
+        <c:delete val="0"/>
+        <c:axPos val="l"/>
+        <c:crossAx val="10000001"/>
+        <c:majorGridlines/>
+      </c:valAx>
+    </c:plotArea>
+    <c:dispBlanksAs val="gap"/>
+    <c:legend>
+      <c:legendPos val="r"/>
+      <c:overlay val="0"/>
+    </c:legend>
+  </c:chart>
+  <c:txPr>
+    <a:bodyPr/>
+    <a:lstStyle/>
+    <a:p>
+      <a:pPr>
+        <a:defRPr sz="1800"/>
+      </a:pPr>
+      <a:endParaRPr lang="en-US"/>
+    </a:p>
+  </c:txPr>
+  <c:externalData r:id="rId1">
+    <c:autoUpdate val="0"/>
+  </c:externalData>
+</c:chartSpace>
+</file>
+
+<file path=ppt/charts/chart14.xml><?xml version="1.0" encoding="utf-8"?>
+<c:chartSpace xmlns:c="http://schemas.openxmlformats.org/drawingml/2006/chart" xmlns:a="http://schemas.openxmlformats.org/drawingml/2006/main" xmlns:r="http://schemas.openxmlformats.org/officeDocument/2006/relationships">
+  <c:date1904 val="0"/>
+  <c:chart>
+    <c:autoTitleDeleted val="0"/>
+    <c:plotArea>
+      <c:barChart>
+        <c:barDir val="col"/>
+        <c:grouping val="clustered"/>
+        <c:ser>
+          <c:idx val="0"/>
+          <c:order val="0"/>
+          <c:tx>
+            <c:strRef>
+              <c:f>Sheet1!$B$1</c:f>
+              <c:strCache>
+                <c:ptCount val="1"/>
+                <c:pt idx="0">
+                  <c:v>S1</c:v>
+                </c:pt>
+              </c:strCache>
+            </c:strRef>
+          </c:tx>
+          <c:cat>
+            <c:strRef>
+              <c:f>Sheet1!$A$2:$A$4</c:f>
+              <c:strCache>
+                <c:ptCount val="3"/>
+                <c:pt idx="0">
+                  <c:v>A</c:v>
+                </c:pt>
+                <c:pt idx="1">
+                  <c:v>B</c:v>
+                </c:pt>
+                <c:pt idx="2">
+                  <c:v>C</c:v>
+                </c:pt>
+              </c:strCache>
+            </c:strRef>
+          </c:cat>
+          <c:val>
+            <c:numRef>
+              <c:f>Sheet1!$B$2:$B$4</c:f>
+              <c:numCache>
+                <c:formatCode>General</c:formatCode>
+                <c:ptCount val="3"/>
+                <c:pt idx="0">
+                  <c:v>30</c:v>
+                </c:pt>
+                <c:pt idx="1">
+                  <c:v>50</c:v>
+                </c:pt>
+                <c:pt idx="2">
+                  <c:v>40</c:v>
+                </c:pt>
+              </c:numCache>
+            </c:numRef>
+          </c:val>
+        </c:ser>
+        <c:axId val="-2068027336"/>
+        <c:axId val="-2113994440"/>
+      </c:barChart>
+      <c:catAx>
+        <c:axId val="-2068027336"/>
+        <c:scaling>
+          <c:orientation val="minMax"/>
+        </c:scaling>
+        <c:delete val="0"/>
+        <c:axPos val="b"/>
+        <c:majorTickMark val="out"/>
+        <c:minorTickMark val="none"/>
+        <c:tickLblPos val="nextTo"/>
+        <c:crossAx val="-2113994440"/>
+        <c:crosses val="autoZero"/>
+        <c:auto val="1"/>
+        <c:lblAlgn val="ctr"/>
+        <c:lblOffset val="100"/>
+        <c:noMultiLvlLbl val="0"/>
+      </c:catAx>
+      <c:valAx>
+        <c:axId val="-2113994440"/>
+        <c:scaling/>
+        <c:delete val="0"/>
+        <c:axPos val="l"/>
+        <c:majorGridlines/>
+        <c:majorTickMark val="out"/>
+        <c:minorTickMark val="none"/>
+        <c:tickLblPos val="nextTo"/>
+        <c:crossAx val="-2068027336"/>
+        <c:crosses val="autoZero"/>
+      </c:valAx>
+    </c:plotArea>
+    <c:dispBlanksAs val="gap"/>
+  </c:chart>
+  <c:txPr>
+    <a:bodyPr/>
+    <a:lstStyle/>
+    <a:p>
+      <a:pPr>
+        <a:defRPr sz="1800"/>
+      </a:pPr>
+      <a:endParaRPr lang="en-US"/>
+    </a:p>
+  </c:txPr>
+  <c:externalData r:id="rId1">
+    <c:autoUpdate val="0"/>
+  </c:externalData>
+</c:chartSpace>
+</file>
+
+<file path=ppt/charts/chart15.xml><?xml version="1.0" encoding="utf-8"?>
+<c:chartSpace xmlns:c="http://schemas.openxmlformats.org/drawingml/2006/chart" xmlns:a="http://schemas.openxmlformats.org/drawingml/2006/main" xmlns:r="http://schemas.openxmlformats.org/officeDocument/2006/relationships">
+  <c:date1904 val="0"/>
+  <c:chart>
+    <c:autoTitleDeleted val="0"/>
+    <c:plotArea>
+      <c:lineChart>
+        <c:grouping val="standard"/>
+        <c:varyColors val="0"/>
+        <c:ser>
+          <c:idx val="0"/>
+          <c:order val="0"/>
+          <c:tx>
+            <c:strRef>
+              <c:f>Sheet1!$B$1</c:f>
+              <c:strCache>
+                <c:ptCount val="1"/>
+                <c:pt idx="0">
+                  <c:v>S1</c:v>
+                </c:pt>
+              </c:strCache>
+            </c:strRef>
+          </c:tx>
+          <c:marker>
+            <c:symbol val="none"/>
+          </c:marker>
+          <c:cat>
+            <c:strRef>
+              <c:f>Sheet1!$A$2:$A$5</c:f>
+              <c:strCache>
+                <c:ptCount val="4"/>
+                <c:pt idx="0">
+                  <c:v>A</c:v>
+                </c:pt>
+                <c:pt idx="1">
+                  <c:v>B</c:v>
+                </c:pt>
+                <c:pt idx="2">
+                  <c:v>C</c:v>
+                </c:pt>
+                <c:pt idx="3">
+                  <c:v>D</c:v>
+                </c:pt>
+              </c:strCache>
+            </c:strRef>
+          </c:cat>
+          <c:val>
+            <c:numRef>
+              <c:f>Sheet1!$B$2:$B$5</c:f>
+              <c:numCache>
+                <c:formatCode>General</c:formatCode>
+                <c:ptCount val="4"/>
+                <c:pt idx="0">
+                  <c:v>10</c:v>
+                </c:pt>
+                <c:pt idx="1">
+                  <c:v>30</c:v>
+                </c:pt>
+                <c:pt idx="2">
+                  <c:v>20</c:v>
+                </c:pt>
+                <c:pt idx="3">
+                  <c:v>40</c:v>
+                </c:pt>
+              </c:numCache>
+            </c:numRef>
+          </c:val>
+          <c:smooth val="0"/>
+        </c:ser>
+        <c:marker val="1"/>
+        <c:smooth val="0"/>
+        <c:axId val="2118791784"/>
+        <c:axId val="2140495176"/>
+      </c:lineChart>
+      <c:catAx>
+        <c:axId val="2118791784"/>
+        <c:scaling>
+          <c:orientation val="minMax"/>
+        </c:scaling>
+        <c:delete val="0"/>
+        <c:axPos val="b"/>
+        <c:majorTickMark val="out"/>
+        <c:minorTickMark val="none"/>
+        <c:tickLblPos val="nextTo"/>
+        <c:crossAx val="2140495176"/>
+        <c:crosses val="autoZero"/>
+        <c:auto val="1"/>
+        <c:lblAlgn val="ctr"/>
+        <c:lblOffset val="100"/>
+        <c:noMultiLvlLbl val="0"/>
+      </c:catAx>
+      <c:valAx>
+        <c:axId val="2140495176"/>
+        <c:scaling/>
+        <c:delete val="0"/>
+        <c:axPos val="l"/>
+        <c:majorGridlines/>
+        <c:majorTickMark val="out"/>
+        <c:minorTickMark val="none"/>
+        <c:tickLblPos val="nextTo"/>
+        <c:crossAx val="2118791784"/>
+        <c:crosses val="autoZero"/>
+      </c:valAx>
+    </c:plotArea>
+    <c:legend>
+      <c:legendPos val="r"/>
+      <c:layout/>
+      <c:overlay val="0"/>
+    </c:legend>
+    <c:plotVisOnly val="1"/>
+    <c:dispBlanksAs val="gap"/>
+    <c:showDLblsOverMax val="0"/>
+  </c:chart>
+  <c:txPr>
+    <a:bodyPr/>
+    <a:lstStyle/>
+    <a:p>
+      <a:pPr>
+        <a:defRPr sz="1800"/>
+      </a:pPr>
+      <a:endParaRPr lang="en-US"/>
+    </a:p>
+  </c:txPr>
+  <c:externalData r:id="rId1">
+    <c:autoUpdate val="0"/>
+  </c:externalData>
+</c:chartSpace>
+</file>
+
+<file path=ppt/charts/chart16.xml><?xml version="1.0" encoding="utf-8"?>
+<c:chartSpace xmlns:c="http://schemas.openxmlformats.org/drawingml/2006/chart" xmlns:a="http://schemas.openxmlformats.org/drawingml/2006/main" xmlns:r="http://schemas.openxmlformats.org/officeDocument/2006/relationships">
+  <c:chart>
+    <c:autoTitleDeleted val="0"/>
+    <c:plotArea>
+      <c:pieChart>
+        <c:varyColors val="1"/>
+        <c:ser>
+          <c:idx val="0"/>
+          <c:order val="0"/>
+          <c:tx>
+            <c:strRef>
+              <c:f>Sheet1!$B$1</c:f>
+              <c:strCache>
+                <c:ptCount val="1"/>
+                <c:pt idx="0">
+                  <c:v>S1</c:v>
+                </c:pt>
+              </c:strCache>
+            </c:strRef>
+          </c:tx>
+          <c:cat>
+            <c:strRef>
+              <c:f>Sheet1!$A$2:$A$4</c:f>
+              <c:strCache>
+                <c:ptCount val="3"/>
+                <c:pt idx="0">
+                  <c:v>X</c:v>
+                </c:pt>
+                <c:pt idx="1">
+                  <c:v>Y</c:v>
+                </c:pt>
+                <c:pt idx="2">
+                  <c:v>Z</c:v>
+                </c:pt>
+              </c:strCache>
+            </c:strRef>
+          </c:cat>
+          <c:val>
+            <c:numRef>
+              <c:f>Sheet1!$B$2:$B$4</c:f>
+              <c:numCache>
+                <c:formatCode>General</c:formatCode>
+                <c:ptCount val="3"/>
+                <c:pt idx="0">
+                  <c:v>40</c:v>
+                </c:pt>
+                <c:pt idx="1">
+                  <c:v>35</c:v>
+                </c:pt>
+                <c:pt idx="2">
+                  <c:v>25</c:v>
+                </c:pt>
+              </c:numCache>
+            </c:numRef>
+          </c:val>
+        </c:ser>
+      </c:pieChart>
+    </c:plotArea>
+    <c:dispBlanksAs val="gap"/>
+  </c:chart>
+  <c:txPr>
+    <a:bodyPr/>
+    <a:lstStyle/>
+    <a:p>
+      <a:pPr>
+        <a:defRPr sz="1800"/>
+      </a:pPr>
+      <a:endParaRPr lang="en-US"/>
+    </a:p>
+  </c:txPr>
+  <c:externalData r:id="rId1">
+    <c:autoUpdate val="0"/>
+  </c:externalData>
+</c:chartSpace>
+</file>
+
+<file path=ppt/charts/chart17.xml><?xml version="1.0" encoding="utf-8"?>
+<c:chartSpace xmlns:c="http://schemas.openxmlformats.org/drawingml/2006/chart" xmlns:a="http://schemas.openxmlformats.org/drawingml/2006/main" xmlns:r="http://schemas.openxmlformats.org/officeDocument/2006/relationships">
+  <c:date1904 val="0"/>
+  <c:chart>
+    <c:autoTitleDeleted val="0"/>
+    <c:plotArea>
+      <c:barChart>
+        <c:barDir val="bar"/>
+        <c:grouping val="clustered"/>
+        <c:ser>
+          <c:idx val="0"/>
+          <c:order val="0"/>
+          <c:tx>
+            <c:strRef>
+              <c:f>Sheet1!$B$1</c:f>
+              <c:strCache>
+                <c:ptCount val="1"/>
+                <c:pt idx="0">
+                  <c:v>S1</c:v>
+                </c:pt>
+              </c:strCache>
+            </c:strRef>
+          </c:tx>
+          <c:cat>
+            <c:strRef>
+              <c:f>Sheet1!$A$2:$A$4</c:f>
+              <c:strCache>
+                <c:ptCount val="3"/>
+                <c:pt idx="0">
+                  <c:v>P</c:v>
+                </c:pt>
+                <c:pt idx="1">
+                  <c:v>Q</c:v>
+                </c:pt>
+                <c:pt idx="2">
+                  <c:v>R</c:v>
+                </c:pt>
+              </c:strCache>
+            </c:strRef>
+          </c:cat>
+          <c:val>
+            <c:numRef>
+              <c:f>Sheet1!$B$2:$B$4</c:f>
+              <c:numCache>
+                <c:formatCode>General</c:formatCode>
+                <c:ptCount val="3"/>
+                <c:pt idx="0">
+                  <c:v>25</c:v>
+                </c:pt>
+                <c:pt idx="1">
+                  <c:v>40</c:v>
+                </c:pt>
+                <c:pt idx="2">
+                  <c:v>35</c:v>
+                </c:pt>
+              </c:numCache>
+            </c:numRef>
+          </c:val>
+        </c:ser>
+        <c:axId val="-2068027336"/>
+        <c:axId val="-2113994440"/>
+      </c:barChart>
+      <c:catAx>
+        <c:axId val="-2068027336"/>
+        <c:scaling>
+          <c:orientation val="minMax"/>
+        </c:scaling>
+        <c:delete val="0"/>
+        <c:axPos val="l"/>
+        <c:majorTickMark val="out"/>
+        <c:minorTickMark val="none"/>
+        <c:tickLblPos val="nextTo"/>
+        <c:crossAx val="-2113994440"/>
+        <c:crosses val="autoZero"/>
+        <c:auto val="1"/>
+        <c:lblAlgn val="ctr"/>
+        <c:lblOffset val="100"/>
+        <c:noMultiLvlLbl val="0"/>
+      </c:catAx>
+      <c:valAx>
+        <c:axId val="-2113994440"/>
+        <c:scaling/>
+        <c:delete val="0"/>
+        <c:axPos val="b"/>
+        <c:majorGridlines/>
+        <c:majorTickMark val="out"/>
+        <c:minorTickMark val="none"/>
+        <c:tickLblPos val="nextTo"/>
+        <c:crossAx val="-2068027336"/>
+        <c:crosses val="autoZero"/>
+      </c:valAx>
+    </c:plotArea>
+    <c:dispBlanksAs val="gap"/>
+  </c:chart>
+  <c:txPr>
+    <a:bodyPr/>
+    <a:lstStyle/>
+    <a:p>
+      <a:pPr>
+        <a:defRPr sz="1800"/>
+      </a:pPr>
+      <a:endParaRPr lang="en-US"/>
+    </a:p>
+  </c:txPr>
+  <c:externalData r:id="rId1">
+    <c:autoUpdate val="0"/>
+  </c:externalData>
+</c:chartSpace>
+</file>
+
+<file path=ppt/charts/chart18.xml><?xml version="1.0" encoding="utf-8"?>
+<c:chartSpace xmlns:c="http://schemas.openxmlformats.org/drawingml/2006/chart" xmlns:a="http://schemas.openxmlformats.org/drawingml/2006/main" xmlns:r="http://schemas.openxmlformats.org/officeDocument/2006/relationships">
+  <c:chart>
+    <c:plotArea>
+      <c:scatterChart>
+        <c:scatterStyle val="lineMarker"/>
+        <c:varyColors val="0"/>
+        <c:ser>
+          <c:idx val="0"/>
+          <c:order val="0"/>
+          <c:tx>
+            <c:strRef>
+              <c:f>Sheet1!$B$1</c:f>
+              <c:strCache>
+                <c:ptCount val="1"/>
+                <c:pt idx="0">
+                  <c:v>S1</c:v>
+                </c:pt>
+              </c:strCache>
+            </c:strRef>
+          </c:tx>
+          <c:spPr>
+            <a:ln w="47625">
+              <a:noFill/>
+            </a:ln>
+          </c:spPr>
+          <c:xVal>
+            <c:numRef>
+              <c:f>Sheet1!$A$2:$A$5</c:f>
+              <c:numCache>
+                <c:formatCode>General</c:formatCode>
+                <c:ptCount val="4"/>
+                <c:pt idx="0">
+                  <c:v>5</c:v>
+                </c:pt>
+                <c:pt idx="1">
+                  <c:v>15</c:v>
+                </c:pt>
+                <c:pt idx="2">
+                  <c:v>25</c:v>
+                </c:pt>
+                <c:pt idx="3">
+                  <c:v>35</c:v>
+                </c:pt>
+              </c:numCache>
+            </c:numRef>
+          </c:xVal>
+          <c:yVal>
+            <c:numRef>
+              <c:f>Sheet1!$B$2:$B$5</c:f>
+              <c:numCache>
+                <c:formatCode>General</c:formatCode>
+                <c:ptCount val="4"/>
+                <c:pt idx="0">
+                  <c:v>10</c:v>
+                </c:pt>
+                <c:pt idx="1">
+                  <c:v>30</c:v>
+                </c:pt>
+                <c:pt idx="2">
+                  <c:v>20</c:v>
+                </c:pt>
+                <c:pt idx="3">
+                  <c:v>40</c:v>
+                </c:pt>
+              </c:numCache>
+            </c:numRef>
+          </c:yVal>
+          <c:smooth val="0"/>
+        </c:ser>
+        <c:axId val="-2128940872"/>
+        <c:axId val="-2129643912"/>
+      </c:scatterChart>
+      <c:valAx>
+        <c:axId val="-2128940872"/>
+        <c:scaling>
+          <c:orientation val="minMax"/>
+        </c:scaling>
+        <c:delete val="0"/>
+        <c:axPos val="b"/>
+        <c:numFmt formatCode="General" sourceLinked="1"/>
+        <c:majorTickMark val="out"/>
+        <c:minorTickMark val="none"/>
+        <c:tickLblPos val="nextTo"/>
+        <c:crossAx val="-2129643912"/>
+        <c:crosses val="autoZero"/>
+        <c:crossBetween val="midCat"/>
+      </c:valAx>
+      <c:valAx>
+        <c:axId val="-2129643912"/>
+        <c:scaling>
+          <c:orientation val="minMax"/>
+        </c:scaling>
+        <c:delete val="0"/>
+        <c:axPos val="l"/>
+        <c:majorGridlines/>
+        <c:numFmt formatCode="General" sourceLinked="1"/>
+        <c:majorTickMark val="out"/>
+        <c:minorTickMark val="none"/>
+        <c:tickLblPos val="nextTo"/>
+        <c:crossAx val="-2128940872"/>
+        <c:crosses val="autoZero"/>
+        <c:crossBetween val="midCat"/>
+      </c:valAx>
+    </c:plotArea>
+    <c:legend>
+      <c:legendPos val="r"/>
+      <c:layout/>
+      <c:overlay val="0"/>
+    </c:legend>
+    <c:plotVisOnly val="1"/>
+    <c:dispBlanksAs val="gap"/>
+    <c:showDLblsOverMax val="0"/>
+  </c:chart>
+  <c:txPr>
+    <a:bodyPr/>
+    <a:lstStyle/>
+    <a:p>
+      <a:pPr>
+        <a:defRPr sz="1800"/>
+      </a:pPr>
+      <a:endParaRPr lang="en-US"/>
+    </a:p>
+  </c:txPr>
+  <c:externalData r:id="rId1">
+    <c:autoUpdate val="0"/>
+  </c:externalData>
+</c:chartSpace>
+</file>
+
+<file path=ppt/charts/chart19.xml><?xml version="1.0" encoding="utf-8"?>
+<c:chartSpace xmlns:c="http://schemas.openxmlformats.org/drawingml/2006/chart" xmlns:a="http://schemas.openxmlformats.org/drawingml/2006/main" xmlns:r="http://schemas.openxmlformats.org/officeDocument/2006/relationships">
+  <c:date1904 val="0"/>
+  <c:roundedCorners val="0"/>
+  <c:chart>
+    <c:autoTitleDeleted val="0"/>
+    <c:plotArea>
+      <c:layout/>
+      <c:doughnutChart>
+        <c:varyColors val="1"/>
+        <c:ser>
+          <c:idx val="0"/>
+          <c:order val="0"/>
+          <c:tx>
+            <c:strRef>
+              <c:f>Sheet1!$B$1</c:f>
+              <c:strCache>
+                <c:ptCount val="1"/>
+                <c:pt idx="0">
+                  <c:v>S1</c:v>
+                </c:pt>
+              </c:strCache>
+            </c:strRef>
+          </c:tx>
+          <c:cat>
+            <c:strRef>
+              <c:f>Sheet1!$A$2:$A$4</c:f>
+              <c:strCache>
+                <c:ptCount val="3"/>
+                <c:pt idx="0">
+                  <c:v>A</c:v>
+                </c:pt>
+                <c:pt idx="1">
+                  <c:v>B</c:v>
+                </c:pt>
+                <c:pt idx="2">
+                  <c:v>C</c:v>
+                </c:pt>
+              </c:strCache>
+            </c:strRef>
+          </c:cat>
+          <c:val>
+            <c:numRef>
+              <c:f>Sheet1!$B$2:$B$4</c:f>
+              <c:numCache>
+                <c:formatCode>General</c:formatCode>
+                <c:ptCount val="3"/>
+                <c:pt idx="0">
+                  <c:v>50</c:v>
+                </c:pt>
+                <c:pt idx="1">
+                  <c:v>30</c:v>
+                </c:pt>
+                <c:pt idx="2">
+                  <c:v>20</c:v>
+                </c:pt>
+              </c:numCache>
+            </c:numRef>
+          </c:val>
+        </c:ser>
+        <c:dLbls>
+          <c:showLegendKey val="0"/>
+          <c:showVal val="0"/>
+          <c:showCatName val="0"/>
+          <c:showSerName val="0"/>
+          <c:showPercent val="0"/>
+          <c:showBubbleSize val="0"/>
+          <c:showLeaderLines val="1"/>
+        </c:dLbls>
+        <c:firstSliceAng val="0"/>
+        <c:holeSize val="50"/>
+      </c:doughnutChart>
+    </c:plotArea>
+    <c:legend>
+      <c:legendPos val="r"/>
+      <c:layout/>
+      <c:overlay val="0"/>
+    </c:legend>
+    <c:plotVisOnly val="1"/>
+    <c:dispBlanksAs val="gap"/>
+    <c:showDLblsOverMax val="0"/>
+  </c:chart>
+  <c:txPr>
+    <a:bodyPr/>
+    <a:lstStyle/>
+    <a:p>
+      <a:pPr>
+        <a:defRPr sz="1800"/>
+      </a:pPr>
+      <a:endParaRPr/>
+    </a:p>
+  </c:txPr>
+  <c:externalData r:id="rId1">
+    <c:autoUpdate val="0"/>
+  </c:externalData>
+</c:chartSpace>
+</file>
+
 <file path=ppt/charts/chart2.xml><?xml version="1.0" encoding="utf-8"?>
 <c:chartSpace xmlns:c="http://schemas.openxmlformats.org/drawingml/2006/chart" xmlns:a="http://schemas.openxmlformats.org/drawingml/2006/main" xmlns:r="http://schemas.openxmlformats.org/officeDocument/2006/relationships">
   <c:date1904 val="0"/>
@@ -1280,6 +2828,199 @@
         <c:tickLblPos val="nextTo"/>
         <c:crossAx val="2118791784"/>
         <c:crosses val="autoZero"/>
+      </c:valAx>
+    </c:plotArea>
+    <c:legend>
+      <c:legendPos val="r"/>
+      <c:layout/>
+      <c:overlay val="0"/>
+    </c:legend>
+    <c:plotVisOnly val="1"/>
+    <c:dispBlanksAs val="gap"/>
+    <c:showDLblsOverMax val="0"/>
+  </c:chart>
+  <c:txPr>
+    <a:bodyPr/>
+    <a:lstStyle/>
+    <a:p>
+      <a:pPr>
+        <a:defRPr sz="1800"/>
+      </a:pPr>
+      <a:endParaRPr lang="en-US"/>
+    </a:p>
+  </c:txPr>
+  <c:externalData r:id="rId1">
+    <c:autoUpdate val="0"/>
+  </c:externalData>
+</c:chartSpace>
+</file>
+
+<file path=ppt/charts/chart9.xml><?xml version="1.0" encoding="utf-8"?>
+<c:chartSpace xmlns:c="http://schemas.openxmlformats.org/drawingml/2006/chart" xmlns:a="http://schemas.openxmlformats.org/drawingml/2006/main" xmlns:r="http://schemas.openxmlformats.org/officeDocument/2006/relationships">
+  <c:chart>
+    <c:plotArea>
+      <c:scatterChart>
+        <c:scatterStyle val="lineMarker"/>
+        <c:varyColors val="0"/>
+        <c:ser>
+          <c:idx val="0"/>
+          <c:order val="0"/>
+          <c:tx>
+            <c:strRef>
+              <c:f>Sheet1!$B$1</c:f>
+              <c:strCache>
+                <c:ptCount val="1"/>
+                <c:pt idx="0">
+                  <c:v>Group A</c:v>
+                </c:pt>
+              </c:strCache>
+            </c:strRef>
+          </c:tx>
+          <c:spPr>
+            <a:ln w="47625">
+              <a:noFill/>
+            </a:ln>
+          </c:spPr>
+          <c:xVal>
+            <c:numRef>
+              <c:f>Sheet1!$A$2:$A$5</c:f>
+              <c:numCache>
+                <c:formatCode>General</c:formatCode>
+                <c:ptCount val="4"/>
+                <c:pt idx="0">
+                  <c:v>10</c:v>
+                </c:pt>
+                <c:pt idx="1">
+                  <c:v>30</c:v>
+                </c:pt>
+                <c:pt idx="2">
+                  <c:v>50</c:v>
+                </c:pt>
+                <c:pt idx="3">
+                  <c:v>70</c:v>
+                </c:pt>
+              </c:numCache>
+            </c:numRef>
+          </c:xVal>
+          <c:yVal>
+            <c:numRef>
+              <c:f>Sheet1!$B$2:$B$5</c:f>
+              <c:numCache>
+                <c:formatCode>General</c:formatCode>
+                <c:ptCount val="4"/>
+                <c:pt idx="0">
+                  <c:v>20</c:v>
+                </c:pt>
+                <c:pt idx="1">
+                  <c:v>50</c:v>
+                </c:pt>
+                <c:pt idx="2">
+                  <c:v>40</c:v>
+                </c:pt>
+                <c:pt idx="3">
+                  <c:v>80</c:v>
+                </c:pt>
+              </c:numCache>
+            </c:numRef>
+          </c:yVal>
+          <c:smooth val="0"/>
+        </c:ser>
+        <c:ser>
+          <c:idx val="1"/>
+          <c:order val="1"/>
+          <c:tx>
+            <c:strRef>
+              <c:f>Sheet1!$B$7</c:f>
+              <c:strCache>
+                <c:ptCount val="1"/>
+                <c:pt idx="0">
+                  <c:v>Group B</c:v>
+                </c:pt>
+              </c:strCache>
+            </c:strRef>
+          </c:tx>
+          <c:spPr>
+            <a:ln w="47625">
+              <a:noFill/>
+            </a:ln>
+          </c:spPr>
+          <c:xVal>
+            <c:numRef>
+              <c:f>Sheet1!$A$8:$A$11</c:f>
+              <c:numCache>
+                <c:formatCode>General</c:formatCode>
+                <c:ptCount val="4"/>
+                <c:pt idx="0">
+                  <c:v>15</c:v>
+                </c:pt>
+                <c:pt idx="1">
+                  <c:v>35</c:v>
+                </c:pt>
+                <c:pt idx="2">
+                  <c:v>55</c:v>
+                </c:pt>
+                <c:pt idx="3">
+                  <c:v>75</c:v>
+                </c:pt>
+              </c:numCache>
+            </c:numRef>
+          </c:xVal>
+          <c:yVal>
+            <c:numRef>
+              <c:f>Sheet1!$B$8:$B$11</c:f>
+              <c:numCache>
+                <c:formatCode>General</c:formatCode>
+                <c:ptCount val="4"/>
+                <c:pt idx="0">
+                  <c:v>60</c:v>
+                </c:pt>
+                <c:pt idx="1">
+                  <c:v>30</c:v>
+                </c:pt>
+                <c:pt idx="2">
+                  <c:v>70</c:v>
+                </c:pt>
+                <c:pt idx="3">
+                  <c:v>45</c:v>
+                </c:pt>
+              </c:numCache>
+            </c:numRef>
+          </c:yVal>
+          <c:smooth val="0"/>
+        </c:ser>
+        <c:axId val="-2128940872"/>
+        <c:axId val="-2129643912"/>
+      </c:scatterChart>
+      <c:valAx>
+        <c:axId val="-2128940872"/>
+        <c:scaling>
+          <c:orientation val="minMax"/>
+        </c:scaling>
+        <c:delete val="0"/>
+        <c:axPos val="b"/>
+        <c:numFmt formatCode="General" sourceLinked="1"/>
+        <c:majorTickMark val="out"/>
+        <c:minorTickMark val="none"/>
+        <c:tickLblPos val="nextTo"/>
+        <c:crossAx val="-2129643912"/>
+        <c:crosses val="autoZero"/>
+        <c:crossBetween val="midCat"/>
+      </c:valAx>
+      <c:valAx>
+        <c:axId val="-2129643912"/>
+        <c:scaling>
+          <c:orientation val="minMax"/>
+        </c:scaling>
+        <c:delete val="0"/>
+        <c:axPos val="l"/>
+        <c:majorGridlines/>
+        <c:numFmt formatCode="General" sourceLinked="1"/>
+        <c:majorTickMark val="out"/>
+        <c:minorTickMark val="none"/>
+        <c:tickLblPos val="nextTo"/>
+        <c:crossAx val="-2128940872"/>
+        <c:crosses val="autoZero"/>
+        <c:crossBetween val="midCat"/>
       </c:valAx>
     </c:plotArea>
     <c:legend>
@@ -13680,6 +15421,91 @@
 </p:sld>
 </file>
 
+<file path=ppt/slides/slide59.xml><?xml version="1.0" encoding="utf-8"?>
+<p:sld xmlns:a="http://schemas.openxmlformats.org/drawingml/2006/main" xmlns:p="http://schemas.openxmlformats.org/presentationml/2006/main" xmlns:r="http://schemas.openxmlformats.org/officeDocument/2006/relationships">
+  <p:cSld>
+    <p:spTree>
+      <p:nvGrpSpPr>
+        <p:cNvPr id="1" name=""/>
+        <p:cNvGrpSpPr/>
+        <p:nvPr/>
+      </p:nvGrpSpPr>
+      <p:grpSpPr/>
+      <p:graphicFrame>
+        <p:nvGraphicFramePr>
+          <p:cNvPr id="2" name="Chart 1"/>
+          <p:cNvGraphicFramePr>
+            <a:graphicFrameLocks noGrp="1"/>
+          </p:cNvGraphicFramePr>
+          <p:nvPr/>
+        </p:nvGraphicFramePr>
+        <p:xfrm>
+          <a:off x="274320" y="1371600"/>
+          <a:ext cx="4114800" cy="3657600"/>
+        </p:xfrm>
+        <a:graphic>
+          <a:graphicData uri="http://schemas.openxmlformats.org/drawingml/2006/chart">
+            <c:chart xmlns:c="http://schemas.openxmlformats.org/drawingml/2006/chart" r:id="rId2"/>
+          </a:graphicData>
+        </a:graphic>
+      </p:graphicFrame>
+      <p:graphicFrame>
+        <p:nvGraphicFramePr>
+          <p:cNvPr id="3" name="Chart 2"/>
+          <p:cNvGraphicFramePr>
+            <a:graphicFrameLocks noGrp="1"/>
+          </p:cNvGraphicFramePr>
+          <p:nvPr/>
+        </p:nvGraphicFramePr>
+        <p:xfrm>
+          <a:off x="4754880" y="1371600"/>
+          <a:ext cx="4114800" cy="3657600"/>
+        </p:xfrm>
+        <a:graphic>
+          <a:graphicData uri="http://schemas.openxmlformats.org/drawingml/2006/chart">
+            <c:chart xmlns:c="http://schemas.openxmlformats.org/drawingml/2006/chart" r:id="rId3"/>
+          </a:graphicData>
+        </a:graphic>
+      </p:graphicFrame>
+      <p:sp>
+        <p:nvSpPr>
+          <p:cNvPr id="4" name="TextBox 3"/>
+          <p:cNvSpPr txBox="1"/>
+          <p:nvPr/>
+        </p:nvSpPr>
+        <p:spPr>
+          <a:xfrm>
+            <a:off x="274320" y="182880"/>
+            <a:ext cx="8229600" cy="457200"/>
+          </a:xfrm>
+          <a:prstGeom prst="rect">
+            <a:avLst/>
+          </a:prstGeom>
+          <a:noFill/>
+        </p:spPr>
+        <p:txBody>
+          <a:bodyPr wrap="none">
+            <a:spAutoFit/>
+          </a:bodyPr>
+          <a:lstStyle/>
+          <a:p>
+            <a:pPr>
+              <a:defRPr sz="1800" b="1"/>
+            </a:pPr>
+            <a:r>
+              <a:t>Slide 59: Scatter chart + Area chart</a:t>
+            </a:r>
+          </a:p>
+        </p:txBody>
+      </p:sp>
+    </p:spTree>
+  </p:cSld>
+  <p:clrMapOvr>
+    <a:masterClrMapping/>
+  </p:clrMapOvr>
+</p:sld>
+</file>
+
 <file path=ppt/slides/slide6.xml><?xml version="1.0" encoding="utf-8"?>
 <p:sld xmlns:a="http://schemas.openxmlformats.org/drawingml/2006/main" xmlns:p="http://schemas.openxmlformats.org/presentationml/2006/main" xmlns:r="http://schemas.openxmlformats.org/officeDocument/2006/relationships">
   <p:cSld>
@@ -13768,6 +15594,364 @@
             </a:pPr>
             <a:r>
               <a:t>White bg = inheritance FAILED</a:t>
+            </a:r>
+          </a:p>
+        </p:txBody>
+      </p:sp>
+    </p:spTree>
+  </p:cSld>
+  <p:clrMapOvr>
+    <a:masterClrMapping/>
+  </p:clrMapOvr>
+</p:sld>
+</file>
+
+<file path=ppt/slides/slide60.xml><?xml version="1.0" encoding="utf-8"?>
+<p:sld xmlns:a="http://schemas.openxmlformats.org/drawingml/2006/main" xmlns:p="http://schemas.openxmlformats.org/presentationml/2006/main" xmlns:r="http://schemas.openxmlformats.org/officeDocument/2006/relationships">
+  <p:cSld>
+    <p:spTree>
+      <p:nvGrpSpPr>
+        <p:cNvPr id="1" name=""/>
+        <p:cNvGrpSpPr/>
+        <p:nvPr/>
+      </p:nvGrpSpPr>
+      <p:grpSpPr/>
+      <p:graphicFrame>
+        <p:nvGraphicFramePr>
+          <p:cNvPr id="2" name="Chart 1"/>
+          <p:cNvGraphicFramePr>
+            <a:graphicFrameLocks noGrp="1"/>
+          </p:cNvGraphicFramePr>
+          <p:nvPr/>
+        </p:nvGraphicFramePr>
+        <p:xfrm>
+          <a:off x="1828800" y="1371600"/>
+          <a:ext cx="4572000" cy="4114800"/>
+        </p:xfrm>
+        <a:graphic>
+          <a:graphicData uri="http://schemas.openxmlformats.org/drawingml/2006/chart">
+            <c:chart xmlns:c="http://schemas.openxmlformats.org/drawingml/2006/chart" r:id="rId2"/>
+          </a:graphicData>
+        </a:graphic>
+      </p:graphicFrame>
+      <p:sp>
+        <p:nvSpPr>
+          <p:cNvPr id="3" name="TextBox 2"/>
+          <p:cNvSpPr txBox="1"/>
+          <p:nvPr/>
+        </p:nvSpPr>
+        <p:spPr>
+          <a:xfrm>
+            <a:off x="274320" y="182880"/>
+            <a:ext cx="8229600" cy="457200"/>
+          </a:xfrm>
+          <a:prstGeom prst="rect">
+            <a:avLst/>
+          </a:prstGeom>
+          <a:noFill/>
+        </p:spPr>
+        <p:txBody>
+          <a:bodyPr wrap="none">
+            <a:spAutoFit/>
+          </a:bodyPr>
+          <a:lstStyle/>
+          <a:p>
+            <a:pPr>
+              <a:defRPr sz="1800" b="1"/>
+            </a:pPr>
+            <a:r>
+              <a:t>Slide 60: Radar chart</a:t>
+            </a:r>
+          </a:p>
+        </p:txBody>
+      </p:sp>
+    </p:spTree>
+  </p:cSld>
+  <p:clrMapOvr>
+    <a:masterClrMapping/>
+  </p:clrMapOvr>
+</p:sld>
+</file>
+
+<file path=ppt/slides/slide61.xml><?xml version="1.0" encoding="utf-8"?>
+<p:sld xmlns:a="http://schemas.openxmlformats.org/drawingml/2006/main" xmlns:p="http://schemas.openxmlformats.org/presentationml/2006/main" xmlns:r="http://schemas.openxmlformats.org/officeDocument/2006/relationships">
+  <p:cSld>
+    <p:spTree>
+      <p:nvGrpSpPr>
+        <p:cNvPr id="1" name=""/>
+        <p:cNvGrpSpPr/>
+        <p:nvPr/>
+      </p:nvGrpSpPr>
+      <p:grpSpPr/>
+      <p:graphicFrame>
+        <p:nvGraphicFramePr>
+          <p:cNvPr id="2" name="Chart 1"/>
+          <p:cNvGraphicFramePr>
+            <a:graphicFrameLocks noGrp="1"/>
+          </p:cNvGraphicFramePr>
+          <p:nvPr/>
+        </p:nvGraphicFramePr>
+        <p:xfrm>
+          <a:off x="1371600" y="1371600"/>
+          <a:ext cx="5486400" cy="4114800"/>
+        </p:xfrm>
+        <a:graphic>
+          <a:graphicData uri="http://schemas.openxmlformats.org/drawingml/2006/chart">
+            <c:chart xmlns:c="http://schemas.openxmlformats.org/drawingml/2006/chart" r:id="rId2"/>
+          </a:graphicData>
+        </a:graphic>
+      </p:graphicFrame>
+      <p:sp>
+        <p:nvSpPr>
+          <p:cNvPr id="3" name="TextBox 2"/>
+          <p:cNvSpPr txBox="1"/>
+          <p:nvPr/>
+        </p:nvSpPr>
+        <p:spPr>
+          <a:xfrm>
+            <a:off x="274320" y="182880"/>
+            <a:ext cx="8229600" cy="457200"/>
+          </a:xfrm>
+          <a:prstGeom prst="rect">
+            <a:avLst/>
+          </a:prstGeom>
+          <a:noFill/>
+        </p:spPr>
+        <p:txBody>
+          <a:bodyPr wrap="none">
+            <a:spAutoFit/>
+          </a:bodyPr>
+          <a:lstStyle/>
+          <a:p>
+            <a:pPr>
+              <a:defRPr sz="1800" b="1"/>
+            </a:pPr>
+            <a:r>
+              <a:t>Slide 61: Bubble chart</a:t>
+            </a:r>
+          </a:p>
+        </p:txBody>
+      </p:sp>
+    </p:spTree>
+  </p:cSld>
+  <p:clrMapOvr>
+    <a:masterClrMapping/>
+  </p:clrMapOvr>
+</p:sld>
+</file>
+
+<file path=ppt/slides/slide62.xml><?xml version="1.0" encoding="utf-8"?>
+<p:sld xmlns:a="http://schemas.openxmlformats.org/drawingml/2006/main" xmlns:p="http://schemas.openxmlformats.org/presentationml/2006/main" xmlns:r="http://schemas.openxmlformats.org/officeDocument/2006/relationships">
+  <p:cSld>
+    <p:spTree>
+      <p:nvGrpSpPr>
+        <p:cNvPr id="1" name=""/>
+        <p:cNvGrpSpPr/>
+        <p:nvPr/>
+      </p:nvGrpSpPr>
+      <p:grpSpPr/>
+      <p:graphicFrame>
+        <p:nvGraphicFramePr>
+          <p:cNvPr id="2" name="Chart 1"/>
+          <p:cNvGraphicFramePr>
+            <a:graphicFrameLocks noGrp="1"/>
+          </p:cNvGraphicFramePr>
+          <p:nvPr/>
+        </p:nvGraphicFramePr>
+        <p:xfrm>
+          <a:off x="914400" y="1371600"/>
+          <a:ext cx="6400800" cy="4114800"/>
+        </p:xfrm>
+        <a:graphic>
+          <a:graphicData uri="http://schemas.openxmlformats.org/drawingml/2006/chart">
+            <c:chart xmlns:c="http://schemas.openxmlformats.org/drawingml/2006/chart" r:id="rId2"/>
+          </a:graphicData>
+        </a:graphic>
+      </p:graphicFrame>
+      <p:sp>
+        <p:nvSpPr>
+          <p:cNvPr id="3" name="TextBox 2"/>
+          <p:cNvSpPr txBox="1"/>
+          <p:nvPr/>
+        </p:nvSpPr>
+        <p:spPr>
+          <a:xfrm>
+            <a:off x="274320" y="182880"/>
+            <a:ext cx="8229600" cy="457200"/>
+          </a:xfrm>
+          <a:prstGeom prst="rect">
+            <a:avLst/>
+          </a:prstGeom>
+          <a:noFill/>
+        </p:spPr>
+        <p:txBody>
+          <a:bodyPr wrap="none">
+            <a:spAutoFit/>
+          </a:bodyPr>
+          <a:lstStyle/>
+          <a:p>
+            <a:pPr>
+              <a:defRPr sz="1800" b="1"/>
+            </a:pPr>
+            <a:r>
+              <a:t>Slide 62: Stock chart (OHLC)</a:t>
+            </a:r>
+          </a:p>
+        </p:txBody>
+      </p:sp>
+    </p:spTree>
+  </p:cSld>
+  <p:clrMapOvr>
+    <a:masterClrMapping/>
+  </p:clrMapOvr>
+</p:sld>
+</file>
+
+<file path=ppt/slides/slide63.xml><?xml version="1.0" encoding="utf-8"?>
+<p:sld xmlns:a="http://schemas.openxmlformats.org/drawingml/2006/main" xmlns:p="http://schemas.openxmlformats.org/presentationml/2006/main" xmlns:r="http://schemas.openxmlformats.org/officeDocument/2006/relationships">
+  <p:cSld>
+    <p:spTree>
+      <p:nvGrpSpPr>
+        <p:cNvPr id="1" name=""/>
+        <p:cNvGrpSpPr/>
+        <p:nvPr/>
+      </p:nvGrpSpPr>
+      <p:grpSpPr/>
+      <p:graphicFrame>
+        <p:nvGraphicFramePr>
+          <p:cNvPr id="2" name="Chart 1"/>
+          <p:cNvGraphicFramePr>
+            <a:graphicFrameLocks noGrp="1"/>
+          </p:cNvGraphicFramePr>
+          <p:nvPr/>
+        </p:nvGraphicFramePr>
+        <p:xfrm>
+          <a:off x="274320" y="1097280"/>
+          <a:ext cx="2743200" cy="2286000"/>
+        </p:xfrm>
+        <a:graphic>
+          <a:graphicData uri="http://schemas.openxmlformats.org/drawingml/2006/chart">
+            <c:chart xmlns:c="http://schemas.openxmlformats.org/drawingml/2006/chart" r:id="rId2"/>
+          </a:graphicData>
+        </a:graphic>
+      </p:graphicFrame>
+      <p:graphicFrame>
+        <p:nvGraphicFramePr>
+          <p:cNvPr id="3" name="Chart 2"/>
+          <p:cNvGraphicFramePr>
+            <a:graphicFrameLocks noGrp="1"/>
+          </p:cNvGraphicFramePr>
+          <p:nvPr/>
+        </p:nvGraphicFramePr>
+        <p:xfrm>
+          <a:off x="3200400" y="1097280"/>
+          <a:ext cx="2743200" cy="2286000"/>
+        </p:xfrm>
+        <a:graphic>
+          <a:graphicData uri="http://schemas.openxmlformats.org/drawingml/2006/chart">
+            <c:chart xmlns:c="http://schemas.openxmlformats.org/drawingml/2006/chart" r:id="rId3"/>
+          </a:graphicData>
+        </a:graphic>
+      </p:graphicFrame>
+      <p:graphicFrame>
+        <p:nvGraphicFramePr>
+          <p:cNvPr id="4" name="Chart 3"/>
+          <p:cNvGraphicFramePr>
+            <a:graphicFrameLocks noGrp="1"/>
+          </p:cNvGraphicFramePr>
+          <p:nvPr/>
+        </p:nvGraphicFramePr>
+        <p:xfrm>
+          <a:off x="6126480" y="1097280"/>
+          <a:ext cx="2743200" cy="2286000"/>
+        </p:xfrm>
+        <a:graphic>
+          <a:graphicData uri="http://schemas.openxmlformats.org/drawingml/2006/chart">
+            <c:chart xmlns:c="http://schemas.openxmlformats.org/drawingml/2006/chart" r:id="rId4"/>
+          </a:graphicData>
+        </a:graphic>
+      </p:graphicFrame>
+      <p:graphicFrame>
+        <p:nvGraphicFramePr>
+          <p:cNvPr id="5" name="Chart 4"/>
+          <p:cNvGraphicFramePr>
+            <a:graphicFrameLocks noGrp="1"/>
+          </p:cNvGraphicFramePr>
+          <p:nvPr/>
+        </p:nvGraphicFramePr>
+        <p:xfrm>
+          <a:off x="274320" y="3657600"/>
+          <a:ext cx="2743200" cy="2286000"/>
+        </p:xfrm>
+        <a:graphic>
+          <a:graphicData uri="http://schemas.openxmlformats.org/drawingml/2006/chart">
+            <c:chart xmlns:c="http://schemas.openxmlformats.org/drawingml/2006/chart" r:id="rId5"/>
+          </a:graphicData>
+        </a:graphic>
+      </p:graphicFrame>
+      <p:graphicFrame>
+        <p:nvGraphicFramePr>
+          <p:cNvPr id="6" name="Chart 5"/>
+          <p:cNvGraphicFramePr>
+            <a:graphicFrameLocks noGrp="1"/>
+          </p:cNvGraphicFramePr>
+          <p:nvPr/>
+        </p:nvGraphicFramePr>
+        <p:xfrm>
+          <a:off x="3200400" y="3657600"/>
+          <a:ext cx="2743200" cy="2286000"/>
+        </p:xfrm>
+        <a:graphic>
+          <a:graphicData uri="http://schemas.openxmlformats.org/drawingml/2006/chart">
+            <c:chart xmlns:c="http://schemas.openxmlformats.org/drawingml/2006/chart" r:id="rId6"/>
+          </a:graphicData>
+        </a:graphic>
+      </p:graphicFrame>
+      <p:graphicFrame>
+        <p:nvGraphicFramePr>
+          <p:cNvPr id="7" name="Chart 6"/>
+          <p:cNvGraphicFramePr>
+            <a:graphicFrameLocks noGrp="1"/>
+          </p:cNvGraphicFramePr>
+          <p:nvPr/>
+        </p:nvGraphicFramePr>
+        <p:xfrm>
+          <a:off x="6126480" y="3657600"/>
+          <a:ext cx="2743200" cy="2286000"/>
+        </p:xfrm>
+        <a:graphic>
+          <a:graphicData uri="http://schemas.openxmlformats.org/drawingml/2006/chart">
+            <c:chart xmlns:c="http://schemas.openxmlformats.org/drawingml/2006/chart" r:id="rId7"/>
+          </a:graphicData>
+        </a:graphic>
+      </p:graphicFrame>
+      <p:sp>
+        <p:nvSpPr>
+          <p:cNvPr id="8" name="TextBox 7"/>
+          <p:cNvSpPr txBox="1"/>
+          <p:nvPr/>
+        </p:nvSpPr>
+        <p:spPr>
+          <a:xfrm>
+            <a:off x="274320" y="182880"/>
+            <a:ext cx="8229600" cy="457200"/>
+          </a:xfrm>
+          <a:prstGeom prst="rect">
+            <a:avLst/>
+          </a:prstGeom>
+          <a:noFill/>
+        </p:spPr>
+        <p:txBody>
+          <a:bodyPr wrap="none">
+            <a:spAutoFit/>
+          </a:bodyPr>
+          <a:lstStyle/>
+          <a:p>
+            <a:pPr>
+              <a:defRPr sz="1800" b="1"/>
+            </a:pPr>
+            <a:r>
+              <a:t>Slide 63: All chart types overview</a:t>
             </a:r>
           </a:p>
         </p:txBody>

</xml_diff>

<commit_message>
feat: trendlines, error bars, composite chart fix + refactoring
Add trendline rendering (linear regression with least-squares fit),
error bar rendering (fixedVal/percentage with caps), and fix composite
chart axis range to consider all ChartGroups. Refactor: extract constants,
convert while→for-in loops, parse errBars spPr, clean up TODO.md.

Co-Authored-By: Claude Opus 4.6 <noreply@anthropic.com>
</commit_message>
<xml_diff>
--- a/test_fixtures/test_features.pptx
+++ b/test_fixtures/test_features.pptx
@@ -68,6 +68,9 @@
     <p:sldId id="316" r:id="rId67"/>
     <p:sldId id="317" r:id="rId68"/>
     <p:sldId id="318" r:id="rId69"/>
+    <p:sldId id="319" r:id="rId70"/>
+    <p:sldId id="320" r:id="rId71"/>
+    <p:sldId id="321" r:id="rId72"/>
   </p:sldIdLst>
   <p:sldSz cx="9144000" cy="6858000" type="screen4x3"/>
   <p:notesSz cx="6858000" cy="9144000"/>
@@ -2069,6 +2072,466 @@
     <c:plotVisOnly val="1"/>
     <c:dispBlanksAs val="gap"/>
     <c:showDLblsOverMax val="0"/>
+  </c:chart>
+  <c:txPr>
+    <a:bodyPr/>
+    <a:lstStyle/>
+    <a:p>
+      <a:pPr>
+        <a:defRPr sz="1800"/>
+      </a:pPr>
+      <a:endParaRPr lang="en-US"/>
+    </a:p>
+  </c:txPr>
+  <c:externalData r:id="rId1">
+    <c:autoUpdate val="0"/>
+  </c:externalData>
+</c:chartSpace>
+</file>
+
+<file path=ppt/charts/chart20.xml><?xml version="1.0" encoding="utf-8"?>
+<c:chartSpace xmlns:c="http://schemas.openxmlformats.org/drawingml/2006/chart" xmlns:a="http://schemas.openxmlformats.org/drawingml/2006/main" xmlns:r="http://schemas.openxmlformats.org/officeDocument/2006/relationships">
+  <c:date1904 val="0"/>
+  <c:chart>
+    <c:autoTitleDeleted val="0"/>
+    <c:plotArea>
+      <c:lineChart>
+        <c:grouping val="standard"/>
+        <c:varyColors val="0"/>
+        <c:ser>
+          <c:idx val="0"/>
+          <c:order val="0"/>
+          <c:tx>
+            <c:strRef>
+              <c:f>Sheet1!$B$1</c:f>
+              <c:strCache>
+                <c:ptCount val="1"/>
+                <c:pt idx="0">
+                  <c:v>Sales</c:v>
+                </c:pt>
+              </c:strCache>
+            </c:strRef>
+          </c:tx>
+          <c:marker>
+            <c:symbol val="none"/>
+          </c:marker>
+          <c:cat>
+            <c:strRef>
+              <c:f>Sheet1!$A$2:$A$7</c:f>
+              <c:strCache>
+                <c:ptCount val="6"/>
+                <c:pt idx="0">
+                  <c:v>Jan</c:v>
+                </c:pt>
+                <c:pt idx="1">
+                  <c:v>Feb</c:v>
+                </c:pt>
+                <c:pt idx="2">
+                  <c:v>Mar</c:v>
+                </c:pt>
+                <c:pt idx="3">
+                  <c:v>Apr</c:v>
+                </c:pt>
+                <c:pt idx="4">
+                  <c:v>May</c:v>
+                </c:pt>
+                <c:pt idx="5">
+                  <c:v>Jun</c:v>
+                </c:pt>
+              </c:strCache>
+            </c:strRef>
+          </c:cat>
+          <c:val>
+            <c:numRef>
+              <c:f>Sheet1!$B$2:$B$7</c:f>
+              <c:numCache>
+                <c:formatCode>General</c:formatCode>
+                <c:ptCount val="6"/>
+                <c:pt idx="0">
+                  <c:v>20</c:v>
+                </c:pt>
+                <c:pt idx="1">
+                  <c:v>35</c:v>
+                </c:pt>
+                <c:pt idx="2">
+                  <c:v>28</c:v>
+                </c:pt>
+                <c:pt idx="3">
+                  <c:v>45</c:v>
+                </c:pt>
+                <c:pt idx="4">
+                  <c:v>52</c:v>
+                </c:pt>
+                <c:pt idx="5">
+                  <c:v>60</c:v>
+                </c:pt>
+              </c:numCache>
+            </c:numRef>
+          </c:val>
+          <c:smooth val="0"/>
+          <c:trendline>
+            <c:trendlineType val="linear"/>
+            <c:spPr>
+              <a:ln w="12700">
+                <a:solidFill>
+                  <a:srgbClr val="FF0000"/>
+                </a:solidFill>
+                <a:prstDash val="dash"/>
+              </a:ln>
+            </c:spPr>
+          </c:trendline>
+        </c:ser>
+        <c:marker val="1"/>
+        <c:smooth val="0"/>
+        <c:axId val="2118791784"/>
+        <c:axId val="2140495176"/>
+      </c:lineChart>
+      <c:catAx>
+        <c:axId val="2118791784"/>
+        <c:scaling>
+          <c:orientation val="minMax"/>
+        </c:scaling>
+        <c:delete val="0"/>
+        <c:axPos val="b"/>
+        <c:majorTickMark val="out"/>
+        <c:minorTickMark val="none"/>
+        <c:tickLblPos val="nextTo"/>
+        <c:crossAx val="2140495176"/>
+        <c:crosses val="autoZero"/>
+        <c:auto val="1"/>
+        <c:lblAlgn val="ctr"/>
+        <c:lblOffset val="100"/>
+        <c:noMultiLvlLbl val="0"/>
+      </c:catAx>
+      <c:valAx>
+        <c:axId val="2140495176"/>
+        <c:scaling/>
+        <c:delete val="0"/>
+        <c:axPos val="l"/>
+        <c:majorGridlines/>
+        <c:majorTickMark val="out"/>
+        <c:minorTickMark val="none"/>
+        <c:tickLblPos val="nextTo"/>
+        <c:crossAx val="2118791784"/>
+        <c:crosses val="autoZero"/>
+      </c:valAx>
+    </c:plotArea>
+    <c:legend>
+      <c:legendPos val="r"/>
+      <c:layout/>
+      <c:overlay val="0"/>
+    </c:legend>
+    <c:plotVisOnly val="1"/>
+    <c:dispBlanksAs val="gap"/>
+    <c:showDLblsOverMax val="0"/>
+  </c:chart>
+  <c:txPr>
+    <a:bodyPr/>
+    <a:lstStyle/>
+    <a:p>
+      <a:pPr>
+        <a:defRPr sz="1800"/>
+      </a:pPr>
+      <a:endParaRPr lang="en-US"/>
+    </a:p>
+  </c:txPr>
+  <c:externalData r:id="rId1">
+    <c:autoUpdate val="0"/>
+  </c:externalData>
+</c:chartSpace>
+</file>
+
+<file path=ppt/charts/chart21.xml><?xml version="1.0" encoding="utf-8"?>
+<c:chartSpace xmlns:c="http://schemas.openxmlformats.org/drawingml/2006/chart" xmlns:a="http://schemas.openxmlformats.org/drawingml/2006/main" xmlns:r="http://schemas.openxmlformats.org/officeDocument/2006/relationships">
+  <c:date1904 val="0"/>
+  <c:chart>
+    <c:autoTitleDeleted val="0"/>
+    <c:plotArea>
+      <c:barChart>
+        <c:barDir val="col"/>
+        <c:grouping val="clustered"/>
+        <c:ser>
+          <c:idx val="0"/>
+          <c:order val="0"/>
+          <c:tx>
+            <c:strRef>
+              <c:f>Sheet1!$B$1</c:f>
+              <c:strCache>
+                <c:ptCount val="1"/>
+                <c:pt idx="0">
+                  <c:v>Measurement</c:v>
+                </c:pt>
+              </c:strCache>
+            </c:strRef>
+          </c:tx>
+          <c:cat>
+            <c:strRef>
+              <c:f>Sheet1!$A$2:$A$5</c:f>
+              <c:strCache>
+                <c:ptCount val="4"/>
+                <c:pt idx="0">
+                  <c:v>Group A</c:v>
+                </c:pt>
+                <c:pt idx="1">
+                  <c:v>Group B</c:v>
+                </c:pt>
+                <c:pt idx="2">
+                  <c:v>Group C</c:v>
+                </c:pt>
+                <c:pt idx="3">
+                  <c:v>Group D</c:v>
+                </c:pt>
+              </c:strCache>
+            </c:strRef>
+          </c:cat>
+          <c:val>
+            <c:numRef>
+              <c:f>Sheet1!$B$2:$B$5</c:f>
+              <c:numCache>
+                <c:formatCode>General</c:formatCode>
+                <c:ptCount val="4"/>
+                <c:pt idx="0">
+                  <c:v>85</c:v>
+                </c:pt>
+                <c:pt idx="1">
+                  <c:v>92</c:v>
+                </c:pt>
+                <c:pt idx="2">
+                  <c:v>78</c:v>
+                </c:pt>
+                <c:pt idx="3">
+                  <c:v>95</c:v>
+                </c:pt>
+              </c:numCache>
+            </c:numRef>
+          </c:val>
+          <c:errBars>
+            <c:errDir val="y"/>
+            <c:errBarType val="both"/>
+            <c:errValType val="fixedVal"/>
+            <c:val val="8"/>
+          </c:errBars>
+        </c:ser>
+        <c:axId val="-2068027336"/>
+        <c:axId val="-2113994440"/>
+      </c:barChart>
+      <c:catAx>
+        <c:axId val="-2068027336"/>
+        <c:scaling>
+          <c:orientation val="minMax"/>
+        </c:scaling>
+        <c:delete val="0"/>
+        <c:axPos val="b"/>
+        <c:majorTickMark val="out"/>
+        <c:minorTickMark val="none"/>
+        <c:tickLblPos val="nextTo"/>
+        <c:crossAx val="-2113994440"/>
+        <c:crosses val="autoZero"/>
+        <c:auto val="1"/>
+        <c:lblAlgn val="ctr"/>
+        <c:lblOffset val="100"/>
+        <c:noMultiLvlLbl val="0"/>
+      </c:catAx>
+      <c:valAx>
+        <c:axId val="-2113994440"/>
+        <c:scaling/>
+        <c:delete val="0"/>
+        <c:axPos val="l"/>
+        <c:majorGridlines/>
+        <c:majorTickMark val="out"/>
+        <c:minorTickMark val="none"/>
+        <c:tickLblPos val="nextTo"/>
+        <c:crossAx val="-2068027336"/>
+        <c:crosses val="autoZero"/>
+      </c:valAx>
+    </c:plotArea>
+    <c:legend/>
+    <c:dispBlanksAs val="gap"/>
+  </c:chart>
+  <c:txPr>
+    <a:bodyPr/>
+    <a:lstStyle/>
+    <a:p>
+      <a:pPr>
+        <a:defRPr sz="1800"/>
+      </a:pPr>
+      <a:endParaRPr lang="en-US"/>
+    </a:p>
+  </c:txPr>
+  <c:externalData r:id="rId1">
+    <c:autoUpdate val="0"/>
+  </c:externalData>
+</c:chartSpace>
+</file>
+
+<file path=ppt/charts/chart22.xml><?xml version="1.0" encoding="utf-8"?>
+<c:chartSpace xmlns:c="http://schemas.openxmlformats.org/drawingml/2006/chart" xmlns:a="http://schemas.openxmlformats.org/drawingml/2006/main" xmlns:r="http://schemas.openxmlformats.org/officeDocument/2006/relationships">
+  <c:date1904 val="0"/>
+  <c:chart>
+    <c:autoTitleDeleted val="0"/>
+    <c:plotArea>
+      <c:barChart>
+        <c:barDir val="col"/>
+        <c:grouping val="clustered"/>
+        <c:ser>
+          <c:idx val="0"/>
+          <c:order val="0"/>
+          <c:tx>
+            <c:strRef>
+              <c:f>Sheet1!$B$1</c:f>
+              <c:strCache>
+                <c:ptCount val="1"/>
+                <c:pt idx="0">
+                  <c:v>Revenue</c:v>
+                </c:pt>
+              </c:strCache>
+            </c:strRef>
+          </c:tx>
+          <c:cat>
+            <c:strRef>
+              <c:f>Sheet1!$A$2:$A$5</c:f>
+              <c:strCache>
+                <c:ptCount val="4"/>
+                <c:pt idx="0">
+                  <c:v>Q1</c:v>
+                </c:pt>
+                <c:pt idx="1">
+                  <c:v>Q2</c:v>
+                </c:pt>
+                <c:pt idx="2">
+                  <c:v>Q3</c:v>
+                </c:pt>
+                <c:pt idx="3">
+                  <c:v>Q4</c:v>
+                </c:pt>
+              </c:strCache>
+            </c:strRef>
+          </c:cat>
+          <c:val>
+            <c:numRef>
+              <c:f>Sheet1!$B$2:$B$5</c:f>
+              <c:numCache>
+                <c:formatCode>General</c:formatCode>
+                <c:ptCount val="4"/>
+                <c:pt idx="0">
+                  <c:v>300</c:v>
+                </c:pt>
+                <c:pt idx="1">
+                  <c:v>350</c:v>
+                </c:pt>
+                <c:pt idx="2">
+                  <c:v>400</c:v>
+                </c:pt>
+                <c:pt idx="3">
+                  <c:v>450</c:v>
+                </c:pt>
+              </c:numCache>
+            </c:numRef>
+          </c:val>
+        </c:ser>
+        <c:axId val="-2068027336"/>
+        <c:axId val="-2113994440"/>
+      </c:barChart>
+      <c:lineChart>
+        <c:grouping val="standard"/>
+        <c:ser>
+          <c:idx val="1"/>
+          <c:order val="1"/>
+          <c:tx>
+            <c:strRef>
+              <c:f>Sheet1!$C$1</c:f>
+              <c:strCache>
+                <c:ptCount val="1"/>
+                <c:pt idx="0">
+                  <c:v>Profit</c:v>
+                </c:pt>
+              </c:strCache>
+            </c:strRef>
+          </c:tx>
+          <c:spPr>
+            <a:ln w="25400">
+              <a:solidFill>
+                <a:srgbClr val="FF0000"/>
+              </a:solidFill>
+            </a:ln>
+          </c:spPr>
+          <c:cat>
+            <c:strRef>
+              <c:f>Sheet1!$A$2:$A$5</c:f>
+              <c:strCache>
+                <c:ptCount val="4"/>
+                <c:pt idx="0">
+                  <c:v>Q1</c:v>
+                </c:pt>
+                <c:pt idx="1">
+                  <c:v>Q2</c:v>
+                </c:pt>
+                <c:pt idx="2">
+                  <c:v>Q3</c:v>
+                </c:pt>
+                <c:pt idx="3">
+                  <c:v>Q4</c:v>
+                </c:pt>
+              </c:strCache>
+            </c:strRef>
+          </c:cat>
+          <c:val>
+            <c:numRef>
+              <c:f>Sheet1!$C$2:$C$5</c:f>
+              <c:numCache>
+                <c:formatCode>General</c:formatCode>
+                <c:ptCount val="4"/>
+                <c:pt idx="0">
+                  <c:v>80</c:v>
+                </c:pt>
+                <c:pt idx="1">
+                  <c:v>120</c:v>
+                </c:pt>
+                <c:pt idx="2">
+                  <c:v>150</c:v>
+                </c:pt>
+                <c:pt idx="3">
+                  <c:v>200</c:v>
+                </c:pt>
+              </c:numCache>
+            </c:numRef>
+          </c:val>
+        </c:ser>
+        <c:axId val="-2068027336"/>
+        <c:axId val="-2113994440"/>
+      </c:lineChart>
+      <c:catAx>
+        <c:axId val="-2068027336"/>
+        <c:scaling>
+          <c:orientation val="minMax"/>
+        </c:scaling>
+        <c:delete val="0"/>
+        <c:axPos val="b"/>
+        <c:majorTickMark val="out"/>
+        <c:minorTickMark val="none"/>
+        <c:tickLblPos val="nextTo"/>
+        <c:crossAx val="-2113994440"/>
+        <c:crosses val="autoZero"/>
+        <c:auto val="1"/>
+        <c:lblAlgn val="ctr"/>
+        <c:lblOffset val="100"/>
+        <c:noMultiLvlLbl val="0"/>
+      </c:catAx>
+      <c:valAx>
+        <c:axId val="-2113994440"/>
+        <c:scaling/>
+        <c:delete val="0"/>
+        <c:axPos val="l"/>
+        <c:majorGridlines/>
+        <c:majorTickMark val="out"/>
+        <c:minorTickMark val="none"/>
+        <c:tickLblPos val="nextTo"/>
+        <c:crossAx val="-2068027336"/>
+        <c:crosses val="autoZero"/>
+      </c:valAx>
+    </c:plotArea>
+    <c:legend/>
+    <c:dispBlanksAs val="gap"/>
   </c:chart>
   <c:txPr>
     <a:bodyPr/>
@@ -15952,6 +16415,207 @@
             </a:pPr>
             <a:r>
               <a:t>Slide 63: All chart types overview</a:t>
+            </a:r>
+          </a:p>
+        </p:txBody>
+      </p:sp>
+    </p:spTree>
+  </p:cSld>
+  <p:clrMapOvr>
+    <a:masterClrMapping/>
+  </p:clrMapOvr>
+</p:sld>
+</file>
+
+<file path=ppt/slides/slide64.xml><?xml version="1.0" encoding="utf-8"?>
+<p:sld xmlns:a="http://schemas.openxmlformats.org/drawingml/2006/main" xmlns:p="http://schemas.openxmlformats.org/presentationml/2006/main" xmlns:r="http://schemas.openxmlformats.org/officeDocument/2006/relationships">
+  <p:cSld>
+    <p:spTree>
+      <p:nvGrpSpPr>
+        <p:cNvPr id="1" name=""/>
+        <p:cNvGrpSpPr/>
+        <p:nvPr/>
+      </p:nvGrpSpPr>
+      <p:grpSpPr/>
+      <p:graphicFrame>
+        <p:nvGraphicFramePr>
+          <p:cNvPr id="2" name="Chart 1"/>
+          <p:cNvGraphicFramePr>
+            <a:graphicFrameLocks noGrp="1"/>
+          </p:cNvGraphicFramePr>
+          <p:nvPr/>
+        </p:nvGraphicFramePr>
+        <p:xfrm>
+          <a:off x="914400" y="1371600"/>
+          <a:ext cx="6400800" cy="4114800"/>
+        </p:xfrm>
+        <a:graphic>
+          <a:graphicData uri="http://schemas.openxmlformats.org/drawingml/2006/chart">
+            <c:chart xmlns:c="http://schemas.openxmlformats.org/drawingml/2006/chart" r:id="rId2"/>
+          </a:graphicData>
+        </a:graphic>
+      </p:graphicFrame>
+      <p:sp>
+        <p:nvSpPr>
+          <p:cNvPr id="3" name="TextBox 2"/>
+          <p:cNvSpPr txBox="1"/>
+          <p:nvPr/>
+        </p:nvSpPr>
+        <p:spPr>
+          <a:xfrm>
+            <a:off x="274320" y="182880"/>
+            <a:ext cx="8229600" cy="457200"/>
+          </a:xfrm>
+          <a:prstGeom prst="rect">
+            <a:avLst/>
+          </a:prstGeom>
+          <a:noFill/>
+        </p:spPr>
+        <p:txBody>
+          <a:bodyPr wrap="none">
+            <a:spAutoFit/>
+          </a:bodyPr>
+          <a:lstStyle/>
+          <a:p>
+            <a:pPr>
+              <a:defRPr sz="1800" b="1"/>
+            </a:pPr>
+            <a:r>
+              <a:t>Slide 64: Line chart with linear trendline</a:t>
+            </a:r>
+          </a:p>
+        </p:txBody>
+      </p:sp>
+    </p:spTree>
+  </p:cSld>
+  <p:clrMapOvr>
+    <a:masterClrMapping/>
+  </p:clrMapOvr>
+</p:sld>
+</file>
+
+<file path=ppt/slides/slide65.xml><?xml version="1.0" encoding="utf-8"?>
+<p:sld xmlns:a="http://schemas.openxmlformats.org/drawingml/2006/main" xmlns:p="http://schemas.openxmlformats.org/presentationml/2006/main" xmlns:r="http://schemas.openxmlformats.org/officeDocument/2006/relationships">
+  <p:cSld>
+    <p:spTree>
+      <p:nvGrpSpPr>
+        <p:cNvPr id="1" name=""/>
+        <p:cNvGrpSpPr/>
+        <p:nvPr/>
+      </p:nvGrpSpPr>
+      <p:grpSpPr/>
+      <p:graphicFrame>
+        <p:nvGraphicFramePr>
+          <p:cNvPr id="2" name="Chart 1"/>
+          <p:cNvGraphicFramePr>
+            <a:graphicFrameLocks noGrp="1"/>
+          </p:cNvGraphicFramePr>
+          <p:nvPr/>
+        </p:nvGraphicFramePr>
+        <p:xfrm>
+          <a:off x="914400" y="1371600"/>
+          <a:ext cx="6400800" cy="4114800"/>
+        </p:xfrm>
+        <a:graphic>
+          <a:graphicData uri="http://schemas.openxmlformats.org/drawingml/2006/chart">
+            <c:chart xmlns:c="http://schemas.openxmlformats.org/drawingml/2006/chart" r:id="rId2"/>
+          </a:graphicData>
+        </a:graphic>
+      </p:graphicFrame>
+      <p:sp>
+        <p:nvSpPr>
+          <p:cNvPr id="3" name="TextBox 2"/>
+          <p:cNvSpPr txBox="1"/>
+          <p:nvPr/>
+        </p:nvSpPr>
+        <p:spPr>
+          <a:xfrm>
+            <a:off x="274320" y="182880"/>
+            <a:ext cx="8229600" cy="457200"/>
+          </a:xfrm>
+          <a:prstGeom prst="rect">
+            <a:avLst/>
+          </a:prstGeom>
+          <a:noFill/>
+        </p:spPr>
+        <p:txBody>
+          <a:bodyPr wrap="none">
+            <a:spAutoFit/>
+          </a:bodyPr>
+          <a:lstStyle/>
+          <a:p>
+            <a:pPr>
+              <a:defRPr sz="1800" b="1"/>
+            </a:pPr>
+            <a:r>
+              <a:t>Slide 65: Column chart with error bars (±8)</a:t>
+            </a:r>
+          </a:p>
+        </p:txBody>
+      </p:sp>
+    </p:spTree>
+  </p:cSld>
+  <p:clrMapOvr>
+    <a:masterClrMapping/>
+  </p:clrMapOvr>
+</p:sld>
+</file>
+
+<file path=ppt/slides/slide66.xml><?xml version="1.0" encoding="utf-8"?>
+<p:sld xmlns:a="http://schemas.openxmlformats.org/drawingml/2006/main" xmlns:p="http://schemas.openxmlformats.org/presentationml/2006/main" xmlns:r="http://schemas.openxmlformats.org/officeDocument/2006/relationships">
+  <p:cSld>
+    <p:spTree>
+      <p:nvGrpSpPr>
+        <p:cNvPr id="1" name=""/>
+        <p:cNvGrpSpPr/>
+        <p:nvPr/>
+      </p:nvGrpSpPr>
+      <p:grpSpPr/>
+      <p:graphicFrame>
+        <p:nvGraphicFramePr>
+          <p:cNvPr id="2" name="Chart 1"/>
+          <p:cNvGraphicFramePr>
+            <a:graphicFrameLocks noGrp="1"/>
+          </p:cNvGraphicFramePr>
+          <p:nvPr/>
+        </p:nvGraphicFramePr>
+        <p:xfrm>
+          <a:off x="914400" y="1371600"/>
+          <a:ext cx="6400800" cy="4114800"/>
+        </p:xfrm>
+        <a:graphic>
+          <a:graphicData uri="http://schemas.openxmlformats.org/drawingml/2006/chart">
+            <c:chart xmlns:c="http://schemas.openxmlformats.org/drawingml/2006/chart" r:id="rId2"/>
+          </a:graphicData>
+        </a:graphic>
+      </p:graphicFrame>
+      <p:sp>
+        <p:nvSpPr>
+          <p:cNvPr id="3" name="TextBox 2"/>
+          <p:cNvSpPr txBox="1"/>
+          <p:nvPr/>
+        </p:nvSpPr>
+        <p:spPr>
+          <a:xfrm>
+            <a:off x="274320" y="182880"/>
+            <a:ext cx="8229600" cy="457200"/>
+          </a:xfrm>
+          <a:prstGeom prst="rect">
+            <a:avLst/>
+          </a:prstGeom>
+          <a:noFill/>
+        </p:spPr>
+        <p:txBody>
+          <a:bodyPr wrap="none">
+            <a:spAutoFit/>
+          </a:bodyPr>
+          <a:lstStyle/>
+          <a:p>
+            <a:pPr>
+              <a:defRPr sz="1800" b="1"/>
+            </a:pPr>
+            <a:r>
+              <a:t>Slide 66: Composite chart (column + line)</a:t>
             </a:r>
           </a:p>
         </p:txBody>

</xml_diff>

<commit_message>
feat: surface chart, ofPie chart, view3D/serAx support + refactoring
Add SurfaceChart (2D heatmap approximation), OfPieChart (pie fallback),
ChartView3D parsing/preservation, and c:serAx axis dispatch. Fix
parse_view_3d to distinguish missing elements from val="0". Extract
heatmap min sentinel constant. Clean up TODO.md section numbering.

Co-Authored-By: Claude Opus 4.6 <noreply@anthropic.com>
</commit_message>
<xml_diff>
--- a/test_fixtures/test_features.pptx
+++ b/test_fixtures/test_features.pptx
@@ -71,6 +71,9 @@
     <p:sldId id="319" r:id="rId70"/>
     <p:sldId id="320" r:id="rId71"/>
     <p:sldId id="321" r:id="rId72"/>
+    <p:sldId id="322" r:id="rId73"/>
+    <p:sldId id="323" r:id="rId74"/>
+    <p:sldId id="324" r:id="rId75"/>
   </p:sldIdLst>
   <p:sldSz cx="9144000" cy="6858000" type="screen4x3"/>
   <p:notesSz cx="6858000" cy="9144000"/>
@@ -2531,6 +2534,523 @@
       </c:valAx>
     </c:plotArea>
     <c:legend/>
+    <c:dispBlanksAs val="gap"/>
+  </c:chart>
+  <c:txPr>
+    <a:bodyPr/>
+    <a:lstStyle/>
+    <a:p>
+      <a:pPr>
+        <a:defRPr sz="1800"/>
+      </a:pPr>
+      <a:endParaRPr lang="en-US"/>
+    </a:p>
+  </c:txPr>
+  <c:externalData r:id="rId1">
+    <c:autoUpdate val="0"/>
+  </c:externalData>
+</c:chartSpace>
+</file>
+
+<file path=ppt/charts/chart23.xml><?xml version="1.0" encoding="utf-8"?>
+<c:chartSpace xmlns:c="http://schemas.openxmlformats.org/drawingml/2006/chart" xmlns:a="http://schemas.openxmlformats.org/drawingml/2006/main" xmlns:r="http://schemas.openxmlformats.org/officeDocument/2006/relationships">
+  <c:date1904 val="0"/>
+  <c:chart>
+    <c:view3D>
+      <c:rotX val="15"/>
+      <c:rotY val="20"/>
+      <c:depthPercent val="100"/>
+      <c:rAngAx val="1"/>
+      <c:perspective val="30"/>
+    </c:view3D>
+    <c:autoTitleDeleted val="0"/>
+    <c:plotArea>
+      <c:surfaceChart>
+        <c:wireframe val="0"/>
+        <c:ser>
+          <c:idx val="0"/>
+          <c:order val="0"/>
+          <c:tx>
+            <c:strRef>
+              <c:f>Sheet1!$B$1</c:f>
+              <c:strCache>
+                <c:ptCount val="1"/>
+                <c:pt idx="0">
+                  <c:v>Row 1</c:v>
+                </c:pt>
+              </c:strCache>
+            </c:strRef>
+          </c:tx>
+          <c:cat>
+            <c:strRef>
+              <c:f>Sheet1!$A$2:$A$6</c:f>
+              <c:strCache>
+                <c:ptCount val="5"/>
+                <c:pt idx="0">
+                  <c:v>X1</c:v>
+                </c:pt>
+                <c:pt idx="1">
+                  <c:v>X2</c:v>
+                </c:pt>
+                <c:pt idx="2">
+                  <c:v>X3</c:v>
+                </c:pt>
+                <c:pt idx="3">
+                  <c:v>X4</c:v>
+                </c:pt>
+                <c:pt idx="4">
+                  <c:v>X5</c:v>
+                </c:pt>
+              </c:strCache>
+            </c:strRef>
+          </c:cat>
+          <c:val>
+            <c:numRef>
+              <c:f>Sheet1!$B$2:$B$6</c:f>
+              <c:numCache>
+                <c:formatCode>General</c:formatCode>
+                <c:ptCount val="5"/>
+                <c:pt idx="0">
+                  <c:v>10</c:v>
+                </c:pt>
+                <c:pt idx="1">
+                  <c:v>25</c:v>
+                </c:pt>
+                <c:pt idx="2">
+                  <c:v>40</c:v>
+                </c:pt>
+                <c:pt idx="3">
+                  <c:v>30</c:v>
+                </c:pt>
+                <c:pt idx="4">
+                  <c:v>15</c:v>
+                </c:pt>
+              </c:numCache>
+            </c:numRef>
+          </c:val>
+        </c:ser>
+        <c:ser>
+          <c:idx val="1"/>
+          <c:order val="1"/>
+          <c:tx>
+            <c:strRef>
+              <c:f>Sheet1!$C$1</c:f>
+              <c:strCache>
+                <c:ptCount val="1"/>
+                <c:pt idx="0">
+                  <c:v>Row 2</c:v>
+                </c:pt>
+              </c:strCache>
+            </c:strRef>
+          </c:tx>
+          <c:val>
+            <c:numRef>
+              <c:f>Sheet1!$C$2:$C$6</c:f>
+              <c:numCache>
+                <c:formatCode>General</c:formatCode>
+                <c:ptCount val="5"/>
+                <c:pt idx="0">
+                  <c:v>20</c:v>
+                </c:pt>
+                <c:pt idx="1">
+                  <c:v>35</c:v>
+                </c:pt>
+                <c:pt idx="2">
+                  <c:v>50</c:v>
+                </c:pt>
+                <c:pt idx="3">
+                  <c:v>45</c:v>
+                </c:pt>
+                <c:pt idx="4">
+                  <c:v>30</c:v>
+                </c:pt>
+              </c:numCache>
+            </c:numRef>
+          </c:val>
+        </c:ser>
+        <c:ser>
+          <c:idx val="2"/>
+          <c:order val="2"/>
+          <c:tx>
+            <c:strRef>
+              <c:f>Sheet1!$D$1</c:f>
+              <c:strCache>
+                <c:ptCount val="1"/>
+                <c:pt idx="0">
+                  <c:v>Row 3</c:v>
+                </c:pt>
+              </c:strCache>
+            </c:strRef>
+          </c:tx>
+          <c:val>
+            <c:numRef>
+              <c:f>Sheet1!$D$2:$D$6</c:f>
+              <c:numCache>
+                <c:formatCode>General</c:formatCode>
+                <c:ptCount val="5"/>
+                <c:pt idx="0">
+                  <c:v>35</c:v>
+                </c:pt>
+                <c:pt idx="1">
+                  <c:v>50</c:v>
+                </c:pt>
+                <c:pt idx="2">
+                  <c:v>60</c:v>
+                </c:pt>
+                <c:pt idx="3">
+                  <c:v>55</c:v>
+                </c:pt>
+                <c:pt idx="4">
+                  <c:v>40</c:v>
+                </c:pt>
+              </c:numCache>
+            </c:numRef>
+          </c:val>
+        </c:ser>
+        <c:ser>
+          <c:idx val="3"/>
+          <c:order val="3"/>
+          <c:tx>
+            <c:strRef>
+              <c:f>Sheet1!$E$1</c:f>
+              <c:strCache>
+                <c:ptCount val="1"/>
+                <c:pt idx="0">
+                  <c:v>Row 4</c:v>
+                </c:pt>
+              </c:strCache>
+            </c:strRef>
+          </c:tx>
+          <c:val>
+            <c:numRef>
+              <c:f>Sheet1!$E$2:$E$6</c:f>
+              <c:numCache>
+                <c:formatCode>General</c:formatCode>
+                <c:ptCount val="5"/>
+                <c:pt idx="0">
+                  <c:v>25</c:v>
+                </c:pt>
+                <c:pt idx="1">
+                  <c:v>40</c:v>
+                </c:pt>
+                <c:pt idx="2">
+                  <c:v>45</c:v>
+                </c:pt>
+                <c:pt idx="3">
+                  <c:v>50</c:v>
+                </c:pt>
+                <c:pt idx="4">
+                  <c:v>35</c:v>
+                </c:pt>
+              </c:numCache>
+            </c:numRef>
+          </c:val>
+        </c:ser>
+        <c:bandFmts/>
+        <c:axId val="111111"/>
+        <c:axId val="222222"/>
+        <c:axId val="333333"/>
+      </c:surfaceChart>
+      <c:catAx>
+        <c:axId val="111111"/>
+        <c:scaling>
+          <c:orientation val="minMax"/>
+        </c:scaling>
+        <c:delete val="0"/>
+        <c:axPos val="b"/>
+        <c:crossAx val="222222"/>
+      </c:catAx>
+      <c:valAx>
+        <c:axId val="222222"/>
+        <c:scaling>
+          <c:orientation val="minMax"/>
+        </c:scaling>
+        <c:delete val="0"/>
+        <c:axPos val="l"/>
+        <c:crossAx val="111111"/>
+        <c:majorGridlines/>
+      </c:valAx>
+      <c:serAx>
+        <c:axId val="333333"/>
+        <c:scaling>
+          <c:orientation val="minMax"/>
+        </c:scaling>
+        <c:delete val="0"/>
+        <c:axPos val="b"/>
+        <c:crossAx val="222222"/>
+      </c:serAx>
+    </c:plotArea>
+    <c:dispBlanksAs val="gap"/>
+  </c:chart>
+  <c:txPr>
+    <a:bodyPr/>
+    <a:lstStyle/>
+    <a:p>
+      <a:pPr>
+        <a:defRPr sz="1800"/>
+      </a:pPr>
+      <a:endParaRPr lang="en-US"/>
+    </a:p>
+  </c:txPr>
+  <c:externalData r:id="rId1">
+    <c:autoUpdate val="0"/>
+  </c:externalData>
+</c:chartSpace>
+</file>
+
+<file path=ppt/charts/chart24.xml><?xml version="1.0" encoding="utf-8"?>
+<c:chartSpace xmlns:c="http://schemas.openxmlformats.org/drawingml/2006/chart" xmlns:a="http://schemas.openxmlformats.org/drawingml/2006/main" xmlns:r="http://schemas.openxmlformats.org/officeDocument/2006/relationships">
+  <c:chart>
+    <c:autoTitleDeleted val="0"/>
+    <c:plotArea>
+      <c:ofPieChart>
+        <c:ofPieType val="pie"/>
+        <c:varyColors val="1"/>
+        <c:ser>
+          <c:idx val="0"/>
+          <c:order val="0"/>
+          <c:tx>
+            <c:strRef>
+              <c:f>Sheet1!$B$1</c:f>
+              <c:strCache>
+                <c:ptCount val="1"/>
+                <c:pt idx="0">
+                  <c:v>Sales</c:v>
+                </c:pt>
+              </c:strCache>
+            </c:strRef>
+          </c:tx>
+          <c:cat>
+            <c:strRef>
+              <c:f>Sheet1!$A$2:$A$6</c:f>
+              <c:strCache>
+                <c:ptCount val="5"/>
+                <c:pt idx="0">
+                  <c:v>Product A</c:v>
+                </c:pt>
+                <c:pt idx="1">
+                  <c:v>Product B</c:v>
+                </c:pt>
+                <c:pt idx="2">
+                  <c:v>Product C</c:v>
+                </c:pt>
+                <c:pt idx="3">
+                  <c:v>Product D</c:v>
+                </c:pt>
+                <c:pt idx="4">
+                  <c:v>Product E</c:v>
+                </c:pt>
+              </c:strCache>
+            </c:strRef>
+          </c:cat>
+          <c:val>
+            <c:numRef>
+              <c:f>Sheet1!$B$2:$B$6</c:f>
+              <c:numCache>
+                <c:formatCode>General</c:formatCode>
+                <c:ptCount val="5"/>
+                <c:pt idx="0">
+                  <c:v>40</c:v>
+                </c:pt>
+                <c:pt idx="1">
+                  <c:v>25</c:v>
+                </c:pt>
+                <c:pt idx="2">
+                  <c:v>15</c:v>
+                </c:pt>
+                <c:pt idx="3">
+                  <c:v>12</c:v>
+                </c:pt>
+                <c:pt idx="4">
+                  <c:v>8</c:v>
+                </c:pt>
+              </c:numCache>
+            </c:numRef>
+          </c:val>
+        </c:ser>
+        <c:gapWidth val="150"/>
+        <c:splitPos val="2"/>
+      </c:ofPieChart>
+    </c:plotArea>
+    <c:dispBlanksAs val="gap"/>
+  </c:chart>
+  <c:txPr>
+    <a:bodyPr/>
+    <a:lstStyle/>
+    <a:p>
+      <a:pPr>
+        <a:defRPr sz="1800"/>
+      </a:pPr>
+      <a:endParaRPr lang="en-US"/>
+    </a:p>
+  </c:txPr>
+  <c:externalData r:id="rId1">
+    <c:autoUpdate val="0"/>
+  </c:externalData>
+</c:chartSpace>
+</file>
+
+<file path=ppt/charts/chart25.xml><?xml version="1.0" encoding="utf-8"?>
+<c:chartSpace xmlns:c="http://schemas.openxmlformats.org/drawingml/2006/chart" xmlns:a="http://schemas.openxmlformats.org/drawingml/2006/main" xmlns:r="http://schemas.openxmlformats.org/officeDocument/2006/relationships">
+  <c:date1904 val="0"/>
+  <c:chart>
+    <c:view3D>
+      <c:rotX val="20"/>
+      <c:rotY val="30"/>
+      <c:depthPercent val="150"/>
+      <c:rAngAx val="1"/>
+      <c:perspective val="40"/>
+    </c:view3D>
+    <c:autoTitleDeleted val="0"/>
+    <c:plotArea>
+      <c:bar3DChart>
+        <c:barDir val="col"/>
+        <c:grouping val="clustered"/>
+        <c:ser>
+          <c:idx val="0"/>
+          <c:order val="0"/>
+          <c:tx>
+            <c:strRef>
+              <c:f>Sheet1!$B$1</c:f>
+              <c:strCache>
+                <c:ptCount val="1"/>
+                <c:pt idx="0">
+                  <c:v>Revenue</c:v>
+                </c:pt>
+              </c:strCache>
+            </c:strRef>
+          </c:tx>
+          <c:cat>
+            <c:strRef>
+              <c:f>Sheet1!$A$2:$A$5</c:f>
+              <c:strCache>
+                <c:ptCount val="4"/>
+                <c:pt idx="0">
+                  <c:v>East</c:v>
+                </c:pt>
+                <c:pt idx="1">
+                  <c:v>West</c:v>
+                </c:pt>
+                <c:pt idx="2">
+                  <c:v>North</c:v>
+                </c:pt>
+                <c:pt idx="3">
+                  <c:v>South</c:v>
+                </c:pt>
+              </c:strCache>
+            </c:strRef>
+          </c:cat>
+          <c:val>
+            <c:numRef>
+              <c:f>Sheet1!$B$2:$B$5</c:f>
+              <c:numCache>
+                <c:formatCode>General</c:formatCode>
+                <c:ptCount val="4"/>
+                <c:pt idx="0">
+                  <c:v>320</c:v>
+                </c:pt>
+                <c:pt idx="1">
+                  <c:v>280</c:v>
+                </c:pt>
+                <c:pt idx="2">
+                  <c:v>190</c:v>
+                </c:pt>
+                <c:pt idx="3">
+                  <c:v>250</c:v>
+                </c:pt>
+              </c:numCache>
+            </c:numRef>
+          </c:val>
+        </c:ser>
+        <c:ser>
+          <c:idx val="1"/>
+          <c:order val="1"/>
+          <c:tx>
+            <c:strRef>
+              <c:f>Sheet1!$C$1</c:f>
+              <c:strCache>
+                <c:ptCount val="1"/>
+                <c:pt idx="0">
+                  <c:v>Cost</c:v>
+                </c:pt>
+              </c:strCache>
+            </c:strRef>
+          </c:tx>
+          <c:cat>
+            <c:strRef>
+              <c:f>Sheet1!$A$2:$A$5</c:f>
+              <c:strCache>
+                <c:ptCount val="4"/>
+                <c:pt idx="0">
+                  <c:v>East</c:v>
+                </c:pt>
+                <c:pt idx="1">
+                  <c:v>West</c:v>
+                </c:pt>
+                <c:pt idx="2">
+                  <c:v>North</c:v>
+                </c:pt>
+                <c:pt idx="3">
+                  <c:v>South</c:v>
+                </c:pt>
+              </c:strCache>
+            </c:strRef>
+          </c:cat>
+          <c:val>
+            <c:numRef>
+              <c:f>Sheet1!$C$2:$C$5</c:f>
+              <c:numCache>
+                <c:formatCode>General</c:formatCode>
+                <c:ptCount val="4"/>
+                <c:pt idx="0">
+                  <c:v>200</c:v>
+                </c:pt>
+                <c:pt idx="1">
+                  <c:v>180</c:v>
+                </c:pt>
+                <c:pt idx="2">
+                  <c:v>140</c:v>
+                </c:pt>
+                <c:pt idx="3">
+                  <c:v>160</c:v>
+                </c:pt>
+              </c:numCache>
+            </c:numRef>
+          </c:val>
+        </c:ser>
+        <c:axId val="-2068027336"/>
+        <c:axId val="-2113994440"/>
+      </c:bar3DChart>
+      <c:catAx>
+        <c:axId val="-2068027336"/>
+        <c:scaling>
+          <c:orientation val="minMax"/>
+        </c:scaling>
+        <c:delete val="0"/>
+        <c:axPos val="b"/>
+        <c:majorTickMark val="out"/>
+        <c:minorTickMark val="none"/>
+        <c:tickLblPos val="nextTo"/>
+        <c:crossAx val="-2113994440"/>
+        <c:crosses val="autoZero"/>
+        <c:auto val="1"/>
+        <c:lblAlgn val="ctr"/>
+        <c:lblOffset val="100"/>
+        <c:noMultiLvlLbl val="0"/>
+      </c:catAx>
+      <c:valAx>
+        <c:axId val="-2113994440"/>
+        <c:scaling/>
+        <c:delete val="0"/>
+        <c:axPos val="l"/>
+        <c:majorGridlines/>
+        <c:majorTickMark val="out"/>
+        <c:minorTickMark val="none"/>
+        <c:tickLblPos val="nextTo"/>
+        <c:crossAx val="-2068027336"/>
+        <c:crosses val="autoZero"/>
+      </c:valAx>
+    </c:plotArea>
     <c:dispBlanksAs val="gap"/>
   </c:chart>
   <c:txPr>
@@ -16616,6 +17136,207 @@
             </a:pPr>
             <a:r>
               <a:t>Slide 66: Composite chart (column + line)</a:t>
+            </a:r>
+          </a:p>
+        </p:txBody>
+      </p:sp>
+    </p:spTree>
+  </p:cSld>
+  <p:clrMapOvr>
+    <a:masterClrMapping/>
+  </p:clrMapOvr>
+</p:sld>
+</file>
+
+<file path=ppt/slides/slide67.xml><?xml version="1.0" encoding="utf-8"?>
+<p:sld xmlns:a="http://schemas.openxmlformats.org/drawingml/2006/main" xmlns:p="http://schemas.openxmlformats.org/presentationml/2006/main" xmlns:r="http://schemas.openxmlformats.org/officeDocument/2006/relationships">
+  <p:cSld>
+    <p:spTree>
+      <p:nvGrpSpPr>
+        <p:cNvPr id="1" name=""/>
+        <p:cNvGrpSpPr/>
+        <p:nvPr/>
+      </p:nvGrpSpPr>
+      <p:grpSpPr/>
+      <p:graphicFrame>
+        <p:nvGraphicFramePr>
+          <p:cNvPr id="2" name="Chart 1"/>
+          <p:cNvGraphicFramePr>
+            <a:graphicFrameLocks noGrp="1"/>
+          </p:cNvGraphicFramePr>
+          <p:nvPr/>
+        </p:nvGraphicFramePr>
+        <p:xfrm>
+          <a:off x="914400" y="1371600"/>
+          <a:ext cx="6400800" cy="4114800"/>
+        </p:xfrm>
+        <a:graphic>
+          <a:graphicData uri="http://schemas.openxmlformats.org/drawingml/2006/chart">
+            <c:chart xmlns:c="http://schemas.openxmlformats.org/drawingml/2006/chart" r:id="rId2"/>
+          </a:graphicData>
+        </a:graphic>
+      </p:graphicFrame>
+      <p:sp>
+        <p:nvSpPr>
+          <p:cNvPr id="3" name="TextBox 2"/>
+          <p:cNvSpPr txBox="1"/>
+          <p:nvPr/>
+        </p:nvSpPr>
+        <p:spPr>
+          <a:xfrm>
+            <a:off x="274320" y="182880"/>
+            <a:ext cx="8229600" cy="457200"/>
+          </a:xfrm>
+          <a:prstGeom prst="rect">
+            <a:avLst/>
+          </a:prstGeom>
+          <a:noFill/>
+        </p:spPr>
+        <p:txBody>
+          <a:bodyPr wrap="none">
+            <a:spAutoFit/>
+          </a:bodyPr>
+          <a:lstStyle/>
+          <a:p>
+            <a:pPr>
+              <a:defRPr sz="1800" b="1"/>
+            </a:pPr>
+            <a:r>
+              <a:t>Slide 67: Surface chart (2D heatmap)</a:t>
+            </a:r>
+          </a:p>
+        </p:txBody>
+      </p:sp>
+    </p:spTree>
+  </p:cSld>
+  <p:clrMapOvr>
+    <a:masterClrMapping/>
+  </p:clrMapOvr>
+</p:sld>
+</file>
+
+<file path=ppt/slides/slide68.xml><?xml version="1.0" encoding="utf-8"?>
+<p:sld xmlns:a="http://schemas.openxmlformats.org/drawingml/2006/main" xmlns:p="http://schemas.openxmlformats.org/presentationml/2006/main" xmlns:r="http://schemas.openxmlformats.org/officeDocument/2006/relationships">
+  <p:cSld>
+    <p:spTree>
+      <p:nvGrpSpPr>
+        <p:cNvPr id="1" name=""/>
+        <p:cNvGrpSpPr/>
+        <p:nvPr/>
+      </p:nvGrpSpPr>
+      <p:grpSpPr/>
+      <p:graphicFrame>
+        <p:nvGraphicFramePr>
+          <p:cNvPr id="2" name="Chart 1"/>
+          <p:cNvGraphicFramePr>
+            <a:graphicFrameLocks noGrp="1"/>
+          </p:cNvGraphicFramePr>
+          <p:nvPr/>
+        </p:nvGraphicFramePr>
+        <p:xfrm>
+          <a:off x="914400" y="1371600"/>
+          <a:ext cx="6400800" cy="4114800"/>
+        </p:xfrm>
+        <a:graphic>
+          <a:graphicData uri="http://schemas.openxmlformats.org/drawingml/2006/chart">
+            <c:chart xmlns:c="http://schemas.openxmlformats.org/drawingml/2006/chart" r:id="rId2"/>
+          </a:graphicData>
+        </a:graphic>
+      </p:graphicFrame>
+      <p:sp>
+        <p:nvSpPr>
+          <p:cNvPr id="3" name="TextBox 2"/>
+          <p:cNvSpPr txBox="1"/>
+          <p:nvPr/>
+        </p:nvSpPr>
+        <p:spPr>
+          <a:xfrm>
+            <a:off x="274320" y="182880"/>
+            <a:ext cx="8229600" cy="457200"/>
+          </a:xfrm>
+          <a:prstGeom prst="rect">
+            <a:avLst/>
+          </a:prstGeom>
+          <a:noFill/>
+        </p:spPr>
+        <p:txBody>
+          <a:bodyPr wrap="none">
+            <a:spAutoFit/>
+          </a:bodyPr>
+          <a:lstStyle/>
+          <a:p>
+            <a:pPr>
+              <a:defRPr sz="1800" b="1"/>
+            </a:pPr>
+            <a:r>
+              <a:t>Slide 68: Pie of pie chart (ofPieChart)</a:t>
+            </a:r>
+          </a:p>
+        </p:txBody>
+      </p:sp>
+    </p:spTree>
+  </p:cSld>
+  <p:clrMapOvr>
+    <a:masterClrMapping/>
+  </p:clrMapOvr>
+</p:sld>
+</file>
+
+<file path=ppt/slides/slide69.xml><?xml version="1.0" encoding="utf-8"?>
+<p:sld xmlns:a="http://schemas.openxmlformats.org/drawingml/2006/main" xmlns:p="http://schemas.openxmlformats.org/presentationml/2006/main" xmlns:r="http://schemas.openxmlformats.org/officeDocument/2006/relationships">
+  <p:cSld>
+    <p:spTree>
+      <p:nvGrpSpPr>
+        <p:cNvPr id="1" name=""/>
+        <p:cNvGrpSpPr/>
+        <p:nvPr/>
+      </p:nvGrpSpPr>
+      <p:grpSpPr/>
+      <p:graphicFrame>
+        <p:nvGraphicFramePr>
+          <p:cNvPr id="2" name="Chart 1"/>
+          <p:cNvGraphicFramePr>
+            <a:graphicFrameLocks noGrp="1"/>
+          </p:cNvGraphicFramePr>
+          <p:nvPr/>
+        </p:nvGraphicFramePr>
+        <p:xfrm>
+          <a:off x="914400" y="1371600"/>
+          <a:ext cx="6400800" cy="4114800"/>
+        </p:xfrm>
+        <a:graphic>
+          <a:graphicData uri="http://schemas.openxmlformats.org/drawingml/2006/chart">
+            <c:chart xmlns:c="http://schemas.openxmlformats.org/drawingml/2006/chart" r:id="rId2"/>
+          </a:graphicData>
+        </a:graphic>
+      </p:graphicFrame>
+      <p:sp>
+        <p:nvSpPr>
+          <p:cNvPr id="3" name="TextBox 2"/>
+          <p:cNvSpPr txBox="1"/>
+          <p:nvPr/>
+        </p:nvSpPr>
+        <p:spPr>
+          <a:xfrm>
+            <a:off x="274320" y="182880"/>
+            <a:ext cx="8229600" cy="457200"/>
+          </a:xfrm>
+          <a:prstGeom prst="rect">
+            <a:avLst/>
+          </a:prstGeom>
+          <a:noFill/>
+        </p:spPr>
+        <p:txBody>
+          <a:bodyPr wrap="none">
+            <a:spAutoFit/>
+          </a:bodyPr>
+          <a:lstStyle/>
+          <a:p>
+            <a:pPr>
+              <a:defRPr sz="1800" b="1"/>
+            </a:pPr>
+            <a:r>
+              <a:t>Slide 69: 3D bar chart (view3D preserved)</a:t>
             </a:r>
           </a:p>
         </p:txBody>

</xml_diff>

<commit_message>
feat: text advanced features — outline, gradient/pattern fill, warp
Add text outline (a:rPr/a:ln) with SVG stroke rendering, text gradient
and pattern fill (a:rPr/a:gradFill, a:pattFill) with first-color fallback,
and text warp (a:prstTxWarp) with data preservation and round-trip support.

- TextRun: outline_color, outline_w, text_grad_fill, text_patt_fill fields
- BodyProps: warp_prst, warp_av1, warp_av2 fields
- Full round-trip via data-ooxml-* SVG attributes (tgrad-*, tpatt-*, outline-*, warp-*)
- default_outline_w constant (12700 EMU = 1pt)
- Test slides 70-72, 708 assertions pass

Co-Authored-By: Claude Opus 4.6 <noreply@anthropic.com>
</commit_message>
<xml_diff>
--- a/test_fixtures/test_features.pptx
+++ b/test_fixtures/test_features.pptx
@@ -74,6 +74,9 @@
     <p:sldId id="322" r:id="rId73"/>
     <p:sldId id="323" r:id="rId74"/>
     <p:sldId id="324" r:id="rId75"/>
+    <p:sldId id="325" r:id="rId76"/>
+    <p:sldId id="326" r:id="rId77"/>
+    <p:sldId id="327" r:id="rId78"/>
   </p:sldIdLst>
   <p:sldSz cx="9144000" cy="6858000" type="screen4x3"/>
   <p:notesSz cx="6858000" cy="9144000"/>
@@ -17443,6 +17446,411 @@
             </a:pPr>
             <a:r>
               <a:t>^ Title should be 44pt centered white. Body bullets should be 24pt/20pt white/gray.</a:t>
+            </a:r>
+          </a:p>
+        </p:txBody>
+      </p:sp>
+    </p:spTree>
+  </p:cSld>
+  <p:clrMapOvr>
+    <a:masterClrMapping/>
+  </p:clrMapOvr>
+</p:sld>
+</file>
+
+<file path=ppt/slides/slide70.xml><?xml version="1.0" encoding="utf-8"?>
+<p:sld xmlns:a="http://schemas.openxmlformats.org/drawingml/2006/main" xmlns:p="http://schemas.openxmlformats.org/presentationml/2006/main" xmlns:r="http://schemas.openxmlformats.org/officeDocument/2006/relationships">
+  <p:cSld>
+    <p:spTree>
+      <p:nvGrpSpPr>
+        <p:cNvPr id="1" name=""/>
+        <p:cNvGrpSpPr/>
+        <p:nvPr/>
+      </p:nvGrpSpPr>
+      <p:grpSpPr/>
+      <p:sp>
+        <p:nvSpPr>
+          <p:cNvPr id="2" name="TextBox 1"/>
+          <p:cNvSpPr txBox="1"/>
+          <p:nvPr/>
+        </p:nvSpPr>
+        <p:spPr>
+          <a:xfrm>
+            <a:off x="274320" y="182880"/>
+            <a:ext cx="8229600" cy="457200"/>
+          </a:xfrm>
+          <a:prstGeom prst="rect">
+            <a:avLst/>
+          </a:prstGeom>
+          <a:noFill/>
+        </p:spPr>
+        <p:txBody>
+          <a:bodyPr wrap="none">
+            <a:spAutoFit/>
+          </a:bodyPr>
+          <a:lstStyle/>
+          <a:p>
+            <a:pPr>
+              <a:defRPr sz="1800" b="1"/>
+            </a:pPr>
+            <a:r>
+              <a:t>Slide 70: Text outline (a:rPr/a:ln)</a:t>
+            </a:r>
+          </a:p>
+        </p:txBody>
+      </p:sp>
+      <p:sp>
+        <p:nvSpPr>
+          <p:cNvPr id="3" name="TextBox 2"/>
+          <p:cNvSpPr txBox="1"/>
+          <p:nvPr/>
+        </p:nvSpPr>
+        <p:spPr>
+          <a:xfrm>
+            <a:off x="457200" y="1371600"/>
+            <a:ext cx="7315200" cy="1371600"/>
+          </a:xfrm>
+          <a:prstGeom prst="rect">
+            <a:avLst/>
+          </a:prstGeom>
+          <a:noFill/>
+        </p:spPr>
+        <p:txBody>
+          <a:bodyPr wrap="none">
+            <a:spAutoFit/>
+          </a:bodyPr>
+          <a:lstStyle/>
+          <a:p>
+            <a:r>
+              <a:rPr sz="4800" b="1">
+                <a:ln w="25400">
+                  <a:solidFill>
+                    <a:srgbClr val="FF0000"/>
+                  </a:solidFill>
+                </a:ln>
+              </a:rPr>
+              <a:t>Red Outlined Text</a:t>
+            </a:r>
+          </a:p>
+        </p:txBody>
+      </p:sp>
+      <p:sp>
+        <p:nvSpPr>
+          <p:cNvPr id="4" name="TextBox 3"/>
+          <p:cNvSpPr txBox="1"/>
+          <p:nvPr/>
+        </p:nvSpPr>
+        <p:spPr>
+          <a:xfrm>
+            <a:off x="457200" y="3200400"/>
+            <a:ext cx="7315200" cy="1371600"/>
+          </a:xfrm>
+          <a:prstGeom prst="rect">
+            <a:avLst/>
+          </a:prstGeom>
+          <a:noFill/>
+        </p:spPr>
+        <p:txBody>
+          <a:bodyPr wrap="none">
+            <a:spAutoFit/>
+          </a:bodyPr>
+          <a:lstStyle/>
+          <a:p>
+            <a:r>
+              <a:rPr sz="3600">
+                <a:solidFill>
+                  <a:srgbClr val="333333"/>
+                </a:solidFill>
+                <a:ln w="12700">
+                  <a:solidFill>
+                    <a:srgbClr val="0000FF"/>
+                  </a:solidFill>
+                </a:ln>
+              </a:rPr>
+              <a:t>Blue Outlined (thin)</a:t>
+            </a:r>
+          </a:p>
+        </p:txBody>
+      </p:sp>
+    </p:spTree>
+  </p:cSld>
+  <p:clrMapOvr>
+    <a:masterClrMapping/>
+  </p:clrMapOvr>
+</p:sld>
+</file>
+
+<file path=ppt/slides/slide71.xml><?xml version="1.0" encoding="utf-8"?>
+<p:sld xmlns:a="http://schemas.openxmlformats.org/drawingml/2006/main" xmlns:p="http://schemas.openxmlformats.org/presentationml/2006/main" xmlns:r="http://schemas.openxmlformats.org/officeDocument/2006/relationships">
+  <p:cSld>
+    <p:spTree>
+      <p:nvGrpSpPr>
+        <p:cNvPr id="1" name=""/>
+        <p:cNvGrpSpPr/>
+        <p:nvPr/>
+      </p:nvGrpSpPr>
+      <p:grpSpPr/>
+      <p:sp>
+        <p:nvSpPr>
+          <p:cNvPr id="2" name="TextBox 1"/>
+          <p:cNvSpPr txBox="1"/>
+          <p:nvPr/>
+        </p:nvSpPr>
+        <p:spPr>
+          <a:xfrm>
+            <a:off x="274320" y="182880"/>
+            <a:ext cx="8229600" cy="457200"/>
+          </a:xfrm>
+          <a:prstGeom prst="rect">
+            <a:avLst/>
+          </a:prstGeom>
+          <a:noFill/>
+        </p:spPr>
+        <p:txBody>
+          <a:bodyPr wrap="none">
+            <a:spAutoFit/>
+          </a:bodyPr>
+          <a:lstStyle/>
+          <a:p>
+            <a:pPr>
+              <a:defRPr sz="1800" b="1"/>
+            </a:pPr>
+            <a:r>
+              <a:t>Slide 71: Text gradient fill (a:rPr/a:gradFill)</a:t>
+            </a:r>
+          </a:p>
+        </p:txBody>
+      </p:sp>
+      <p:sp>
+        <p:nvSpPr>
+          <p:cNvPr id="3" name="TextBox 2"/>
+          <p:cNvSpPr txBox="1"/>
+          <p:nvPr/>
+        </p:nvSpPr>
+        <p:spPr>
+          <a:xfrm>
+            <a:off x="457200" y="1371600"/>
+            <a:ext cx="7315200" cy="1828800"/>
+          </a:xfrm>
+          <a:prstGeom prst="rect">
+            <a:avLst/>
+          </a:prstGeom>
+          <a:noFill/>
+        </p:spPr>
+        <p:txBody>
+          <a:bodyPr wrap="none">
+            <a:spAutoFit/>
+          </a:bodyPr>
+          <a:lstStyle/>
+          <a:p>
+            <a:r>
+              <a:rPr sz="6000" b="1">
+                <a:gradFill>
+                  <a:gsLst>
+                    <a:gs pos="0">
+                      <a:srgbClr val="FF0000"/>
+                    </a:gs>
+                    <a:gs pos="50000">
+                      <a:srgbClr val="FFFF00"/>
+                    </a:gs>
+                    <a:gs pos="100000">
+                      <a:srgbClr val="0000FF"/>
+                    </a:gs>
+                  </a:gsLst>
+                  <a:lin ang="0" scaled="1"/>
+                </a:gradFill>
+              </a:rPr>
+              <a:t>Gradient Text</a:t>
+            </a:r>
+          </a:p>
+        </p:txBody>
+      </p:sp>
+      <p:sp>
+        <p:nvSpPr>
+          <p:cNvPr id="4" name="TextBox 3"/>
+          <p:cNvSpPr txBox="1"/>
+          <p:nvPr/>
+        </p:nvSpPr>
+        <p:spPr>
+          <a:xfrm>
+            <a:off x="457200" y="3657600"/>
+            <a:ext cx="7315200" cy="1828800"/>
+          </a:xfrm>
+          <a:prstGeom prst="rect">
+            <a:avLst/>
+          </a:prstGeom>
+          <a:noFill/>
+        </p:spPr>
+        <p:txBody>
+          <a:bodyPr wrap="none">
+            <a:spAutoFit/>
+          </a:bodyPr>
+          <a:lstStyle/>
+          <a:p>
+            <a:r>
+              <a:rPr sz="4800">
+                <a:gradFill>
+                  <a:gsLst>
+                    <a:gs pos="0">
+                      <a:srgbClr val="00FF00"/>
+                    </a:gs>
+                    <a:gs pos="100000">
+                      <a:srgbClr val="0000FF"/>
+                    </a:gs>
+                  </a:gsLst>
+                  <a:lin ang="5400000" scaled="1"/>
+                </a:gradFill>
+              </a:rPr>
+              <a:t>Green-Blue Grad</a:t>
+            </a:r>
+          </a:p>
+        </p:txBody>
+      </p:sp>
+    </p:spTree>
+  </p:cSld>
+  <p:clrMapOvr>
+    <a:masterClrMapping/>
+  </p:clrMapOvr>
+</p:sld>
+</file>
+
+<file path=ppt/slides/slide72.xml><?xml version="1.0" encoding="utf-8"?>
+<p:sld xmlns:a="http://schemas.openxmlformats.org/drawingml/2006/main" xmlns:p="http://schemas.openxmlformats.org/presentationml/2006/main" xmlns:r="http://schemas.openxmlformats.org/officeDocument/2006/relationships">
+  <p:cSld>
+    <p:spTree>
+      <p:nvGrpSpPr>
+        <p:cNvPr id="1" name=""/>
+        <p:cNvGrpSpPr/>
+        <p:nvPr/>
+      </p:nvGrpSpPr>
+      <p:grpSpPr/>
+      <p:sp>
+        <p:nvSpPr>
+          <p:cNvPr id="2" name="TextBox 1"/>
+          <p:cNvSpPr txBox="1"/>
+          <p:nvPr/>
+        </p:nvSpPr>
+        <p:spPr>
+          <a:xfrm>
+            <a:off x="274320" y="182880"/>
+            <a:ext cx="8229600" cy="457200"/>
+          </a:xfrm>
+          <a:prstGeom prst="rect">
+            <a:avLst/>
+          </a:prstGeom>
+          <a:noFill/>
+        </p:spPr>
+        <p:txBody>
+          <a:bodyPr wrap="none">
+            <a:spAutoFit/>
+          </a:bodyPr>
+          <a:lstStyle/>
+          <a:p>
+            <a:pPr>
+              <a:defRPr sz="1800" b="1"/>
+            </a:pPr>
+            <a:r>
+              <a:t>Slide 72: Text warp (a:prstTxWarp)</a:t>
+            </a:r>
+          </a:p>
+        </p:txBody>
+      </p:sp>
+      <p:sp>
+        <p:nvSpPr>
+          <p:cNvPr id="3" name="TextBox 2"/>
+          <p:cNvSpPr txBox="1"/>
+          <p:nvPr/>
+        </p:nvSpPr>
+        <p:spPr>
+          <a:xfrm>
+            <a:off x="457200" y="1371600"/>
+            <a:ext cx="3657600" cy="1828800"/>
+          </a:xfrm>
+          <a:prstGeom prst="rect">
+            <a:avLst/>
+          </a:prstGeom>
+          <a:noFill/>
+        </p:spPr>
+        <p:txBody>
+          <a:bodyPr wrap="none">
+            <a:prstTxWarp prst="textWave1">
+              <a:avLst>
+                <a:gd name="adj" fmla="val 19773"/>
+              </a:avLst>
+            </a:prstTxWarp>
+            <a:spAutoFit/>
+          </a:bodyPr>
+          <a:lstStyle/>
+          <a:p>
+            <a:r>
+              <a:rPr sz="3600" b="1"/>
+              <a:t>Wave Text</a:t>
+            </a:r>
+          </a:p>
+        </p:txBody>
+      </p:sp>
+      <p:sp>
+        <p:nvSpPr>
+          <p:cNvPr id="4" name="TextBox 3"/>
+          <p:cNvSpPr txBox="1"/>
+          <p:nvPr/>
+        </p:nvSpPr>
+        <p:spPr>
+          <a:xfrm>
+            <a:off x="4572000" y="1371600"/>
+            <a:ext cx="3657600" cy="1828800"/>
+          </a:xfrm>
+          <a:prstGeom prst="rect">
+            <a:avLst/>
+          </a:prstGeom>
+          <a:noFill/>
+        </p:spPr>
+        <p:txBody>
+          <a:bodyPr wrap="none">
+            <a:prstTxWarp prst="textArchUp">
+              <a:avLst>
+                <a:gd name="adj" fmla="val 10800000"/>
+              </a:avLst>
+            </a:prstTxWarp>
+            <a:spAutoFit/>
+          </a:bodyPr>
+          <a:lstStyle/>
+          <a:p>
+            <a:r>
+              <a:rPr sz="3600" b="1"/>
+              <a:t>Arch Up</a:t>
+            </a:r>
+          </a:p>
+        </p:txBody>
+      </p:sp>
+      <p:sp>
+        <p:nvSpPr>
+          <p:cNvPr id="5" name="TextBox 4"/>
+          <p:cNvSpPr txBox="1"/>
+          <p:nvPr/>
+        </p:nvSpPr>
+        <p:spPr>
+          <a:xfrm>
+            <a:off x="457200" y="3657600"/>
+            <a:ext cx="7315200" cy="1828800"/>
+          </a:xfrm>
+          <a:prstGeom prst="rect">
+            <a:avLst/>
+          </a:prstGeom>
+          <a:noFill/>
+        </p:spPr>
+        <p:txBody>
+          <a:bodyPr wrap="none">
+            <a:prstTxWarp prst="textDeflate">
+              <a:avLst/>
+            </a:prstTxWarp>
+            <a:spAutoFit/>
+          </a:bodyPr>
+          <a:lstStyle/>
+          <a:p>
+            <a:r>
+              <a:rPr sz="3600"/>
+              <a:t>Deflate Text</a:t>
             </a:r>
           </a:p>
         </p:txBody>

</xml_diff>

<commit_message>
feat: support stacked/percentStacked bar charts + test slide 73
- Handle grouping="stacked" and "percentStacked" in render_bar_chart:
  series are stacked within each category instead of side-by-side
- Fix percentStacked scale: use chart_val_scale (10000) not 1000000
- Update render_bar_data_labels and get_value_axis_max for stacked modes
- Extract compute_cat_totals and pct_stacked_val helpers to reduce duplication
- Add test slide 73 (BAR_STACKED_100, COLUMN_STACKED, COLUMN_STACKED_100)

Co-Authored-By: Claude Opus 4.6 <noreply@anthropic.com>
</commit_message>
<xml_diff>
--- a/test_fixtures/test_features.pptx
+++ b/test_fixtures/test_features.pptx
@@ -77,6 +77,7 @@
     <p:sldId id="325" r:id="rId76"/>
     <p:sldId id="326" r:id="rId77"/>
     <p:sldId id="327" r:id="rId78"/>
+    <p:sldId id="328" r:id="rId79"/>
   </p:sldIdLst>
   <p:sldSz cx="9144000" cy="6858000" type="screen4x3"/>
   <p:notesSz cx="6858000" cy="9144000"/>
@@ -3024,6 +3025,533 @@
         <c:axId val="-2068027336"/>
         <c:axId val="-2113994440"/>
       </c:bar3DChart>
+      <c:catAx>
+        <c:axId val="-2068027336"/>
+        <c:scaling>
+          <c:orientation val="minMax"/>
+        </c:scaling>
+        <c:delete val="0"/>
+        <c:axPos val="b"/>
+        <c:majorTickMark val="out"/>
+        <c:minorTickMark val="none"/>
+        <c:tickLblPos val="nextTo"/>
+        <c:crossAx val="-2113994440"/>
+        <c:crosses val="autoZero"/>
+        <c:auto val="1"/>
+        <c:lblAlgn val="ctr"/>
+        <c:lblOffset val="100"/>
+        <c:noMultiLvlLbl val="0"/>
+      </c:catAx>
+      <c:valAx>
+        <c:axId val="-2113994440"/>
+        <c:scaling/>
+        <c:delete val="0"/>
+        <c:axPos val="l"/>
+        <c:majorGridlines/>
+        <c:majorTickMark val="out"/>
+        <c:minorTickMark val="none"/>
+        <c:tickLblPos val="nextTo"/>
+        <c:crossAx val="-2068027336"/>
+        <c:crosses val="autoZero"/>
+      </c:valAx>
+    </c:plotArea>
+    <c:dispBlanksAs val="gap"/>
+  </c:chart>
+  <c:txPr>
+    <a:bodyPr/>
+    <a:lstStyle/>
+    <a:p>
+      <a:pPr>
+        <a:defRPr sz="1800"/>
+      </a:pPr>
+      <a:endParaRPr lang="en-US"/>
+    </a:p>
+  </c:txPr>
+  <c:externalData r:id="rId1">
+    <c:autoUpdate val="0"/>
+  </c:externalData>
+</c:chartSpace>
+</file>
+
+<file path=ppt/charts/chart26.xml><?xml version="1.0" encoding="utf-8"?>
+<c:chartSpace xmlns:c="http://schemas.openxmlformats.org/drawingml/2006/chart" xmlns:a="http://schemas.openxmlformats.org/drawingml/2006/main" xmlns:r="http://schemas.openxmlformats.org/officeDocument/2006/relationships">
+  <c:date1904 val="0"/>
+  <c:chart>
+    <c:autoTitleDeleted val="0"/>
+    <c:plotArea>
+      <c:barChart>
+        <c:barDir val="bar"/>
+        <c:grouping val="percentStacked"/>
+        <c:ser>
+          <c:idx val="0"/>
+          <c:order val="0"/>
+          <c:tx>
+            <c:strRef>
+              <c:f>Sheet1!$B$1</c:f>
+              <c:strCache>
+                <c:ptCount val="1"/>
+                <c:pt idx="0">
+                  <c:v>Male</c:v>
+                </c:pt>
+              </c:strCache>
+            </c:strRef>
+          </c:tx>
+          <c:cat>
+            <c:strRef>
+              <c:f>Sheet1!$A$2:$A$2</c:f>
+              <c:strCache>
+                <c:ptCount val="1"/>
+                <c:pt idx="0">
+                  <c:v>Gender</c:v>
+                </c:pt>
+              </c:strCache>
+            </c:strRef>
+          </c:cat>
+          <c:val>
+            <c:numRef>
+              <c:f>Sheet1!$B$2:$B$2</c:f>
+              <c:numCache>
+                <c:formatCode>General</c:formatCode>
+                <c:ptCount val="1"/>
+                <c:pt idx="0">
+                  <c:v>58.1</c:v>
+                </c:pt>
+              </c:numCache>
+            </c:numRef>
+          </c:val>
+        </c:ser>
+        <c:ser>
+          <c:idx val="1"/>
+          <c:order val="1"/>
+          <c:tx>
+            <c:strRef>
+              <c:f>Sheet1!$C$1</c:f>
+              <c:strCache>
+                <c:ptCount val="1"/>
+                <c:pt idx="0">
+                  <c:v>Female</c:v>
+                </c:pt>
+              </c:strCache>
+            </c:strRef>
+          </c:tx>
+          <c:cat>
+            <c:strRef>
+              <c:f>Sheet1!$A$2:$A$2</c:f>
+              <c:strCache>
+                <c:ptCount val="1"/>
+                <c:pt idx="0">
+                  <c:v>Gender</c:v>
+                </c:pt>
+              </c:strCache>
+            </c:strRef>
+          </c:cat>
+          <c:val>
+            <c:numRef>
+              <c:f>Sheet1!$C$2:$C$2</c:f>
+              <c:numCache>
+                <c:formatCode>General</c:formatCode>
+                <c:ptCount val="1"/>
+                <c:pt idx="0">
+                  <c:v>41.9</c:v>
+                </c:pt>
+              </c:numCache>
+            </c:numRef>
+          </c:val>
+        </c:ser>
+        <c:overlap val="100"/>
+        <c:axId val="-2068027336"/>
+        <c:axId val="-2113994440"/>
+      </c:barChart>
+      <c:catAx>
+        <c:axId val="-2068027336"/>
+        <c:scaling>
+          <c:orientation val="minMax"/>
+        </c:scaling>
+        <c:delete val="0"/>
+        <c:axPos val="l"/>
+        <c:majorTickMark val="out"/>
+        <c:minorTickMark val="none"/>
+        <c:tickLblPos val="nextTo"/>
+        <c:crossAx val="-2113994440"/>
+        <c:crosses val="autoZero"/>
+        <c:auto val="1"/>
+        <c:lblAlgn val="ctr"/>
+        <c:lblOffset val="100"/>
+        <c:noMultiLvlLbl val="0"/>
+      </c:catAx>
+      <c:valAx>
+        <c:axId val="-2113994440"/>
+        <c:scaling/>
+        <c:delete val="0"/>
+        <c:axPos val="b"/>
+        <c:majorGridlines/>
+        <c:majorTickMark val="out"/>
+        <c:minorTickMark val="none"/>
+        <c:tickLblPos val="nextTo"/>
+        <c:crossAx val="-2068027336"/>
+        <c:crosses val="autoZero"/>
+      </c:valAx>
+    </c:plotArea>
+    <c:dispBlanksAs val="gap"/>
+  </c:chart>
+  <c:txPr>
+    <a:bodyPr/>
+    <a:lstStyle/>
+    <a:p>
+      <a:pPr>
+        <a:defRPr sz="1800"/>
+      </a:pPr>
+      <a:endParaRPr lang="en-US"/>
+    </a:p>
+  </c:txPr>
+  <c:externalData r:id="rId1">
+    <c:autoUpdate val="0"/>
+  </c:externalData>
+</c:chartSpace>
+</file>
+
+<file path=ppt/charts/chart27.xml><?xml version="1.0" encoding="utf-8"?>
+<c:chartSpace xmlns:c="http://schemas.openxmlformats.org/drawingml/2006/chart" xmlns:a="http://schemas.openxmlformats.org/drawingml/2006/main" xmlns:r="http://schemas.openxmlformats.org/officeDocument/2006/relationships">
+  <c:date1904 val="0"/>
+  <c:chart>
+    <c:autoTitleDeleted val="0"/>
+    <c:plotArea>
+      <c:barChart>
+        <c:barDir val="col"/>
+        <c:grouping val="stacked"/>
+        <c:ser>
+          <c:idx val="0"/>
+          <c:order val="0"/>
+          <c:tx>
+            <c:strRef>
+              <c:f>Sheet1!$B$1</c:f>
+              <c:strCache>
+                <c:ptCount val="1"/>
+                <c:pt idx="0">
+                  <c:v>Product A</c:v>
+                </c:pt>
+              </c:strCache>
+            </c:strRef>
+          </c:tx>
+          <c:cat>
+            <c:strRef>
+              <c:f>Sheet1!$A$2:$A$5</c:f>
+              <c:strCache>
+                <c:ptCount val="4"/>
+                <c:pt idx="0">
+                  <c:v>Q1</c:v>
+                </c:pt>
+                <c:pt idx="1">
+                  <c:v>Q2</c:v>
+                </c:pt>
+                <c:pt idx="2">
+                  <c:v>Q3</c:v>
+                </c:pt>
+                <c:pt idx="3">
+                  <c:v>Q4</c:v>
+                </c:pt>
+              </c:strCache>
+            </c:strRef>
+          </c:cat>
+          <c:val>
+            <c:numRef>
+              <c:f>Sheet1!$B$2:$B$5</c:f>
+              <c:numCache>
+                <c:formatCode>General</c:formatCode>
+                <c:ptCount val="4"/>
+                <c:pt idx="0">
+                  <c:v>100</c:v>
+                </c:pt>
+                <c:pt idx="1">
+                  <c:v>120</c:v>
+                </c:pt>
+                <c:pt idx="2">
+                  <c:v>90</c:v>
+                </c:pt>
+                <c:pt idx="3">
+                  <c:v>150</c:v>
+                </c:pt>
+              </c:numCache>
+            </c:numRef>
+          </c:val>
+        </c:ser>
+        <c:ser>
+          <c:idx val="1"/>
+          <c:order val="1"/>
+          <c:tx>
+            <c:strRef>
+              <c:f>Sheet1!$C$1</c:f>
+              <c:strCache>
+                <c:ptCount val="1"/>
+                <c:pt idx="0">
+                  <c:v>Product B</c:v>
+                </c:pt>
+              </c:strCache>
+            </c:strRef>
+          </c:tx>
+          <c:cat>
+            <c:strRef>
+              <c:f>Sheet1!$A$2:$A$5</c:f>
+              <c:strCache>
+                <c:ptCount val="4"/>
+                <c:pt idx="0">
+                  <c:v>Q1</c:v>
+                </c:pt>
+                <c:pt idx="1">
+                  <c:v>Q2</c:v>
+                </c:pt>
+                <c:pt idx="2">
+                  <c:v>Q3</c:v>
+                </c:pt>
+                <c:pt idx="3">
+                  <c:v>Q4</c:v>
+                </c:pt>
+              </c:strCache>
+            </c:strRef>
+          </c:cat>
+          <c:val>
+            <c:numRef>
+              <c:f>Sheet1!$C$2:$C$5</c:f>
+              <c:numCache>
+                <c:formatCode>General</c:formatCode>
+                <c:ptCount val="4"/>
+                <c:pt idx="0">
+                  <c:v>80</c:v>
+                </c:pt>
+                <c:pt idx="1">
+                  <c:v>70</c:v>
+                </c:pt>
+                <c:pt idx="2">
+                  <c:v>110</c:v>
+                </c:pt>
+                <c:pt idx="3">
+                  <c:v>60</c:v>
+                </c:pt>
+              </c:numCache>
+            </c:numRef>
+          </c:val>
+        </c:ser>
+        <c:ser>
+          <c:idx val="2"/>
+          <c:order val="2"/>
+          <c:tx>
+            <c:strRef>
+              <c:f>Sheet1!$D$1</c:f>
+              <c:strCache>
+                <c:ptCount val="1"/>
+                <c:pt idx="0">
+                  <c:v>Product C</c:v>
+                </c:pt>
+              </c:strCache>
+            </c:strRef>
+          </c:tx>
+          <c:cat>
+            <c:strRef>
+              <c:f>Sheet1!$A$2:$A$5</c:f>
+              <c:strCache>
+                <c:ptCount val="4"/>
+                <c:pt idx="0">
+                  <c:v>Q1</c:v>
+                </c:pt>
+                <c:pt idx="1">
+                  <c:v>Q2</c:v>
+                </c:pt>
+                <c:pt idx="2">
+                  <c:v>Q3</c:v>
+                </c:pt>
+                <c:pt idx="3">
+                  <c:v>Q4</c:v>
+                </c:pt>
+              </c:strCache>
+            </c:strRef>
+          </c:cat>
+          <c:val>
+            <c:numRef>
+              <c:f>Sheet1!$D$2:$D$5</c:f>
+              <c:numCache>
+                <c:formatCode>General</c:formatCode>
+                <c:ptCount val="4"/>
+                <c:pt idx="0">
+                  <c:v>50</c:v>
+                </c:pt>
+                <c:pt idx="1">
+                  <c:v>40</c:v>
+                </c:pt>
+                <c:pt idx="2">
+                  <c:v>30</c:v>
+                </c:pt>
+                <c:pt idx="3">
+                  <c:v>80</c:v>
+                </c:pt>
+              </c:numCache>
+            </c:numRef>
+          </c:val>
+        </c:ser>
+        <c:overlap val="100"/>
+        <c:axId val="-2068027336"/>
+        <c:axId val="-2113994440"/>
+      </c:barChart>
+      <c:catAx>
+        <c:axId val="-2068027336"/>
+        <c:scaling>
+          <c:orientation val="minMax"/>
+        </c:scaling>
+        <c:delete val="0"/>
+        <c:axPos val="b"/>
+        <c:majorTickMark val="out"/>
+        <c:minorTickMark val="none"/>
+        <c:tickLblPos val="nextTo"/>
+        <c:crossAx val="-2113994440"/>
+        <c:crosses val="autoZero"/>
+        <c:auto val="1"/>
+        <c:lblAlgn val="ctr"/>
+        <c:lblOffset val="100"/>
+        <c:noMultiLvlLbl val="0"/>
+      </c:catAx>
+      <c:valAx>
+        <c:axId val="-2113994440"/>
+        <c:scaling/>
+        <c:delete val="0"/>
+        <c:axPos val="l"/>
+        <c:majorGridlines/>
+        <c:majorTickMark val="out"/>
+        <c:minorTickMark val="none"/>
+        <c:tickLblPos val="nextTo"/>
+        <c:crossAx val="-2068027336"/>
+        <c:crosses val="autoZero"/>
+      </c:valAx>
+    </c:plotArea>
+    <c:dispBlanksAs val="gap"/>
+  </c:chart>
+  <c:txPr>
+    <a:bodyPr/>
+    <a:lstStyle/>
+    <a:p>
+      <a:pPr>
+        <a:defRPr sz="1800"/>
+      </a:pPr>
+      <a:endParaRPr lang="en-US"/>
+    </a:p>
+  </c:txPr>
+  <c:externalData r:id="rId1">
+    <c:autoUpdate val="0"/>
+  </c:externalData>
+</c:chartSpace>
+</file>
+
+<file path=ppt/charts/chart28.xml><?xml version="1.0" encoding="utf-8"?>
+<c:chartSpace xmlns:c="http://schemas.openxmlformats.org/drawingml/2006/chart" xmlns:a="http://schemas.openxmlformats.org/drawingml/2006/main" xmlns:r="http://schemas.openxmlformats.org/officeDocument/2006/relationships">
+  <c:date1904 val="0"/>
+  <c:chart>
+    <c:autoTitleDeleted val="0"/>
+    <c:plotArea>
+      <c:barChart>
+        <c:barDir val="col"/>
+        <c:grouping val="percentStacked"/>
+        <c:ser>
+          <c:idx val="0"/>
+          <c:order val="0"/>
+          <c:tx>
+            <c:strRef>
+              <c:f>Sheet1!$B$1</c:f>
+              <c:strCache>
+                <c:ptCount val="1"/>
+                <c:pt idx="0">
+                  <c:v>2024</c:v>
+                </c:pt>
+              </c:strCache>
+            </c:strRef>
+          </c:tx>
+          <c:cat>
+            <c:strRef>
+              <c:f>Sheet1!$A$2:$A$4</c:f>
+              <c:strCache>
+                <c:ptCount val="3"/>
+                <c:pt idx="0">
+                  <c:v>East</c:v>
+                </c:pt>
+                <c:pt idx="1">
+                  <c:v>West</c:v>
+                </c:pt>
+                <c:pt idx="2">
+                  <c:v>North</c:v>
+                </c:pt>
+              </c:strCache>
+            </c:strRef>
+          </c:cat>
+          <c:val>
+            <c:numRef>
+              <c:f>Sheet1!$B$2:$B$4</c:f>
+              <c:numCache>
+                <c:formatCode>General</c:formatCode>
+                <c:ptCount val="3"/>
+                <c:pt idx="0">
+                  <c:v>300</c:v>
+                </c:pt>
+                <c:pt idx="1">
+                  <c:v>200</c:v>
+                </c:pt>
+                <c:pt idx="2">
+                  <c:v>150</c:v>
+                </c:pt>
+              </c:numCache>
+            </c:numRef>
+          </c:val>
+        </c:ser>
+        <c:ser>
+          <c:idx val="1"/>
+          <c:order val="1"/>
+          <c:tx>
+            <c:strRef>
+              <c:f>Sheet1!$C$1</c:f>
+              <c:strCache>
+                <c:ptCount val="1"/>
+                <c:pt idx="0">
+                  <c:v>2025</c:v>
+                </c:pt>
+              </c:strCache>
+            </c:strRef>
+          </c:tx>
+          <c:cat>
+            <c:strRef>
+              <c:f>Sheet1!$A$2:$A$4</c:f>
+              <c:strCache>
+                <c:ptCount val="3"/>
+                <c:pt idx="0">
+                  <c:v>East</c:v>
+                </c:pt>
+                <c:pt idx="1">
+                  <c:v>West</c:v>
+                </c:pt>
+                <c:pt idx="2">
+                  <c:v>North</c:v>
+                </c:pt>
+              </c:strCache>
+            </c:strRef>
+          </c:cat>
+          <c:val>
+            <c:numRef>
+              <c:f>Sheet1!$C$2:$C$4</c:f>
+              <c:numCache>
+                <c:formatCode>General</c:formatCode>
+                <c:ptCount val="3"/>
+                <c:pt idx="0">
+                  <c:v>250</c:v>
+                </c:pt>
+                <c:pt idx="1">
+                  <c:v>350</c:v>
+                </c:pt>
+                <c:pt idx="2">
+                  <c:v>200</c:v>
+                </c:pt>
+              </c:numCache>
+            </c:numRef>
+          </c:val>
+        </c:ser>
+        <c:overlap val="100"/>
+        <c:axId val="-2068027336"/>
+        <c:axId val="-2113994440"/>
+      </c:barChart>
       <c:catAx>
         <c:axId val="-2068027336"/>
         <c:scaling>
@@ -17851,6 +18379,109 @@
             <a:r>
               <a:rPr sz="3600"/>
               <a:t>Deflate Text</a:t>
+            </a:r>
+          </a:p>
+        </p:txBody>
+      </p:sp>
+    </p:spTree>
+  </p:cSld>
+  <p:clrMapOvr>
+    <a:masterClrMapping/>
+  </p:clrMapOvr>
+</p:sld>
+</file>
+
+<file path=ppt/slides/slide73.xml><?xml version="1.0" encoding="utf-8"?>
+<p:sld xmlns:a="http://schemas.openxmlformats.org/drawingml/2006/main" xmlns:p="http://schemas.openxmlformats.org/presentationml/2006/main" xmlns:r="http://schemas.openxmlformats.org/officeDocument/2006/relationships">
+  <p:cSld>
+    <p:spTree>
+      <p:nvGrpSpPr>
+        <p:cNvPr id="1" name=""/>
+        <p:cNvGrpSpPr/>
+        <p:nvPr/>
+      </p:nvGrpSpPr>
+      <p:grpSpPr/>
+      <p:graphicFrame>
+        <p:nvGraphicFramePr>
+          <p:cNvPr id="2" name="Chart 1"/>
+          <p:cNvGraphicFramePr>
+            <a:graphicFrameLocks noGrp="1"/>
+          </p:cNvGraphicFramePr>
+          <p:nvPr/>
+        </p:nvGraphicFramePr>
+        <p:xfrm>
+          <a:off x="457200" y="1371600"/>
+          <a:ext cx="3657600" cy="2743200"/>
+        </p:xfrm>
+        <a:graphic>
+          <a:graphicData uri="http://schemas.openxmlformats.org/drawingml/2006/chart">
+            <c:chart xmlns:c="http://schemas.openxmlformats.org/drawingml/2006/chart" r:id="rId2"/>
+          </a:graphicData>
+        </a:graphic>
+      </p:graphicFrame>
+      <p:graphicFrame>
+        <p:nvGraphicFramePr>
+          <p:cNvPr id="3" name="Chart 2"/>
+          <p:cNvGraphicFramePr>
+            <a:graphicFrameLocks noGrp="1"/>
+          </p:cNvGraphicFramePr>
+          <p:nvPr/>
+        </p:nvGraphicFramePr>
+        <p:xfrm>
+          <a:off x="4572000" y="1371600"/>
+          <a:ext cx="3657600" cy="2743200"/>
+        </p:xfrm>
+        <a:graphic>
+          <a:graphicData uri="http://schemas.openxmlformats.org/drawingml/2006/chart">
+            <c:chart xmlns:c="http://schemas.openxmlformats.org/drawingml/2006/chart" r:id="rId3"/>
+          </a:graphicData>
+        </a:graphic>
+      </p:graphicFrame>
+      <p:graphicFrame>
+        <p:nvGraphicFramePr>
+          <p:cNvPr id="4" name="Chart 3"/>
+          <p:cNvGraphicFramePr>
+            <a:graphicFrameLocks noGrp="1"/>
+          </p:cNvGraphicFramePr>
+          <p:nvPr/>
+        </p:nvGraphicFramePr>
+        <p:xfrm>
+          <a:off x="2286000" y="4572000"/>
+          <a:ext cx="3657600" cy="1828800"/>
+        </p:xfrm>
+        <a:graphic>
+          <a:graphicData uri="http://schemas.openxmlformats.org/drawingml/2006/chart">
+            <c:chart xmlns:c="http://schemas.openxmlformats.org/drawingml/2006/chart" r:id="rId4"/>
+          </a:graphicData>
+        </a:graphic>
+      </p:graphicFrame>
+      <p:sp>
+        <p:nvSpPr>
+          <p:cNvPr id="5" name="TextBox 4"/>
+          <p:cNvSpPr txBox="1"/>
+          <p:nvPr/>
+        </p:nvSpPr>
+        <p:spPr>
+          <a:xfrm>
+            <a:off x="274320" y="182880"/>
+            <a:ext cx="8229600" cy="457200"/>
+          </a:xfrm>
+          <a:prstGeom prst="rect">
+            <a:avLst/>
+          </a:prstGeom>
+          <a:noFill/>
+        </p:spPr>
+        <p:txBody>
+          <a:bodyPr wrap="none">
+            <a:spAutoFit/>
+          </a:bodyPr>
+          <a:lstStyle/>
+          <a:p>
+            <a:pPr>
+              <a:defRPr sz="1800" b="1"/>
+            </a:pPr>
+            <a:r>
+              <a:t>Slide 73: Stacked / Percent-stacked bar charts</a:t>
             </a:r>
           </a:p>
         </p:txBody>

</xml_diff>

<commit_message>
feat: note and comment suport
</commit_message>
<xml_diff>
--- a/test_fixtures/test_features.pptx
+++ b/test_fixtures/test_features.pptx
@@ -78,6 +78,7 @@
     <p:sldId id="326" r:id="rId77"/>
     <p:sldId id="327" r:id="rId78"/>
     <p:sldId id="328" r:id="rId79"/>
+    <p:sldId id="329" r:id="rId80"/>
   </p:sldIdLst>
   <p:sldSz cx="9144000" cy="6858000" type="screen4x3"/>
   <p:notesSz cx="6858000" cy="9144000"/>
@@ -177,6 +178,12 @@
     </a:lvl9pPr>
   </p:defaultTextStyle>
 </p:presentation>
+</file>
+
+<file path=ppt/commentAuthors.xml><?xml version="1.0" encoding="utf-8"?>
+<p:cmAuthorLst xmlns:p="http://schemas.openxmlformats.org/presentationml/2006/main">
+  <p:cmAuthor id="1" name="Test User" initials="TU" lastIdx="2" clrIdx="0"/>
+</p:cmAuthorLst>
 </file>
 
 <file path=ppt/charts/chart1.xml><?xml version="1.0" encoding="utf-8"?>
@@ -4560,6 +4567,449 @@
     <c:autoUpdate val="0"/>
   </c:externalData>
 </c:chartSpace>
+</file>
+
+<file path=ppt/comments/comment74.xml><?xml version="1.0" encoding="utf-8"?>
+<p:cmLst xmlns:p="http://schemas.openxmlformats.org/presentationml/2006/main">
+  <p:cm authorId="1" dt="2025-01-15T10:30:00.000" idx="1">
+    <p:pos x="100" y="200"/>
+    <p:text>This is a test comment on slide 74.</p:text>
+  </p:cm>
+  <p:cm authorId="1" dt="2025-01-15T11:00:00.000" idx="2">
+    <p:pos x="300" y="400"/>
+    <p:text>Second comment with review feedback.</p:text>
+  </p:cm>
+</p:cmLst>
+</file>
+
+<file path=ppt/notesMasters/notesMaster1.xml><?xml version="1.0" encoding="utf-8"?>
+<p:notesMaster xmlns:a="http://schemas.openxmlformats.org/drawingml/2006/main" xmlns:p="http://schemas.openxmlformats.org/presentationml/2006/main" xmlns:r="http://schemas.openxmlformats.org/officeDocument/2006/relationships">
+  <p:cSld>
+    <p:bg>
+      <p:bgRef idx="1001">
+        <a:schemeClr val="bg1"/>
+      </p:bgRef>
+    </p:bg>
+    <p:spTree>
+      <p:nvGrpSpPr>
+        <p:cNvPr id="1" name=""/>
+        <p:cNvGrpSpPr/>
+        <p:nvPr/>
+      </p:nvGrpSpPr>
+      <p:grpSpPr>
+        <a:xfrm>
+          <a:off x="0" y="0"/>
+          <a:ext cx="0" cy="0"/>
+          <a:chOff x="0" y="0"/>
+          <a:chExt cx="0" cy="0"/>
+        </a:xfrm>
+      </p:grpSpPr>
+      <p:sp>
+        <p:nvSpPr>
+          <p:cNvPr id="2" name="Header Placeholder 1"/>
+          <p:cNvSpPr>
+            <a:spLocks noGrp="1"/>
+          </p:cNvSpPr>
+          <p:nvPr>
+            <p:ph type="hdr" sz="quarter"/>
+          </p:nvPr>
+        </p:nvSpPr>
+        <p:spPr>
+          <a:xfrm>
+            <a:off x="0" y="0"/>
+            <a:ext cx="2971800" cy="457200"/>
+          </a:xfrm>
+          <a:prstGeom prst="rect">
+            <a:avLst/>
+          </a:prstGeom>
+        </p:spPr>
+        <p:txBody>
+          <a:bodyPr vert="horz" lIns="91440" tIns="45720" rIns="91440" bIns="45720" rtlCol="0"/>
+          <a:lstStyle>
+            <a:lvl1pPr algn="l">
+              <a:defRPr sz="1200"/>
+            </a:lvl1pPr>
+          </a:lstStyle>
+          <a:p>
+            <a:endParaRPr lang="en-US"/>
+          </a:p>
+        </p:txBody>
+      </p:sp>
+      <p:sp>
+        <p:nvSpPr>
+          <p:cNvPr id="3" name="Date Placeholder 2"/>
+          <p:cNvSpPr>
+            <a:spLocks noGrp="1"/>
+          </p:cNvSpPr>
+          <p:nvPr>
+            <p:ph type="dt" idx="1"/>
+          </p:nvPr>
+        </p:nvSpPr>
+        <p:spPr>
+          <a:xfrm>
+            <a:off x="3884613" y="0"/>
+            <a:ext cx="2971800" cy="457200"/>
+          </a:xfrm>
+          <a:prstGeom prst="rect">
+            <a:avLst/>
+          </a:prstGeom>
+        </p:spPr>
+        <p:txBody>
+          <a:bodyPr vert="horz" lIns="91440" tIns="45720" rIns="91440" bIns="45720" rtlCol="0"/>
+          <a:lstStyle>
+            <a:lvl1pPr algn="r">
+              <a:defRPr sz="1200"/>
+            </a:lvl1pPr>
+          </a:lstStyle>
+          <a:p>
+            <a:fld id="{0F89C1C7-3DCD-1040-A9CF-14679D8B5DDD}" type="datetimeFigureOut">
+              <a:rPr lang="en-US" smtClean="0"/>
+              <a:t>10/17/16</a:t>
+            </a:fld>
+            <a:endParaRPr lang="en-US"/>
+          </a:p>
+        </p:txBody>
+      </p:sp>
+      <p:sp>
+        <p:nvSpPr>
+          <p:cNvPr id="4" name="Slide Image Placeholder 3"/>
+          <p:cNvSpPr>
+            <a:spLocks noGrp="1" noRot="1" noChangeAspect="1"/>
+          </p:cNvSpPr>
+          <p:nvPr>
+            <p:ph type="sldImg" idx="2"/>
+          </p:nvPr>
+        </p:nvSpPr>
+        <p:spPr>
+          <a:xfrm>
+            <a:off x="1143000" y="685800"/>
+            <a:ext cx="4572000" cy="3429000"/>
+          </a:xfrm>
+          <a:prstGeom prst="rect">
+            <a:avLst/>
+          </a:prstGeom>
+          <a:noFill/>
+          <a:ln w="12700">
+            <a:solidFill>
+              <a:prstClr val="black"/>
+            </a:solidFill>
+          </a:ln>
+        </p:spPr>
+        <p:txBody>
+          <a:bodyPr vert="horz" lIns="91440" tIns="45720" rIns="91440" bIns="45720" rtlCol="0" anchor="ctr"/>
+          <a:lstStyle/>
+          <a:p>
+            <a:endParaRPr lang="en-US"/>
+          </a:p>
+        </p:txBody>
+      </p:sp>
+      <p:sp>
+        <p:nvSpPr>
+          <p:cNvPr id="5" name="Notes Placeholder 4"/>
+          <p:cNvSpPr>
+            <a:spLocks noGrp="1"/>
+          </p:cNvSpPr>
+          <p:nvPr>
+            <p:ph type="body" sz="quarter" idx="3"/>
+          </p:nvPr>
+        </p:nvSpPr>
+        <p:spPr>
+          <a:xfrm>
+            <a:off x="685800" y="4343400"/>
+            <a:ext cx="5486400" cy="4114800"/>
+          </a:xfrm>
+          <a:prstGeom prst="rect">
+            <a:avLst/>
+          </a:prstGeom>
+        </p:spPr>
+        <p:txBody>
+          <a:bodyPr vert="horz" lIns="91440" tIns="45720" rIns="91440" bIns="45720" rtlCol="0"/>
+          <a:lstStyle/>
+          <a:p>
+            <a:pPr lvl="0"/>
+            <a:r>
+              <a:rPr lang="en-US" smtClean="0"/>
+              <a:t>Click to edit Master text styles</a:t>
+            </a:r>
+          </a:p>
+          <a:p>
+            <a:pPr lvl="1"/>
+            <a:r>
+              <a:rPr lang="en-US" smtClean="0"/>
+              <a:t>Second level</a:t>
+            </a:r>
+          </a:p>
+          <a:p>
+            <a:pPr lvl="2"/>
+            <a:r>
+              <a:rPr lang="en-US" smtClean="0"/>
+              <a:t>Third level</a:t>
+            </a:r>
+          </a:p>
+          <a:p>
+            <a:pPr lvl="3"/>
+            <a:r>
+              <a:rPr lang="en-US" smtClean="0"/>
+              <a:t>Fourth level</a:t>
+            </a:r>
+          </a:p>
+          <a:p>
+            <a:pPr lvl="4"/>
+            <a:r>
+              <a:rPr lang="en-US" smtClean="0"/>
+              <a:t>Fifth level</a:t>
+            </a:r>
+            <a:endParaRPr lang="en-US"/>
+          </a:p>
+        </p:txBody>
+      </p:sp>
+      <p:sp>
+        <p:nvSpPr>
+          <p:cNvPr id="6" name="Footer Placeholder 5"/>
+          <p:cNvSpPr>
+            <a:spLocks noGrp="1"/>
+          </p:cNvSpPr>
+          <p:nvPr>
+            <p:ph type="ftr" sz="quarter" idx="4"/>
+          </p:nvPr>
+        </p:nvSpPr>
+        <p:spPr>
+          <a:xfrm>
+            <a:off x="0" y="8685213"/>
+            <a:ext cx="2971800" cy="457200"/>
+          </a:xfrm>
+          <a:prstGeom prst="rect">
+            <a:avLst/>
+          </a:prstGeom>
+        </p:spPr>
+        <p:txBody>
+          <a:bodyPr vert="horz" lIns="91440" tIns="45720" rIns="91440" bIns="45720" rtlCol="0" anchor="b"/>
+          <a:lstStyle>
+            <a:lvl1pPr algn="l">
+              <a:defRPr sz="1200"/>
+            </a:lvl1pPr>
+          </a:lstStyle>
+          <a:p>
+            <a:endParaRPr lang="en-US"/>
+          </a:p>
+        </p:txBody>
+      </p:sp>
+      <p:sp>
+        <p:nvSpPr>
+          <p:cNvPr id="7" name="Slide Number Placeholder 6"/>
+          <p:cNvSpPr>
+            <a:spLocks noGrp="1"/>
+          </p:cNvSpPr>
+          <p:nvPr>
+            <p:ph type="sldNum" sz="quarter" idx="5"/>
+          </p:nvPr>
+        </p:nvSpPr>
+        <p:spPr>
+          <a:xfrm>
+            <a:off x="3884613" y="8685213"/>
+            <a:ext cx="2971800" cy="457200"/>
+          </a:xfrm>
+          <a:prstGeom prst="rect">
+            <a:avLst/>
+          </a:prstGeom>
+        </p:spPr>
+        <p:txBody>
+          <a:bodyPr vert="horz" lIns="91440" tIns="45720" rIns="91440" bIns="45720" rtlCol="0" anchor="b"/>
+          <a:lstStyle>
+            <a:lvl1pPr algn="r">
+              <a:defRPr sz="1200"/>
+            </a:lvl1pPr>
+          </a:lstStyle>
+          <a:p>
+            <a:fld id="{BB5E49A5-4136-284D-997B-48E1D791AD67}" type="slidenum">
+              <a:rPr lang="en-US" smtClean="0"/>
+              <a:t>‹#›</a:t>
+            </a:fld>
+            <a:endParaRPr lang="en-US"/>
+          </a:p>
+        </p:txBody>
+      </p:sp>
+    </p:spTree>
+    <p:extLst>
+      <p:ext uri="{BB962C8B-B14F-4D97-AF65-F5344CB8AC3E}">
+        <p14:creationId xmlns:p14="http://schemas.microsoft.com/office/powerpoint/2010/main" val="2623252185"/>
+      </p:ext>
+    </p:extLst>
+  </p:cSld>
+  <p:clrMap bg1="lt1" tx1="dk1" bg2="lt2" tx2="dk2" accent1="accent1" accent2="accent2" accent3="accent3" accent4="accent4" accent5="accent5" accent6="accent6" hlink="hlink" folHlink="folHlink"/>
+  <p:notesStyle>
+    <a:lvl1pPr marL="0" algn="l" defTabSz="457200" rtl="0" eaLnBrk="1" latinLnBrk="0" hangingPunct="1">
+      <a:defRPr sz="1200" kern="1200">
+        <a:solidFill>
+          <a:schemeClr val="tx1"/>
+        </a:solidFill>
+        <a:latin typeface="+mn-lt"/>
+        <a:ea typeface="+mn-ea"/>
+        <a:cs typeface="+mn-cs"/>
+      </a:defRPr>
+    </a:lvl1pPr>
+    <a:lvl2pPr marL="457200" algn="l" defTabSz="457200" rtl="0" eaLnBrk="1" latinLnBrk="0" hangingPunct="1">
+      <a:defRPr sz="1200" kern="1200">
+        <a:solidFill>
+          <a:schemeClr val="tx1"/>
+        </a:solidFill>
+        <a:latin typeface="+mn-lt"/>
+        <a:ea typeface="+mn-ea"/>
+        <a:cs typeface="+mn-cs"/>
+      </a:defRPr>
+    </a:lvl2pPr>
+    <a:lvl3pPr marL="914400" algn="l" defTabSz="457200" rtl="0" eaLnBrk="1" latinLnBrk="0" hangingPunct="1">
+      <a:defRPr sz="1200" kern="1200">
+        <a:solidFill>
+          <a:schemeClr val="tx1"/>
+        </a:solidFill>
+        <a:latin typeface="+mn-lt"/>
+        <a:ea typeface="+mn-ea"/>
+        <a:cs typeface="+mn-cs"/>
+      </a:defRPr>
+    </a:lvl3pPr>
+    <a:lvl4pPr marL="1371600" algn="l" defTabSz="457200" rtl="0" eaLnBrk="1" latinLnBrk="0" hangingPunct="1">
+      <a:defRPr sz="1200" kern="1200">
+        <a:solidFill>
+          <a:schemeClr val="tx1"/>
+        </a:solidFill>
+        <a:latin typeface="+mn-lt"/>
+        <a:ea typeface="+mn-ea"/>
+        <a:cs typeface="+mn-cs"/>
+      </a:defRPr>
+    </a:lvl4pPr>
+    <a:lvl5pPr marL="1828800" algn="l" defTabSz="457200" rtl="0" eaLnBrk="1" latinLnBrk="0" hangingPunct="1">
+      <a:defRPr sz="1200" kern="1200">
+        <a:solidFill>
+          <a:schemeClr val="tx1"/>
+        </a:solidFill>
+        <a:latin typeface="+mn-lt"/>
+        <a:ea typeface="+mn-ea"/>
+        <a:cs typeface="+mn-cs"/>
+      </a:defRPr>
+    </a:lvl5pPr>
+    <a:lvl6pPr marL="2286000" algn="l" defTabSz="457200" rtl="0" eaLnBrk="1" latinLnBrk="0" hangingPunct="1">
+      <a:defRPr sz="1200" kern="1200">
+        <a:solidFill>
+          <a:schemeClr val="tx1"/>
+        </a:solidFill>
+        <a:latin typeface="+mn-lt"/>
+        <a:ea typeface="+mn-ea"/>
+        <a:cs typeface="+mn-cs"/>
+      </a:defRPr>
+    </a:lvl6pPr>
+    <a:lvl7pPr marL="2743200" algn="l" defTabSz="457200" rtl="0" eaLnBrk="1" latinLnBrk="0" hangingPunct="1">
+      <a:defRPr sz="1200" kern="1200">
+        <a:solidFill>
+          <a:schemeClr val="tx1"/>
+        </a:solidFill>
+        <a:latin typeface="+mn-lt"/>
+        <a:ea typeface="+mn-ea"/>
+        <a:cs typeface="+mn-cs"/>
+      </a:defRPr>
+    </a:lvl7pPr>
+    <a:lvl8pPr marL="3200400" algn="l" defTabSz="457200" rtl="0" eaLnBrk="1" latinLnBrk="0" hangingPunct="1">
+      <a:defRPr sz="1200" kern="1200">
+        <a:solidFill>
+          <a:schemeClr val="tx1"/>
+        </a:solidFill>
+        <a:latin typeface="+mn-lt"/>
+        <a:ea typeface="+mn-ea"/>
+        <a:cs typeface="+mn-cs"/>
+      </a:defRPr>
+    </a:lvl8pPr>
+    <a:lvl9pPr marL="3657600" algn="l" defTabSz="457200" rtl="0" eaLnBrk="1" latinLnBrk="0" hangingPunct="1">
+      <a:defRPr sz="1200" kern="1200">
+        <a:solidFill>
+          <a:schemeClr val="tx1"/>
+        </a:solidFill>
+        <a:latin typeface="+mn-lt"/>
+        <a:ea typeface="+mn-ea"/>
+        <a:cs typeface="+mn-cs"/>
+      </a:defRPr>
+    </a:lvl9pPr>
+  </p:notesStyle>
+</p:notesMaster>
+</file>
+
+<file path=ppt/notesSlides/notesSlide1.xml><?xml version="1.0" encoding="utf-8"?>
+<p:notes xmlns:a="http://schemas.openxmlformats.org/drawingml/2006/main" xmlns:p="http://schemas.openxmlformats.org/presentationml/2006/main" xmlns:r="http://schemas.openxmlformats.org/officeDocument/2006/relationships">
+  <p:cSld>
+    <p:spTree>
+      <p:nvGrpSpPr>
+        <p:cNvPr id="1" name=""/>
+        <p:cNvGrpSpPr/>
+        <p:nvPr/>
+      </p:nvGrpSpPr>
+      <p:grpSpPr>
+        <a:xfrm>
+          <a:off x="0" y="0"/>
+          <a:ext cx="0" cy="0"/>
+          <a:chOff x="0" y="0"/>
+          <a:chExt cx="0" cy="0"/>
+        </a:xfrm>
+      </p:grpSpPr>
+      <p:sp>
+        <p:nvSpPr>
+          <p:cNvPr id="2" name="Slide Image Placeholder 1"/>
+          <p:cNvSpPr>
+            <a:spLocks noGrp="1"/>
+          </p:cNvSpPr>
+          <p:nvPr>
+            <p:ph type="sldImg" idx="2"/>
+          </p:nvPr>
+        </p:nvSpPr>
+        <p:spPr/>
+      </p:sp>
+      <p:sp>
+        <p:nvSpPr>
+          <p:cNvPr id="3" name="Notes Placeholder 2"/>
+          <p:cNvSpPr>
+            <a:spLocks noGrp="1"/>
+          </p:cNvSpPr>
+          <p:nvPr>
+            <p:ph type="body" idx="3" sz="quarter"/>
+          </p:nvPr>
+        </p:nvSpPr>
+        <p:spPr/>
+        <p:txBody>
+          <a:bodyPr/>
+          <a:lstStyle/>
+          <a:p>
+            <a:r>
+              <a:t>These are the speaker notes for slide 74.</a:t>
+            </a:r>
+          </a:p>
+          <a:p>
+            <a:r>
+              <a:t>Second paragraph of notes with key points.</a:t>
+            </a:r>
+          </a:p>
+          <a:p>
+            <a:r>
+              <a:t>Remember to mention the round-trip preservation.</a:t>
+            </a:r>
+          </a:p>
+        </p:txBody>
+      </p:sp>
+      <p:sp>
+        <p:nvSpPr>
+          <p:cNvPr id="4" name="Slide Number Placeholder 3"/>
+          <p:cNvSpPr>
+            <a:spLocks noGrp="1"/>
+          </p:cNvSpPr>
+          <p:nvPr>
+            <p:ph type="sldNum" idx="5" sz="quarter"/>
+          </p:nvPr>
+        </p:nvSpPr>
+        <p:spPr/>
+      </p:sp>
+    </p:spTree>
+  </p:cSld>
+  <p:clrMapOvr>
+    <a:masterClrMapping/>
+  </p:clrMapOvr>
+</p:notes>
 </file>
 
 <file path=ppt/slideLayouts/slideLayout1.xml><?xml version="1.0" encoding="utf-8"?>
@@ -18482,6 +18932,90 @@
             </a:pPr>
             <a:r>
               <a:t>Slide 73: Stacked / Percent-stacked bar charts</a:t>
+            </a:r>
+          </a:p>
+        </p:txBody>
+      </p:sp>
+    </p:spTree>
+  </p:cSld>
+  <p:clrMapOvr>
+    <a:masterClrMapping/>
+  </p:clrMapOvr>
+</p:sld>
+</file>
+
+<file path=ppt/slides/slide74.xml><?xml version="1.0" encoding="utf-8"?>
+<p:sld xmlns:a="http://schemas.openxmlformats.org/drawingml/2006/main" xmlns:p="http://schemas.openxmlformats.org/presentationml/2006/main" xmlns:r="http://schemas.openxmlformats.org/officeDocument/2006/relationships">
+  <p:cSld>
+    <p:spTree>
+      <p:nvGrpSpPr>
+        <p:cNvPr id="1" name=""/>
+        <p:cNvGrpSpPr/>
+        <p:nvPr/>
+      </p:nvGrpSpPr>
+      <p:grpSpPr/>
+      <p:sp>
+        <p:nvSpPr>
+          <p:cNvPr id="2" name="TextBox 1"/>
+          <p:cNvSpPr txBox="1"/>
+          <p:nvPr/>
+        </p:nvSpPr>
+        <p:spPr>
+          <a:xfrm>
+            <a:off x="274320" y="182880"/>
+            <a:ext cx="8229600" cy="457200"/>
+          </a:xfrm>
+          <a:prstGeom prst="rect">
+            <a:avLst/>
+          </a:prstGeom>
+          <a:noFill/>
+        </p:spPr>
+        <p:txBody>
+          <a:bodyPr wrap="none">
+            <a:spAutoFit/>
+          </a:bodyPr>
+          <a:lstStyle/>
+          <a:p>
+            <a:pPr>
+              <a:defRPr sz="1800" b="1"/>
+            </a:pPr>
+            <a:r>
+              <a:t>Slide 74: Speaker notes + comments</a:t>
+            </a:r>
+          </a:p>
+        </p:txBody>
+      </p:sp>
+      <p:sp>
+        <p:nvSpPr>
+          <p:cNvPr id="3" name="TextBox 2"/>
+          <p:cNvSpPr txBox="1"/>
+          <p:nvPr/>
+        </p:nvSpPr>
+        <p:spPr>
+          <a:xfrm>
+            <a:off x="457200" y="1371600"/>
+            <a:ext cx="7315200" cy="2743200"/>
+          </a:xfrm>
+          <a:prstGeom prst="rect">
+            <a:avLst/>
+          </a:prstGeom>
+          <a:noFill/>
+        </p:spPr>
+        <p:txBody>
+          <a:bodyPr wrap="square">
+            <a:spAutoFit/>
+          </a:bodyPr>
+          <a:lstStyle/>
+          <a:p>
+            <a:pPr>
+              <a:defRPr sz="1400"/>
+            </a:pPr>
+            <a:r>
+              <a:t>This slide has speaker notes and comments attached.</a:t>
+            </a:r>
+            <a:br/>
+            <a:r>
+              <a:t>Notes and comments are metadata not rendered on slide, but preserved in round-trip export.</a:t>
             </a:r>
           </a:p>
         </p:txBody>
@@ -19090,4 +19624,324 @@
   </a:objectDefaults>
   <a:extraClrSchemeLst/>
 </a:theme>
+</file>
+
+<file path=ppt/theme/theme2.xml><?xml version="1.0" encoding="utf-8"?>
+<a:theme xmlns:a="http://schemas.openxmlformats.org/drawingml/2006/main" name="Office Theme">
+  <a:themeElements>
+    <a:clrScheme name="Office">
+      <a:dk1>
+        <a:sysClr val="windowText" lastClr="000000"/>
+      </a:dk1>
+      <a:lt1>
+        <a:sysClr val="window" lastClr="FFFFFF"/>
+      </a:lt1>
+      <a:dk2>
+        <a:srgbClr val="1F497D"/>
+      </a:dk2>
+      <a:lt2>
+        <a:srgbClr val="EEECE1"/>
+      </a:lt2>
+      <a:accent1>
+        <a:srgbClr val="4F81BD"/>
+      </a:accent1>
+      <a:accent2>
+        <a:srgbClr val="C0504D"/>
+      </a:accent2>
+      <a:accent3>
+        <a:srgbClr val="9BBB59"/>
+      </a:accent3>
+      <a:accent4>
+        <a:srgbClr val="8064A2"/>
+      </a:accent4>
+      <a:accent5>
+        <a:srgbClr val="4BACC6"/>
+      </a:accent5>
+      <a:accent6>
+        <a:srgbClr val="F79646"/>
+      </a:accent6>
+      <a:hlink>
+        <a:srgbClr val="0000FF"/>
+      </a:hlink>
+      <a:folHlink>
+        <a:srgbClr val="800080"/>
+      </a:folHlink>
+    </a:clrScheme>
+    <a:fontScheme name="Office">
+      <a:majorFont>
+        <a:latin typeface="Calibri"/>
+        <a:ea typeface=""/>
+        <a:cs typeface=""/>
+        <a:font script="Jpan" typeface="ＭＳ Ｐゴシック"/>
+        <a:font script="Hang" typeface="맑은 고딕"/>
+        <a:font script="Hans" typeface="宋体"/>
+        <a:font script="Hant" typeface="新細明體"/>
+        <a:font script="Arab" typeface="Times New Roman"/>
+        <a:font script="Hebr" typeface="Times New Roman"/>
+        <a:font script="Thai" typeface="Angsana New"/>
+        <a:font script="Ethi" typeface="Nyala"/>
+        <a:font script="Beng" typeface="Vrinda"/>
+        <a:font script="Gujr" typeface="Shruti"/>
+        <a:font script="Khmr" typeface="MoolBoran"/>
+        <a:font script="Knda" typeface="Tunga"/>
+        <a:font script="Guru" typeface="Raavi"/>
+        <a:font script="Cans" typeface="Euphemia"/>
+        <a:font script="Cher" typeface="Plantagenet Cherokee"/>
+        <a:font script="Yiii" typeface="Microsoft Yi Baiti"/>
+        <a:font script="Tibt" typeface="Microsoft Himalaya"/>
+        <a:font script="Thaa" typeface="MV Boli"/>
+        <a:font script="Deva" typeface="Mangal"/>
+        <a:font script="Telu" typeface="Gautami"/>
+        <a:font script="Taml" typeface="Latha"/>
+        <a:font script="Syrc" typeface="Estrangelo Edessa"/>
+        <a:font script="Orya" typeface="Kalinga"/>
+        <a:font script="Mlym" typeface="Kartika"/>
+        <a:font script="Laoo" typeface="DokChampa"/>
+        <a:font script="Sinh" typeface="Iskoola Pota"/>
+        <a:font script="Mong" typeface="Mongolian Baiti"/>
+        <a:font script="Viet" typeface="Times New Roman"/>
+        <a:font script="Uigh" typeface="Microsoft Uighur"/>
+        <a:font script="Geor" typeface="Sylfaen"/>
+      </a:majorFont>
+      <a:minorFont>
+        <a:latin typeface="Calibri"/>
+        <a:ea typeface=""/>
+        <a:cs typeface=""/>
+        <a:font script="Jpan" typeface="ＭＳ Ｐゴシック"/>
+        <a:font script="Hang" typeface="맑은 고딕"/>
+        <a:font script="Hans" typeface="宋体"/>
+        <a:font script="Hant" typeface="新細明體"/>
+        <a:font script="Arab" typeface="Arial"/>
+        <a:font script="Hebr" typeface="Arial"/>
+        <a:font script="Thai" typeface="Cordia New"/>
+        <a:font script="Ethi" typeface="Nyala"/>
+        <a:font script="Beng" typeface="Vrinda"/>
+        <a:font script="Gujr" typeface="Shruti"/>
+        <a:font script="Khmr" typeface="DaunPenh"/>
+        <a:font script="Knda" typeface="Tunga"/>
+        <a:font script="Guru" typeface="Raavi"/>
+        <a:font script="Cans" typeface="Euphemia"/>
+        <a:font script="Cher" typeface="Plantagenet Cherokee"/>
+        <a:font script="Yiii" typeface="Microsoft Yi Baiti"/>
+        <a:font script="Tibt" typeface="Microsoft Himalaya"/>
+        <a:font script="Thaa" typeface="MV Boli"/>
+        <a:font script="Deva" typeface="Mangal"/>
+        <a:font script="Telu" typeface="Gautami"/>
+        <a:font script="Taml" typeface="Latha"/>
+        <a:font script="Syrc" typeface="Estrangelo Edessa"/>
+        <a:font script="Orya" typeface="Kalinga"/>
+        <a:font script="Mlym" typeface="Kartika"/>
+        <a:font script="Laoo" typeface="DokChampa"/>
+        <a:font script="Sinh" typeface="Iskoola Pota"/>
+        <a:font script="Mong" typeface="Mongolian Baiti"/>
+        <a:font script="Viet" typeface="Arial"/>
+        <a:font script="Uigh" typeface="Microsoft Uighur"/>
+        <a:font script="Geor" typeface="Sylfaen"/>
+      </a:minorFont>
+    </a:fontScheme>
+    <a:fmtScheme name="Office">
+      <a:fillStyleLst>
+        <a:solidFill>
+          <a:schemeClr val="phClr"/>
+        </a:solidFill>
+        <a:gradFill rotWithShape="1">
+          <a:gsLst>
+            <a:gs pos="0">
+              <a:schemeClr val="phClr">
+                <a:tint val="50000"/>
+                <a:satMod val="300000"/>
+              </a:schemeClr>
+            </a:gs>
+            <a:gs pos="35000">
+              <a:schemeClr val="phClr">
+                <a:tint val="37000"/>
+                <a:satMod val="300000"/>
+              </a:schemeClr>
+            </a:gs>
+            <a:gs pos="100000">
+              <a:schemeClr val="phClr">
+                <a:tint val="15000"/>
+                <a:satMod val="350000"/>
+              </a:schemeClr>
+            </a:gs>
+          </a:gsLst>
+          <a:lin ang="16200000" scaled="1"/>
+        </a:gradFill>
+        <a:gradFill rotWithShape="1">
+          <a:gsLst>
+            <a:gs pos="0">
+              <a:schemeClr val="phClr">
+                <a:tint val="100000"/>
+                <a:shade val="100000"/>
+                <a:satMod val="130000"/>
+              </a:schemeClr>
+            </a:gs>
+            <a:gs pos="100000">
+              <a:schemeClr val="phClr">
+                <a:tint val="50000"/>
+                <a:shade val="100000"/>
+                <a:satMod val="350000"/>
+              </a:schemeClr>
+            </a:gs>
+          </a:gsLst>
+          <a:lin ang="16200000" scaled="0"/>
+        </a:gradFill>
+      </a:fillStyleLst>
+      <a:lnStyleLst>
+        <a:ln w="9525" cap="flat" cmpd="sng" algn="ctr">
+          <a:solidFill>
+            <a:schemeClr val="phClr">
+              <a:shade val="95000"/>
+              <a:satMod val="105000"/>
+            </a:schemeClr>
+          </a:solidFill>
+          <a:prstDash val="solid"/>
+        </a:ln>
+        <a:ln w="25400" cap="flat" cmpd="sng" algn="ctr">
+          <a:solidFill>
+            <a:schemeClr val="phClr"/>
+          </a:solidFill>
+          <a:prstDash val="solid"/>
+        </a:ln>
+        <a:ln w="38100" cap="flat" cmpd="sng" algn="ctr">
+          <a:solidFill>
+            <a:schemeClr val="phClr"/>
+          </a:solidFill>
+          <a:prstDash val="solid"/>
+        </a:ln>
+      </a:lnStyleLst>
+      <a:effectStyleLst>
+        <a:effectStyle>
+          <a:effectLst>
+            <a:outerShdw blurRad="40000" dist="20000" dir="5400000" rotWithShape="0">
+              <a:srgbClr val="000000">
+                <a:alpha val="38000"/>
+              </a:srgbClr>
+            </a:outerShdw>
+          </a:effectLst>
+        </a:effectStyle>
+        <a:effectStyle>
+          <a:effectLst>
+            <a:outerShdw blurRad="40000" dist="23000" dir="5400000" rotWithShape="0">
+              <a:srgbClr val="000000">
+                <a:alpha val="35000"/>
+              </a:srgbClr>
+            </a:outerShdw>
+          </a:effectLst>
+        </a:effectStyle>
+        <a:effectStyle>
+          <a:effectLst>
+            <a:outerShdw blurRad="40000" dist="23000" dir="5400000" rotWithShape="0">
+              <a:srgbClr val="000000">
+                <a:alpha val="35000"/>
+              </a:srgbClr>
+            </a:outerShdw>
+          </a:effectLst>
+          <a:scene3d>
+            <a:camera prst="orthographicFront">
+              <a:rot lat="0" lon="0" rev="0"/>
+            </a:camera>
+            <a:lightRig rig="threePt" dir="t">
+              <a:rot lat="0" lon="0" rev="1200000"/>
+            </a:lightRig>
+          </a:scene3d>
+          <a:sp3d>
+            <a:bevelT w="63500" h="25400"/>
+          </a:sp3d>
+        </a:effectStyle>
+      </a:effectStyleLst>
+      <a:bgFillStyleLst>
+        <a:solidFill>
+          <a:schemeClr val="phClr"/>
+        </a:solidFill>
+        <a:gradFill rotWithShape="1">
+          <a:gsLst>
+            <a:gs pos="0">
+              <a:schemeClr val="phClr">
+                <a:tint val="40000"/>
+                <a:satMod val="350000"/>
+              </a:schemeClr>
+            </a:gs>
+            <a:gs pos="40000">
+              <a:schemeClr val="phClr">
+                <a:tint val="45000"/>
+                <a:shade val="99000"/>
+                <a:satMod val="350000"/>
+              </a:schemeClr>
+            </a:gs>
+            <a:gs pos="100000">
+              <a:schemeClr val="phClr">
+                <a:shade val="20000"/>
+                <a:satMod val="255000"/>
+              </a:schemeClr>
+            </a:gs>
+          </a:gsLst>
+          <a:path path="circle">
+            <a:fillToRect l="50000" t="-80000" r="50000" b="180000"/>
+          </a:path>
+        </a:gradFill>
+        <a:gradFill rotWithShape="1">
+          <a:gsLst>
+            <a:gs pos="0">
+              <a:schemeClr val="phClr">
+                <a:tint val="80000"/>
+                <a:satMod val="300000"/>
+              </a:schemeClr>
+            </a:gs>
+            <a:gs pos="100000">
+              <a:schemeClr val="phClr">
+                <a:shade val="30000"/>
+                <a:satMod val="200000"/>
+              </a:schemeClr>
+            </a:gs>
+          </a:gsLst>
+          <a:path path="circle">
+            <a:fillToRect l="50000" t="50000" r="50000" b="50000"/>
+          </a:path>
+        </a:gradFill>
+      </a:bgFillStyleLst>
+    </a:fmtScheme>
+  </a:themeElements>
+  <a:objectDefaults>
+    <a:spDef>
+      <a:spPr/>
+      <a:bodyPr/>
+      <a:lstStyle/>
+      <a:style>
+        <a:lnRef idx="1">
+          <a:schemeClr val="accent1"/>
+        </a:lnRef>
+        <a:fillRef idx="3">
+          <a:schemeClr val="accent1"/>
+        </a:fillRef>
+        <a:effectRef idx="2">
+          <a:schemeClr val="accent1"/>
+        </a:effectRef>
+        <a:fontRef idx="minor">
+          <a:schemeClr val="lt1"/>
+        </a:fontRef>
+      </a:style>
+    </a:spDef>
+    <a:lnDef>
+      <a:spPr/>
+      <a:bodyPr/>
+      <a:lstStyle/>
+      <a:style>
+        <a:lnRef idx="2">
+          <a:schemeClr val="accent1"/>
+        </a:lnRef>
+        <a:fillRef idx="0">
+          <a:schemeClr val="accent1"/>
+        </a:fillRef>
+        <a:effectRef idx="1">
+          <a:schemeClr val="accent1"/>
+        </a:effectRef>
+        <a:fontRef idx="minor">
+          <a:schemeClr val="tx1"/>
+        </a:fontRef>
+      </a:style>
+    </a:lnDef>
+  </a:objectDefaults>
+  <a:extraClrSchemeLst/>
+</a:theme>
 </file>
</xml_diff>

<commit_message>
feat: media support (video/audio with poster frame)
Detect a:videoFile/a:audioFile in p:nvPr and preserve original p:pic XML
for round-trip export. Poster frame image renders via existing pipeline.

Co-Authored-By: Claude Opus 4.6 <noreply@anthropic.com>
</commit_message>
<xml_diff>
--- a/test_fixtures/test_features.pptx
+++ b/test_fixtures/test_features.pptx
@@ -81,6 +81,7 @@
     <p:sldId id="329" r:id="rId80"/>
     <p:sldId id="330" r:id="rId83"/>
     <p:sldId id="331" r:id="rId84"/>
+    <p:sldId id="332" r:id="rId85"/>
   </p:sldIdLst>
   <p:sldSz cx="9144000" cy="6858000" type="screen4x3"/>
   <p:notesSz cx="6858000" cy="9144000"/>
@@ -19295,6 +19296,79 @@
             </a:pPr>
             <a:r>
               <a:t>Slide 76: OLE Embedded Object (p:oleObj)</a:t>
+            </a:r>
+          </a:p>
+        </p:txBody>
+      </p:sp>
+    </p:spTree>
+  </p:cSld>
+  <p:clrMapOvr>
+    <a:masterClrMapping/>
+  </p:clrMapOvr>
+</p:sld>
+</file>
+
+<file path=ppt/slides/slide77.xml><?xml version="1.0" encoding="utf-8"?>
+<p:sld xmlns:a="http://schemas.openxmlformats.org/drawingml/2006/main" xmlns:p="http://schemas.openxmlformats.org/presentationml/2006/main" xmlns:r="http://schemas.openxmlformats.org/officeDocument/2006/relationships">
+  <p:cSld>
+    <p:spTree>
+      <p:nvGrpSpPr>
+        <p:cNvPr id="1" name=""/>
+        <p:cNvGrpSpPr/>
+        <p:nvPr/>
+      </p:nvGrpSpPr>
+      <p:grpSpPr/>
+      <p:pic>
+        <p:nvPicPr>
+          <p:cNvPr id="300" name="Video Placeholder"/>
+          <p:cNvPicPr/>
+          <p:nvPr>
+            <a:videoFile r:link="rId3"/>
+          </p:nvPr>
+        </p:nvPicPr>
+        <p:blipFill>
+          <a:blip r:embed="rId2"/>
+          <a:stretch>
+            <a:fillRect/>
+          </a:stretch>
+        </p:blipFill>
+        <p:spPr>
+          <a:xfrm>
+            <a:off x="1371600" y="1828800"/>
+            <a:ext cx="6858000" cy="3886200"/>
+          </a:xfrm>
+          <a:prstGeom prst="rect">
+            <a:avLst/>
+          </a:prstGeom>
+        </p:spPr>
+      </p:pic>
+      <p:sp>
+        <p:nvSpPr>
+          <p:cNvPr id="301" name="TextBox 300"/>
+          <p:cNvSpPr txBox="1"/>
+          <p:nvPr/>
+        </p:nvSpPr>
+        <p:spPr>
+          <a:xfrm>
+            <a:off x="457200" y="274320"/>
+            <a:ext cx="8229600" cy="731520"/>
+          </a:xfrm>
+          <a:prstGeom prst="rect">
+            <a:avLst/>
+          </a:prstGeom>
+          <a:noFill/>
+        </p:spPr>
+        <p:txBody>
+          <a:bodyPr wrap="none">
+            <a:spAutoFit/>
+          </a:bodyPr>
+          <a:lstStyle/>
+          <a:p>
+            <a:pPr>
+              <a:defRPr sz="2400" b="1"/>
+            </a:pPr>
+            <a:r>
+              <a:t>Slide 77: Media (Video with Poster Frame)</a:t>
             </a:r>
           </a:p>
         </p:txBody>

</xml_diff>

<commit_message>
feat: Math equations support
</commit_message>
<xml_diff>
--- a/test_fixtures/test_features.pptx
+++ b/test_fixtures/test_features.pptx
@@ -82,6 +82,7 @@
     <p:sldId id="330" r:id="rId83"/>
     <p:sldId id="331" r:id="rId84"/>
     <p:sldId id="332" r:id="rId85"/>
+    <p:sldId id="333" r:id="rId86"/>
   </p:sldIdLst>
   <p:sldSz cx="9144000" cy="6858000" type="screen4x3"/>
   <p:notesSz cx="6858000" cy="9144000"/>
@@ -19370,6 +19371,128 @@
             <a:r>
               <a:t>Slide 77: Media (Video with Poster Frame)</a:t>
             </a:r>
+          </a:p>
+        </p:txBody>
+      </p:sp>
+    </p:spTree>
+  </p:cSld>
+  <p:clrMapOvr>
+    <a:masterClrMapping/>
+  </p:clrMapOvr>
+</p:sld>
+</file>
+
+<file path=ppt/slides/slide78.xml><?xml version="1.0" encoding="utf-8"?>
+<p:sld xmlns:a="http://schemas.openxmlformats.org/drawingml/2006/main" xmlns:p="http://schemas.openxmlformats.org/presentationml/2006/main" xmlns:r="http://schemas.openxmlformats.org/officeDocument/2006/relationships">
+  <p:cSld>
+    <p:spTree>
+      <p:nvGrpSpPr>
+        <p:cNvPr id="1" name=""/>
+        <p:cNvGrpSpPr/>
+        <p:nvPr/>
+      </p:nvGrpSpPr>
+      <p:grpSpPr/>
+      <p:sp>
+        <p:nvSpPr>
+          <p:cNvPr id="2" name="TextBox 1"/>
+          <p:cNvSpPr txBox="1"/>
+          <p:nvPr/>
+        </p:nvSpPr>
+        <p:spPr>
+          <a:xfrm>
+            <a:off x="914400" y="274320"/>
+            <a:ext cx="7315200" cy="731520"/>
+          </a:xfrm>
+          <a:prstGeom prst="rect">
+            <a:avLst/>
+          </a:prstGeom>
+          <a:noFill/>
+        </p:spPr>
+        <p:txBody>
+          <a:bodyPr wrap="none">
+            <a:spAutoFit/>
+          </a:bodyPr>
+          <a:lstStyle/>
+          <a:p>
+            <a:pPr>
+              <a:defRPr sz="2800" b="1"/>
+            </a:pPr>
+            <a:r>
+              <a:t>Slide 78: Math Equation (OMML)</a:t>
+            </a:r>
+          </a:p>
+        </p:txBody>
+      </p:sp>
+      <p:sp>
+        <p:nvSpPr>
+          <p:cNvPr id="3" name="TextBox 2"/>
+          <p:cNvSpPr txBox="1"/>
+          <p:nvPr/>
+        </p:nvSpPr>
+        <p:spPr>
+          <a:xfrm>
+            <a:off x="1828800" y="1828800"/>
+            <a:ext cx="5486400" cy="1828800"/>
+          </a:xfrm>
+          <a:prstGeom prst="rect">
+            <a:avLst/>
+          </a:prstGeom>
+          <a:noFill/>
+        </p:spPr>
+        <p:txBody>
+          <a:bodyPr wrap="none">
+            <a:spAutoFit/>
+          </a:bodyPr>
+          <a:lstStyle/>
+          <a:p>
+            <a:pPr>
+              <a:defRPr sz="2400"/>
+            </a:pPr>
+            <m:oMathPara xmlns:m="http://schemas.openxmlformats.org/officeDocument/2006/math">
+              <m:oMath>
+                <m:r>
+                  <m:t>x</m:t>
+                </m:r>
+                <m:r>
+                  <m:t>=</m:t>
+                </m:r>
+                <m:f>
+                  <m:num>
+                    <m:r>
+                      <m:t>-b±</m:t>
+                    </m:r>
+                    <m:rad>
+                      <m:radPr>
+                        <m:degHide m:val="1"/>
+                      </m:radPr>
+                      <m:deg/>
+                      <m:e>
+                        <m:sSup>
+                          <m:e>
+                            <m:r>
+                              <m:t>b</m:t>
+                            </m:r>
+                          </m:e>
+                          <m:sup>
+                            <m:r>
+                              <m:t>2</m:t>
+                            </m:r>
+                          </m:sup>
+                        </m:sSup>
+                        <m:r>
+                          <m:t>-4ac</m:t>
+                        </m:r>
+                      </m:e>
+                    </m:rad>
+                  </m:num>
+                  <m:den>
+                    <m:r>
+                      <m:t>2a</m:t>
+                    </m:r>
+                  </m:den>
+                </m:f>
+              </m:oMath>
+            </m:oMathPara>
           </a:p>
         </p:txBody>
       </p:sp>

</xml_diff>

<commit_message>
feat: transition/timing round-trip preservation + hidden slide detection + bug fixes
- Add transition_xml / timing_xml fields to SlideData for round-trip preservation
- Add hidden field + isSlideHidden() API for detecting show="0" slides
- Fix text not rendering in shapes with cy="0" (auto-size for text boxes)
- Fix spurious black borders from empty <a:ln> elements
- Fix lines/connectors becoming diagonal from cy=0 auto-size
- Remove redundant string helper wrappers in main.mbt
- Update README, CHANGELOG, CLAUDE.md, docs/svg-specification.md

Co-Authored-By: Claude Opus 4.6 <noreply@anthropic.com>
</commit_message>
<xml_diff>
--- a/test_fixtures/test_features.pptx
+++ b/test_fixtures/test_features.pptx
@@ -83,6 +83,8 @@
     <p:sldId id="331" r:id="rId84"/>
     <p:sldId id="332" r:id="rId85"/>
     <p:sldId id="333" r:id="rId86"/>
+    <p:sldId id="334" r:id="rId87"/>
+    <p:sldId id="335" r:id="rId88"/>
   </p:sldIdLst>
   <p:sldSz cx="9144000" cy="6858000" type="screen4x3"/>
   <p:notesSz cx="6858000" cy="9144000"/>
@@ -19504,6 +19506,96 @@
 </p:sld>
 </file>
 
+<file path=ppt/slides/slide79.xml><?xml version="1.0" encoding="utf-8"?>
+<p:sld xmlns:a="http://schemas.openxmlformats.org/drawingml/2006/main" xmlns:p="http://schemas.openxmlformats.org/presentationml/2006/main" xmlns:r="http://schemas.openxmlformats.org/officeDocument/2006/relationships">
+  <p:cSld>
+    <p:spTree>
+      <p:nvGrpSpPr>
+        <p:cNvPr id="1" name=""/>
+        <p:cNvGrpSpPr/>
+        <p:nvPr/>
+      </p:nvGrpSpPr>
+      <p:grpSpPr/>
+      <p:sp>
+        <p:nvSpPr>
+          <p:cNvPr id="2" name="TextBox 1"/>
+          <p:cNvSpPr txBox="1"/>
+          <p:nvPr/>
+        </p:nvSpPr>
+        <p:spPr>
+          <a:xfrm>
+            <a:off x="457200" y="274320"/>
+            <a:ext cx="8229600" cy="731520"/>
+          </a:xfrm>
+          <a:prstGeom prst="rect">
+            <a:avLst/>
+          </a:prstGeom>
+          <a:noFill/>
+        </p:spPr>
+        <p:txBody>
+          <a:bodyPr wrap="none">
+            <a:spAutoFit/>
+          </a:bodyPr>
+          <a:lstStyle/>
+          <a:p>
+            <a:pPr>
+              <a:defRPr sz="2400" b="1"/>
+            </a:pPr>
+            <a:r>
+              <a:t>Slide 79: Transition + Timing (round-trip)</a:t>
+            </a:r>
+          </a:p>
+        </p:txBody>
+      </p:sp>
+      <p:sp>
+        <p:nvSpPr>
+          <p:cNvPr id="3" name="TextBox 2"/>
+          <p:cNvSpPr txBox="1"/>
+          <p:nvPr/>
+        </p:nvSpPr>
+        <p:spPr>
+          <a:xfrm>
+            <a:off x="457200" y="1371600"/>
+            <a:ext cx="8229600" cy="914400"/>
+          </a:xfrm>
+          <a:prstGeom prst="rect">
+            <a:avLst/>
+          </a:prstGeom>
+          <a:noFill/>
+        </p:spPr>
+        <p:txBody>
+          <a:bodyPr wrap="none">
+            <a:spAutoFit/>
+          </a:bodyPr>
+          <a:lstStyle/>
+          <a:p>
+            <a:pPr>
+              <a:defRPr sz="1600"/>
+            </a:pPr>
+            <a:r>
+              <a:t>This slide has a fade transition and timing data for round-trip.</a:t>
+            </a:r>
+          </a:p>
+        </p:txBody>
+      </p:sp>
+    </p:spTree>
+  </p:cSld>
+  <p:clrMapOvr>
+    <a:masterClrMapping/>
+  </p:clrMapOvr>
+  <p:transition spd="med">
+    <p:fade/>
+  </p:transition>
+  <p:timing>
+    <p:tnLst>
+      <p:par>
+        <p:cTn id="1" dur="indefinite" restart="never" nodeType="tmRoot"/>
+      </p:par>
+    </p:tnLst>
+  </p:timing>
+</p:sld>
+</file>
+
 <file path=ppt/slides/slide8.xml><?xml version="1.0" encoding="utf-8"?>
 <p:sld xmlns:a="http://schemas.openxmlformats.org/drawingml/2006/main" xmlns:p="http://schemas.openxmlformats.org/presentationml/2006/main" xmlns:r="http://schemas.openxmlformats.org/officeDocument/2006/relationships">
   <p:cSld>
@@ -19600,6 +19692,86 @@
             </a:pPr>
             <a:r>
               <a:t>If you see green, explicit bg override is working correctly.</a:t>
+            </a:r>
+          </a:p>
+        </p:txBody>
+      </p:sp>
+    </p:spTree>
+  </p:cSld>
+  <p:clrMapOvr>
+    <a:masterClrMapping/>
+  </p:clrMapOvr>
+</p:sld>
+</file>
+
+<file path=ppt/slides/slide80.xml><?xml version="1.0" encoding="utf-8"?>
+<p:sld xmlns:a="http://schemas.openxmlformats.org/drawingml/2006/main" xmlns:p="http://schemas.openxmlformats.org/presentationml/2006/main" xmlns:r="http://schemas.openxmlformats.org/officeDocument/2006/relationships" show="0">
+  <p:cSld>
+    <p:spTree>
+      <p:nvGrpSpPr>
+        <p:cNvPr id="1" name=""/>
+        <p:cNvGrpSpPr/>
+        <p:nvPr/>
+      </p:nvGrpSpPr>
+      <p:grpSpPr/>
+      <p:sp>
+        <p:nvSpPr>
+          <p:cNvPr id="2" name="TextBox 1"/>
+          <p:cNvSpPr txBox="1"/>
+          <p:nvPr/>
+        </p:nvSpPr>
+        <p:spPr>
+          <a:xfrm>
+            <a:off x="457200" y="274320"/>
+            <a:ext cx="8229600" cy="731520"/>
+          </a:xfrm>
+          <a:prstGeom prst="rect">
+            <a:avLst/>
+          </a:prstGeom>
+          <a:noFill/>
+        </p:spPr>
+        <p:txBody>
+          <a:bodyPr wrap="none">
+            <a:spAutoFit/>
+          </a:bodyPr>
+          <a:lstStyle/>
+          <a:p>
+            <a:pPr>
+              <a:defRPr sz="2400" b="1"/>
+            </a:pPr>
+            <a:r>
+              <a:t>Slide 80: Hidden Slide</a:t>
+            </a:r>
+          </a:p>
+        </p:txBody>
+      </p:sp>
+      <p:sp>
+        <p:nvSpPr>
+          <p:cNvPr id="3" name="TextBox 2"/>
+          <p:cNvSpPr txBox="1"/>
+          <p:nvPr/>
+        </p:nvSpPr>
+        <p:spPr>
+          <a:xfrm>
+            <a:off x="457200" y="1371600"/>
+            <a:ext cx="8229600" cy="914400"/>
+          </a:xfrm>
+          <a:prstGeom prst="rect">
+            <a:avLst/>
+          </a:prstGeom>
+          <a:noFill/>
+        </p:spPr>
+        <p:txBody>
+          <a:bodyPr wrap="none">
+            <a:spAutoFit/>
+          </a:bodyPr>
+          <a:lstStyle/>
+          <a:p>
+            <a:pPr>
+              <a:defRPr sz="1600"/>
+            </a:pPr>
+            <a:r>
+              <a:t>This slide is marked as hidden (show='0').</a:t>
             </a:r>
           </a:p>
         </p:txBody>

</xml_diff>

<commit_message>
feat: text warp visual rendering (prstTxWarp → SVG textPath/transform)
Add visual rendering for 39 OOXML text warp presets. Curved warps (arch,
circle, wave, curve, inflate/deflate, chevron, etc.) use SVG <textPath>,
linear warps (slant, fade, cascade) use SVG transforms.

Co-Authored-By: Claude Opus 4.6 <noreply@anthropic.com>
</commit_message>
<xml_diff>
--- a/test_fixtures/test_features.pptx
+++ b/test_fixtures/test_features.pptx
@@ -79,12 +79,13 @@
     <p:sldId id="327" r:id="rId78"/>
     <p:sldId id="328" r:id="rId79"/>
     <p:sldId id="329" r:id="rId80"/>
-    <p:sldId id="330" r:id="rId83"/>
+    <p:sldId id="330" r:id="rId81"/>
     <p:sldId id="331" r:id="rId84"/>
     <p:sldId id="332" r:id="rId85"/>
     <p:sldId id="333" r:id="rId86"/>
     <p:sldId id="334" r:id="rId87"/>
     <p:sldId id="335" r:id="rId88"/>
+    <p:sldId id="336" r:id="rId89"/>
   </p:sldIdLst>
   <p:sldSz cx="9144000" cy="6858000" type="screen4x3"/>
   <p:notesSz cx="6858000" cy="9144000"/>
@@ -4575,7 +4576,7 @@
 </c:chartSpace>
 </file>
 
-<file path=ppt/comments/comment74.xml><?xml version="1.0" encoding="utf-8"?>
+<file path=ppt/comments/comment75.xml><?xml version="1.0" encoding="utf-8"?>
 <p:cmLst xmlns:p="http://schemas.openxmlformats.org/presentationml/2006/main">
   <p:cm authorId="1" dt="2025-01-15T10:30:00.000" idx="1">
     <p:pos x="100" y="200"/>
@@ -18857,63 +18858,9 @@
         <p:nvPr/>
       </p:nvGrpSpPr>
       <p:grpSpPr/>
-      <p:graphicFrame>
-        <p:nvGraphicFramePr>
-          <p:cNvPr id="2" name="Chart 1"/>
-          <p:cNvGraphicFramePr>
-            <a:graphicFrameLocks noGrp="1"/>
-          </p:cNvGraphicFramePr>
-          <p:nvPr/>
-        </p:nvGraphicFramePr>
-        <p:xfrm>
-          <a:off x="457200" y="1371600"/>
-          <a:ext cx="3657600" cy="2743200"/>
-        </p:xfrm>
-        <a:graphic>
-          <a:graphicData uri="http://schemas.openxmlformats.org/drawingml/2006/chart">
-            <c:chart xmlns:c="http://schemas.openxmlformats.org/drawingml/2006/chart" r:id="rId2"/>
-          </a:graphicData>
-        </a:graphic>
-      </p:graphicFrame>
-      <p:graphicFrame>
-        <p:nvGraphicFramePr>
-          <p:cNvPr id="3" name="Chart 2"/>
-          <p:cNvGraphicFramePr>
-            <a:graphicFrameLocks noGrp="1"/>
-          </p:cNvGraphicFramePr>
-          <p:nvPr/>
-        </p:nvGraphicFramePr>
-        <p:xfrm>
-          <a:off x="4572000" y="1371600"/>
-          <a:ext cx="3657600" cy="2743200"/>
-        </p:xfrm>
-        <a:graphic>
-          <a:graphicData uri="http://schemas.openxmlformats.org/drawingml/2006/chart">
-            <c:chart xmlns:c="http://schemas.openxmlformats.org/drawingml/2006/chart" r:id="rId3"/>
-          </a:graphicData>
-        </a:graphic>
-      </p:graphicFrame>
-      <p:graphicFrame>
-        <p:nvGraphicFramePr>
-          <p:cNvPr id="4" name="Chart 3"/>
-          <p:cNvGraphicFramePr>
-            <a:graphicFrameLocks noGrp="1"/>
-          </p:cNvGraphicFramePr>
-          <p:nvPr/>
-        </p:nvGraphicFramePr>
-        <p:xfrm>
-          <a:off x="2286000" y="4572000"/>
-          <a:ext cx="3657600" cy="1828800"/>
-        </p:xfrm>
-        <a:graphic>
-          <a:graphicData uri="http://schemas.openxmlformats.org/drawingml/2006/chart">
-            <c:chart xmlns:c="http://schemas.openxmlformats.org/drawingml/2006/chart" r:id="rId4"/>
-          </a:graphicData>
-        </a:graphic>
-      </p:graphicFrame>
-      <p:sp>
-        <p:nvSpPr>
-          <p:cNvPr id="5" name="TextBox 4"/>
+      <p:sp>
+        <p:nvSpPr>
+          <p:cNvPr id="2" name="TextBox 1"/>
           <p:cNvSpPr txBox="1"/>
           <p:nvPr/>
         </p:nvSpPr>
@@ -18937,7 +18884,187 @@
               <a:defRPr sz="1800" b="1"/>
             </a:pPr>
             <a:r>
-              <a:t>Slide 73: Stacked / Percent-stacked bar charts</a:t>
+              <a:t>Slide 72b: Additional text warp presets</a:t>
+            </a:r>
+          </a:p>
+        </p:txBody>
+      </p:sp>
+      <p:sp>
+        <p:nvSpPr>
+          <p:cNvPr id="3" name="TextBox 2"/>
+          <p:cNvSpPr txBox="1"/>
+          <p:nvPr/>
+        </p:nvSpPr>
+        <p:spPr>
+          <a:xfrm>
+            <a:off x="457200" y="914400"/>
+            <a:ext cx="3657600" cy="1371600"/>
+          </a:xfrm>
+          <a:prstGeom prst="rect">
+            <a:avLst/>
+          </a:prstGeom>
+          <a:noFill/>
+        </p:spPr>
+        <p:txBody>
+          <a:bodyPr wrap="none">
+            <a:prstTxWarp prst="textSlantUp">
+              <a:avLst>
+                <a:gd name="adj" fmla="val 55556"/>
+              </a:avLst>
+            </a:prstTxWarp>
+            <a:spAutoFit/>
+          </a:bodyPr>
+          <a:lstStyle/>
+          <a:p>
+            <a:r>
+              <a:rPr sz="3600" b="1"/>
+              <a:t>Slant Up</a:t>
+            </a:r>
+          </a:p>
+        </p:txBody>
+      </p:sp>
+      <p:sp>
+        <p:nvSpPr>
+          <p:cNvPr id="4" name="TextBox 3"/>
+          <p:cNvSpPr txBox="1"/>
+          <p:nvPr/>
+        </p:nvSpPr>
+        <p:spPr>
+          <a:xfrm>
+            <a:off x="4572000" y="914400"/>
+            <a:ext cx="3657600" cy="1371600"/>
+          </a:xfrm>
+          <a:prstGeom prst="rect">
+            <a:avLst/>
+          </a:prstGeom>
+          <a:noFill/>
+        </p:spPr>
+        <p:txBody>
+          <a:bodyPr wrap="none">
+            <a:prstTxWarp prst="textCurveUp">
+              <a:avLst>
+                <a:gd name="adj" fmla="val 45977"/>
+              </a:avLst>
+            </a:prstTxWarp>
+            <a:spAutoFit/>
+          </a:bodyPr>
+          <a:lstStyle/>
+          <a:p>
+            <a:r>
+              <a:rPr sz="3600" b="1">
+                <a:solidFill>
+                  <a:srgbClr val="0070C0"/>
+                </a:solidFill>
+              </a:rPr>
+              <a:t>Curve Up</a:t>
+            </a:r>
+          </a:p>
+        </p:txBody>
+      </p:sp>
+      <p:sp>
+        <p:nvSpPr>
+          <p:cNvPr id="5" name="TextBox 4"/>
+          <p:cNvSpPr txBox="1"/>
+          <p:nvPr/>
+        </p:nvSpPr>
+        <p:spPr>
+          <a:xfrm>
+            <a:off x="457200" y="2743200"/>
+            <a:ext cx="3657600" cy="1371600"/>
+          </a:xfrm>
+          <a:prstGeom prst="rect">
+            <a:avLst/>
+          </a:prstGeom>
+          <a:noFill/>
+        </p:spPr>
+        <p:txBody>
+          <a:bodyPr wrap="none">
+            <a:prstTxWarp prst="textInflate">
+              <a:avLst/>
+            </a:prstTxWarp>
+            <a:spAutoFit/>
+          </a:bodyPr>
+          <a:lstStyle/>
+          <a:p>
+            <a:r>
+              <a:rPr sz="3600" b="1">
+                <a:solidFill>
+                  <a:srgbClr val="C00000"/>
+                </a:solidFill>
+              </a:rPr>
+              <a:t>Inflate</a:t>
+            </a:r>
+          </a:p>
+        </p:txBody>
+      </p:sp>
+      <p:sp>
+        <p:nvSpPr>
+          <p:cNvPr id="6" name="TextBox 5"/>
+          <p:cNvSpPr txBox="1"/>
+          <p:nvPr/>
+        </p:nvSpPr>
+        <p:spPr>
+          <a:xfrm>
+            <a:off x="4572000" y="2743200"/>
+            <a:ext cx="3657600" cy="1371600"/>
+          </a:xfrm>
+          <a:prstGeom prst="rect">
+            <a:avLst/>
+          </a:prstGeom>
+          <a:noFill/>
+        </p:spPr>
+        <p:txBody>
+          <a:bodyPr wrap="none">
+            <a:prstTxWarp prst="textChevron">
+              <a:avLst>
+                <a:gd name="adj" fmla="val 25000"/>
+              </a:avLst>
+            </a:prstTxWarp>
+            <a:spAutoFit/>
+          </a:bodyPr>
+          <a:lstStyle/>
+          <a:p>
+            <a:r>
+              <a:rPr sz="3600" b="1">
+                <a:solidFill>
+                  <a:srgbClr val="00B050"/>
+                </a:solidFill>
+              </a:rPr>
+              <a:t>Chevron</a:t>
+            </a:r>
+          </a:p>
+        </p:txBody>
+      </p:sp>
+      <p:sp>
+        <p:nvSpPr>
+          <p:cNvPr id="7" name="TextBox 6"/>
+          <p:cNvSpPr txBox="1"/>
+          <p:nvPr/>
+        </p:nvSpPr>
+        <p:spPr>
+          <a:xfrm>
+            <a:off x="2286000" y="4572000"/>
+            <a:ext cx="3657600" cy="2286000"/>
+          </a:xfrm>
+          <a:prstGeom prst="rect">
+            <a:avLst/>
+          </a:prstGeom>
+          <a:noFill/>
+        </p:spPr>
+        <p:txBody>
+          <a:bodyPr wrap="none">
+            <a:prstTxWarp prst="textCircle">
+              <a:avLst>
+                <a:gd name="adj" fmla="val 10800000"/>
+              </a:avLst>
+            </a:prstTxWarp>
+            <a:spAutoFit/>
+          </a:bodyPr>
+          <a:lstStyle/>
+          <a:p>
+            <a:r>
+              <a:rPr sz="2800" b="1"/>
+              <a:t>Circle Text Example</a:t>
             </a:r>
           </a:p>
         </p:txBody>
@@ -18960,9 +19087,63 @@
         <p:nvPr/>
       </p:nvGrpSpPr>
       <p:grpSpPr/>
-      <p:sp>
-        <p:nvSpPr>
-          <p:cNvPr id="2" name="TextBox 1"/>
+      <p:graphicFrame>
+        <p:nvGraphicFramePr>
+          <p:cNvPr id="2" name="Chart 1"/>
+          <p:cNvGraphicFramePr>
+            <a:graphicFrameLocks noGrp="1"/>
+          </p:cNvGraphicFramePr>
+          <p:nvPr/>
+        </p:nvGraphicFramePr>
+        <p:xfrm>
+          <a:off x="457200" y="1371600"/>
+          <a:ext cx="3657600" cy="2743200"/>
+        </p:xfrm>
+        <a:graphic>
+          <a:graphicData uri="http://schemas.openxmlformats.org/drawingml/2006/chart">
+            <c:chart xmlns:c="http://schemas.openxmlformats.org/drawingml/2006/chart" r:id="rId2"/>
+          </a:graphicData>
+        </a:graphic>
+      </p:graphicFrame>
+      <p:graphicFrame>
+        <p:nvGraphicFramePr>
+          <p:cNvPr id="3" name="Chart 2"/>
+          <p:cNvGraphicFramePr>
+            <a:graphicFrameLocks noGrp="1"/>
+          </p:cNvGraphicFramePr>
+          <p:nvPr/>
+        </p:nvGraphicFramePr>
+        <p:xfrm>
+          <a:off x="4572000" y="1371600"/>
+          <a:ext cx="3657600" cy="2743200"/>
+        </p:xfrm>
+        <a:graphic>
+          <a:graphicData uri="http://schemas.openxmlformats.org/drawingml/2006/chart">
+            <c:chart xmlns:c="http://schemas.openxmlformats.org/drawingml/2006/chart" r:id="rId3"/>
+          </a:graphicData>
+        </a:graphic>
+      </p:graphicFrame>
+      <p:graphicFrame>
+        <p:nvGraphicFramePr>
+          <p:cNvPr id="4" name="Chart 3"/>
+          <p:cNvGraphicFramePr>
+            <a:graphicFrameLocks noGrp="1"/>
+          </p:cNvGraphicFramePr>
+          <p:nvPr/>
+        </p:nvGraphicFramePr>
+        <p:xfrm>
+          <a:off x="2286000" y="4572000"/>
+          <a:ext cx="3657600" cy="1828800"/>
+        </p:xfrm>
+        <a:graphic>
+          <a:graphicData uri="http://schemas.openxmlformats.org/drawingml/2006/chart">
+            <c:chart xmlns:c="http://schemas.openxmlformats.org/drawingml/2006/chart" r:id="rId4"/>
+          </a:graphicData>
+        </a:graphic>
+      </p:graphicFrame>
+      <p:sp>
+        <p:nvSpPr>
+          <p:cNvPr id="5" name="TextBox 4"/>
           <p:cNvSpPr txBox="1"/>
           <p:nvPr/>
         </p:nvSpPr>
@@ -18986,42 +19167,7 @@
               <a:defRPr sz="1800" b="1"/>
             </a:pPr>
             <a:r>
-              <a:t>Slide 74: Speaker notes + comments</a:t>
-            </a:r>
-          </a:p>
-        </p:txBody>
-      </p:sp>
-      <p:sp>
-        <p:nvSpPr>
-          <p:cNvPr id="3" name="TextBox 2"/>
-          <p:cNvSpPr txBox="1"/>
-          <p:nvPr/>
-        </p:nvSpPr>
-        <p:spPr>
-          <a:xfrm>
-            <a:off x="457200" y="1371600"/>
-            <a:ext cx="7315200" cy="2743200"/>
-          </a:xfrm>
-          <a:prstGeom prst="rect">
-            <a:avLst/>
-          </a:prstGeom>
-          <a:noFill/>
-        </p:spPr>
-        <p:txBody>
-          <a:bodyPr wrap="square">
-            <a:spAutoFit/>
-          </a:bodyPr>
-          <a:lstStyle/>
-          <a:p>
-            <a:pPr>
-              <a:defRPr sz="1400"/>
-            </a:pPr>
-            <a:r>
-              <a:t>This slide has speaker notes and comments attached.</a:t>
-            </a:r>
-            <a:br/>
-            <a:r>
-              <a:t>Notes and comments are metadata not rendered on slide, but preserved in round-trip export.</a:t>
+              <a:t>Slide 73: Stacked / Percent-stacked bar charts</a:t>
             </a:r>
           </a:p>
         </p:txBody>
@@ -19035,6 +19181,90 @@
 </file>
 
 <file path=ppt/slides/slide75.xml><?xml version="1.0" encoding="utf-8"?>
+<p:sld xmlns:a="http://schemas.openxmlformats.org/drawingml/2006/main" xmlns:p="http://schemas.openxmlformats.org/presentationml/2006/main" xmlns:r="http://schemas.openxmlformats.org/officeDocument/2006/relationships">
+  <p:cSld>
+    <p:spTree>
+      <p:nvGrpSpPr>
+        <p:cNvPr id="1" name=""/>
+        <p:cNvGrpSpPr/>
+        <p:nvPr/>
+      </p:nvGrpSpPr>
+      <p:grpSpPr/>
+      <p:sp>
+        <p:nvSpPr>
+          <p:cNvPr id="2" name="TextBox 1"/>
+          <p:cNvSpPr txBox="1"/>
+          <p:nvPr/>
+        </p:nvSpPr>
+        <p:spPr>
+          <a:xfrm>
+            <a:off x="274320" y="182880"/>
+            <a:ext cx="8229600" cy="457200"/>
+          </a:xfrm>
+          <a:prstGeom prst="rect">
+            <a:avLst/>
+          </a:prstGeom>
+          <a:noFill/>
+        </p:spPr>
+        <p:txBody>
+          <a:bodyPr wrap="none">
+            <a:spAutoFit/>
+          </a:bodyPr>
+          <a:lstStyle/>
+          <a:p>
+            <a:pPr>
+              <a:defRPr sz="1800" b="1"/>
+            </a:pPr>
+            <a:r>
+              <a:t>Slide 74: Speaker notes + comments</a:t>
+            </a:r>
+          </a:p>
+        </p:txBody>
+      </p:sp>
+      <p:sp>
+        <p:nvSpPr>
+          <p:cNvPr id="3" name="TextBox 2"/>
+          <p:cNvSpPr txBox="1"/>
+          <p:nvPr/>
+        </p:nvSpPr>
+        <p:spPr>
+          <a:xfrm>
+            <a:off x="457200" y="1371600"/>
+            <a:ext cx="7315200" cy="2743200"/>
+          </a:xfrm>
+          <a:prstGeom prst="rect">
+            <a:avLst/>
+          </a:prstGeom>
+          <a:noFill/>
+        </p:spPr>
+        <p:txBody>
+          <a:bodyPr wrap="square">
+            <a:spAutoFit/>
+          </a:bodyPr>
+          <a:lstStyle/>
+          <a:p>
+            <a:pPr>
+              <a:defRPr sz="1400"/>
+            </a:pPr>
+            <a:r>
+              <a:t>This slide has speaker notes and comments attached.</a:t>
+            </a:r>
+            <a:br/>
+            <a:r>
+              <a:t>Notes and comments are metadata not rendered on slide, but preserved in round-trip export.</a:t>
+            </a:r>
+          </a:p>
+        </p:txBody>
+      </p:sp>
+    </p:spTree>
+  </p:cSld>
+  <p:clrMapOvr>
+    <a:masterClrMapping/>
+  </p:clrMapOvr>
+</p:sld>
+</file>
+
+<file path=ppt/slides/slide76.xml><?xml version="1.0" encoding="utf-8"?>
 <p:sld xmlns:a="http://schemas.openxmlformats.org/drawingml/2006/main" xmlns:p="http://schemas.openxmlformats.org/presentationml/2006/main" xmlns:r="http://schemas.openxmlformats.org/officeDocument/2006/relationships">
   <p:cSld>
     <p:spTree>
@@ -19222,7 +19452,7 @@
 </p:sld>
 </file>
 
-<file path=ppt/slides/slide76.xml><?xml version="1.0" encoding="utf-8"?>
+<file path=ppt/slides/slide77.xml><?xml version="1.0" encoding="utf-8"?>
 <p:sld xmlns:a="http://schemas.openxmlformats.org/drawingml/2006/main" xmlns:p="http://schemas.openxmlformats.org/presentationml/2006/main" xmlns:r="http://schemas.openxmlformats.org/officeDocument/2006/relationships">
   <p:cSld>
     <p:spTree>
@@ -19311,7 +19541,7 @@
 </p:sld>
 </file>
 
-<file path=ppt/slides/slide77.xml><?xml version="1.0" encoding="utf-8"?>
+<file path=ppt/slides/slide78.xml><?xml version="1.0" encoding="utf-8"?>
 <p:sld xmlns:a="http://schemas.openxmlformats.org/drawingml/2006/main" xmlns:p="http://schemas.openxmlformats.org/presentationml/2006/main" xmlns:r="http://schemas.openxmlformats.org/officeDocument/2006/relationships">
   <p:cSld>
     <p:spTree>
@@ -19384,7 +19614,7 @@
 </p:sld>
 </file>
 
-<file path=ppt/slides/slide78.xml><?xml version="1.0" encoding="utf-8"?>
+<file path=ppt/slides/slide79.xml><?xml version="1.0" encoding="utf-8"?>
 <p:sld xmlns:a="http://schemas.openxmlformats.org/drawingml/2006/main" xmlns:p="http://schemas.openxmlformats.org/presentationml/2006/main" xmlns:r="http://schemas.openxmlformats.org/officeDocument/2006/relationships">
   <p:cSld>
     <p:spTree>
@@ -19506,7 +19736,115 @@
 </p:sld>
 </file>
 
-<file path=ppt/slides/slide79.xml><?xml version="1.0" encoding="utf-8"?>
+<file path=ppt/slides/slide8.xml><?xml version="1.0" encoding="utf-8"?>
+<p:sld xmlns:a="http://schemas.openxmlformats.org/drawingml/2006/main" xmlns:p="http://schemas.openxmlformats.org/presentationml/2006/main" xmlns:r="http://schemas.openxmlformats.org/officeDocument/2006/relationships">
+  <p:cSld>
+    <p:bg>
+      <p:bgPr>
+        <a:solidFill>
+          <a:srgbClr val="228B22"/>
+        </a:solidFill>
+        <a:effectLst/>
+      </p:bgPr>
+    </p:bg>
+    <p:spTree>
+      <p:nvGrpSpPr>
+        <p:cNvPr id="1" name=""/>
+        <p:cNvGrpSpPr/>
+        <p:nvPr/>
+      </p:nvGrpSpPr>
+      <p:grpSpPr/>
+      <p:sp>
+        <p:nvSpPr>
+          <p:cNvPr id="2" name="TextBox 1"/>
+          <p:cNvSpPr txBox="1"/>
+          <p:nvPr/>
+        </p:nvSpPr>
+        <p:spPr>
+          <a:xfrm>
+            <a:off x="457200" y="274320"/>
+            <a:ext cx="8229600" cy="731520"/>
+          </a:xfrm>
+          <a:prstGeom prst="rect">
+            <a:avLst/>
+          </a:prstGeom>
+          <a:noFill/>
+        </p:spPr>
+        <p:txBody>
+          <a:bodyPr wrap="none">
+            <a:spAutoFit/>
+          </a:bodyPr>
+          <a:lstStyle/>
+          <a:p>
+            <a:pPr>
+              <a:defRPr sz="2000" b="1">
+                <a:solidFill>
+                  <a:srgbClr val="FFFFFF"/>
+                </a:solidFill>
+              </a:defRPr>
+            </a:pPr>
+            <a:r>
+              <a:t>Slide 8: Explicit green bg (#228B22) — overrides master</a:t>
+            </a:r>
+          </a:p>
+        </p:txBody>
+      </p:sp>
+      <p:sp>
+        <p:nvSpPr>
+          <p:cNvPr id="3" name="TextBox 2"/>
+          <p:cNvSpPr txBox="1"/>
+          <p:nvPr/>
+        </p:nvSpPr>
+        <p:spPr>
+          <a:xfrm>
+            <a:off x="457200" y="1828800"/>
+            <a:ext cx="8229600" cy="2743200"/>
+          </a:xfrm>
+          <a:prstGeom prst="rect">
+            <a:avLst/>
+          </a:prstGeom>
+          <a:noFill/>
+        </p:spPr>
+        <p:txBody>
+          <a:bodyPr wrap="square">
+            <a:spAutoFit/>
+          </a:bodyPr>
+          <a:lstStyle/>
+          <a:p>
+            <a:pPr>
+              <a:defRPr sz="1800">
+                <a:solidFill>
+                  <a:srgbClr val="DCFFDC"/>
+                </a:solidFill>
+              </a:defRPr>
+            </a:pPr>
+            <a:r>
+              <a:t>This slide has an explicit green background. It should NOT show the master's navy.</a:t>
+            </a:r>
+          </a:p>
+          <a:p>
+            <a:pPr>
+              <a:defRPr sz="1800">
+                <a:solidFill>
+                  <a:srgbClr val="FFFFFF"/>
+                </a:solidFill>
+              </a:defRPr>
+            </a:pPr>
+            <a:r>
+              <a:t>If you see green, explicit bg override is working correctly.</a:t>
+            </a:r>
+          </a:p>
+        </p:txBody>
+      </p:sp>
+    </p:spTree>
+  </p:cSld>
+  <p:clrMapOvr>
+    <a:masterClrMapping/>
+  </p:clrMapOvr>
+</p:sld>
+</file>
+
+<file path=ppt/slides/slide80.xml><?xml version="1.0" encoding="utf-8"?>
 <p:sld xmlns:a="http://schemas.openxmlformats.org/drawingml/2006/main" xmlns:p="http://schemas.openxmlformats.org/presentationml/2006/main" xmlns:r="http://schemas.openxmlformats.org/officeDocument/2006/relationships">
   <p:cSld>
     <p:spTree>
@@ -19596,115 +19934,7 @@
 </p:sld>
 </file>
 
-<file path=ppt/slides/slide8.xml><?xml version="1.0" encoding="utf-8"?>
-<p:sld xmlns:a="http://schemas.openxmlformats.org/drawingml/2006/main" xmlns:p="http://schemas.openxmlformats.org/presentationml/2006/main" xmlns:r="http://schemas.openxmlformats.org/officeDocument/2006/relationships">
-  <p:cSld>
-    <p:bg>
-      <p:bgPr>
-        <a:solidFill>
-          <a:srgbClr val="228B22"/>
-        </a:solidFill>
-        <a:effectLst/>
-      </p:bgPr>
-    </p:bg>
-    <p:spTree>
-      <p:nvGrpSpPr>
-        <p:cNvPr id="1" name=""/>
-        <p:cNvGrpSpPr/>
-        <p:nvPr/>
-      </p:nvGrpSpPr>
-      <p:grpSpPr/>
-      <p:sp>
-        <p:nvSpPr>
-          <p:cNvPr id="2" name="TextBox 1"/>
-          <p:cNvSpPr txBox="1"/>
-          <p:nvPr/>
-        </p:nvSpPr>
-        <p:spPr>
-          <a:xfrm>
-            <a:off x="457200" y="274320"/>
-            <a:ext cx="8229600" cy="731520"/>
-          </a:xfrm>
-          <a:prstGeom prst="rect">
-            <a:avLst/>
-          </a:prstGeom>
-          <a:noFill/>
-        </p:spPr>
-        <p:txBody>
-          <a:bodyPr wrap="none">
-            <a:spAutoFit/>
-          </a:bodyPr>
-          <a:lstStyle/>
-          <a:p>
-            <a:pPr>
-              <a:defRPr sz="2000" b="1">
-                <a:solidFill>
-                  <a:srgbClr val="FFFFFF"/>
-                </a:solidFill>
-              </a:defRPr>
-            </a:pPr>
-            <a:r>
-              <a:t>Slide 8: Explicit green bg (#228B22) — overrides master</a:t>
-            </a:r>
-          </a:p>
-        </p:txBody>
-      </p:sp>
-      <p:sp>
-        <p:nvSpPr>
-          <p:cNvPr id="3" name="TextBox 2"/>
-          <p:cNvSpPr txBox="1"/>
-          <p:nvPr/>
-        </p:nvSpPr>
-        <p:spPr>
-          <a:xfrm>
-            <a:off x="457200" y="1828800"/>
-            <a:ext cx="8229600" cy="2743200"/>
-          </a:xfrm>
-          <a:prstGeom prst="rect">
-            <a:avLst/>
-          </a:prstGeom>
-          <a:noFill/>
-        </p:spPr>
-        <p:txBody>
-          <a:bodyPr wrap="square">
-            <a:spAutoFit/>
-          </a:bodyPr>
-          <a:lstStyle/>
-          <a:p>
-            <a:pPr>
-              <a:defRPr sz="1800">
-                <a:solidFill>
-                  <a:srgbClr val="DCFFDC"/>
-                </a:solidFill>
-              </a:defRPr>
-            </a:pPr>
-            <a:r>
-              <a:t>This slide has an explicit green background. It should NOT show the master's navy.</a:t>
-            </a:r>
-          </a:p>
-          <a:p>
-            <a:pPr>
-              <a:defRPr sz="1800">
-                <a:solidFill>
-                  <a:srgbClr val="FFFFFF"/>
-                </a:solidFill>
-              </a:defRPr>
-            </a:pPr>
-            <a:r>
-              <a:t>If you see green, explicit bg override is working correctly.</a:t>
-            </a:r>
-          </a:p>
-        </p:txBody>
-      </p:sp>
-    </p:spTree>
-  </p:cSld>
-  <p:clrMapOvr>
-    <a:masterClrMapping/>
-  </p:clrMapOvr>
-</p:sld>
-</file>
-
-<file path=ppt/slides/slide80.xml><?xml version="1.0" encoding="utf-8"?>
+<file path=ppt/slides/slide81.xml><?xml version="1.0" encoding="utf-8"?>
 <p:sld xmlns:a="http://schemas.openxmlformats.org/drawingml/2006/main" xmlns:p="http://schemas.openxmlformats.org/presentationml/2006/main" xmlns:r="http://schemas.openxmlformats.org/officeDocument/2006/relationships" show="0">
   <p:cSld>
     <p:spTree>

</xml_diff>

<commit_message>
feat: WMF → SVG converter + test slide + docs update
Add lightweight WMF (Windows Metafile) to SVG converter following the
same architecture as the existing EMF converter. Supports Standard and
Placeable WMF formats with vector paths, brushes, pens, text, and
embedded bitmaps. Update README to reflect WMF rendering support.

Co-Authored-By: Claude Opus 4.6 <noreply@anthropic.com>
</commit_message>
<xml_diff>
--- a/test_fixtures/test_features.pptx
+++ b/test_fixtures/test_features.pptx
@@ -86,6 +86,7 @@
     <p:sldId id="334" r:id="rId87"/>
     <p:sldId id="335" r:id="rId88"/>
     <p:sldId id="336" r:id="rId89"/>
+    <p:sldId id="337" r:id="rId90"/>
   </p:sldIdLst>
   <p:sldSz cx="9144000" cy="6858000" type="screen4x3"/>
   <p:notesSz cx="6858000" cy="9144000"/>
@@ -20006,6 +20007,48 @@
           </a:p>
         </p:txBody>
       </p:sp>
+    </p:spTree>
+  </p:cSld>
+  <p:clrMapOvr>
+    <a:masterClrMapping/>
+  </p:clrMapOvr>
+</p:sld>
+</file>
+
+<file path=ppt/slides/slide82.xml><?xml version="1.0" encoding="utf-8"?>
+<p:sld xmlns:a="http://schemas.openxmlformats.org/drawingml/2006/main" xmlns:p="http://schemas.openxmlformats.org/presentationml/2006/main" xmlns:r="http://schemas.openxmlformats.org/officeDocument/2006/relationships">
+  <p:cSld>
+    <p:spTree>
+      <p:nvGrpSpPr>
+        <p:cNvPr id="1" name=""/>
+        <p:cNvGrpSpPr/>
+        <p:nvPr/>
+      </p:nvGrpSpPr>
+      <p:grpSpPr/>
+      <p:pic>
+        <p:nvPicPr>
+          <p:cNvPr id="100" name="WMF Picture"/>
+          <p:cNvPicPr>
+            <a:picLocks noChangeAspect="1"/>
+          </p:cNvPicPr>
+          <p:nvPr/>
+        </p:nvPicPr>
+        <p:blipFill>
+          <a:blip r:embed="rWmf1"/>
+          <a:stretch>
+            <a:fillRect/>
+          </a:stretch>
+        </p:blipFill>
+        <p:spPr>
+          <a:xfrm>
+            <a:off x="914400" y="2286000"/>
+            <a:ext cx="4572000" cy="3657600"/>
+          </a:xfrm>
+          <a:prstGeom prst="rect">
+            <a:avLst/>
+          </a:prstGeom>
+        </p:spPr>
+      </p:pic>
     </p:spTree>
   </p:cSld>
   <p:clrMapOvr>

</xml_diff>

<commit_message>
feat: OMML math rendering (fractions, radicals, integrals, matrices, accents → SVG)
Implement visual SVG rendering for OMML math equations, replacing the
previous plain-text fallback. Adds recursive layout engine in
renderer_math.mbt that converts m:oMath XML into positioned SVG elements
with proper baseline alignment and structural notation (fraction bars,
radical signs, large operators, bracket scaling, accent paths).

Supported elements: m:f (fraction), m:sSup/m:sSub/m:sSubSup (scripts),
m:rad (radical), m:nary (∫/Σ/Π), m:d (delimiters), m:acc (accent),
m:m (matrix), m:bar (over/under bar). Round-trip preserved via
data-ooxml-math-xml attribute.

Co-Authored-By: Claude Opus 4.6 <noreply@anthropic.com>
</commit_message>
<xml_diff>
--- a/test_fixtures/test_features.pptx
+++ b/test_fixtures/test_features.pptx
@@ -87,6 +87,9 @@
     <p:sldId id="335" r:id="rId88"/>
     <p:sldId id="336" r:id="rId89"/>
     <p:sldId id="337" r:id="rId90"/>
+    <p:sldId id="338" r:id="rId91"/>
+    <p:sldId id="339" r:id="rId92"/>
+    <p:sldId id="340" r:id="rId93"/>
   </p:sldIdLst>
   <p:sldSz cx="9144000" cy="6858000" type="screen4x3"/>
   <p:notesSz cx="6858000" cy="9144000"/>
@@ -20049,6 +20052,368 @@
           </a:prstGeom>
         </p:spPr>
       </p:pic>
+    </p:spTree>
+  </p:cSld>
+  <p:clrMapOvr>
+    <a:masterClrMapping/>
+  </p:clrMapOvr>
+</p:sld>
+</file>
+
+<file path=ppt/slides/slide83.xml><?xml version="1.0" encoding="utf-8"?>
+<p:sld xmlns:a="http://schemas.openxmlformats.org/drawingml/2006/main" xmlns:p="http://schemas.openxmlformats.org/presentationml/2006/main" xmlns:r="http://schemas.openxmlformats.org/officeDocument/2006/relationships">
+  <p:cSld>
+    <p:spTree>
+      <p:nvGrpSpPr>
+        <p:cNvPr id="1" name=""/>
+        <p:cNvGrpSpPr/>
+        <p:nvPr/>
+      </p:nvGrpSpPr>
+      <p:grpSpPr/>
+      <p:sp>
+        <p:nvSpPr>
+          <p:cNvPr id="2" name="TextBox 1"/>
+          <p:cNvSpPr txBox="1"/>
+          <p:nvPr/>
+        </p:nvSpPr>
+        <p:spPr>
+          <a:xfrm>
+            <a:off x="457200" y="274320"/>
+            <a:ext cx="8229600" cy="731520"/>
+          </a:xfrm>
+          <a:prstGeom prst="rect">
+            <a:avLst/>
+          </a:prstGeom>
+          <a:noFill/>
+        </p:spPr>
+        <p:txBody>
+          <a:bodyPr wrap="none">
+            <a:spAutoFit/>
+          </a:bodyPr>
+          <a:lstStyle/>
+          <a:p>
+            <a:pPr>
+              <a:defRPr sz="2400" b="1"/>
+            </a:pPr>
+            <a:r>
+              <a:t>Slide 82: OMML — Large Operators + Delimiters</a:t>
+            </a:r>
+          </a:p>
+        </p:txBody>
+      </p:sp>
+      <p:sp>
+        <p:nvSpPr>
+          <p:cNvPr id="3" name="TextBox 2"/>
+          <p:cNvSpPr txBox="1"/>
+          <p:nvPr/>
+        </p:nvSpPr>
+        <p:spPr>
+          <a:xfrm>
+            <a:off x="914400" y="1828800"/>
+            <a:ext cx="7315200" cy="2743200"/>
+          </a:xfrm>
+          <a:prstGeom prst="rect">
+            <a:avLst/>
+          </a:prstGeom>
+          <a:noFill/>
+        </p:spPr>
+        <p:txBody>
+          <a:bodyPr wrap="none">
+            <a:spAutoFit/>
+          </a:bodyPr>
+          <a:lstStyle/>
+          <a:p>
+            <a:pPr>
+              <a:defRPr sz="2400"/>
+            </a:pPr>
+            <m:oMathPara xmlns:m="http://schemas.openxmlformats.org/officeDocument/2006/math">
+              <m:oMath>
+                <m:nary>
+                  <m:naryPr>
+                    <m:chr m:val="∫"/>
+                    <m:limLoc m:val="subSup"/>
+                  </m:naryPr>
+                  <m:sub>
+                    <m:r>
+                      <m:t>0</m:t>
+                    </m:r>
+                  </m:sub>
+                  <m:sup>
+                    <m:r>
+                      <m:t>∞</m:t>
+                    </m:r>
+                  </m:sup>
+                  <m:e>
+                    <m:sSup>
+                      <m:e>
+                        <m:r>
+                          <m:t>e</m:t>
+                        </m:r>
+                      </m:e>
+                      <m:sup>
+                        <m:r>
+                          <m:t>-x</m:t>
+                        </m:r>
+                      </m:sup>
+                    </m:sSup>
+                    <m:r>
+                      <m:t>dx</m:t>
+                    </m:r>
+                  </m:e>
+                </m:nary>
+                <m:r>
+                  <m:t>=</m:t>
+                </m:r>
+                <m:r>
+                  <m:t>1</m:t>
+                </m:r>
+              </m:oMath>
+            </m:oMathPara>
+          </a:p>
+        </p:txBody>
+      </p:sp>
+    </p:spTree>
+  </p:cSld>
+  <p:clrMapOvr>
+    <a:masterClrMapping/>
+  </p:clrMapOvr>
+</p:sld>
+</file>
+
+<file path=ppt/slides/slide84.xml><?xml version="1.0" encoding="utf-8"?>
+<p:sld xmlns:a="http://schemas.openxmlformats.org/drawingml/2006/main" xmlns:p="http://schemas.openxmlformats.org/presentationml/2006/main" xmlns:r="http://schemas.openxmlformats.org/officeDocument/2006/relationships">
+  <p:cSld>
+    <p:spTree>
+      <p:nvGrpSpPr>
+        <p:cNvPr id="1" name=""/>
+        <p:cNvGrpSpPr/>
+        <p:nvPr/>
+      </p:nvGrpSpPr>
+      <p:grpSpPr/>
+      <p:sp>
+        <p:nvSpPr>
+          <p:cNvPr id="2" name="TextBox 1"/>
+          <p:cNvSpPr txBox="1"/>
+          <p:nvPr/>
+        </p:nvSpPr>
+        <p:spPr>
+          <a:xfrm>
+            <a:off x="457200" y="274320"/>
+            <a:ext cx="8229600" cy="731520"/>
+          </a:xfrm>
+          <a:prstGeom prst="rect">
+            <a:avLst/>
+          </a:prstGeom>
+          <a:noFill/>
+        </p:spPr>
+        <p:txBody>
+          <a:bodyPr wrap="none">
+            <a:spAutoFit/>
+          </a:bodyPr>
+          <a:lstStyle/>
+          <a:p>
+            <a:pPr>
+              <a:defRPr sz="2400" b="1"/>
+            </a:pPr>
+            <a:r>
+              <a:t>Slide 83: OMML — Matrix + Delimiters</a:t>
+            </a:r>
+          </a:p>
+        </p:txBody>
+      </p:sp>
+      <p:sp>
+        <p:nvSpPr>
+          <p:cNvPr id="3" name="TextBox 2"/>
+          <p:cNvSpPr txBox="1"/>
+          <p:nvPr/>
+        </p:nvSpPr>
+        <p:spPr>
+          <a:xfrm>
+            <a:off x="914400" y="1828800"/>
+            <a:ext cx="7315200" cy="2743200"/>
+          </a:xfrm>
+          <a:prstGeom prst="rect">
+            <a:avLst/>
+          </a:prstGeom>
+          <a:noFill/>
+        </p:spPr>
+        <p:txBody>
+          <a:bodyPr wrap="none">
+            <a:spAutoFit/>
+          </a:bodyPr>
+          <a:lstStyle/>
+          <a:p>
+            <a:pPr>
+              <a:defRPr sz="2400"/>
+            </a:pPr>
+            <m:oMathPara xmlns:m="http://schemas.openxmlformats.org/officeDocument/2006/math">
+              <m:oMath>
+                <m:r>
+                  <m:t>A=</m:t>
+                </m:r>
+                <m:d>
+                  <m:dPr>
+                    <m:begChr m:val="["/>
+                    <m:endChr m:val="]"/>
+                  </m:dPr>
+                  <m:e>
+                    <m:m>
+                      <m:mr>
+                        <m:e>
+                          <m:r>
+                            <m:t>a</m:t>
+                          </m:r>
+                        </m:e>
+                        <m:e>
+                          <m:r>
+                            <m:t>b</m:t>
+                          </m:r>
+                        </m:e>
+                      </m:mr>
+                      <m:mr>
+                        <m:e>
+                          <m:r>
+                            <m:t>c</m:t>
+                          </m:r>
+                        </m:e>
+                        <m:e>
+                          <m:r>
+                            <m:t>d</m:t>
+                          </m:r>
+                        </m:e>
+                      </m:mr>
+                    </m:m>
+                  </m:e>
+                </m:d>
+              </m:oMath>
+            </m:oMathPara>
+          </a:p>
+        </p:txBody>
+      </p:sp>
+    </p:spTree>
+  </p:cSld>
+  <p:clrMapOvr>
+    <a:masterClrMapping/>
+  </p:clrMapOvr>
+</p:sld>
+</file>
+
+<file path=ppt/slides/slide85.xml><?xml version="1.0" encoding="utf-8"?>
+<p:sld xmlns:a="http://schemas.openxmlformats.org/drawingml/2006/main" xmlns:p="http://schemas.openxmlformats.org/presentationml/2006/main" xmlns:r="http://schemas.openxmlformats.org/officeDocument/2006/relationships">
+  <p:cSld>
+    <p:spTree>
+      <p:nvGrpSpPr>
+        <p:cNvPr id="1" name=""/>
+        <p:cNvGrpSpPr/>
+        <p:nvPr/>
+      </p:nvGrpSpPr>
+      <p:grpSpPr/>
+      <p:sp>
+        <p:nvSpPr>
+          <p:cNvPr id="2" name="TextBox 1"/>
+          <p:cNvSpPr txBox="1"/>
+          <p:nvPr/>
+        </p:nvSpPr>
+        <p:spPr>
+          <a:xfrm>
+            <a:off x="457200" y="274320"/>
+            <a:ext cx="8229600" cy="731520"/>
+          </a:xfrm>
+          <a:prstGeom prst="rect">
+            <a:avLst/>
+          </a:prstGeom>
+          <a:noFill/>
+        </p:spPr>
+        <p:txBody>
+          <a:bodyPr wrap="none">
+            <a:spAutoFit/>
+          </a:bodyPr>
+          <a:lstStyle/>
+          <a:p>
+            <a:pPr>
+              <a:defRPr sz="2400" b="1"/>
+            </a:pPr>
+            <a:r>
+              <a:t>Slide 84: OMML — Accent + Bar + SubSup</a:t>
+            </a:r>
+          </a:p>
+        </p:txBody>
+      </p:sp>
+      <p:sp>
+        <p:nvSpPr>
+          <p:cNvPr id="3" name="TextBox 2"/>
+          <p:cNvSpPr txBox="1"/>
+          <p:nvPr/>
+        </p:nvSpPr>
+        <p:spPr>
+          <a:xfrm>
+            <a:off x="914400" y="1828800"/>
+            <a:ext cx="7315200" cy="2743200"/>
+          </a:xfrm>
+          <a:prstGeom prst="rect">
+            <a:avLst/>
+          </a:prstGeom>
+          <a:noFill/>
+        </p:spPr>
+        <p:txBody>
+          <a:bodyPr wrap="none">
+            <a:spAutoFit/>
+          </a:bodyPr>
+          <a:lstStyle/>
+          <a:p>
+            <a:pPr>
+              <a:defRPr sz="2400"/>
+            </a:pPr>
+            <m:oMathPara xmlns:m="http://schemas.openxmlformats.org/officeDocument/2006/math">
+              <m:oMath>
+                <m:acc>
+                  <m:accPr>
+                    <m:chr m:val="̂"/>
+                  </m:accPr>
+                  <m:e>
+                    <m:r>
+                      <m:t>x</m:t>
+                    </m:r>
+                  </m:e>
+                </m:acc>
+                <m:r>
+                  <m:t>=</m:t>
+                </m:r>
+                <m:bar>
+                  <m:barPr>
+                    <m:pos m:val="top"/>
+                  </m:barPr>
+                  <m:e>
+                    <m:r>
+                      <m:t>y</m:t>
+                    </m:r>
+                  </m:e>
+                </m:bar>
+                <m:r>
+                  <m:t>+</m:t>
+                </m:r>
+                <m:sSubSup>
+                  <m:e>
+                    <m:r>
+                      <m:t>z</m:t>
+                    </m:r>
+                  </m:e>
+                  <m:sub>
+                    <m:r>
+                      <m:t>i</m:t>
+                    </m:r>
+                  </m:sub>
+                  <m:sup>
+                    <m:r>
+                      <m:t>n</m:t>
+                    </m:r>
+                  </m:sup>
+                </m:sSubSup>
+              </m:oMath>
+            </m:oMathPara>
+          </a:p>
+        </p:txBody>
+      </p:sp>
     </p:spTree>
   </p:cSld>
   <p:clrMapOvr>

</xml_diff>

<commit_message>
feat: blur effect (a:blur) + test coverage expansion (86→109 tests) + docs update
- Add a:blur effect support across full pipeline (parse→render→SVG data attrs→serialize)
- Add 23 new MoonBit unit tests: effect type constructors, roundtrip tests for
  blur/shadow/glow/softEdge/fill/stroke/geometry/multiple shapes, serializer
  effect output verification, SVG parser effect attribute parsing
- Update README/README.ja: add blur to effects list, add hundredthsToPt/ooxmlToDegrees helpers
- Update svg-specification.md: add blur data attributes (eff-blur-rad, reff-blur-rad)
- Add test slide 85 (blur effect) to gen_test_features.py + test_node.mjs assertions

Co-Authored-By: Claude Opus 4.6 <noreply@anthropic.com>
</commit_message>
<xml_diff>
--- a/test_fixtures/test_features.pptx
+++ b/test_fixtures/test_features.pptx
@@ -90,6 +90,7 @@
     <p:sldId id="338" r:id="rId91"/>
     <p:sldId id="339" r:id="rId92"/>
     <p:sldId id="340" r:id="rId93"/>
+    <p:sldId id="341" r:id="rId94"/>
   </p:sldIdLst>
   <p:sldSz cx="9144000" cy="6858000" type="screen4x3"/>
   <p:notesSz cx="6858000" cy="9144000"/>
@@ -20411,6 +20412,88 @@
                 </m:sSubSup>
               </m:oMath>
             </m:oMathPara>
+          </a:p>
+        </p:txBody>
+      </p:sp>
+    </p:spTree>
+  </p:cSld>
+  <p:clrMapOvr>
+    <a:masterClrMapping/>
+  </p:clrMapOvr>
+</p:sld>
+</file>
+
+<file path=ppt/slides/slide86.xml><?xml version="1.0" encoding="utf-8"?>
+<p:sld xmlns:a="http://schemas.openxmlformats.org/drawingml/2006/main" xmlns:p="http://schemas.openxmlformats.org/presentationml/2006/main" xmlns:r="http://schemas.openxmlformats.org/officeDocument/2006/relationships">
+  <p:cSld>
+    <p:spTree>
+      <p:nvGrpSpPr>
+        <p:cNvPr id="1" name=""/>
+        <p:cNvGrpSpPr/>
+        <p:nvPr/>
+      </p:nvGrpSpPr>
+      <p:grpSpPr/>
+      <p:sp>
+        <p:nvSpPr>
+          <p:cNvPr id="2" name="TextBox 1"/>
+          <p:cNvSpPr txBox="1"/>
+          <p:nvPr/>
+        </p:nvSpPr>
+        <p:spPr>
+          <a:xfrm>
+            <a:off x="457200" y="274320"/>
+            <a:ext cx="8229600" cy="731520"/>
+          </a:xfrm>
+          <a:prstGeom prst="rect">
+            <a:avLst/>
+          </a:prstGeom>
+          <a:noFill/>
+        </p:spPr>
+        <p:txBody>
+          <a:bodyPr wrap="none">
+            <a:spAutoFit/>
+          </a:bodyPr>
+          <a:lstStyle/>
+          <a:p>
+            <a:pPr>
+              <a:defRPr sz="2400" b="1"/>
+            </a:pPr>
+            <a:r>
+              <a:t>Slide 85: Blur Effect (a:blur)</a:t>
+            </a:r>
+          </a:p>
+        </p:txBody>
+      </p:sp>
+      <p:sp xmlns:p="http://schemas.openxmlformats.org/presentationml/2006/main" xmlns:a="http://schemas.openxmlformats.org/drawingml/2006/main" xmlns:r="http://schemas.openxmlformats.org/officeDocument/2006/relationships">
+        <p:nvSpPr>
+          <p:cNvPr id="401" name="BlurShape"/>
+          <p:cNvSpPr/>
+          <p:nvPr/>
+        </p:nvSpPr>
+        <p:spPr>
+          <a:xfrm>
+            <a:off x="1828800" y="1828800"/>
+            <a:ext cx="5486400" cy="2743200"/>
+          </a:xfrm>
+          <a:prstGeom prst="roundRect">
+            <a:avLst/>
+          </a:prstGeom>
+          <a:solidFill>
+            <a:srgbClr val="4472C4"/>
+          </a:solidFill>
+          <a:effectLst>
+            <a:blur rad="76200"/>
+          </a:effectLst>
+        </p:spPr>
+        <p:txBody>
+          <a:bodyPr anchor="ctr"/>
+          <a:lstStyle/>
+          <a:p>
+            <a:pPr algn="ctr"/>
+            <a:r>
+              <a:rPr lang="en-US" sz="2400" b="1"/>
+              <a:t>Blur Effect</a:t>
+            </a:r>
           </a:p>
         </p:txBody>
       </p:sp>

</xml_diff>

<commit_message>
feat: preset shadow (a:prstShdw) + text-level effect round-trip fix
Add preset shadow effect rendering (shdw1-shdw20) with SVG feDropShadow
and CSS drop-shadow. Fix text-level effects round-trip: reff-* data
attributes were emitted but never parsed back by SVG parser, losing
text run effects on round-trip. Extract render_drop_shadow_filter() and
render_css_drop_shadow() helpers to deduplicate shadow rendering code.

Co-Authored-By: Claude Opus 4.6 <noreply@anthropic.com>
</commit_message>
<xml_diff>
--- a/test_fixtures/test_features.pptx
+++ b/test_fixtures/test_features.pptx
@@ -91,6 +91,7 @@
     <p:sldId id="339" r:id="rId92"/>
     <p:sldId id="340" r:id="rId93"/>
     <p:sldId id="341" r:id="rId94"/>
+    <p:sldId id="342" r:id="rId95"/>
   </p:sldIdLst>
   <p:sldSz cx="9144000" cy="6858000" type="screen4x3"/>
   <p:notesSz cx="6858000" cy="9144000"/>
@@ -20493,6 +20494,145 @@
             <a:r>
               <a:rPr lang="en-US" sz="2400" b="1"/>
               <a:t>Blur Effect</a:t>
+            </a:r>
+          </a:p>
+        </p:txBody>
+      </p:sp>
+    </p:spTree>
+  </p:cSld>
+  <p:clrMapOvr>
+    <a:masterClrMapping/>
+  </p:clrMapOvr>
+</p:sld>
+</file>
+
+<file path=ppt/slides/slide87.xml><?xml version="1.0" encoding="utf-8"?>
+<p:sld xmlns:a="http://schemas.openxmlformats.org/drawingml/2006/main" xmlns:p="http://schemas.openxmlformats.org/presentationml/2006/main" xmlns:r="http://schemas.openxmlformats.org/officeDocument/2006/relationships">
+  <p:cSld>
+    <p:bg>
+      <p:bgPr>
+        <a:solidFill>
+          <a:srgbClr val="FFFFFF"/>
+        </a:solidFill>
+        <a:effectLst/>
+      </p:bgPr>
+    </p:bg>
+    <p:spTree>
+      <p:nvGrpSpPr>
+        <p:cNvPr id="1" name=""/>
+        <p:cNvGrpSpPr/>
+        <p:nvPr/>
+      </p:nvGrpSpPr>
+      <p:grpSpPr/>
+      <p:sp>
+        <p:nvSpPr>
+          <p:cNvPr id="2" name="TextBox 1"/>
+          <p:cNvSpPr txBox="1"/>
+          <p:nvPr/>
+        </p:nvSpPr>
+        <p:spPr>
+          <a:xfrm>
+            <a:off x="457200" y="274320"/>
+            <a:ext cx="8229600" cy="731520"/>
+          </a:xfrm>
+          <a:prstGeom prst="rect">
+            <a:avLst/>
+          </a:prstGeom>
+          <a:noFill/>
+        </p:spPr>
+        <p:txBody>
+          <a:bodyPr wrap="none">
+            <a:spAutoFit/>
+          </a:bodyPr>
+          <a:lstStyle/>
+          <a:p>
+            <a:pPr>
+              <a:defRPr sz="2400" b="1"/>
+            </a:pPr>
+            <a:r>
+              <a:t>Slide 86: Preset Shadow (a:prstShdw)</a:t>
+            </a:r>
+          </a:p>
+        </p:txBody>
+      </p:sp>
+      <p:sp xmlns:p="http://schemas.openxmlformats.org/presentationml/2006/main" xmlns:a="http://schemas.openxmlformats.org/drawingml/2006/main" xmlns:r="http://schemas.openxmlformats.org/officeDocument/2006/relationships">
+        <p:nvSpPr>
+          <p:cNvPr id="501" name="PrstShdw1"/>
+          <p:cNvSpPr/>
+          <p:nvPr/>
+        </p:nvSpPr>
+        <p:spPr>
+          <a:xfrm>
+            <a:off x="457200" y="1828800"/>
+            <a:ext cx="3657600" cy="2286000"/>
+          </a:xfrm>
+          <a:prstGeom prst="roundRect">
+            <a:avLst/>
+          </a:prstGeom>
+          <a:solidFill>
+            <a:srgbClr val="4472C4"/>
+          </a:solidFill>
+          <a:effectLst>
+            <a:prstShdw prst="shdw1" dist="76200" dir="2700000">
+              <a:srgbClr val="000000">
+                <a:alpha val="60000"/>
+              </a:srgbClr>
+            </a:prstShdw>
+          </a:effectLst>
+        </p:spPr>
+        <p:txBody>
+          <a:bodyPr anchor="ctr"/>
+          <a:lstStyle/>
+          <a:p>
+            <a:pPr algn="ctr"/>
+            <a:r>
+              <a:rPr lang="en-US" sz="1400" b="1">
+                <a:solidFill>
+                  <a:srgbClr val="FFFFFF"/>
+                </a:solidFill>
+              </a:rPr>
+              <a:t>shdw1 (Bottom Right)</a:t>
+            </a:r>
+          </a:p>
+        </p:txBody>
+      </p:sp>
+      <p:sp xmlns:p="http://schemas.openxmlformats.org/presentationml/2006/main" xmlns:a="http://schemas.openxmlformats.org/drawingml/2006/main" xmlns:r="http://schemas.openxmlformats.org/officeDocument/2006/relationships">
+        <p:nvSpPr>
+          <p:cNvPr id="502" name="PrstShdw2"/>
+          <p:cNvSpPr/>
+          <p:nvPr/>
+        </p:nvSpPr>
+        <p:spPr>
+          <a:xfrm>
+            <a:off x="5029200" y="1828800"/>
+            <a:ext cx="3657600" cy="2286000"/>
+          </a:xfrm>
+          <a:prstGeom prst="roundRect">
+            <a:avLst/>
+          </a:prstGeom>
+          <a:solidFill>
+            <a:srgbClr val="ED7D31"/>
+          </a:solidFill>
+          <a:effectLst>
+            <a:prstShdw prst="shdw2" dist="76200" dir="5400000">
+              <a:srgbClr val="000000">
+                <a:alpha val="60000"/>
+              </a:srgbClr>
+            </a:prstShdw>
+          </a:effectLst>
+        </p:spPr>
+        <p:txBody>
+          <a:bodyPr anchor="ctr"/>
+          <a:lstStyle/>
+          <a:p>
+            <a:pPr algn="ctr"/>
+            <a:r>
+              <a:rPr lang="en-US" sz="1400" b="1">
+                <a:solidFill>
+                  <a:srgbClr val="FFFFFF"/>
+                </a:solidFill>
+              </a:rPr>
+              <a:t>shdw2 (Bottom)</a:t>
             </a:r>
           </a:p>
         </p:txBody>

</xml_diff>

<commit_message>
feat: fill overlay effect (a:fillOverlay) with 5 blend modes
Add fillOverlay support with SVG feFlood+feBlend filter rendering.
Supports over/mult/screen/darken/lighten blend modes. Fix pre-existing
bug in serialize_eff_color using to_hex (AARRGGBB) instead of
to_hex_rgb (RRGGBB) for OOXML srgbClr val attributes.

Co-Authored-By: Claude Opus 4.6 <noreply@anthropic.com>
</commit_message>
<xml_diff>
--- a/test_fixtures/test_features.pptx
+++ b/test_fixtures/test_features.pptx
@@ -92,6 +92,7 @@
     <p:sldId id="340" r:id="rId93"/>
     <p:sldId id="341" r:id="rId94"/>
     <p:sldId id="342" r:id="rId95"/>
+    <p:sldId id="343" r:id="rId96"/>
   </p:sldIdLst>
   <p:sldSz cx="9144000" cy="6858000" type="screen4x3"/>
   <p:notesSz cx="6858000" cy="9144000"/>
@@ -20633,6 +20634,274 @@
                 </a:solidFill>
               </a:rPr>
               <a:t>shdw2 (Bottom)</a:t>
+            </a:r>
+          </a:p>
+        </p:txBody>
+      </p:sp>
+    </p:spTree>
+  </p:cSld>
+  <p:clrMapOvr>
+    <a:masterClrMapping/>
+  </p:clrMapOvr>
+</p:sld>
+</file>
+
+<file path=ppt/slides/slide88.xml><?xml version="1.0" encoding="utf-8"?>
+<p:sld xmlns:a="http://schemas.openxmlformats.org/drawingml/2006/main" xmlns:p="http://schemas.openxmlformats.org/presentationml/2006/main" xmlns:r="http://schemas.openxmlformats.org/officeDocument/2006/relationships">
+  <p:cSld>
+    <p:spTree>
+      <p:nvGrpSpPr>
+        <p:cNvPr id="1" name=""/>
+        <p:cNvGrpSpPr/>
+        <p:nvPr/>
+      </p:nvGrpSpPr>
+      <p:grpSpPr/>
+      <p:sp>
+        <p:nvSpPr>
+          <p:cNvPr id="2" name="TextBox 1"/>
+          <p:cNvSpPr txBox="1"/>
+          <p:nvPr/>
+        </p:nvSpPr>
+        <p:spPr>
+          <a:xfrm>
+            <a:off x="457200" y="274320"/>
+            <a:ext cx="8229600" cy="731520"/>
+          </a:xfrm>
+          <a:prstGeom prst="rect">
+            <a:avLst/>
+          </a:prstGeom>
+          <a:noFill/>
+          <a:effectLst>
+            <a:fillOverlay blend="over">
+              <a:solidFill>
+                <a:srgbClr val="FF0000">
+                  <a:alpha val="50000"/>
+                </a:srgbClr>
+              </a:solidFill>
+            </a:fillOverlay>
+          </a:effectLst>
+        </p:spPr>
+        <p:txBody>
+          <a:bodyPr wrap="none">
+            <a:spAutoFit/>
+          </a:bodyPr>
+          <a:lstStyle/>
+          <a:p>
+            <a:pPr>
+              <a:defRPr sz="2400" b="1"/>
+            </a:pPr>
+            <a:r>
+              <a:t>Slide 87: Fill Overlay (a:fillOverlay)</a:t>
+            </a:r>
+          </a:p>
+        </p:txBody>
+      </p:sp>
+      <p:sp>
+        <p:nvSpPr>
+          <p:cNvPr id="3" name="TextBox 2"/>
+          <p:cNvSpPr txBox="1"/>
+          <p:nvPr/>
+        </p:nvSpPr>
+        <p:spPr>
+          <a:xfrm>
+            <a:off x="457200" y="1371600"/>
+            <a:ext cx="1371600" cy="1371600"/>
+          </a:xfrm>
+          <a:prstGeom prst="rect">
+            <a:avLst/>
+          </a:prstGeom>
+          <a:solidFill>
+            <a:srgbClr val="0000FF"/>
+          </a:solidFill>
+          <a:effectLst>
+            <a:fillOverlay blend="over">
+              <a:solidFill>
+                <a:srgbClr val="FF0000">
+                  <a:alpha val="50000"/>
+                </a:srgbClr>
+              </a:solidFill>
+            </a:fillOverlay>
+          </a:effectLst>
+        </p:spPr>
+        <p:txBody>
+          <a:bodyPr wrap="none">
+            <a:spAutoFit/>
+          </a:bodyPr>
+          <a:lstStyle/>
+          <a:p>
+            <a:pPr>
+              <a:defRPr sz="1400" b="1"/>
+            </a:pPr>
+            <a:r>
+              <a:t>over</a:t>
+            </a:r>
+          </a:p>
+        </p:txBody>
+      </p:sp>
+      <p:sp>
+        <p:nvSpPr>
+          <p:cNvPr id="4" name="TextBox 3"/>
+          <p:cNvSpPr txBox="1"/>
+          <p:nvPr/>
+        </p:nvSpPr>
+        <p:spPr>
+          <a:xfrm>
+            <a:off x="2103120" y="1371600"/>
+            <a:ext cx="1371600" cy="1371600"/>
+          </a:xfrm>
+          <a:prstGeom prst="rect">
+            <a:avLst/>
+          </a:prstGeom>
+          <a:solidFill>
+            <a:srgbClr val="00AA00"/>
+          </a:solidFill>
+          <a:effectLst>
+            <a:fillOverlay blend="mult">
+              <a:solidFill>
+                <a:srgbClr val="FF0000">
+                  <a:alpha val="50000"/>
+                </a:srgbClr>
+              </a:solidFill>
+            </a:fillOverlay>
+          </a:effectLst>
+        </p:spPr>
+        <p:txBody>
+          <a:bodyPr wrap="none">
+            <a:spAutoFit/>
+          </a:bodyPr>
+          <a:lstStyle/>
+          <a:p>
+            <a:pPr>
+              <a:defRPr sz="1400" b="1"/>
+            </a:pPr>
+            <a:r>
+              <a:t>mult</a:t>
+            </a:r>
+          </a:p>
+        </p:txBody>
+      </p:sp>
+      <p:sp>
+        <p:nvSpPr>
+          <p:cNvPr id="5" name="TextBox 4"/>
+          <p:cNvSpPr txBox="1"/>
+          <p:nvPr/>
+        </p:nvSpPr>
+        <p:spPr>
+          <a:xfrm>
+            <a:off x="3749039" y="1371600"/>
+            <a:ext cx="1371600" cy="1371600"/>
+          </a:xfrm>
+          <a:prstGeom prst="rect">
+            <a:avLst/>
+          </a:prstGeom>
+          <a:solidFill>
+            <a:srgbClr val="FF6600"/>
+          </a:solidFill>
+          <a:effectLst>
+            <a:fillOverlay blend="screen">
+              <a:solidFill>
+                <a:srgbClr val="FF0000">
+                  <a:alpha val="50000"/>
+                </a:srgbClr>
+              </a:solidFill>
+            </a:fillOverlay>
+          </a:effectLst>
+        </p:spPr>
+        <p:txBody>
+          <a:bodyPr wrap="none">
+            <a:spAutoFit/>
+          </a:bodyPr>
+          <a:lstStyle/>
+          <a:p>
+            <a:pPr>
+              <a:defRPr sz="1400" b="1"/>
+            </a:pPr>
+            <a:r>
+              <a:t>screen</a:t>
+            </a:r>
+          </a:p>
+        </p:txBody>
+      </p:sp>
+      <p:sp>
+        <p:nvSpPr>
+          <p:cNvPr id="6" name="TextBox 5"/>
+          <p:cNvSpPr txBox="1"/>
+          <p:nvPr/>
+        </p:nvSpPr>
+        <p:spPr>
+          <a:xfrm>
+            <a:off x="5394960" y="1371600"/>
+            <a:ext cx="1371600" cy="1371600"/>
+          </a:xfrm>
+          <a:prstGeom prst="rect">
+            <a:avLst/>
+          </a:prstGeom>
+          <a:solidFill>
+            <a:srgbClr val="8800CC"/>
+          </a:solidFill>
+          <a:effectLst>
+            <a:fillOverlay blend="darken">
+              <a:solidFill>
+                <a:srgbClr val="FF0000">
+                  <a:alpha val="50000"/>
+                </a:srgbClr>
+              </a:solidFill>
+            </a:fillOverlay>
+          </a:effectLst>
+        </p:spPr>
+        <p:txBody>
+          <a:bodyPr wrap="none">
+            <a:spAutoFit/>
+          </a:bodyPr>
+          <a:lstStyle/>
+          <a:p>
+            <a:pPr>
+              <a:defRPr sz="1400" b="1"/>
+            </a:pPr>
+            <a:r>
+              <a:t>darken</a:t>
+            </a:r>
+          </a:p>
+        </p:txBody>
+      </p:sp>
+      <p:sp>
+        <p:nvSpPr>
+          <p:cNvPr id="7" name="TextBox 6"/>
+          <p:cNvSpPr txBox="1"/>
+          <p:nvPr/>
+        </p:nvSpPr>
+        <p:spPr>
+          <a:xfrm>
+            <a:off x="7040880" y="1371600"/>
+            <a:ext cx="1371600" cy="1371600"/>
+          </a:xfrm>
+          <a:prstGeom prst="rect">
+            <a:avLst/>
+          </a:prstGeom>
+          <a:solidFill>
+            <a:srgbClr val="CC0000"/>
+          </a:solidFill>
+          <a:effectLst>
+            <a:fillOverlay blend="lighten">
+              <a:solidFill>
+                <a:srgbClr val="FF0000">
+                  <a:alpha val="50000"/>
+                </a:srgbClr>
+              </a:solidFill>
+            </a:fillOverlay>
+          </a:effectLst>
+        </p:spPr>
+        <p:txBody>
+          <a:bodyPr wrap="none">
+            <a:spAutoFit/>
+          </a:bodyPr>
+          <a:lstStyle/>
+          <a:p>
+            <a:pPr>
+              <a:defRPr sz="1400" b="1"/>
+            </a:pPr>
+            <a:r>
+              <a:t>lighten</a:t>
             </a:r>
           </a:p>
         </p:txBody>

</xml_diff>

<commit_message>
feat: justified text (algn="just") with word-spacing distribution
Implement SVG justify approximation since SVG has no native justify support.
Distributes extra space via word-spacing for Latin text and letter-spacing
for CJK text (no spaces). Only applies to non-last wrapped lines.

Co-Authored-By: Claude Opus 4.6 <noreply@anthropic.com>
</commit_message>
<xml_diff>
--- a/test_fixtures/test_features.pptx
+++ b/test_fixtures/test_features.pptx
@@ -93,6 +93,7 @@
     <p:sldId id="341" r:id="rId94"/>
     <p:sldId id="342" r:id="rId95"/>
     <p:sldId id="343" r:id="rId96"/>
+    <p:sldId id="344" r:id="rId97"/>
   </p:sldIdLst>
   <p:sldSz cx="9144000" cy="6858000" type="screen4x3"/>
   <p:notesSz cx="6858000" cy="9144000"/>
@@ -20902,6 +20903,125 @@
             </a:pPr>
             <a:r>
               <a:t>lighten</a:t>
+            </a:r>
+          </a:p>
+        </p:txBody>
+      </p:sp>
+    </p:spTree>
+  </p:cSld>
+  <p:clrMapOvr>
+    <a:masterClrMapping/>
+  </p:clrMapOvr>
+</p:sld>
+</file>
+
+<file path=ppt/slides/slide89.xml><?xml version="1.0" encoding="utf-8"?>
+<p:sld xmlns:a="http://schemas.openxmlformats.org/drawingml/2006/main" xmlns:p="http://schemas.openxmlformats.org/presentationml/2006/main" xmlns:r="http://schemas.openxmlformats.org/officeDocument/2006/relationships">
+  <p:cSld>
+    <p:spTree>
+      <p:nvGrpSpPr>
+        <p:cNvPr id="1" name=""/>
+        <p:cNvGrpSpPr/>
+        <p:nvPr/>
+      </p:nvGrpSpPr>
+      <p:grpSpPr/>
+      <p:sp>
+        <p:nvSpPr>
+          <p:cNvPr id="2" name="TextBox 1"/>
+          <p:cNvSpPr txBox="1"/>
+          <p:nvPr/>
+        </p:nvSpPr>
+        <p:spPr>
+          <a:xfrm>
+            <a:off x="457200" y="274320"/>
+            <a:ext cx="8229600" cy="731520"/>
+          </a:xfrm>
+          <a:prstGeom prst="rect">
+            <a:avLst/>
+          </a:prstGeom>
+          <a:noFill/>
+        </p:spPr>
+        <p:txBody>
+          <a:bodyPr wrap="none">
+            <a:spAutoFit/>
+          </a:bodyPr>
+          <a:lstStyle/>
+          <a:p>
+            <a:pPr>
+              <a:defRPr sz="2400" b="1"/>
+            </a:pPr>
+            <a:r>
+              <a:t>Slide 88: Justified Text (algn="just")</a:t>
+            </a:r>
+          </a:p>
+        </p:txBody>
+      </p:sp>
+      <p:sp>
+        <p:nvSpPr>
+          <p:cNvPr id="3" name="TextBox 2"/>
+          <p:cNvSpPr txBox="1"/>
+          <p:nvPr/>
+        </p:nvSpPr>
+        <p:spPr>
+          <a:xfrm>
+            <a:off x="914400" y="1371600"/>
+            <a:ext cx="4572000" cy="2743200"/>
+          </a:xfrm>
+          <a:prstGeom prst="rect">
+            <a:avLst/>
+          </a:prstGeom>
+          <a:noFill/>
+        </p:spPr>
+        <p:txBody>
+          <a:bodyPr wrap="square">
+            <a:spAutoFit/>
+          </a:bodyPr>
+          <a:lstStyle/>
+          <a:p>
+            <a:pPr algn="just">
+              <a:defRPr sz="1600"/>
+            </a:pPr>
+            <a:r>
+              <a:t>This is a justified paragraph with enough text to wrap across multiple lines. The word spacing should be adjusted so that each line extends to fill the full width of the text box evenly.</a:t>
+            </a:r>
+          </a:p>
+          <a:p>
+            <a:pPr algn="just">
+              <a:defRPr sz="1600"/>
+            </a:pPr>
+            <a:r>
+              <a:t>Short last line.</a:t>
+            </a:r>
+          </a:p>
+        </p:txBody>
+      </p:sp>
+      <p:sp>
+        <p:nvSpPr>
+          <p:cNvPr id="4" name="TextBox 3"/>
+          <p:cNvSpPr txBox="1"/>
+          <p:nvPr/>
+        </p:nvSpPr>
+        <p:spPr>
+          <a:xfrm>
+            <a:off x="914400" y="4572000"/>
+            <a:ext cx="4572000" cy="1828800"/>
+          </a:xfrm>
+          <a:prstGeom prst="rect">
+            <a:avLst/>
+          </a:prstGeom>
+          <a:noFill/>
+        </p:spPr>
+        <p:txBody>
+          <a:bodyPr wrap="square">
+            <a:spAutoFit/>
+          </a:bodyPr>
+          <a:lstStyle/>
+          <a:p>
+            <a:pPr algn="just">
+              <a:defRPr sz="1600"/>
+            </a:pPr>
+            <a:r>
+              <a:t>均等割り付けのテスト文章です。日本語テキストはスペースがないため文字間隔で調整されます。</a:t>
             </a:r>
           </a:p>
         </p:txBody>

</xml_diff>

<commit_message>
feat: Office 2016+ cx:chart rendering (waterfall, treemap, sunburst, histogram, box & whisker, funnel)
Add full parsing and SVG rendering for 6 Office 2016+ chart types using the
cx:chartSpace XML schema (MS-ODRAWXML). Includes cx:chart detection in
graphic frames, chartex XML parser with hierarchical data support, and
dedicated renderers for each chart type. Constants extracted for chart
layout parameters, 11 new unit tests added, integration test fixtures
updated with 6 new slides (89-94).

Co-Authored-By: Claude Opus 4.6 <noreply@anthropic.com>
</commit_message>
<xml_diff>
--- a/test_fixtures/test_features.pptx
+++ b/test_fixtures/test_features.pptx
@@ -94,6 +94,12 @@
     <p:sldId id="342" r:id="rId95"/>
     <p:sldId id="343" r:id="rId96"/>
     <p:sldId id="344" r:id="rId97"/>
+    <p:sldId id="345" r:id="rId98"/>
+    <p:sldId id="346" r:id="rId99"/>
+    <p:sldId id="347" r:id="rId100"/>
+    <p:sldId id="348" r:id="rId101"/>
+    <p:sldId id="349" r:id="rId102"/>
+    <p:sldId id="350" r:id="rId103"/>
   </p:sldIdLst>
   <p:sldSz cx="9144000" cy="6858000" type="screen4x3"/>
   <p:notesSz cx="6858000" cy="9144000"/>
@@ -4582,6 +4588,225 @@
     <c:autoUpdate val="0"/>
   </c:externalData>
 </c:chartSpace>
+</file>
+
+<file path=ppt/charts/chartEx1.xml><?xml version="1.0" encoding="utf-8"?>
+<cx:chartSpace xmlns:cx="http://schemas.microsoft.com/office/drawing/2014/chartex" xmlns:a="http://schemas.openxmlformats.org/drawingml/2006/main" xmlns:r="http://schemas.openxmlformats.org/officeDocument/2006/relationships">
+  <cx:chartData>
+    <cx:data id="0">
+      <cx:strDim type="cat">
+        <cx:lvl ptCount="5">
+          <cx:pt idx="0">Q1</cx:pt>
+          <cx:pt idx="1">Q2</cx:pt>
+          <cx:pt idx="2">Q3</cx:pt>
+          <cx:pt idx="3">Q4</cx:pt>
+          <cx:pt idx="4">Total</cx:pt>
+        </cx:lvl>
+      </cx:strDim>
+      <cx:numDim type="val">
+        <cx:lvl ptCount="5" formatCode="General">
+          <cx:pt idx="0">100</cx:pt>
+          <cx:pt idx="1">-20</cx:pt>
+          <cx:pt idx="2">50</cx:pt>
+          <cx:pt idx="3">-10</cx:pt>
+          <cx:pt idx="4">120</cx:pt>
+        </cx:lvl>
+      </cx:numDim>
+    </cx:data>
+  </cx:chartData>
+  <cx:chart>
+    <cx:plotArea>
+      <cx:plotAreaRegion>
+        <cx:series layoutId="waterfall">
+          <cx:dataId val="0"/>
+          <cx:layoutPr>
+            <cx:subtotals>
+              <cx:idx val="4"/>
+            </cx:subtotals>
+          </cx:layoutPr>
+        </cx:series>
+      </cx:plotAreaRegion>
+    </cx:plotArea>
+  </cx:chart>
+</cx:chartSpace>
+</file>
+
+<file path=ppt/charts/chartEx2.xml><?xml version="1.0" encoding="utf-8"?>
+<cx:chartSpace xmlns:cx="http://schemas.microsoft.com/office/drawing/2014/chartex" xmlns:a="http://schemas.openxmlformats.org/drawingml/2006/main">
+  <cx:chartData>
+    <cx:data id="0">
+      <cx:strDim type="cat">
+        <cx:lvl ptCount="5">
+          <cx:pt idx="0">Product A</cx:pt>
+          <cx:pt idx="1">Product B</cx:pt>
+          <cx:pt idx="2">Product C</cx:pt>
+          <cx:pt idx="3">Product D</cx:pt>
+          <cx:pt idx="4">Product E</cx:pt>
+        </cx:lvl>
+      </cx:strDim>
+      <cx:numDim type="val">
+        <cx:lvl ptCount="5">
+          <cx:pt idx="0">50</cx:pt>
+          <cx:pt idx="1">30</cx:pt>
+          <cx:pt idx="2">20</cx:pt>
+          <cx:pt idx="3">15</cx:pt>
+          <cx:pt idx="4">10</cx:pt>
+        </cx:lvl>
+      </cx:numDim>
+    </cx:data>
+  </cx:chartData>
+  <cx:chart>
+    <cx:plotArea>
+      <cx:plotAreaRegion>
+        <cx:series layoutId="treemap">
+          <cx:dataId val="0"/>
+        </cx:series>
+      </cx:plotAreaRegion>
+    </cx:plotArea>
+  </cx:chart>
+</cx:chartSpace>
+</file>
+
+<file path=ppt/charts/chartEx3.xml><?xml version="1.0" encoding="utf-8"?>
+<cx:chartSpace xmlns:cx="http://schemas.microsoft.com/office/drawing/2014/chartex" xmlns:a="http://schemas.openxmlformats.org/drawingml/2006/main">
+  <cx:chartData>
+    <cx:data id="0">
+      <cx:strDim type="cat">
+        <cx:lvl ptCount="4">
+          <cx:pt idx="0">North</cx:pt>
+          <cx:pt idx="1">South</cx:pt>
+          <cx:pt idx="2">East</cx:pt>
+          <cx:pt idx="3">West</cx:pt>
+        </cx:lvl>
+      </cx:strDim>
+      <cx:numDim type="val">
+        <cx:lvl ptCount="4">
+          <cx:pt idx="0">40</cx:pt>
+          <cx:pt idx="1">30</cx:pt>
+          <cx:pt idx="2">20</cx:pt>
+          <cx:pt idx="3">10</cx:pt>
+        </cx:lvl>
+      </cx:numDim>
+    </cx:data>
+  </cx:chartData>
+  <cx:chart>
+    <cx:plotArea>
+      <cx:plotAreaRegion>
+        <cx:series layoutId="sunburst">
+          <cx:dataId val="0"/>
+        </cx:series>
+      </cx:plotAreaRegion>
+    </cx:plotArea>
+  </cx:chart>
+</cx:chartSpace>
+</file>
+
+<file path=ppt/charts/chartEx4.xml><?xml version="1.0" encoding="utf-8"?>
+<cx:chartSpace xmlns:cx="http://schemas.microsoft.com/office/drawing/2014/chartex" xmlns:a="http://schemas.openxmlformats.org/drawingml/2006/main">
+  <cx:chartData>
+    <cx:data id="0">
+      <cx:strDim type="cat">
+        <cx:lvl ptCount="5">
+          <cx:pt idx="0">0-20</cx:pt>
+          <cx:pt idx="1">20-40</cx:pt>
+          <cx:pt idx="2">40-60</cx:pt>
+          <cx:pt idx="3">60-80</cx:pt>
+          <cx:pt idx="4">80-100</cx:pt>
+        </cx:lvl>
+      </cx:strDim>
+      <cx:numDim type="val">
+        <cx:lvl ptCount="5">
+          <cx:pt idx="0">5</cx:pt>
+          <cx:pt idx="1">15</cx:pt>
+          <cx:pt idx="2">25</cx:pt>
+          <cx:pt idx="3">12</cx:pt>
+          <cx:pt idx="4">8</cx:pt>
+        </cx:lvl>
+      </cx:numDim>
+    </cx:data>
+  </cx:chartData>
+  <cx:chart>
+    <cx:plotArea>
+      <cx:plotAreaRegion>
+        <cx:series layoutId="clusteredColumn">
+          <cx:dataId val="0"/>
+        </cx:series>
+      </cx:plotAreaRegion>
+    </cx:plotArea>
+  </cx:chart>
+</cx:chartSpace>
+</file>
+
+<file path=ppt/charts/chartEx5.xml><?xml version="1.0" encoding="utf-8"?>
+<cx:chartSpace xmlns:cx="http://schemas.microsoft.com/office/drawing/2014/chartex" xmlns:a="http://schemas.openxmlformats.org/drawingml/2006/main">
+  <cx:chartData>
+    <cx:data id="0">
+      <cx:strDim type="cat">
+        <cx:lvl ptCount="1">
+          <cx:pt idx="0">Dataset</cx:pt>
+        </cx:lvl>
+      </cx:strDim>
+      <cx:numDim type="val">
+        <cx:lvl ptCount="10">
+          <cx:pt idx="0">12</cx:pt>
+          <cx:pt idx="1">15</cx:pt>
+          <cx:pt idx="2">18</cx:pt>
+          <cx:pt idx="3">22</cx:pt>
+          <cx:pt idx="4">25</cx:pt>
+          <cx:pt idx="5">28</cx:pt>
+          <cx:pt idx="6">30</cx:pt>
+          <cx:pt idx="7">35</cx:pt>
+          <cx:pt idx="8">40</cx:pt>
+          <cx:pt idx="9">45</cx:pt>
+        </cx:lvl>
+      </cx:numDim>
+    </cx:data>
+  </cx:chartData>
+  <cx:chart>
+    <cx:plotArea>
+      <cx:plotAreaRegion>
+        <cx:series layoutId="boxWhisker">
+          <cx:dataId val="0"/>
+        </cx:series>
+      </cx:plotAreaRegion>
+    </cx:plotArea>
+  </cx:chart>
+</cx:chartSpace>
+</file>
+
+<file path=ppt/charts/chartEx6.xml><?xml version="1.0" encoding="utf-8"?>
+<cx:chartSpace xmlns:cx="http://schemas.microsoft.com/office/drawing/2014/chartex" xmlns:a="http://schemas.openxmlformats.org/drawingml/2006/main">
+  <cx:chartData>
+    <cx:data id="0">
+      <cx:strDim type="cat">
+        <cx:lvl ptCount="4">
+          <cx:pt idx="0">Prospects</cx:pt>
+          <cx:pt idx="1">Qualified</cx:pt>
+          <cx:pt idx="2">Proposals</cx:pt>
+          <cx:pt idx="3">Closed</cx:pt>
+        </cx:lvl>
+      </cx:strDim>
+      <cx:numDim type="val">
+        <cx:lvl ptCount="4">
+          <cx:pt idx="0">1000</cx:pt>
+          <cx:pt idx="1">600</cx:pt>
+          <cx:pt idx="2">300</cx:pt>
+          <cx:pt idx="3">100</cx:pt>
+        </cx:lvl>
+      </cx:numDim>
+    </cx:data>
+  </cx:chartData>
+  <cx:chart>
+    <cx:plotArea>
+      <cx:plotAreaRegion>
+        <cx:series layoutId="funnel">
+          <cx:dataId val="0"/>
+        </cx:series>
+      </cx:plotAreaRegion>
+    </cx:plotArea>
+    <cx:legend pos="r"/>
+  </cx:chart>
+</cx:chartSpace>
 </file>
 
 <file path=ppt/comments/comment75.xml><?xml version="1.0" encoding="utf-8"?>
@@ -21196,6 +21421,408 @@
           </a:p>
         </p:txBody>
       </p:sp>
+    </p:spTree>
+  </p:cSld>
+  <p:clrMapOvr>
+    <a:masterClrMapping/>
+  </p:clrMapOvr>
+</p:sld>
+</file>
+
+<file path=ppt/slides/slide90.xml><?xml version="1.0" encoding="utf-8"?>
+<p:sld xmlns:a="http://schemas.openxmlformats.org/drawingml/2006/main" xmlns:p="http://schemas.openxmlformats.org/presentationml/2006/main" xmlns:r="http://schemas.openxmlformats.org/officeDocument/2006/relationships">
+  <p:cSld>
+    <p:spTree>
+      <p:nvGrpSpPr>
+        <p:cNvPr id="1" name=""/>
+        <p:cNvGrpSpPr/>
+        <p:nvPr/>
+      </p:nvGrpSpPr>
+      <p:grpSpPr/>
+      <p:sp>
+        <p:nvSpPr>
+          <p:cNvPr id="2" name="TextBox 1"/>
+          <p:cNvSpPr txBox="1"/>
+          <p:nvPr/>
+        </p:nvSpPr>
+        <p:spPr>
+          <a:xfrm>
+            <a:off x="457200" y="274320"/>
+            <a:ext cx="8229600" cy="731520"/>
+          </a:xfrm>
+          <a:prstGeom prst="rect">
+            <a:avLst/>
+          </a:prstGeom>
+          <a:noFill/>
+        </p:spPr>
+        <p:txBody>
+          <a:bodyPr wrap="none">
+            <a:spAutoFit/>
+          </a:bodyPr>
+          <a:lstStyle/>
+          <a:p>
+            <a:pPr>
+              <a:defRPr sz="1800" b="1"/>
+            </a:pPr>
+            <a:r>
+              <a:t>Slide 89: Waterfall Chart (cx:chart)</a:t>
+            </a:r>
+          </a:p>
+        </p:txBody>
+      </p:sp>
+      <p:graphicFrame>
+        <p:nvGraphicFramePr>
+          <p:cNvPr id="990" name="ChartEx 1"/>
+          <p:cNvGraphicFramePr>
+            <a:graphicFrameLocks noGrp="1"/>
+          </p:cNvGraphicFramePr>
+          <p:nvPr/>
+        </p:nvGraphicFramePr>
+        <p:xfrm>
+          <a:off x="914400" y="1371600"/>
+          <a:ext cx="7315200" cy="4572000"/>
+        </p:xfrm>
+        <a:graphic>
+          <a:graphicData uri="http://schemas.microsoft.com/office/drawing/2014/chartex">
+            <cx:chart xmlns:cx="http://schemas.microsoft.com/office/drawing/2014/chartex" xmlns:r="http://schemas.openxmlformats.org/officeDocument/2006/relationships" r:id="rIdCx1"/>
+          </a:graphicData>
+        </a:graphic>
+      </p:graphicFrame>
+    </p:spTree>
+  </p:cSld>
+  <p:clrMapOvr>
+    <a:masterClrMapping/>
+  </p:clrMapOvr>
+</p:sld>
+</file>
+
+<file path=ppt/slides/slide91.xml><?xml version="1.0" encoding="utf-8"?>
+<p:sld xmlns:a="http://schemas.openxmlformats.org/drawingml/2006/main" xmlns:p="http://schemas.openxmlformats.org/presentationml/2006/main" xmlns:r="http://schemas.openxmlformats.org/officeDocument/2006/relationships">
+  <p:cSld>
+    <p:spTree>
+      <p:nvGrpSpPr>
+        <p:cNvPr id="1" name=""/>
+        <p:cNvGrpSpPr/>
+        <p:nvPr/>
+      </p:nvGrpSpPr>
+      <p:grpSpPr/>
+      <p:sp>
+        <p:nvSpPr>
+          <p:cNvPr id="2" name="TextBox 1"/>
+          <p:cNvSpPr txBox="1"/>
+          <p:nvPr/>
+        </p:nvSpPr>
+        <p:spPr>
+          <a:xfrm>
+            <a:off x="457200" y="274320"/>
+            <a:ext cx="8229600" cy="731520"/>
+          </a:xfrm>
+          <a:prstGeom prst="rect">
+            <a:avLst/>
+          </a:prstGeom>
+          <a:noFill/>
+        </p:spPr>
+        <p:txBody>
+          <a:bodyPr wrap="none">
+            <a:spAutoFit/>
+          </a:bodyPr>
+          <a:lstStyle/>
+          <a:p>
+            <a:pPr>
+              <a:defRPr sz="1800" b="1"/>
+            </a:pPr>
+            <a:r>
+              <a:t>Slide 90: Treemap Chart (cx:chart)</a:t>
+            </a:r>
+          </a:p>
+        </p:txBody>
+      </p:sp>
+      <p:graphicFrame>
+        <p:nvGraphicFramePr>
+          <p:cNvPr id="991" name="ChartEx 2"/>
+          <p:cNvGraphicFramePr>
+            <a:graphicFrameLocks noGrp="1"/>
+          </p:cNvGraphicFramePr>
+          <p:nvPr/>
+        </p:nvGraphicFramePr>
+        <p:xfrm>
+          <a:off x="914400" y="1371600"/>
+          <a:ext cx="7315200" cy="4572000"/>
+        </p:xfrm>
+        <a:graphic>
+          <a:graphicData uri="http://schemas.microsoft.com/office/drawing/2014/chartex">
+            <cx:chart xmlns:cx="http://schemas.microsoft.com/office/drawing/2014/chartex" xmlns:r="http://schemas.openxmlformats.org/officeDocument/2006/relationships" r:id="rIdCx2"/>
+          </a:graphicData>
+        </a:graphic>
+      </p:graphicFrame>
+    </p:spTree>
+  </p:cSld>
+  <p:clrMapOvr>
+    <a:masterClrMapping/>
+  </p:clrMapOvr>
+</p:sld>
+</file>
+
+<file path=ppt/slides/slide92.xml><?xml version="1.0" encoding="utf-8"?>
+<p:sld xmlns:a="http://schemas.openxmlformats.org/drawingml/2006/main" xmlns:p="http://schemas.openxmlformats.org/presentationml/2006/main" xmlns:r="http://schemas.openxmlformats.org/officeDocument/2006/relationships">
+  <p:cSld>
+    <p:spTree>
+      <p:nvGrpSpPr>
+        <p:cNvPr id="1" name=""/>
+        <p:cNvGrpSpPr/>
+        <p:nvPr/>
+      </p:nvGrpSpPr>
+      <p:grpSpPr/>
+      <p:sp>
+        <p:nvSpPr>
+          <p:cNvPr id="2" name="TextBox 1"/>
+          <p:cNvSpPr txBox="1"/>
+          <p:nvPr/>
+        </p:nvSpPr>
+        <p:spPr>
+          <a:xfrm>
+            <a:off x="457200" y="274320"/>
+            <a:ext cx="8229600" cy="731520"/>
+          </a:xfrm>
+          <a:prstGeom prst="rect">
+            <a:avLst/>
+          </a:prstGeom>
+          <a:noFill/>
+        </p:spPr>
+        <p:txBody>
+          <a:bodyPr wrap="none">
+            <a:spAutoFit/>
+          </a:bodyPr>
+          <a:lstStyle/>
+          <a:p>
+            <a:pPr>
+              <a:defRPr sz="1800" b="1"/>
+            </a:pPr>
+            <a:r>
+              <a:t>Slide 91: Sunburst Chart (cx:chart)</a:t>
+            </a:r>
+          </a:p>
+        </p:txBody>
+      </p:sp>
+      <p:graphicFrame>
+        <p:nvGraphicFramePr>
+          <p:cNvPr id="992" name="ChartEx 3"/>
+          <p:cNvGraphicFramePr>
+            <a:graphicFrameLocks noGrp="1"/>
+          </p:cNvGraphicFramePr>
+          <p:nvPr/>
+        </p:nvGraphicFramePr>
+        <p:xfrm>
+          <a:off x="914400" y="1371600"/>
+          <a:ext cx="7315200" cy="4572000"/>
+        </p:xfrm>
+        <a:graphic>
+          <a:graphicData uri="http://schemas.microsoft.com/office/drawing/2014/chartex">
+            <cx:chart xmlns:cx="http://schemas.microsoft.com/office/drawing/2014/chartex" xmlns:r="http://schemas.openxmlformats.org/officeDocument/2006/relationships" r:id="rIdCx3"/>
+          </a:graphicData>
+        </a:graphic>
+      </p:graphicFrame>
+    </p:spTree>
+  </p:cSld>
+  <p:clrMapOvr>
+    <a:masterClrMapping/>
+  </p:clrMapOvr>
+</p:sld>
+</file>
+
+<file path=ppt/slides/slide93.xml><?xml version="1.0" encoding="utf-8"?>
+<p:sld xmlns:a="http://schemas.openxmlformats.org/drawingml/2006/main" xmlns:p="http://schemas.openxmlformats.org/presentationml/2006/main" xmlns:r="http://schemas.openxmlformats.org/officeDocument/2006/relationships">
+  <p:cSld>
+    <p:spTree>
+      <p:nvGrpSpPr>
+        <p:cNvPr id="1" name=""/>
+        <p:cNvGrpSpPr/>
+        <p:nvPr/>
+      </p:nvGrpSpPr>
+      <p:grpSpPr/>
+      <p:sp>
+        <p:nvSpPr>
+          <p:cNvPr id="2" name="TextBox 1"/>
+          <p:cNvSpPr txBox="1"/>
+          <p:nvPr/>
+        </p:nvSpPr>
+        <p:spPr>
+          <a:xfrm>
+            <a:off x="457200" y="274320"/>
+            <a:ext cx="8229600" cy="731520"/>
+          </a:xfrm>
+          <a:prstGeom prst="rect">
+            <a:avLst/>
+          </a:prstGeom>
+          <a:noFill/>
+        </p:spPr>
+        <p:txBody>
+          <a:bodyPr wrap="none">
+            <a:spAutoFit/>
+          </a:bodyPr>
+          <a:lstStyle/>
+          <a:p>
+            <a:pPr>
+              <a:defRPr sz="1800" b="1"/>
+            </a:pPr>
+            <a:r>
+              <a:t>Slide 92: Histogram Chart (cx:chart)</a:t>
+            </a:r>
+          </a:p>
+        </p:txBody>
+      </p:sp>
+      <p:graphicFrame>
+        <p:nvGraphicFramePr>
+          <p:cNvPr id="993" name="ChartEx 4"/>
+          <p:cNvGraphicFramePr>
+            <a:graphicFrameLocks noGrp="1"/>
+          </p:cNvGraphicFramePr>
+          <p:nvPr/>
+        </p:nvGraphicFramePr>
+        <p:xfrm>
+          <a:off x="914400" y="1371600"/>
+          <a:ext cx="7315200" cy="4572000"/>
+        </p:xfrm>
+        <a:graphic>
+          <a:graphicData uri="http://schemas.microsoft.com/office/drawing/2014/chartex">
+            <cx:chart xmlns:cx="http://schemas.microsoft.com/office/drawing/2014/chartex" xmlns:r="http://schemas.openxmlformats.org/officeDocument/2006/relationships" r:id="rIdCx4"/>
+          </a:graphicData>
+        </a:graphic>
+      </p:graphicFrame>
+    </p:spTree>
+  </p:cSld>
+  <p:clrMapOvr>
+    <a:masterClrMapping/>
+  </p:clrMapOvr>
+</p:sld>
+</file>
+
+<file path=ppt/slides/slide94.xml><?xml version="1.0" encoding="utf-8"?>
+<p:sld xmlns:a="http://schemas.openxmlformats.org/drawingml/2006/main" xmlns:p="http://schemas.openxmlformats.org/presentationml/2006/main" xmlns:r="http://schemas.openxmlformats.org/officeDocument/2006/relationships">
+  <p:cSld>
+    <p:spTree>
+      <p:nvGrpSpPr>
+        <p:cNvPr id="1" name=""/>
+        <p:cNvGrpSpPr/>
+        <p:nvPr/>
+      </p:nvGrpSpPr>
+      <p:grpSpPr/>
+      <p:sp>
+        <p:nvSpPr>
+          <p:cNvPr id="2" name="TextBox 1"/>
+          <p:cNvSpPr txBox="1"/>
+          <p:nvPr/>
+        </p:nvSpPr>
+        <p:spPr>
+          <a:xfrm>
+            <a:off x="457200" y="274320"/>
+            <a:ext cx="8229600" cy="731520"/>
+          </a:xfrm>
+          <a:prstGeom prst="rect">
+            <a:avLst/>
+          </a:prstGeom>
+          <a:noFill/>
+        </p:spPr>
+        <p:txBody>
+          <a:bodyPr wrap="none">
+            <a:spAutoFit/>
+          </a:bodyPr>
+          <a:lstStyle/>
+          <a:p>
+            <a:pPr>
+              <a:defRPr sz="1800" b="1"/>
+            </a:pPr>
+            <a:r>
+              <a:t>Slide 93: Box &amp; Whisker Chart (cx:chart)</a:t>
+            </a:r>
+          </a:p>
+        </p:txBody>
+      </p:sp>
+      <p:graphicFrame>
+        <p:nvGraphicFramePr>
+          <p:cNvPr id="994" name="ChartEx 5"/>
+          <p:cNvGraphicFramePr>
+            <a:graphicFrameLocks noGrp="1"/>
+          </p:cNvGraphicFramePr>
+          <p:nvPr/>
+        </p:nvGraphicFramePr>
+        <p:xfrm>
+          <a:off x="914400" y="1371600"/>
+          <a:ext cx="7315200" cy="4572000"/>
+        </p:xfrm>
+        <a:graphic>
+          <a:graphicData uri="http://schemas.microsoft.com/office/drawing/2014/chartex">
+            <cx:chart xmlns:cx="http://schemas.microsoft.com/office/drawing/2014/chartex" xmlns:r="http://schemas.openxmlformats.org/officeDocument/2006/relationships" r:id="rIdCx5"/>
+          </a:graphicData>
+        </a:graphic>
+      </p:graphicFrame>
+    </p:spTree>
+  </p:cSld>
+  <p:clrMapOvr>
+    <a:masterClrMapping/>
+  </p:clrMapOvr>
+</p:sld>
+</file>
+
+<file path=ppt/slides/slide95.xml><?xml version="1.0" encoding="utf-8"?>
+<p:sld xmlns:a="http://schemas.openxmlformats.org/drawingml/2006/main" xmlns:p="http://schemas.openxmlformats.org/presentationml/2006/main" xmlns:r="http://schemas.openxmlformats.org/officeDocument/2006/relationships">
+  <p:cSld>
+    <p:spTree>
+      <p:nvGrpSpPr>
+        <p:cNvPr id="1" name=""/>
+        <p:cNvGrpSpPr/>
+        <p:nvPr/>
+      </p:nvGrpSpPr>
+      <p:grpSpPr/>
+      <p:sp>
+        <p:nvSpPr>
+          <p:cNvPr id="2" name="TextBox 1"/>
+          <p:cNvSpPr txBox="1"/>
+          <p:nvPr/>
+        </p:nvSpPr>
+        <p:spPr>
+          <a:xfrm>
+            <a:off x="457200" y="274320"/>
+            <a:ext cx="8229600" cy="731520"/>
+          </a:xfrm>
+          <a:prstGeom prst="rect">
+            <a:avLst/>
+          </a:prstGeom>
+          <a:noFill/>
+        </p:spPr>
+        <p:txBody>
+          <a:bodyPr wrap="none">
+            <a:spAutoFit/>
+          </a:bodyPr>
+          <a:lstStyle/>
+          <a:p>
+            <a:pPr>
+              <a:defRPr sz="1800" b="1"/>
+            </a:pPr>
+            <a:r>
+              <a:t>Slide 94: Funnel Chart (cx:chart)</a:t>
+            </a:r>
+          </a:p>
+        </p:txBody>
+      </p:sp>
+      <p:graphicFrame>
+        <p:nvGraphicFramePr>
+          <p:cNvPr id="995" name="ChartEx 6"/>
+          <p:cNvGraphicFramePr>
+            <a:graphicFrameLocks noGrp="1"/>
+          </p:cNvGraphicFramePr>
+          <p:nvPr/>
+        </p:nvGraphicFramePr>
+        <p:xfrm>
+          <a:off x="914400" y="1371600"/>
+          <a:ext cx="7315200" cy="4572000"/>
+        </p:xfrm>
+        <a:graphic>
+          <a:graphicData uri="http://schemas.microsoft.com/office/drawing/2014/chartex">
+            <cx:chart xmlns:cx="http://schemas.microsoft.com/office/drawing/2014/chartex" xmlns:r="http://schemas.openxmlformats.org/officeDocument/2006/relationships" r:id="rIdCx6"/>
+          </a:graphicData>
+        </a:graphic>
+      </p:graphicFrame>
     </p:spTree>
   </p:cSld>
   <p:clrMapOvr>

</xml_diff>

<commit_message>
feat: add support for live date and slide number placeholders in presentations
</commit_message>
<xml_diff>
--- a/test_fixtures/test_features.pptx
+++ b/test_fixtures/test_features.pptx
@@ -101,6 +101,7 @@
     <p:sldId id="349" r:id="rId102"/>
     <p:sldId id="350" r:id="rId103"/>
     <p:sldId id="351" r:id="rId104"/>
+    <p:sldId id="352" r:id="rId105"/>
   </p:sldIdLst>
   <p:sldSz cx="9144000" cy="6858000" type="screen4x3"/>
   <p:notesSz cx="6858000" cy="9144000"/>
@@ -21955,6 +21956,98 @@
           <a:lstStyle/>
           <a:p>
             <a:endParaRPr lang="en-US"/>
+          </a:p>
+        </p:txBody>
+      </p:sp>
+    </p:spTree>
+  </p:cSld>
+  <p:clrMapOvr>
+    <a:masterClrMapping/>
+  </p:clrMapOvr>
+</p:sld>
+</file>
+
+<file path=ppt/slides/slide97.xml><?xml version="1.0" encoding="utf-8"?>
+<p:sld xmlns:a="http://schemas.openxmlformats.org/drawingml/2006/main" xmlns:p="http://schemas.openxmlformats.org/presentationml/2006/main" xmlns:r="http://schemas.openxmlformats.org/officeDocument/2006/relationships">
+  <p:cSld>
+    <p:spTree>
+      <p:nvGrpSpPr>
+        <p:cNvPr id="1" name=""/>
+        <p:cNvGrpSpPr/>
+        <p:nvPr/>
+      </p:nvGrpSpPr>
+      <p:grpSpPr/>
+      <p:sp>
+        <p:nvSpPr>
+          <p:cNvPr id="9701" name="Footer Placeholder"/>
+          <p:cNvSpPr/>
+          <p:nvPr>
+            <p:ph type="ftr" idx="11"/>
+          </p:nvPr>
+        </p:nvSpPr>
+        <p:spPr>
+          <a:xfrm>
+            <a:off x="3124200" y="6356350"/>
+            <a:ext cx="2438400" cy="365125"/>
+          </a:xfrm>
+        </p:spPr>
+        <p:txBody>
+          <a:bodyPr/>
+          <a:lstStyle/>
+          <a:p>
+            <a:r>
+              <a:rPr/>
+              <a:t>moon-pptx footer</a:t>
+            </a:r>
+          </a:p>
+        </p:txBody>
+      </p:sp>
+      <p:sp>
+        <p:nvSpPr>
+          <p:cNvPr id="9702" name="Date Placeholder"/>
+          <p:cNvSpPr/>
+          <p:nvPr>
+            <p:ph type="dt" idx="10"/>
+          </p:nvPr>
+        </p:nvSpPr>
+        <p:spPr>
+          <a:xfrm>
+            <a:off x="457200" y="6356350"/>
+            <a:ext cx="2438400" cy="365125"/>
+          </a:xfrm>
+        </p:spPr>
+        <p:txBody>
+          <a:bodyPr/>
+          <a:lstStyle/>
+          <a:p>
+            <a:fld id="{1F3B9E54-0000-4000-8000-000000000099}" type="datetime1">
+              <a:rPr/>
+            </a:fld>
+          </a:p>
+        </p:txBody>
+      </p:sp>
+      <p:sp>
+        <p:nvSpPr>
+          <p:cNvPr id="9703" name="Slide Number Placeholder"/>
+          <p:cNvSpPr/>
+          <p:nvPr>
+            <p:ph type="sldNum" idx="12"/>
+          </p:nvPr>
+        </p:nvSpPr>
+        <p:spPr>
+          <a:xfrm>
+            <a:off x="6553200" y="6356350"/>
+            <a:ext cx="2438400" cy="365125"/>
+          </a:xfrm>
+        </p:spPr>
+        <p:txBody>
+          <a:bodyPr/>
+          <a:lstStyle/>
+          <a:p>
+            <a:fld id="{1F3B9E54-0000-4000-8000-000000000099}" type="slidenum">
+              <a:rPr/>
+              <a:t>1</a:t>
+            </a:fld>
           </a:p>
         </p:txBody>
       </p:sp>

</xml_diff>

<commit_message>
feat: add underline color support and round-trip functionality for text runs
</commit_message>
<xml_diff>
--- a/test_fixtures/test_features.pptx
+++ b/test_fixtures/test_features.pptx
@@ -102,6 +102,7 @@
     <p:sldId id="350" r:id="rId103"/>
     <p:sldId id="351" r:id="rId104"/>
     <p:sldId id="352" r:id="rId105"/>
+    <p:sldId id="353" r:id="rId106"/>
   </p:sldIdLst>
   <p:sldSz cx="9144000" cy="6858000" type="screen4x3"/>
   <p:notesSz cx="6858000" cy="9144000"/>
@@ -22048,6 +22049,74 @@
               <a:rPr/>
               <a:t>1</a:t>
             </a:fld>
+          </a:p>
+        </p:txBody>
+      </p:sp>
+    </p:spTree>
+  </p:cSld>
+  <p:clrMapOvr>
+    <a:masterClrMapping/>
+  </p:clrMapOvr>
+</p:sld>
+</file>
+
+<file path=ppt/slides/slide98.xml><?xml version="1.0" encoding="utf-8"?>
+<p:sld xmlns:a="http://schemas.openxmlformats.org/drawingml/2006/main" xmlns:p="http://schemas.openxmlformats.org/presentationml/2006/main" xmlns:r="http://schemas.openxmlformats.org/officeDocument/2006/relationships">
+  <p:cSld>
+    <p:spTree>
+      <p:nvGrpSpPr>
+        <p:cNvPr id="1" name=""/>
+        <p:cNvGrpSpPr/>
+        <p:nvPr/>
+      </p:nvGrpSpPr>
+      <p:grpSpPr/>
+      <p:sp>
+        <p:nvSpPr>
+          <p:cNvPr id="9801" name="DecoText"/>
+          <p:cNvSpPr txBox="1"/>
+          <p:nvPr/>
+        </p:nvSpPr>
+        <p:spPr>
+          <a:xfrm>
+            <a:off x="457200" y="1371600"/>
+            <a:ext cx="8229600" cy="914400"/>
+          </a:xfrm>
+          <a:prstGeom prst="rect">
+            <a:avLst/>
+          </a:prstGeom>
+        </p:spPr>
+        <p:txBody>
+          <a:bodyPr/>
+          <a:lstStyle/>
+          <a:p>
+            <a:r>
+              <a:rPr lang="en-US" sz="2000" u="dbl">
+                <a:uFill>
+                  <a:solidFill>
+                    <a:srgbClr val="FF0000"/>
+                  </a:solidFill>
+                </a:uFill>
+              </a:rPr>
+              <a:t>double </a:t>
+            </a:r>
+            <a:r>
+              <a:rPr lang="en-US" sz="2000" u="wavy">
+                <a:uFill>
+                  <a:solidFill>
+                    <a:srgbClr val="00B050"/>
+                  </a:solidFill>
+                </a:uFill>
+              </a:rPr>
+              <a:t>wavy </a:t>
+            </a:r>
+            <a:r>
+              <a:rPr lang="en-US" sz="2000" u="dotted"/>
+              <a:t>dotted </a:t>
+            </a:r>
+            <a:r>
+              <a:rPr lang="en-US" sz="2000" strike="dblStrike"/>
+              <a:t>dblstrike</a:t>
+            </a:r>
           </a:p>
         </p:txBody>
       </p:sp>

</xml_diff>